<commit_message>
OCH: DNR policy wording, branch table split by branch, Branch A/B flowcharts with click-to-open penalty check
Co-Authored-By: Claude Opus 5.5 <noreply@anthropic.com>
Claude-Session: https://claude.ai/code/session_01FEzv8wwqWDgTsXP8Yz6XYn
</commit_message>
<xml_diff>
--- a/billing-disputes/billing-disputes-cash-payments.pptx
+++ b/billing-disputes/billing-disputes-cash-payments.pptx
@@ -631,7 +631,7 @@
           <a:p>
             <a:r>
               <a:rPr lang="en-US" dirty="0"/>
-              <a:t>B1: do we know how much was allegedly overcharged? If not, ask the customer for detail and address other pain points; done for this contact. B2: is the cleaner suspended + DNR for multiple overcharged hours? If yes, skip documentation and treat it as valid: go to Branch A from step 1. If not, B3: request documentation. 1) Refund the Premium Upsell fee if charged. 2) Create a Timed Reminder on the C side: 72 hours (Action On: 72 hours from handling; Who Should Act: Any CS; Action: C &lt;C_ID&gt; reported that CP overcharged J &lt;JOB_ID&gt; for &lt;# OF OVERCHARGED HOURS&gt;. Follow When the Timed Reminder Triggers). 3) Tell the customer we'll follow up in 4-5 business days and the cleaner is blocked from their future requests (not penalized yet). 4) Block the pairing and tell the cleaner documentation is due within 3 days, or the alleged hours will be refunded on their behalf. Done for this contact.</a:t>
+              <a:t>If the overcharge amount isn't known yet, ask the customer for detail first (B1). Is the CP suspended + DNR due to multiple overcharged hours? Yes: skip documentation and treat it as valid: go to Branch A from step 1. No: request documentation. Refund the Premium Upsell fee if charged; create a 72-hour Timed Reminder on the C side; tell the customer we'll follow up in 4-5 business days and the CP is blocked from their future requests (not penalized yet); block the pairing and tell the CP documentation is due within 3 days or the alleged hours will be refunded on their behalf. When the reminder triggers: valid proof from the CP: no refund (confirm the CP stays blocked from this customer). No or insufficient proof: refund the alleged hours via the CP Dashboard, check/refund Premium, log to the Ticket Tracker, then the penalty check. TRAINER: click (or press the right arrow) to open the penalty check. 30 minutes or more overcharged: add the cp_overcharged_hours flag + norequests + the Overcharged Hours macro series. Under 30 minutes: no flag, no penalty + the Overcharged Hours macro series.</a:t>
             </a:r>
             <a:endParaRPr lang="en-US" dirty="0"/>
           </a:p>
@@ -3799,7 +3799,7 @@
           <a:p>
             <a:r>
               <a:rPr lang="en-US" dirty="0"/>
-              <a:t>Claim window: only jobs completed in the last 120 days. Exception: the window does not apply when the overcharge is already clearly proven when the customer reports it (CTJ, message history or job timestamps make it obvious; "likely" or "probably" is not enough). Then refund the difference via the CP Dashboard regardless of job age or the cleaner's status, and follow the rest of the process including the penalty ladder. Example: CTJ shows a 45-minute visit but 2 hours invoiced, reported 150 days later: refund and apply the ladder. If not clearly proven and beyond 120 days: don't request documentation or refund; close the ticket as unresolved instead of escalating (this includes cases where the only reason to refund is the CP's Suspended + DNR history). Evidence-based refund: refund only the hours the evidence supports, not automatically the full disputed amount. Suspended + DNR exemption: if the cleaner is already suspended + DNR for repeated false invoice/overcharge offenses, refund the excess hours even without clear evidence; a documented pattern removes the benefit of the doubt.</a:t>
+              <a:t>Claim window: only jobs completed in the last 120 days. Exception: the window does not apply when the overcharge is already clearly proven when the customer reports it (CTJ, message history or job timestamps make it obvious; "likely" or "probably" is not enough). Then refund the difference via the CP Dashboard regardless of job age or the cleaner's status, and follow the rest of the process including the penalty ladder. Example: CTJ shows a 45-minute visit but 2 hours invoiced, reported 150 days later: refund and apply the ladder. If not clearly proven and beyond 120 days: don't request documentation or refund; close the ticket as unresolved instead of escalating (this includes cases where the only reason to refund is the CP's Suspended + DNR history). Evidence-based refund: refund only the hours the evidence supports, not automatically the full disputed amount. CP Suspended + DNR: if the cleaner is already suspended + DNR for repeated false invoice/overcharge offenses: within 120 days, refund the excess even without clear evidence, with no need to request evidence from the CP (a documented pattern removes the benefit of the doubt); beyond 120 days, refund the excess only when the issue is clearly proven.</a:t>
             </a:r>
             <a:endParaRPr lang="en-US" dirty="0"/>
           </a:p>
@@ -4063,7 +4063,7 @@
           <a:p>
             <a:r>
               <a:rPr lang="en-US" dirty="0"/>
-              <a:t>Customer claims a shorter duration than what you found: if CTJ confirms an overcharge, go to Branch A and refund only what CTJ supports, even if it doesn't match what the customer reported. If only job history or other sources (e.g. C/CP message timestamps) suggest it, go to Branch B. Known bug (Trello): don't treat an abnormally short CTJ interval (30 minutes or less between ARRIVED AT and COMPLETED AT) on its own as clear evidence; it's inconclusive unless other evidence supports it.</a:t>
+              <a:t>Branch A (clear evidence present): a straight line once you're in it: refund, check for a Premium fee, then split on the 30-minute rule. Branch B (no clear evidence present): takes longer and may span more than one contact: request documentation from the CP and resume when the Timed Reminder triggers. If CTJ matches the hours invoiced, that is clear evidence no overcharge occurred: stop, no refund, address other concerns. Known bug (Trello): do not treat an abnormally short CTJ interval (30 minutes or less between ARRIVED AT and COMPLETED AT) on its own as clear evidence; it's inconclusive unless other evidence proves the CP only stayed that long.</a:t>
             </a:r>
             <a:endParaRPr lang="en-US" dirty="0"/>
           </a:p>
@@ -5214,7 +5214,7 @@
                 <a:ea typeface="SF Pro Display" pitchFamily="34" charset="-122"/>
                 <a:cs typeface="SF Pro Display" pitchFamily="34" charset="-120"/>
               </a:rPr>
-              <a:t>Branch B: no clear evidence</a:t>
+              <a:t>Branch B: no clear evidence present</a:t>
             </a:r>
             <a:endParaRPr lang="en-US" sz="2400" dirty="0"/>
           </a:p>
@@ -5253,7 +5253,7 @@
                 <a:ea typeface="SF Pro Text" pitchFamily="34" charset="-122"/>
                 <a:cs typeface="SF Pro Text" pitchFamily="34" charset="-120"/>
               </a:rPr>
-              <a:t>May span more than one contact with the customer.</a:t>
+              <a:t>Takes longer: it pauses while we wait on the CP, and picks back up when the Timed Reminder triggers.</a:t>
             </a:r>
             <a:endParaRPr lang="en-US" sz="1200" dirty="0"/>
           </a:p>
@@ -5267,18 +5267,684 @@
         </p:nvSpPr>
         <p:spPr>
           <a:xfrm>
-            <a:off x="411480" y="1280160"/>
-            <a:ext cx="2682240" cy="1325880"/>
+            <a:off x="2971800" y="1298448"/>
+            <a:ext cx="3200400" cy="502920"/>
           </a:xfrm>
           <a:prstGeom prst="roundRect">
             <a:avLst>
-              <a:gd name="adj" fmla="val 5517"/>
+              <a:gd name="adj" fmla="val 14545"/>
+            </a:avLst>
+          </a:prstGeom>
+          <a:solidFill>
+            <a:srgbClr val="FFF3D6"/>
+          </a:solidFill>
+          <a:ln w="12700">
+            <a:solidFill>
+              <a:srgbClr val="9A6410"/>
+            </a:solidFill>
+            <a:prstDash val="solid"/>
+          </a:ln>
+        </p:spPr>
+      </p:sp>
+      <p:sp>
+        <p:nvSpPr>
+          <p:cNvPr id="7" name="Text 4"/>
+          <p:cNvSpPr txBox="1"/>
+          <p:nvPr/>
+        </p:nvSpPr>
+        <p:spPr>
+          <a:xfrm>
+            <a:off x="2971800" y="1298448"/>
+            <a:ext cx="3200400" cy="502920"/>
+          </a:xfrm>
+          <a:prstGeom prst="rect">
+            <a:avLst/>
+          </a:prstGeom>
+          <a:noFill/>
+          <a:ln/>
+        </p:spPr>
+        <p:txBody>
+          <a:bodyPr wrap="square" lIns="0" tIns="0" rIns="0" bIns="0" rtlCol="0" anchor="ctr"/>
+          <a:lstStyle/>
+          <a:p>
+            <a:pPr algn="ctr" indent="0" marL="0">
+              <a:buNone/>
+            </a:pPr>
+            <a:r>
+              <a:rPr lang="en-US" sz="1000" b="1" dirty="0">
+                <a:solidFill>
+                  <a:srgbClr val="9A6410"/>
+                </a:solidFill>
+                <a:latin typeface="SF Pro Display" pitchFamily="34" charset="0"/>
+                <a:ea typeface="SF Pro Display" pitchFamily="34" charset="-122"/>
+                <a:cs typeface="SF Pro Display" pitchFamily="34" charset="-120"/>
+              </a:rPr>
+              <a:t>CP suspended + DNR due to multiple overcharged hours?</a:t>
+            </a:r>
+            <a:endParaRPr lang="en-US" sz="1000" dirty="0"/>
+          </a:p>
+        </p:txBody>
+      </p:sp>
+      <p:sp>
+        <p:nvSpPr>
+          <p:cNvPr id="8" name="Shape 5"/>
+          <p:cNvSpPr/>
+          <p:nvPr/>
+        </p:nvSpPr>
+        <p:spPr>
+          <a:xfrm>
+            <a:off x="4572000" y="1801368"/>
+            <a:ext cx="0" cy="210312"/>
+          </a:xfrm>
+          <a:prstGeom prst="line">
+            <a:avLst/>
+          </a:prstGeom>
+          <a:noFill/>
+          <a:ln w="12700">
+            <a:solidFill>
+              <a:srgbClr val="6E6E73"/>
+            </a:solidFill>
+            <a:prstDash val="solid"/>
+          </a:ln>
+        </p:spPr>
+      </p:sp>
+      <p:sp>
+        <p:nvSpPr>
+          <p:cNvPr id="9" name="Shape 6"/>
+          <p:cNvSpPr/>
+          <p:nvPr/>
+        </p:nvSpPr>
+        <p:spPr>
+          <a:xfrm>
+            <a:off x="2743200" y="2011680"/>
+            <a:ext cx="4206240" cy="0"/>
+          </a:xfrm>
+          <a:prstGeom prst="line">
+            <a:avLst/>
+          </a:prstGeom>
+          <a:noFill/>
+          <a:ln w="12700">
+            <a:solidFill>
+              <a:srgbClr val="6E6E73"/>
+            </a:solidFill>
+            <a:prstDash val="solid"/>
+          </a:ln>
+        </p:spPr>
+      </p:sp>
+      <p:sp>
+        <p:nvSpPr>
+          <p:cNvPr id="10" name="Shape 7"/>
+          <p:cNvSpPr/>
+          <p:nvPr/>
+        </p:nvSpPr>
+        <p:spPr>
+          <a:xfrm>
+            <a:off x="2743200" y="2011680"/>
+            <a:ext cx="0" cy="228600"/>
+          </a:xfrm>
+          <a:prstGeom prst="line">
+            <a:avLst/>
+          </a:prstGeom>
+          <a:noFill/>
+          <a:ln w="12700">
+            <a:solidFill>
+              <a:srgbClr val="6E6E73"/>
+            </a:solidFill>
+            <a:prstDash val="solid"/>
+            <a:tailEnd type="triangle"/>
+          </a:ln>
+        </p:spPr>
+      </p:sp>
+      <p:sp>
+        <p:nvSpPr>
+          <p:cNvPr id="11" name="Shape 8"/>
+          <p:cNvSpPr/>
+          <p:nvPr/>
+        </p:nvSpPr>
+        <p:spPr>
+          <a:xfrm>
+            <a:off x="6949440" y="2011680"/>
+            <a:ext cx="0" cy="228600"/>
+          </a:xfrm>
+          <a:prstGeom prst="line">
+            <a:avLst/>
+          </a:prstGeom>
+          <a:noFill/>
+          <a:ln w="12700">
+            <a:solidFill>
+              <a:srgbClr val="6E6E73"/>
+            </a:solidFill>
+            <a:prstDash val="solid"/>
+            <a:tailEnd type="triangle"/>
+          </a:ln>
+        </p:spPr>
+      </p:sp>
+      <p:sp>
+        <p:nvSpPr>
+          <p:cNvPr id="12" name="Text 9"/>
+          <p:cNvSpPr txBox="1"/>
+          <p:nvPr/>
+        </p:nvSpPr>
+        <p:spPr>
+          <a:xfrm>
+            <a:off x="2816352" y="2029968"/>
+            <a:ext cx="548640" cy="201168"/>
+          </a:xfrm>
+          <a:prstGeom prst="rect">
+            <a:avLst/>
+          </a:prstGeom>
+          <a:noFill/>
+          <a:ln/>
+        </p:spPr>
+        <p:txBody>
+          <a:bodyPr wrap="square" lIns="0" tIns="0" rIns="0" bIns="0" rtlCol="0" anchor="t"/>
+          <a:lstStyle/>
+          <a:p>
+            <a:pPr indent="0" marL="0">
+              <a:buNone/>
+            </a:pPr>
+            <a:r>
+              <a:rPr lang="en-US" sz="850" b="1" dirty="0">
+                <a:solidFill>
+                  <a:srgbClr val="6E6E73"/>
+                </a:solidFill>
+                <a:latin typeface="SF Pro Text" pitchFamily="34" charset="0"/>
+                <a:ea typeface="SF Pro Text" pitchFamily="34" charset="-122"/>
+                <a:cs typeface="SF Pro Text" pitchFamily="34" charset="-120"/>
+              </a:rPr>
+              <a:t>No</a:t>
+            </a:r>
+            <a:endParaRPr lang="en-US" sz="850" dirty="0"/>
+          </a:p>
+        </p:txBody>
+      </p:sp>
+      <p:sp>
+        <p:nvSpPr>
+          <p:cNvPr id="13" name="Text 10"/>
+          <p:cNvSpPr txBox="1"/>
+          <p:nvPr/>
+        </p:nvSpPr>
+        <p:spPr>
+          <a:xfrm>
+            <a:off x="7022592" y="2029968"/>
+            <a:ext cx="548640" cy="201168"/>
+          </a:xfrm>
+          <a:prstGeom prst="rect">
+            <a:avLst/>
+          </a:prstGeom>
+          <a:noFill/>
+          <a:ln/>
+        </p:spPr>
+        <p:txBody>
+          <a:bodyPr wrap="square" lIns="0" tIns="0" rIns="0" bIns="0" rtlCol="0" anchor="t"/>
+          <a:lstStyle/>
+          <a:p>
+            <a:pPr indent="0" marL="0">
+              <a:buNone/>
+            </a:pPr>
+            <a:r>
+              <a:rPr lang="en-US" sz="850" b="1" dirty="0">
+                <a:solidFill>
+                  <a:srgbClr val="6E6E73"/>
+                </a:solidFill>
+                <a:latin typeface="SF Pro Text" pitchFamily="34" charset="0"/>
+                <a:ea typeface="SF Pro Text" pitchFamily="34" charset="-122"/>
+                <a:cs typeface="SF Pro Text" pitchFamily="34" charset="-120"/>
+              </a:rPr>
+              <a:t>Yes</a:t>
+            </a:r>
+            <a:endParaRPr lang="en-US" sz="850" dirty="0"/>
+          </a:p>
+        </p:txBody>
+      </p:sp>
+      <p:sp>
+        <p:nvSpPr>
+          <p:cNvPr id="14" name="Shape 11"/>
+          <p:cNvSpPr/>
+          <p:nvPr/>
+        </p:nvSpPr>
+        <p:spPr>
+          <a:xfrm>
+            <a:off x="1463040" y="2240280"/>
+            <a:ext cx="2560320" cy="475488"/>
+          </a:xfrm>
+          <a:prstGeom prst="roundRect">
+            <a:avLst>
+              <a:gd name="adj" fmla="val 15385"/>
+            </a:avLst>
+          </a:prstGeom>
+          <a:solidFill>
+            <a:srgbClr val="0B7A6F"/>
+          </a:solidFill>
+          <a:ln w="12700">
+            <a:solidFill>
+              <a:srgbClr val="0B7A6F"/>
+            </a:solidFill>
+            <a:prstDash val="solid"/>
+          </a:ln>
+        </p:spPr>
+      </p:sp>
+      <p:sp>
+        <p:nvSpPr>
+          <p:cNvPr id="15" name="Text 12"/>
+          <p:cNvSpPr txBox="1"/>
+          <p:nvPr/>
+        </p:nvSpPr>
+        <p:spPr>
+          <a:xfrm>
+            <a:off x="1463040" y="2240280"/>
+            <a:ext cx="2560320" cy="475488"/>
+          </a:xfrm>
+          <a:prstGeom prst="rect">
+            <a:avLst/>
+          </a:prstGeom>
+          <a:noFill/>
+          <a:ln/>
+        </p:spPr>
+        <p:txBody>
+          <a:bodyPr wrap="square" lIns="0" tIns="0" rIns="0" bIns="0" rtlCol="0" anchor="ctr"/>
+          <a:lstStyle/>
+          <a:p>
+            <a:pPr algn="ctr" indent="0" marL="0">
+              <a:buNone/>
+            </a:pPr>
+            <a:r>
+              <a:rPr lang="en-US" sz="1000" b="1" dirty="0">
+                <a:solidFill>
+                  <a:srgbClr val="FFFFFF"/>
+                </a:solidFill>
+                <a:latin typeface="SF Pro Display" pitchFamily="34" charset="0"/>
+                <a:ea typeface="SF Pro Display" pitchFamily="34" charset="-122"/>
+                <a:cs typeface="SF Pro Display" pitchFamily="34" charset="-120"/>
+              </a:rPr>
+              <a:t>Request docs</a:t>
+            </a:r>
+            <a:endParaRPr lang="en-US" sz="1000" dirty="0"/>
+          </a:p>
+          <a:p>
+            <a:pPr algn="ctr" indent="0" marL="0">
+              <a:buNone/>
+            </a:pPr>
+            <a:r>
+              <a:rPr lang="en-US" sz="1000" b="1" dirty="0">
+                <a:solidFill>
+                  <a:srgbClr val="FFFFFF"/>
+                </a:solidFill>
+                <a:latin typeface="SF Pro Display" pitchFamily="34" charset="0"/>
+                <a:ea typeface="SF Pro Display" pitchFamily="34" charset="-122"/>
+                <a:cs typeface="SF Pro Display" pitchFamily="34" charset="-120"/>
+              </a:rPr>
+              <a:t>72-hour Timed Reminder</a:t>
+            </a:r>
+            <a:endParaRPr lang="en-US" sz="1000" dirty="0"/>
+          </a:p>
+        </p:txBody>
+      </p:sp>
+      <p:sp>
+        <p:nvSpPr>
+          <p:cNvPr id="16" name="Shape 13"/>
+          <p:cNvSpPr/>
+          <p:nvPr/>
+        </p:nvSpPr>
+        <p:spPr>
+          <a:xfrm>
+            <a:off x="5669280" y="2240280"/>
+            <a:ext cx="2560320" cy="475488"/>
+          </a:xfrm>
+          <a:prstGeom prst="roundRect">
+            <a:avLst>
+              <a:gd name="adj" fmla="val 15385"/>
+            </a:avLst>
+          </a:prstGeom>
+          <a:solidFill>
+            <a:srgbClr val="0B7A6F"/>
+          </a:solidFill>
+          <a:ln w="12700">
+            <a:solidFill>
+              <a:srgbClr val="0B7A6F"/>
+            </a:solidFill>
+            <a:prstDash val="solid"/>
+          </a:ln>
+        </p:spPr>
+      </p:sp>
+      <p:sp>
+        <p:nvSpPr>
+          <p:cNvPr id="17" name="Text 14"/>
+          <p:cNvSpPr txBox="1"/>
+          <p:nvPr/>
+        </p:nvSpPr>
+        <p:spPr>
+          <a:xfrm>
+            <a:off x="5669280" y="2240280"/>
+            <a:ext cx="2560320" cy="475488"/>
+          </a:xfrm>
+          <a:prstGeom prst="rect">
+            <a:avLst/>
+          </a:prstGeom>
+          <a:noFill/>
+          <a:ln/>
+        </p:spPr>
+        <p:txBody>
+          <a:bodyPr wrap="square" lIns="0" tIns="0" rIns="0" bIns="0" rtlCol="0" anchor="ctr"/>
+          <a:lstStyle/>
+          <a:p>
+            <a:pPr algn="ctr" indent="0" marL="0">
+              <a:buNone/>
+            </a:pPr>
+            <a:r>
+              <a:rPr lang="en-US" sz="1000" b="1" dirty="0">
+                <a:solidFill>
+                  <a:srgbClr val="FFFFFF"/>
+                </a:solidFill>
+                <a:latin typeface="SF Pro Display" pitchFamily="34" charset="0"/>
+                <a:ea typeface="SF Pro Display" pitchFamily="34" charset="-122"/>
+                <a:cs typeface="SF Pro Display" pitchFamily="34" charset="-120"/>
+              </a:rPr>
+              <a:t>Skip to Branch A</a:t>
+            </a:r>
+            <a:endParaRPr lang="en-US" sz="1000" dirty="0"/>
+          </a:p>
+        </p:txBody>
+      </p:sp>
+      <p:sp>
+        <p:nvSpPr>
+          <p:cNvPr id="18" name="Shape 15"/>
+          <p:cNvSpPr/>
+          <p:nvPr/>
+        </p:nvSpPr>
+        <p:spPr>
+          <a:xfrm>
+            <a:off x="2743200" y="2715768"/>
+            <a:ext cx="0" cy="228600"/>
+          </a:xfrm>
+          <a:prstGeom prst="line">
+            <a:avLst/>
+          </a:prstGeom>
+          <a:noFill/>
+          <a:ln w="12700">
+            <a:solidFill>
+              <a:srgbClr val="6E6E73"/>
+            </a:solidFill>
+            <a:prstDash val="solid"/>
+            <a:tailEnd type="triangle"/>
+          </a:ln>
+        </p:spPr>
+      </p:sp>
+      <p:sp>
+        <p:nvSpPr>
+          <p:cNvPr id="19" name="Shape 16"/>
+          <p:cNvSpPr/>
+          <p:nvPr/>
+        </p:nvSpPr>
+        <p:spPr>
+          <a:xfrm>
+            <a:off x="1463040" y="2944368"/>
+            <a:ext cx="2560320" cy="475488"/>
+          </a:xfrm>
+          <a:prstGeom prst="roundRect">
+            <a:avLst>
+              <a:gd name="adj" fmla="val 15385"/>
+            </a:avLst>
+          </a:prstGeom>
+          <a:solidFill>
+            <a:srgbClr val="FFF3D6"/>
+          </a:solidFill>
+          <a:ln w="12700">
+            <a:solidFill>
+              <a:srgbClr val="9A6410"/>
+            </a:solidFill>
+            <a:prstDash val="solid"/>
+          </a:ln>
+        </p:spPr>
+      </p:sp>
+      <p:sp>
+        <p:nvSpPr>
+          <p:cNvPr id="20" name="Text 17"/>
+          <p:cNvSpPr txBox="1"/>
+          <p:nvPr/>
+        </p:nvSpPr>
+        <p:spPr>
+          <a:xfrm>
+            <a:off x="1463040" y="2944368"/>
+            <a:ext cx="2560320" cy="475488"/>
+          </a:xfrm>
+          <a:prstGeom prst="rect">
+            <a:avLst/>
+          </a:prstGeom>
+          <a:noFill/>
+          <a:ln/>
+        </p:spPr>
+        <p:txBody>
+          <a:bodyPr wrap="square" lIns="0" tIns="0" rIns="0" bIns="0" rtlCol="0" anchor="ctr"/>
+          <a:lstStyle/>
+          <a:p>
+            <a:pPr algn="ctr" indent="0" marL="0">
+              <a:buNone/>
+            </a:pPr>
+            <a:r>
+              <a:rPr lang="en-US" sz="1000" b="1" dirty="0">
+                <a:solidFill>
+                  <a:srgbClr val="9A6410"/>
+                </a:solidFill>
+                <a:latin typeface="SF Pro Display" pitchFamily="34" charset="0"/>
+                <a:ea typeface="SF Pro Display" pitchFamily="34" charset="-122"/>
+                <a:cs typeface="SF Pro Display" pitchFamily="34" charset="-120"/>
+              </a:rPr>
+              <a:t>Reminder triggers</a:t>
+            </a:r>
+            <a:endParaRPr lang="en-US" sz="1000" dirty="0"/>
+          </a:p>
+          <a:p>
+            <a:pPr algn="ctr" indent="0" marL="0">
+              <a:buNone/>
+            </a:pPr>
+            <a:r>
+              <a:rPr lang="en-US" sz="1000" b="1" dirty="0">
+                <a:solidFill>
+                  <a:srgbClr val="9A6410"/>
+                </a:solidFill>
+                <a:latin typeface="SF Pro Display" pitchFamily="34" charset="0"/>
+                <a:ea typeface="SF Pro Display" pitchFamily="34" charset="-122"/>
+                <a:cs typeface="SF Pro Display" pitchFamily="34" charset="-120"/>
+              </a:rPr>
+              <a:t>CP provided valid proof?</a:t>
+            </a:r>
+            <a:endParaRPr lang="en-US" sz="1000" dirty="0"/>
+          </a:p>
+        </p:txBody>
+      </p:sp>
+      <p:sp>
+        <p:nvSpPr>
+          <p:cNvPr id="21" name="Shape 18"/>
+          <p:cNvSpPr/>
+          <p:nvPr/>
+        </p:nvSpPr>
+        <p:spPr>
+          <a:xfrm>
+            <a:off x="2743200" y="3419856"/>
+            <a:ext cx="0" cy="219456"/>
+          </a:xfrm>
+          <a:prstGeom prst="line">
+            <a:avLst/>
+          </a:prstGeom>
+          <a:noFill/>
+          <a:ln w="12700">
+            <a:solidFill>
+              <a:srgbClr val="6E6E73"/>
+            </a:solidFill>
+            <a:prstDash val="solid"/>
+          </a:ln>
+        </p:spPr>
+      </p:sp>
+      <p:sp>
+        <p:nvSpPr>
+          <p:cNvPr id="22" name="Shape 19"/>
+          <p:cNvSpPr/>
+          <p:nvPr/>
+        </p:nvSpPr>
+        <p:spPr>
+          <a:xfrm>
+            <a:off x="1508760" y="3639312"/>
+            <a:ext cx="2468880" cy="0"/>
+          </a:xfrm>
+          <a:prstGeom prst="line">
+            <a:avLst/>
+          </a:prstGeom>
+          <a:noFill/>
+          <a:ln w="12700">
+            <a:solidFill>
+              <a:srgbClr val="6E6E73"/>
+            </a:solidFill>
+            <a:prstDash val="solid"/>
+          </a:ln>
+        </p:spPr>
+      </p:sp>
+      <p:sp>
+        <p:nvSpPr>
+          <p:cNvPr id="23" name="Shape 20"/>
+          <p:cNvSpPr/>
+          <p:nvPr/>
+        </p:nvSpPr>
+        <p:spPr>
+          <a:xfrm>
+            <a:off x="1508760" y="3639312"/>
+            <a:ext cx="0" cy="384048"/>
+          </a:xfrm>
+          <a:prstGeom prst="line">
+            <a:avLst/>
+          </a:prstGeom>
+          <a:noFill/>
+          <a:ln w="12700">
+            <a:solidFill>
+              <a:srgbClr val="6E6E73"/>
+            </a:solidFill>
+            <a:prstDash val="solid"/>
+            <a:tailEnd type="triangle"/>
+          </a:ln>
+        </p:spPr>
+      </p:sp>
+      <p:sp>
+        <p:nvSpPr>
+          <p:cNvPr id="24" name="Shape 21"/>
+          <p:cNvSpPr/>
+          <p:nvPr/>
+        </p:nvSpPr>
+        <p:spPr>
+          <a:xfrm>
+            <a:off x="3977640" y="3639312"/>
+            <a:ext cx="0" cy="384048"/>
+          </a:xfrm>
+          <a:prstGeom prst="line">
+            <a:avLst/>
+          </a:prstGeom>
+          <a:noFill/>
+          <a:ln w="12700">
+            <a:solidFill>
+              <a:srgbClr val="6E6E73"/>
+            </a:solidFill>
+            <a:prstDash val="solid"/>
+            <a:tailEnd type="triangle"/>
+          </a:ln>
+        </p:spPr>
+      </p:sp>
+      <p:sp>
+        <p:nvSpPr>
+          <p:cNvPr id="25" name="Text 22"/>
+          <p:cNvSpPr txBox="1"/>
+          <p:nvPr/>
+        </p:nvSpPr>
+        <p:spPr>
+          <a:xfrm>
+            <a:off x="1581912" y="3657600"/>
+            <a:ext cx="548640" cy="201168"/>
+          </a:xfrm>
+          <a:prstGeom prst="rect">
+            <a:avLst/>
+          </a:prstGeom>
+          <a:noFill/>
+          <a:ln/>
+        </p:spPr>
+        <p:txBody>
+          <a:bodyPr wrap="square" lIns="0" tIns="0" rIns="0" bIns="0" rtlCol="0" anchor="t"/>
+          <a:lstStyle/>
+          <a:p>
+            <a:pPr indent="0" marL="0">
+              <a:buNone/>
+            </a:pPr>
+            <a:r>
+              <a:rPr lang="en-US" sz="850" b="1" dirty="0">
+                <a:solidFill>
+                  <a:srgbClr val="6E6E73"/>
+                </a:solidFill>
+                <a:latin typeface="SF Pro Text" pitchFamily="34" charset="0"/>
+                <a:ea typeface="SF Pro Text" pitchFamily="34" charset="-122"/>
+                <a:cs typeface="SF Pro Text" pitchFamily="34" charset="-120"/>
+              </a:rPr>
+              <a:t>Yes</a:t>
+            </a:r>
+            <a:endParaRPr lang="en-US" sz="850" dirty="0"/>
+          </a:p>
+        </p:txBody>
+      </p:sp>
+      <p:sp>
+        <p:nvSpPr>
+          <p:cNvPr id="26" name="Text 23"/>
+          <p:cNvSpPr txBox="1"/>
+          <p:nvPr/>
+        </p:nvSpPr>
+        <p:spPr>
+          <a:xfrm>
+            <a:off x="4050792" y="3657600"/>
+            <a:ext cx="548640" cy="201168"/>
+          </a:xfrm>
+          <a:prstGeom prst="rect">
+            <a:avLst/>
+          </a:prstGeom>
+          <a:noFill/>
+          <a:ln/>
+        </p:spPr>
+        <p:txBody>
+          <a:bodyPr wrap="square" lIns="0" tIns="0" rIns="0" bIns="0" rtlCol="0" anchor="t"/>
+          <a:lstStyle/>
+          <a:p>
+            <a:pPr indent="0" marL="0">
+              <a:buNone/>
+            </a:pPr>
+            <a:r>
+              <a:rPr lang="en-US" sz="850" b="1" dirty="0">
+                <a:solidFill>
+                  <a:srgbClr val="6E6E73"/>
+                </a:solidFill>
+                <a:latin typeface="SF Pro Text" pitchFamily="34" charset="0"/>
+                <a:ea typeface="SF Pro Text" pitchFamily="34" charset="-122"/>
+                <a:cs typeface="SF Pro Text" pitchFamily="34" charset="-120"/>
+              </a:rPr>
+              <a:t>No</a:t>
+            </a:r>
+            <a:endParaRPr lang="en-US" sz="850" dirty="0"/>
+          </a:p>
+        </p:txBody>
+      </p:sp>
+      <p:sp>
+        <p:nvSpPr>
+          <p:cNvPr id="27" name="Shape 24"/>
+          <p:cNvSpPr/>
+          <p:nvPr/>
+        </p:nvSpPr>
+        <p:spPr>
+          <a:xfrm>
+            <a:off x="457200" y="4023360"/>
+            <a:ext cx="2103120" cy="420624"/>
+          </a:xfrm>
+          <a:prstGeom prst="roundRect">
+            <a:avLst>
+              <a:gd name="adj" fmla="val 17391"/>
             </a:avLst>
           </a:prstGeom>
           <a:solidFill>
             <a:srgbClr val="FFFFFF"/>
           </a:solidFill>
-          <a:ln w="9525">
+          <a:ln w="12700">
             <a:solidFill>
               <a:srgbClr val="DCE1E7"/>
             </a:solidFill>
@@ -5288,24 +5954,163 @@
       </p:sp>
       <p:sp>
         <p:nvSpPr>
-          <p:cNvPr id="7" name="Shape 4"/>
+          <p:cNvPr id="28" name="Text 25"/>
+          <p:cNvSpPr txBox="1"/>
+          <p:nvPr/>
+        </p:nvSpPr>
+        <p:spPr>
+          <a:xfrm>
+            <a:off x="457200" y="4023360"/>
+            <a:ext cx="2103120" cy="420624"/>
+          </a:xfrm>
+          <a:prstGeom prst="rect">
+            <a:avLst/>
+          </a:prstGeom>
+          <a:noFill/>
+          <a:ln/>
+        </p:spPr>
+        <p:txBody>
+          <a:bodyPr wrap="square" lIns="0" tIns="0" rIns="0" bIns="0" rtlCol="0" anchor="ctr"/>
+          <a:lstStyle/>
+          <a:p>
+            <a:pPr algn="ctr" indent="0" marL="0">
+              <a:buNone/>
+            </a:pPr>
+            <a:r>
+              <a:rPr lang="en-US" sz="1000" b="1" dirty="0">
+                <a:solidFill>
+                  <a:srgbClr val="1D1D1F"/>
+                </a:solidFill>
+                <a:latin typeface="SF Pro Display" pitchFamily="34" charset="0"/>
+                <a:ea typeface="SF Pro Display" pitchFamily="34" charset="-122"/>
+                <a:cs typeface="SF Pro Display" pitchFamily="34" charset="-120"/>
+              </a:rPr>
+              <a:t>No refund</a:t>
+            </a:r>
+            <a:endParaRPr lang="en-US" sz="1000" dirty="0"/>
+          </a:p>
+        </p:txBody>
+      </p:sp>
+      <p:sp>
+        <p:nvSpPr>
+          <p:cNvPr id="29" name="Shape 26"/>
           <p:cNvSpPr/>
           <p:nvPr/>
         </p:nvSpPr>
         <p:spPr>
           <a:xfrm>
-            <a:off x="576072" y="1463040"/>
-            <a:ext cx="274320" cy="274320"/>
-          </a:xfrm>
-          <a:prstGeom prst="ellipse">
-            <a:avLst/>
+            <a:off x="2880360" y="4023360"/>
+            <a:ext cx="2194560" cy="420624"/>
+          </a:xfrm>
+          <a:prstGeom prst="roundRect">
+            <a:avLst>
+              <a:gd name="adj" fmla="val 17391"/>
+            </a:avLst>
           </a:prstGeom>
           <a:solidFill>
-            <a:srgbClr val="E3F4F1"/>
+            <a:srgbClr val="1D1D1F"/>
+          </a:solidFill>
+          <a:ln w="25400">
+            <a:solidFill>
+              <a:srgbClr val="0B7A6F"/>
+            </a:solidFill>
+            <a:prstDash val="solid"/>
+          </a:ln>
+        </p:spPr>
+      </p:sp>
+      <p:sp>
+        <p:nvSpPr>
+          <p:cNvPr id="30" name="Text 27"/>
+          <p:cNvSpPr txBox="1"/>
+          <p:nvPr/>
+        </p:nvSpPr>
+        <p:spPr>
+          <a:xfrm>
+            <a:off x="2880360" y="4023360"/>
+            <a:ext cx="2194560" cy="420624"/>
+          </a:xfrm>
+          <a:prstGeom prst="rect">
+            <a:avLst/>
+          </a:prstGeom>
+          <a:noFill/>
+          <a:ln/>
+        </p:spPr>
+        <p:txBody>
+          <a:bodyPr wrap="square" lIns="0" tIns="0" rIns="0" bIns="0" rtlCol="0" anchor="ctr"/>
+          <a:lstStyle/>
+          <a:p>
+            <a:pPr algn="ctr" indent="0" marL="0">
+              <a:buNone/>
+            </a:pPr>
+            <a:r>
+              <a:rPr lang="en-US" sz="1000" b="1" dirty="0">
+                <a:solidFill>
+                  <a:srgbClr val="FFFFFF"/>
+                </a:solidFill>
+                <a:latin typeface="SF Pro Display" pitchFamily="34" charset="0"/>
+                <a:ea typeface="SF Pro Display" pitchFamily="34" charset="-122"/>
+                <a:cs typeface="SF Pro Display" pitchFamily="34" charset="-120"/>
+              </a:rPr>
+              <a:t>Refund, then penalty check  ›</a:t>
+            </a:r>
+            <a:endParaRPr lang="en-US" sz="1000" dirty="0"/>
+          </a:p>
+        </p:txBody>
+      </p:sp>
+      <p:sp>
+        <p:nvSpPr>
+          <p:cNvPr id="31" name="step1Panel"/>
+          <p:cNvSpPr/>
+          <p:nvPr/>
+        </p:nvSpPr>
+        <p:spPr>
+          <a:xfrm>
+            <a:off x="5349240" y="2852928"/>
+            <a:ext cx="3383280" cy="1691640"/>
+          </a:xfrm>
+          <a:prstGeom prst="roundRect">
+            <a:avLst>
+              <a:gd name="adj" fmla="val 3243"/>
+            </a:avLst>
+          </a:prstGeom>
+          <a:solidFill>
+            <a:srgbClr val="FFFFFF"/>
+          </a:solidFill>
+          <a:ln w="19050">
+            <a:solidFill>
+              <a:srgbClr val="0B7A6F"/>
+            </a:solidFill>
+            <a:prstDash val="solid"/>
+          </a:ln>
+          <a:effectLst>
+            <a:outerShdw sx="100000" sy="100000" kx="0" ky="0" algn="bl" rotWithShape="0" blurRad="76200" dist="25400" dir="5400000">
+              <a:srgbClr val="000000">
+                <a:alpha val="18000"/>
+              </a:srgbClr>
+            </a:outerShdw>
+          </a:effectLst>
+        </p:spPr>
+      </p:sp>
+      <p:sp>
+        <p:nvSpPr>
+          <p:cNvPr id="32" name="step1Head"/>
+          <p:cNvSpPr/>
+          <p:nvPr/>
+        </p:nvSpPr>
+        <p:spPr>
+          <a:xfrm>
+            <a:off x="5349240" y="2852928"/>
+            <a:ext cx="3383280" cy="347472"/>
+          </a:xfrm>
+          <a:prstGeom prst="rect">
+            <a:avLst/>
+          </a:prstGeom>
+          <a:solidFill>
+            <a:srgbClr val="0B7A6F"/>
           </a:solidFill>
           <a:ln w="12700">
             <a:solidFill>
-              <a:srgbClr val="E3F4F1"/>
+              <a:srgbClr val="0B7A6F"/>
             </a:solidFill>
             <a:prstDash val="solid"/>
           </a:ln>
@@ -5313,14 +6118,14 @@
       </p:sp>
       <p:sp>
         <p:nvSpPr>
-          <p:cNvPr id="8" name="Text 5"/>
-          <p:cNvSpPr txBox="1"/>
-          <p:nvPr/>
-        </p:nvSpPr>
-        <p:spPr>
-          <a:xfrm>
-            <a:off x="576072" y="1463040"/>
-            <a:ext cx="274320" cy="274320"/>
+          <p:cNvPr id="33" name="step1Title"/>
+          <p:cNvSpPr txBox="1"/>
+          <p:nvPr/>
+        </p:nvSpPr>
+        <p:spPr>
+          <a:xfrm>
+            <a:off x="5486400" y="2852928"/>
+            <a:ext cx="3108960" cy="347472"/>
           </a:xfrm>
           <a:prstGeom prst="rect">
             <a:avLst/>
@@ -5332,34 +6137,34 @@
           <a:bodyPr wrap="square" lIns="0" tIns="0" rIns="0" bIns="0" rtlCol="0" anchor="ctr"/>
           <a:lstStyle/>
           <a:p>
-            <a:pPr algn="ctr" indent="0" marL="0">
-              <a:buNone/>
-            </a:pPr>
-            <a:r>
-              <a:rPr lang="en-US" sz="900" b="1" dirty="0">
-                <a:solidFill>
-                  <a:srgbClr val="0B7A6F"/>
+            <a:pPr indent="0" marL="0">
+              <a:buNone/>
+            </a:pPr>
+            <a:r>
+              <a:rPr lang="en-US" sz="1100" b="1" dirty="0">
+                <a:solidFill>
+                  <a:srgbClr val="FFFFFF"/>
                 </a:solidFill>
                 <a:latin typeface="SF Pro Display" pitchFamily="34" charset="0"/>
                 <a:ea typeface="SF Pro Display" pitchFamily="34" charset="-122"/>
                 <a:cs typeface="SF Pro Display" pitchFamily="34" charset="-120"/>
               </a:rPr>
-              <a:t>1</a:t>
-            </a:r>
-            <a:endParaRPr lang="en-US" sz="900" dirty="0"/>
-          </a:p>
-        </p:txBody>
-      </p:sp>
-      <p:sp>
-        <p:nvSpPr>
-          <p:cNvPr id="9" name="Text 6"/>
-          <p:cNvSpPr txBox="1"/>
-          <p:nvPr/>
-        </p:nvSpPr>
-        <p:spPr>
-          <a:xfrm>
-            <a:off x="576072" y="1883664"/>
-            <a:ext cx="2353056" cy="274320"/>
+              <a:t>Penalty check</a:t>
+            </a:r>
+            <a:endParaRPr lang="en-US" sz="1100" dirty="0"/>
+          </a:p>
+        </p:txBody>
+      </p:sp>
+      <p:sp>
+        <p:nvSpPr>
+          <p:cNvPr id="34" name="step1Body"/>
+          <p:cNvSpPr txBox="1"/>
+          <p:nvPr/>
+        </p:nvSpPr>
+        <p:spPr>
+          <a:xfrm>
+            <a:off x="5486400" y="3246120"/>
+            <a:ext cx="3154680" cy="1261872"/>
           </a:xfrm>
           <a:prstGeom prst="rect">
             <a:avLst/>
@@ -5372,896 +6177,83 @@
           <a:lstStyle/>
           <a:p>
             <a:pPr indent="0" marL="0">
-              <a:buNone/>
-            </a:pPr>
-            <a:r>
-              <a:rPr lang="en-US" sz="1200" b="1" dirty="0">
-                <a:solidFill>
-                  <a:srgbClr val="1D1D1F"/>
-                </a:solidFill>
-                <a:latin typeface="SF Pro Display" pitchFamily="34" charset="0"/>
-                <a:ea typeface="SF Pro Display" pitchFamily="34" charset="-122"/>
-                <a:cs typeface="SF Pro Display" pitchFamily="34" charset="-120"/>
-              </a:rPr>
-              <a:t>Know the amount?</a:t>
-            </a:r>
-            <a:endParaRPr lang="en-US" sz="1200" dirty="0"/>
-          </a:p>
-        </p:txBody>
-      </p:sp>
-      <p:sp>
-        <p:nvSpPr>
-          <p:cNvPr id="10" name="Text 7"/>
-          <p:cNvSpPr txBox="1"/>
-          <p:nvPr/>
-        </p:nvSpPr>
-        <p:spPr>
-          <a:xfrm>
-            <a:off x="576072" y="2176272"/>
-            <a:ext cx="2353056" cy="338328"/>
-          </a:xfrm>
-          <a:prstGeom prst="rect">
-            <a:avLst/>
-          </a:prstGeom>
-          <a:noFill/>
-          <a:ln/>
-        </p:spPr>
-        <p:txBody>
-          <a:bodyPr wrap="square" lIns="0" tIns="0" rIns="0" bIns="0" rtlCol="0" anchor="t"/>
-          <a:lstStyle/>
-          <a:p>
-            <a:pPr indent="0" marL="0">
-              <a:buNone/>
-            </a:pPr>
-            <a:r>
-              <a:rPr lang="en-US" sz="950" dirty="0">
-                <a:solidFill>
-                  <a:srgbClr val="6E6E73"/>
+              <a:spcAft>
+                <a:spcPts val="300"/>
+              </a:spcAft>
+              <a:buNone/>
+            </a:pPr>
+            <a:r>
+              <a:rPr lang="en-US" sz="900" b="1" dirty="0">
+                <a:solidFill>
+                  <a:srgbClr val="0B7A6F"/>
                 </a:solidFill>
                 <a:latin typeface="SF Pro Text" pitchFamily="34" charset="0"/>
                 <a:ea typeface="SF Pro Text" pitchFamily="34" charset="-122"/>
                 <a:cs typeface="SF Pro Text" pitchFamily="34" charset="-120"/>
               </a:rPr>
-              <a:t>No: ask the customer, then wait.</a:t>
-            </a:r>
-            <a:endParaRPr lang="en-US" sz="950" dirty="0"/>
-          </a:p>
-        </p:txBody>
-      </p:sp>
-      <p:sp>
-        <p:nvSpPr>
-          <p:cNvPr id="11" name="Shape 8"/>
-          <p:cNvSpPr/>
-          <p:nvPr/>
-        </p:nvSpPr>
-        <p:spPr>
-          <a:xfrm>
-            <a:off x="3230880" y="1280160"/>
-            <a:ext cx="2682240" cy="1325880"/>
-          </a:xfrm>
-          <a:prstGeom prst="roundRect">
-            <a:avLst>
-              <a:gd name="adj" fmla="val 5517"/>
-            </a:avLst>
-          </a:prstGeom>
-          <a:solidFill>
-            <a:srgbClr val="FFFFFF"/>
-          </a:solidFill>
-          <a:ln w="9525">
-            <a:solidFill>
-              <a:srgbClr val="DCE1E7"/>
-            </a:solidFill>
-            <a:prstDash val="solid"/>
-          </a:ln>
-        </p:spPr>
-      </p:sp>
-      <p:sp>
-        <p:nvSpPr>
-          <p:cNvPr id="12" name="Shape 9"/>
-          <p:cNvSpPr/>
-          <p:nvPr/>
-        </p:nvSpPr>
-        <p:spPr>
-          <a:xfrm>
-            <a:off x="3395472" y="1463040"/>
-            <a:ext cx="274320" cy="274320"/>
-          </a:xfrm>
-          <a:prstGeom prst="ellipse">
-            <a:avLst/>
-          </a:prstGeom>
-          <a:solidFill>
-            <a:srgbClr val="E3F4F1"/>
-          </a:solidFill>
-          <a:ln w="12700">
-            <a:solidFill>
-              <a:srgbClr val="E3F4F1"/>
-            </a:solidFill>
-            <a:prstDash val="solid"/>
-          </a:ln>
-        </p:spPr>
-      </p:sp>
-      <p:sp>
-        <p:nvSpPr>
-          <p:cNvPr id="13" name="Text 10"/>
-          <p:cNvSpPr txBox="1"/>
-          <p:nvPr/>
-        </p:nvSpPr>
-        <p:spPr>
-          <a:xfrm>
-            <a:off x="3395472" y="1463040"/>
-            <a:ext cx="274320" cy="274320"/>
-          </a:xfrm>
-          <a:prstGeom prst="rect">
-            <a:avLst/>
-          </a:prstGeom>
-          <a:noFill/>
-          <a:ln/>
-        </p:spPr>
-        <p:txBody>
-          <a:bodyPr wrap="square" lIns="0" tIns="0" rIns="0" bIns="0" rtlCol="0" anchor="ctr"/>
-          <a:lstStyle/>
-          <a:p>
-            <a:pPr algn="ctr" indent="0" marL="0">
-              <a:buNone/>
-            </a:pPr>
-            <a:r>
-              <a:rPr lang="en-US" sz="900" b="1" dirty="0">
-                <a:solidFill>
-                  <a:srgbClr val="0B7A6F"/>
-                </a:solidFill>
-                <a:latin typeface="SF Pro Display" pitchFamily="34" charset="0"/>
-                <a:ea typeface="SF Pro Display" pitchFamily="34" charset="-122"/>
-                <a:cs typeface="SF Pro Display" pitchFamily="34" charset="-120"/>
-              </a:rPr>
-              <a:t>2</a:t>
+              <a:t>≥ 30 minutes overcharged</a:t>
             </a:r>
             <a:endParaRPr lang="en-US" sz="900" dirty="0"/>
           </a:p>
-        </p:txBody>
-      </p:sp>
-      <p:sp>
-        <p:nvSpPr>
-          <p:cNvPr id="14" name="Text 11"/>
-          <p:cNvSpPr txBox="1"/>
-          <p:nvPr/>
-        </p:nvSpPr>
-        <p:spPr>
-          <a:xfrm>
-            <a:off x="3395472" y="1883664"/>
-            <a:ext cx="2353056" cy="274320"/>
-          </a:xfrm>
-          <a:prstGeom prst="rect">
-            <a:avLst/>
-          </a:prstGeom>
-          <a:noFill/>
-          <a:ln/>
-        </p:spPr>
-        <p:txBody>
-          <a:bodyPr wrap="square" lIns="0" tIns="0" rIns="0" bIns="0" rtlCol="0" anchor="t"/>
-          <a:lstStyle/>
           <a:p>
             <a:pPr indent="0" marL="0">
-              <a:buNone/>
-            </a:pPr>
-            <a:r>
-              <a:rPr lang="en-US" sz="1200" b="1" dirty="0">
+              <a:spcAft>
+                <a:spcPts val="300"/>
+              </a:spcAft>
+              <a:buNone/>
+            </a:pPr>
+            <a:r>
+              <a:rPr lang="en-US" sz="900" dirty="0">
                 <a:solidFill>
                   <a:srgbClr val="1D1D1F"/>
-                </a:solidFill>
-                <a:latin typeface="SF Pro Display" pitchFamily="34" charset="0"/>
-                <a:ea typeface="SF Pro Display" pitchFamily="34" charset="-122"/>
-                <a:cs typeface="SF Pro Display" pitchFamily="34" charset="-120"/>
-              </a:rPr>
-              <a:t>Suspended + DNR?</a:t>
-            </a:r>
-            <a:endParaRPr lang="en-US" sz="1200" dirty="0"/>
-          </a:p>
-        </p:txBody>
-      </p:sp>
-      <p:sp>
-        <p:nvSpPr>
-          <p:cNvPr id="15" name="Text 12"/>
-          <p:cNvSpPr txBox="1"/>
-          <p:nvPr/>
-        </p:nvSpPr>
-        <p:spPr>
-          <a:xfrm>
-            <a:off x="3395472" y="2176272"/>
-            <a:ext cx="2353056" cy="338328"/>
-          </a:xfrm>
-          <a:prstGeom prst="rect">
-            <a:avLst/>
-          </a:prstGeom>
-          <a:noFill/>
-          <a:ln/>
-        </p:spPr>
-        <p:txBody>
-          <a:bodyPr wrap="square" lIns="0" tIns="0" rIns="0" bIns="0" rtlCol="0" anchor="t"/>
-          <a:lstStyle/>
-          <a:p>
-            <a:pPr indent="0" marL="0">
-              <a:buNone/>
-            </a:pPr>
-            <a:r>
-              <a:rPr lang="en-US" sz="950" dirty="0">
-                <a:solidFill>
-                  <a:srgbClr val="6E6E73"/>
                 </a:solidFill>
                 <a:latin typeface="SF Pro Text" pitchFamily="34" charset="0"/>
                 <a:ea typeface="SF Pro Text" pitchFamily="34" charset="-122"/>
                 <a:cs typeface="SF Pro Text" pitchFamily="34" charset="-120"/>
               </a:rPr>
-              <a:t>Yes: treat as valid, go to Branch A.</a:t>
-            </a:r>
-            <a:endParaRPr lang="en-US" sz="950" dirty="0"/>
-          </a:p>
-        </p:txBody>
-      </p:sp>
-      <p:sp>
-        <p:nvSpPr>
-          <p:cNvPr id="16" name="Shape 13"/>
-          <p:cNvSpPr/>
-          <p:nvPr/>
-        </p:nvSpPr>
-        <p:spPr>
-          <a:xfrm>
-            <a:off x="6050280" y="1280160"/>
-            <a:ext cx="2682240" cy="1325880"/>
-          </a:xfrm>
-          <a:prstGeom prst="roundRect">
-            <a:avLst>
-              <a:gd name="adj" fmla="val 5517"/>
-            </a:avLst>
-          </a:prstGeom>
-          <a:solidFill>
-            <a:srgbClr val="FFFFFF"/>
-          </a:solidFill>
-          <a:ln w="9525">
-            <a:solidFill>
-              <a:srgbClr val="DCE1E7"/>
-            </a:solidFill>
-            <a:prstDash val="solid"/>
-          </a:ln>
-        </p:spPr>
-      </p:sp>
-      <p:sp>
-        <p:nvSpPr>
-          <p:cNvPr id="17" name="Shape 14"/>
-          <p:cNvSpPr/>
-          <p:nvPr/>
-        </p:nvSpPr>
-        <p:spPr>
-          <a:xfrm>
-            <a:off x="6214872" y="1463040"/>
-            <a:ext cx="274320" cy="274320"/>
-          </a:xfrm>
-          <a:prstGeom prst="ellipse">
-            <a:avLst/>
-          </a:prstGeom>
-          <a:solidFill>
-            <a:srgbClr val="E3F4F1"/>
-          </a:solidFill>
-          <a:ln w="12700">
-            <a:solidFill>
-              <a:srgbClr val="E3F4F1"/>
-            </a:solidFill>
-            <a:prstDash val="solid"/>
-          </a:ln>
-        </p:spPr>
-      </p:sp>
-      <p:sp>
-        <p:nvSpPr>
-          <p:cNvPr id="18" name="Text 15"/>
-          <p:cNvSpPr txBox="1"/>
-          <p:nvPr/>
-        </p:nvSpPr>
-        <p:spPr>
-          <a:xfrm>
-            <a:off x="6214872" y="1463040"/>
-            <a:ext cx="274320" cy="274320"/>
-          </a:xfrm>
-          <a:prstGeom prst="rect">
-            <a:avLst/>
-          </a:prstGeom>
-          <a:noFill/>
-          <a:ln/>
-        </p:spPr>
-        <p:txBody>
-          <a:bodyPr wrap="square" lIns="0" tIns="0" rIns="0" bIns="0" rtlCol="0" anchor="ctr"/>
-          <a:lstStyle/>
-          <a:p>
-            <a:pPr algn="ctr" indent="0" marL="0">
+              <a:t>Add flag cp_overcharged_hours + norequests + the Overcharged Hours macro series.</a:t>
+            </a:r>
+            <a:endParaRPr lang="en-US" sz="900" dirty="0"/>
+          </a:p>
+          <a:p>
+            <a:pPr indent="0" marL="0">
+              <a:spcAft>
+                <a:spcPts val="300"/>
+              </a:spcAft>
               <a:buNone/>
             </a:pPr>
             <a:r>
               <a:rPr lang="en-US" sz="900" b="1" dirty="0">
                 <a:solidFill>
                   <a:srgbClr val="0B7A6F"/>
-                </a:solidFill>
-                <a:latin typeface="SF Pro Display" pitchFamily="34" charset="0"/>
-                <a:ea typeface="SF Pro Display" pitchFamily="34" charset="-122"/>
-                <a:cs typeface="SF Pro Display" pitchFamily="34" charset="-120"/>
-              </a:rPr>
-              <a:t>3</a:t>
-            </a:r>
-            <a:endParaRPr lang="en-US" sz="900" dirty="0"/>
-          </a:p>
-        </p:txBody>
-      </p:sp>
-      <p:sp>
-        <p:nvSpPr>
-          <p:cNvPr id="19" name="Text 16"/>
-          <p:cNvSpPr txBox="1"/>
-          <p:nvPr/>
-        </p:nvSpPr>
-        <p:spPr>
-          <a:xfrm>
-            <a:off x="6214872" y="1883664"/>
-            <a:ext cx="2353056" cy="274320"/>
-          </a:xfrm>
-          <a:prstGeom prst="rect">
-            <a:avLst/>
-          </a:prstGeom>
-          <a:noFill/>
-          <a:ln/>
-        </p:spPr>
-        <p:txBody>
-          <a:bodyPr wrap="square" lIns="0" tIns="0" rIns="0" bIns="0" rtlCol="0" anchor="t"/>
-          <a:lstStyle/>
-          <a:p>
-            <a:pPr indent="0" marL="0">
-              <a:buNone/>
-            </a:pPr>
-            <a:r>
-              <a:rPr lang="en-US" sz="1200" b="1" dirty="0">
-                <a:solidFill>
-                  <a:srgbClr val="1D1D1F"/>
-                </a:solidFill>
-                <a:latin typeface="SF Pro Display" pitchFamily="34" charset="0"/>
-                <a:ea typeface="SF Pro Display" pitchFamily="34" charset="-122"/>
-                <a:cs typeface="SF Pro Display" pitchFamily="34" charset="-120"/>
-              </a:rPr>
-              <a:t>Request proof</a:t>
-            </a:r>
-            <a:endParaRPr lang="en-US" sz="1200" dirty="0"/>
-          </a:p>
-        </p:txBody>
-      </p:sp>
-      <p:sp>
-        <p:nvSpPr>
-          <p:cNvPr id="20" name="Text 17"/>
-          <p:cNvSpPr txBox="1"/>
-          <p:nvPr/>
-        </p:nvSpPr>
-        <p:spPr>
-          <a:xfrm>
-            <a:off x="6214872" y="2176272"/>
-            <a:ext cx="2353056" cy="338328"/>
-          </a:xfrm>
-          <a:prstGeom prst="rect">
-            <a:avLst/>
-          </a:prstGeom>
-          <a:noFill/>
-          <a:ln/>
-        </p:spPr>
-        <p:txBody>
-          <a:bodyPr wrap="square" lIns="0" tIns="0" rIns="0" bIns="0" rtlCol="0" anchor="t"/>
-          <a:lstStyle/>
-          <a:p>
-            <a:pPr indent="0" marL="0">
-              <a:buNone/>
-            </a:pPr>
-            <a:r>
-              <a:rPr lang="en-US" sz="950" dirty="0">
-                <a:solidFill>
-                  <a:srgbClr val="6E6E73"/>
                 </a:solidFill>
                 <a:latin typeface="SF Pro Text" pitchFamily="34" charset="0"/>
                 <a:ea typeface="SF Pro Text" pitchFamily="34" charset="-122"/>
                 <a:cs typeface="SF Pro Text" pitchFamily="34" charset="-120"/>
               </a:rPr>
-              <a:t>Cleaner has 3 days to send documentation.</a:t>
-            </a:r>
-            <a:endParaRPr lang="en-US" sz="950" dirty="0"/>
-          </a:p>
-        </p:txBody>
-      </p:sp>
-      <p:sp>
-        <p:nvSpPr>
-          <p:cNvPr id="21" name="Text 18"/>
-          <p:cNvSpPr txBox="1"/>
-          <p:nvPr/>
-        </p:nvSpPr>
-        <p:spPr>
-          <a:xfrm>
-            <a:off x="438912" y="2788920"/>
-            <a:ext cx="4572000" cy="182880"/>
-          </a:xfrm>
-          <a:prstGeom prst="rect">
-            <a:avLst/>
-          </a:prstGeom>
-          <a:noFill/>
-          <a:ln/>
-        </p:spPr>
-        <p:txBody>
-          <a:bodyPr wrap="square" lIns="0" tIns="0" rIns="0" bIns="0" rtlCol="0" anchor="t"/>
-          <a:lstStyle/>
+              <a:t>&lt; 30 minutes overcharged</a:t>
+            </a:r>
+            <a:endParaRPr lang="en-US" sz="900" dirty="0"/>
+          </a:p>
           <a:p>
             <a:pPr indent="0" marL="0">
-              <a:buNone/>
-            </a:pPr>
-            <a:r>
-              <a:rPr lang="en-US" sz="800" b="1" spc="50" kern="0" dirty="0">
-                <a:solidFill>
-                  <a:srgbClr val="6E6E73"/>
-                </a:solidFill>
-                <a:latin typeface="SF Pro Display" pitchFamily="34" charset="0"/>
-                <a:ea typeface="SF Pro Display" pitchFamily="34" charset="-122"/>
-                <a:cs typeface="SF Pro Display" pitchFamily="34" charset="-120"/>
-              </a:rPr>
-              <a:t>WHEN YOU REQUEST PROOF</a:t>
-            </a:r>
-            <a:endParaRPr lang="en-US" sz="800" dirty="0"/>
-          </a:p>
-        </p:txBody>
-      </p:sp>
-      <p:sp>
-        <p:nvSpPr>
-          <p:cNvPr id="22" name="Shape 19"/>
-          <p:cNvSpPr/>
-          <p:nvPr/>
-        </p:nvSpPr>
-        <p:spPr>
-          <a:xfrm>
-            <a:off x="411480" y="3035808"/>
-            <a:ext cx="4114800" cy="457200"/>
-          </a:xfrm>
-          <a:prstGeom prst="roundRect">
-            <a:avLst>
-              <a:gd name="adj" fmla="val 16000"/>
-            </a:avLst>
-          </a:prstGeom>
-          <a:solidFill>
-            <a:srgbClr val="FFFFFF"/>
-          </a:solidFill>
-          <a:ln w="9525">
-            <a:solidFill>
-              <a:srgbClr val="DCE1E7"/>
-            </a:solidFill>
-            <a:prstDash val="solid"/>
-          </a:ln>
-        </p:spPr>
-      </p:sp>
-      <p:sp>
-        <p:nvSpPr>
-          <p:cNvPr id="23" name="Shape 20"/>
-          <p:cNvSpPr/>
-          <p:nvPr/>
-        </p:nvSpPr>
-        <p:spPr>
-          <a:xfrm>
-            <a:off x="521208" y="3118104"/>
-            <a:ext cx="292608" cy="292608"/>
-          </a:xfrm>
-          <a:prstGeom prst="ellipse">
-            <a:avLst/>
-          </a:prstGeom>
-          <a:solidFill>
-            <a:srgbClr val="E3F4F1"/>
-          </a:solidFill>
-          <a:ln w="12700">
-            <a:solidFill>
-              <a:srgbClr val="E3F4F1"/>
-            </a:solidFill>
-            <a:prstDash val="solid"/>
-          </a:ln>
-        </p:spPr>
-      </p:sp>
-      <p:pic>
-        <p:nvPicPr>
-          <p:cNvPr id="24" name="Image 0" descr="preencoded.png">    </p:cNvPr>
-          <p:cNvPicPr>
-            <a:picLocks noChangeAspect="1"/>
-          </p:cNvPicPr>
-          <p:nvPr/>
-        </p:nvPicPr>
-        <p:blipFill>
-          <a:blip r:embed="rId1"/>
-          <a:stretch>
-            <a:fillRect/>
-          </a:stretch>
-        </p:blipFill>
-        <p:spPr>
-          <a:xfrm>
-            <a:off x="591434" y="3188330"/>
-            <a:ext cx="152156" cy="152156"/>
-          </a:xfrm>
-          <a:prstGeom prst="rect">
-            <a:avLst/>
-          </a:prstGeom>
-        </p:spPr>
-      </p:pic>
-      <p:sp>
-        <p:nvSpPr>
-          <p:cNvPr id="25" name="Text 21"/>
-          <p:cNvSpPr txBox="1"/>
-          <p:nvPr/>
-        </p:nvSpPr>
-        <p:spPr>
-          <a:xfrm>
-            <a:off x="914400" y="3035808"/>
-            <a:ext cx="3520440" cy="457200"/>
-          </a:xfrm>
-          <a:prstGeom prst="rect">
-            <a:avLst/>
-          </a:prstGeom>
-          <a:noFill/>
-          <a:ln/>
-        </p:spPr>
-        <p:txBody>
-          <a:bodyPr wrap="square" lIns="0" tIns="0" rIns="0" bIns="0" rtlCol="0" anchor="ctr"/>
-          <a:lstStyle/>
-          <a:p>
-            <a:pPr indent="0" marL="0">
-              <a:buNone/>
-            </a:pPr>
-            <a:r>
-              <a:rPr lang="en-US" sz="1050" b="1" dirty="0">
+              <a:spcAft>
+                <a:spcPts val="300"/>
+              </a:spcAft>
+              <a:buNone/>
+            </a:pPr>
+            <a:r>
+              <a:rPr lang="en-US" sz="900" dirty="0">
                 <a:solidFill>
                   <a:srgbClr val="1D1D1F"/>
                 </a:solidFill>
-                <a:latin typeface="SF Pro Display" pitchFamily="34" charset="0"/>
-                <a:ea typeface="SF Pro Display" pitchFamily="34" charset="-122"/>
-                <a:cs typeface="SF Pro Display" pitchFamily="34" charset="-120"/>
-              </a:rPr>
-              <a:t>Refund Premium Upsell, if charged</a:t>
-            </a:r>
-            <a:endParaRPr lang="en-US" sz="1050" dirty="0"/>
-          </a:p>
-        </p:txBody>
-      </p:sp>
-      <p:sp>
-        <p:nvSpPr>
-          <p:cNvPr id="26" name="Shape 22"/>
-          <p:cNvSpPr/>
-          <p:nvPr/>
-        </p:nvSpPr>
-        <p:spPr>
-          <a:xfrm>
-            <a:off x="411480" y="3566160"/>
-            <a:ext cx="4114800" cy="457200"/>
-          </a:xfrm>
-          <a:prstGeom prst="roundRect">
-            <a:avLst>
-              <a:gd name="adj" fmla="val 16000"/>
-            </a:avLst>
-          </a:prstGeom>
-          <a:solidFill>
-            <a:srgbClr val="FFFFFF"/>
-          </a:solidFill>
-          <a:ln w="9525">
-            <a:solidFill>
-              <a:srgbClr val="DCE1E7"/>
-            </a:solidFill>
-            <a:prstDash val="solid"/>
-          </a:ln>
-        </p:spPr>
-      </p:sp>
-      <p:sp>
-        <p:nvSpPr>
-          <p:cNvPr id="27" name="Shape 23"/>
-          <p:cNvSpPr/>
-          <p:nvPr/>
-        </p:nvSpPr>
-        <p:spPr>
-          <a:xfrm>
-            <a:off x="521208" y="3648456"/>
-            <a:ext cx="292608" cy="292608"/>
-          </a:xfrm>
-          <a:prstGeom prst="ellipse">
-            <a:avLst/>
-          </a:prstGeom>
-          <a:solidFill>
-            <a:srgbClr val="E3F4F1"/>
-          </a:solidFill>
-          <a:ln w="12700">
-            <a:solidFill>
-              <a:srgbClr val="E3F4F1"/>
-            </a:solidFill>
-            <a:prstDash val="solid"/>
-          </a:ln>
-        </p:spPr>
-      </p:sp>
-      <p:pic>
-        <p:nvPicPr>
-          <p:cNvPr id="28" name="Image 1" descr="preencoded.png">    </p:cNvPr>
-          <p:cNvPicPr>
-            <a:picLocks noChangeAspect="1"/>
-          </p:cNvPicPr>
-          <p:nvPr/>
-        </p:nvPicPr>
-        <p:blipFill>
-          <a:blip r:embed="rId2"/>
-          <a:stretch>
-            <a:fillRect/>
-          </a:stretch>
-        </p:blipFill>
-        <p:spPr>
-          <a:xfrm>
-            <a:off x="591434" y="3718682"/>
-            <a:ext cx="152156" cy="152156"/>
-          </a:xfrm>
-          <a:prstGeom prst="rect">
-            <a:avLst/>
-          </a:prstGeom>
-        </p:spPr>
-      </p:pic>
-      <p:sp>
-        <p:nvSpPr>
-          <p:cNvPr id="29" name="Text 24"/>
-          <p:cNvSpPr txBox="1"/>
-          <p:nvPr/>
-        </p:nvSpPr>
-        <p:spPr>
-          <a:xfrm>
-            <a:off x="914400" y="3566160"/>
-            <a:ext cx="3520440" cy="457200"/>
-          </a:xfrm>
-          <a:prstGeom prst="rect">
-            <a:avLst/>
-          </a:prstGeom>
-          <a:noFill/>
-          <a:ln/>
-        </p:spPr>
-        <p:txBody>
-          <a:bodyPr wrap="square" lIns="0" tIns="0" rIns="0" bIns="0" rtlCol="0" anchor="ctr"/>
-          <a:lstStyle/>
-          <a:p>
-            <a:pPr indent="0" marL="0">
-              <a:buNone/>
-            </a:pPr>
-            <a:r>
-              <a:rPr lang="en-US" sz="1050" b="1" dirty="0">
-                <a:solidFill>
-                  <a:srgbClr val="1D1D1F"/>
-                </a:solidFill>
-                <a:latin typeface="SF Pro Display" pitchFamily="34" charset="0"/>
-                <a:ea typeface="SF Pro Display" pitchFamily="34" charset="-122"/>
-                <a:cs typeface="SF Pro Display" pitchFamily="34" charset="-120"/>
-              </a:rPr>
-              <a:t>Timed Reminder on the C side: 72 hrs</a:t>
-            </a:r>
-            <a:endParaRPr lang="en-US" sz="1050" dirty="0"/>
-          </a:p>
-        </p:txBody>
-      </p:sp>
-      <p:sp>
-        <p:nvSpPr>
-          <p:cNvPr id="30" name="Shape 25"/>
-          <p:cNvSpPr/>
-          <p:nvPr/>
-        </p:nvSpPr>
-        <p:spPr>
-          <a:xfrm>
-            <a:off x="4617720" y="3035808"/>
-            <a:ext cx="4114800" cy="457200"/>
-          </a:xfrm>
-          <a:prstGeom prst="roundRect">
-            <a:avLst>
-              <a:gd name="adj" fmla="val 16000"/>
-            </a:avLst>
-          </a:prstGeom>
-          <a:solidFill>
-            <a:srgbClr val="FFFFFF"/>
-          </a:solidFill>
-          <a:ln w="9525">
-            <a:solidFill>
-              <a:srgbClr val="DCE1E7"/>
-            </a:solidFill>
-            <a:prstDash val="solid"/>
-          </a:ln>
-        </p:spPr>
-      </p:sp>
-      <p:sp>
-        <p:nvSpPr>
-          <p:cNvPr id="31" name="Shape 26"/>
-          <p:cNvSpPr/>
-          <p:nvPr/>
-        </p:nvSpPr>
-        <p:spPr>
-          <a:xfrm>
-            <a:off x="4727448" y="3118104"/>
-            <a:ext cx="292608" cy="292608"/>
-          </a:xfrm>
-          <a:prstGeom prst="ellipse">
-            <a:avLst/>
-          </a:prstGeom>
-          <a:solidFill>
-            <a:srgbClr val="E3F4F1"/>
-          </a:solidFill>
-          <a:ln w="12700">
-            <a:solidFill>
-              <a:srgbClr val="E3F4F1"/>
-            </a:solidFill>
-            <a:prstDash val="solid"/>
-          </a:ln>
-        </p:spPr>
-      </p:sp>
-      <p:pic>
-        <p:nvPicPr>
-          <p:cNvPr id="32" name="Image 2" descr="preencoded.png">    </p:cNvPr>
-          <p:cNvPicPr>
-            <a:picLocks noChangeAspect="1"/>
-          </p:cNvPicPr>
-          <p:nvPr/>
-        </p:nvPicPr>
-        <p:blipFill>
-          <a:blip r:embed="rId3"/>
-          <a:stretch>
-            <a:fillRect/>
-          </a:stretch>
-        </p:blipFill>
-        <p:spPr>
-          <a:xfrm>
-            <a:off x="4797674" y="3188330"/>
-            <a:ext cx="152156" cy="152156"/>
-          </a:xfrm>
-          <a:prstGeom prst="rect">
-            <a:avLst/>
-          </a:prstGeom>
-        </p:spPr>
-      </p:pic>
-      <p:sp>
-        <p:nvSpPr>
-          <p:cNvPr id="33" name="Text 27"/>
-          <p:cNvSpPr txBox="1"/>
-          <p:nvPr/>
-        </p:nvSpPr>
-        <p:spPr>
-          <a:xfrm>
-            <a:off x="5120640" y="3035808"/>
-            <a:ext cx="3520440" cy="457200"/>
-          </a:xfrm>
-          <a:prstGeom prst="rect">
-            <a:avLst/>
-          </a:prstGeom>
-          <a:noFill/>
-          <a:ln/>
-        </p:spPr>
-        <p:txBody>
-          <a:bodyPr wrap="square" lIns="0" tIns="0" rIns="0" bIns="0" rtlCol="0" anchor="ctr"/>
-          <a:lstStyle/>
-          <a:p>
-            <a:pPr indent="0" marL="0">
-              <a:buNone/>
-            </a:pPr>
-            <a:r>
-              <a:rPr lang="en-US" sz="1050" b="1" dirty="0">
-                <a:solidFill>
-                  <a:srgbClr val="1D1D1F"/>
-                </a:solidFill>
-                <a:latin typeface="SF Pro Display" pitchFamily="34" charset="0"/>
-                <a:ea typeface="SF Pro Display" pitchFamily="34" charset="-122"/>
-                <a:cs typeface="SF Pro Display" pitchFamily="34" charset="-120"/>
-              </a:rPr>
-              <a:t>Tell the customer: 4–5 business days</a:t>
-            </a:r>
-            <a:endParaRPr lang="en-US" sz="1050" dirty="0"/>
-          </a:p>
-        </p:txBody>
-      </p:sp>
-      <p:sp>
-        <p:nvSpPr>
-          <p:cNvPr id="34" name="Shape 28"/>
-          <p:cNvSpPr/>
-          <p:nvPr/>
-        </p:nvSpPr>
-        <p:spPr>
-          <a:xfrm>
-            <a:off x="4617720" y="3566160"/>
-            <a:ext cx="4114800" cy="457200"/>
-          </a:xfrm>
-          <a:prstGeom prst="roundRect">
-            <a:avLst>
-              <a:gd name="adj" fmla="val 16000"/>
-            </a:avLst>
-          </a:prstGeom>
-          <a:solidFill>
-            <a:srgbClr val="FFFFFF"/>
-          </a:solidFill>
-          <a:ln w="9525">
-            <a:solidFill>
-              <a:srgbClr val="DCE1E7"/>
-            </a:solidFill>
-            <a:prstDash val="solid"/>
-          </a:ln>
-        </p:spPr>
-      </p:sp>
-      <p:sp>
-        <p:nvSpPr>
-          <p:cNvPr id="35" name="Shape 29"/>
-          <p:cNvSpPr/>
-          <p:nvPr/>
-        </p:nvSpPr>
-        <p:spPr>
-          <a:xfrm>
-            <a:off x="4727448" y="3648456"/>
-            <a:ext cx="292608" cy="292608"/>
-          </a:xfrm>
-          <a:prstGeom prst="ellipse">
-            <a:avLst/>
-          </a:prstGeom>
-          <a:solidFill>
-            <a:srgbClr val="E3F4F1"/>
-          </a:solidFill>
-          <a:ln w="12700">
-            <a:solidFill>
-              <a:srgbClr val="E3F4F1"/>
-            </a:solidFill>
-            <a:prstDash val="solid"/>
-          </a:ln>
-        </p:spPr>
-      </p:sp>
-      <p:pic>
-        <p:nvPicPr>
-          <p:cNvPr id="36" name="Image 3" descr="preencoded.png">    </p:cNvPr>
-          <p:cNvPicPr>
-            <a:picLocks noChangeAspect="1"/>
-          </p:cNvPicPr>
-          <p:nvPr/>
-        </p:nvPicPr>
-        <p:blipFill>
-          <a:blip r:embed="rId4"/>
-          <a:stretch>
-            <a:fillRect/>
-          </a:stretch>
-        </p:blipFill>
-        <p:spPr>
-          <a:xfrm>
-            <a:off x="4797674" y="3718682"/>
-            <a:ext cx="152156" cy="152156"/>
-          </a:xfrm>
-          <a:prstGeom prst="rect">
-            <a:avLst/>
-          </a:prstGeom>
-        </p:spPr>
-      </p:pic>
-      <p:sp>
-        <p:nvSpPr>
-          <p:cNvPr id="37" name="Text 30"/>
-          <p:cNvSpPr txBox="1"/>
-          <p:nvPr/>
-        </p:nvSpPr>
-        <p:spPr>
-          <a:xfrm>
-            <a:off x="5120640" y="3566160"/>
-            <a:ext cx="3520440" cy="457200"/>
-          </a:xfrm>
-          <a:prstGeom prst="rect">
-            <a:avLst/>
-          </a:prstGeom>
-          <a:noFill/>
-          <a:ln/>
-        </p:spPr>
-        <p:txBody>
-          <a:bodyPr wrap="square" lIns="0" tIns="0" rIns="0" bIns="0" rtlCol="0" anchor="ctr"/>
-          <a:lstStyle/>
-          <a:p>
-            <a:pPr indent="0" marL="0">
-              <a:buNone/>
-            </a:pPr>
-            <a:r>
-              <a:rPr lang="en-US" sz="1050" b="1" dirty="0">
-                <a:solidFill>
-                  <a:srgbClr val="1D1D1F"/>
-                </a:solidFill>
-                <a:latin typeface="SF Pro Display" pitchFamily="34" charset="0"/>
-                <a:ea typeface="SF Pro Display" pitchFamily="34" charset="-122"/>
-                <a:cs typeface="SF Pro Display" pitchFamily="34" charset="-120"/>
-              </a:rPr>
-              <a:t>Block the pairing, ask the cleaner (3 days)</a:t>
-            </a:r>
-            <a:endParaRPr lang="en-US" sz="1050" dirty="0"/>
+                <a:latin typeface="SF Pro Text" pitchFamily="34" charset="0"/>
+                <a:ea typeface="SF Pro Text" pitchFamily="34" charset="-122"/>
+                <a:cs typeface="SF Pro Text" pitchFamily="34" charset="-120"/>
+              </a:rPr>
+              <a:t>No flag, no penalty + the Overcharged Hours macro series.</a:t>
+            </a:r>
+            <a:endParaRPr lang="en-US" sz="900" dirty="0"/>
           </a:p>
         </p:txBody>
       </p:sp>
@@ -6318,6 +6310,200 @@
   <p:clrMapOvr>
     <a:masterClrMapping/>
   </p:clrMapOvr>
+  <p:timing>
+    <p:tnLst>
+      <p:par>
+        <p:cTn id="1" dur="indefinite" restart="never" nodeType="tmRoot">
+          <p:childTnLst>
+            <p:seq concurrent="1" nextAc="seek">
+              <p:cTn id="2" dur="indefinite" nodeType="mainSeq">
+                <p:childTnLst>
+                  <p:par>
+                    <p:cTn id="15" fill="hold">
+                      <p:stCondLst>
+                        <p:cond delay="indefinite"/>
+                      </p:stCondLst>
+                      <p:childTnLst>
+                        <p:par>
+                          <p:cTn id="16" fill="hold">
+                            <p:stCondLst>
+                              <p:cond delay="0"/>
+                            </p:stCondLst>
+                            <p:childTnLst>
+                              <p:par>
+                                <p:cTn id="5" presetID="10" presetClass="entr" presetSubtype="0" fill="hold" grpId="0" nodeType="clickEffect">
+                                  <p:stCondLst>
+                                    <p:cond delay="0"/>
+                                  </p:stCondLst>
+                                  <p:childTnLst>
+                                    <p:set>
+                                      <p:cBhvr>
+                                        <p:cTn id="6" dur="1" fill="hold">
+                                          <p:stCondLst>
+                                            <p:cond delay="0"/>
+                                          </p:stCondLst>
+                                        </p:cTn>
+                                        <p:tgtEl>
+                                          <p:spTgt spid="31"/>
+                                        </p:tgtEl>
+                                        <p:attrNameLst>
+                                          <p:attrName>style.visibility</p:attrName>
+                                        </p:attrNameLst>
+                                      </p:cBhvr>
+                                      <p:to>
+                                        <p:strVal val="visible"/>
+                                      </p:to>
+                                    </p:set>
+                                    <p:animEffect transition="in" filter="fade">
+                                      <p:cBhvr>
+                                        <p:cTn id="7" dur="600"/>
+                                        <p:tgtEl>
+                                          <p:spTgt spid="31"/>
+                                        </p:tgtEl>
+                                      </p:cBhvr>
+                                    </p:animEffect>
+                                  </p:childTnLst>
+                                </p:cTn>
+                              </p:par>
+                              <p:par>
+                                <p:cTn id="8" presetID="10" presetClass="entr" presetSubtype="0" fill="hold" grpId="0" nodeType="withEffect">
+                                  <p:stCondLst>
+                                    <p:cond delay="0"/>
+                                  </p:stCondLst>
+                                  <p:childTnLst>
+                                    <p:set>
+                                      <p:cBhvr>
+                                        <p:cTn id="9" dur="1" fill="hold">
+                                          <p:stCondLst>
+                                            <p:cond delay="0"/>
+                                          </p:stCondLst>
+                                        </p:cTn>
+                                        <p:tgtEl>
+                                          <p:spTgt spid="32"/>
+                                        </p:tgtEl>
+                                        <p:attrNameLst>
+                                          <p:attrName>style.visibility</p:attrName>
+                                        </p:attrNameLst>
+                                      </p:cBhvr>
+                                      <p:to>
+                                        <p:strVal val="visible"/>
+                                      </p:to>
+                                    </p:set>
+                                    <p:animEffect transition="in" filter="fade">
+                                      <p:cBhvr>
+                                        <p:cTn id="10" dur="600"/>
+                                        <p:tgtEl>
+                                          <p:spTgt spid="32"/>
+                                        </p:tgtEl>
+                                      </p:cBhvr>
+                                    </p:animEffect>
+                                  </p:childTnLst>
+                                </p:cTn>
+                              </p:par>
+                              <p:par>
+                                <p:cTn id="11" presetID="10" presetClass="entr" presetSubtype="0" fill="hold" grpId="0" nodeType="withEffect">
+                                  <p:stCondLst>
+                                    <p:cond delay="0"/>
+                                  </p:stCondLst>
+                                  <p:childTnLst>
+                                    <p:set>
+                                      <p:cBhvr>
+                                        <p:cTn id="12" dur="1" fill="hold">
+                                          <p:stCondLst>
+                                            <p:cond delay="0"/>
+                                          </p:stCondLst>
+                                        </p:cTn>
+                                        <p:tgtEl>
+                                          <p:spTgt spid="33"/>
+                                        </p:tgtEl>
+                                        <p:attrNameLst>
+                                          <p:attrName>style.visibility</p:attrName>
+                                        </p:attrNameLst>
+                                      </p:cBhvr>
+                                      <p:to>
+                                        <p:strVal val="visible"/>
+                                      </p:to>
+                                    </p:set>
+                                    <p:animEffect transition="in" filter="fade">
+                                      <p:cBhvr>
+                                        <p:cTn id="13" dur="600"/>
+                                        <p:tgtEl>
+                                          <p:spTgt spid="33"/>
+                                        </p:tgtEl>
+                                      </p:cBhvr>
+                                    </p:animEffect>
+                                  </p:childTnLst>
+                                </p:cTn>
+                              </p:par>
+                              <p:par>
+                                <p:cTn id="14" presetID="10" presetClass="entr" presetSubtype="0" fill="hold" grpId="0" nodeType="withEffect">
+                                  <p:stCondLst>
+                                    <p:cond delay="0"/>
+                                  </p:stCondLst>
+                                  <p:childTnLst>
+                                    <p:set>
+                                      <p:cBhvr>
+                                        <p:cTn id="15" dur="1" fill="hold">
+                                          <p:stCondLst>
+                                            <p:cond delay="0"/>
+                                          </p:stCondLst>
+                                        </p:cTn>
+                                        <p:tgtEl>
+                                          <p:spTgt spid="34"/>
+                                        </p:tgtEl>
+                                        <p:attrNameLst>
+                                          <p:attrName>style.visibility</p:attrName>
+                                        </p:attrNameLst>
+                                      </p:cBhvr>
+                                      <p:to>
+                                        <p:strVal val="visible"/>
+                                      </p:to>
+                                    </p:set>
+                                    <p:animEffect transition="in" filter="fade">
+                                      <p:cBhvr>
+                                        <p:cTn id="16" dur="600"/>
+                                        <p:tgtEl>
+                                          <p:spTgt spid="34"/>
+                                        </p:tgtEl>
+                                      </p:cBhvr>
+                                    </p:animEffect>
+                                  </p:childTnLst>
+                                </p:cTn>
+                              </p:par>
+                            </p:childTnLst>
+                          </p:cTn>
+                        </p:par>
+                      </p:childTnLst>
+                    </p:cTn>
+                  </p:par>
+                </p:childTnLst>
+              </p:cTn>
+              <p:prevCondLst>
+                <p:cond evt="onPrev" delay="0">
+                  <p:tgtEl>
+                    <p:sldTgt/>
+                  </p:tgtEl>
+                </p:cond>
+              </p:prevCondLst>
+              <p:nextCondLst>
+                <p:cond evt="onNext" delay="0">
+                  <p:tgtEl>
+                    <p:sldTgt/>
+                  </p:tgtEl>
+                </p:cond>
+              </p:nextCondLst>
+            </p:seq>
+          </p:childTnLst>
+        </p:cTn>
+      </p:par>
+    </p:tnLst>
+    <p:bldLst>
+      <p:bldP spid="31" grpId="0" animBg="1"/>
+      <p:bldP spid="32" grpId="0" animBg="1"/>
+      <p:bldP spid="33" grpId="0" animBg="1"/>
+      <p:bldP spid="34" grpId="0" animBg="1"/>
+    </p:bldLst>
+  </p:timing>
 </p:sld>
 </file>
 
@@ -36337,11 +36523,11 @@
         <p:spPr>
           <a:xfrm>
             <a:off x="411480" y="1280160"/>
-            <a:ext cx="2682240" cy="1965960"/>
+            <a:ext cx="2682240" cy="2468880"/>
           </a:xfrm>
           <a:prstGeom prst="roundRect">
             <a:avLst>
-              <a:gd name="adj" fmla="val 3721"/>
+              <a:gd name="adj" fmla="val 2963"/>
             </a:avLst>
           </a:prstGeom>
           <a:solidFill>
@@ -36452,7 +36638,7 @@
         <p:spPr>
           <a:xfrm>
             <a:off x="576072" y="2176272"/>
-            <a:ext cx="2353056" cy="978408"/>
+            <a:ext cx="2353056" cy="1481328"/>
           </a:xfrm>
           <a:prstGeom prst="rect">
             <a:avLst/>
@@ -36491,11 +36677,11 @@
         <p:spPr>
           <a:xfrm>
             <a:off x="3230880" y="1280160"/>
-            <a:ext cx="2682240" cy="1965960"/>
+            <a:ext cx="2682240" cy="2468880"/>
           </a:xfrm>
           <a:prstGeom prst="roundRect">
             <a:avLst>
-              <a:gd name="adj" fmla="val 3721"/>
+              <a:gd name="adj" fmla="val 2963"/>
             </a:avLst>
           </a:prstGeom>
           <a:solidFill>
@@ -36606,7 +36792,7 @@
         <p:spPr>
           <a:xfrm>
             <a:off x="3395472" y="2176272"/>
-            <a:ext cx="2353056" cy="978408"/>
+            <a:ext cx="2353056" cy="1481328"/>
           </a:xfrm>
           <a:prstGeom prst="rect">
             <a:avLst/>
@@ -36645,11 +36831,11 @@
         <p:spPr>
           <a:xfrm>
             <a:off x="6050280" y="1280160"/>
-            <a:ext cx="2682240" cy="1965960"/>
+            <a:ext cx="2682240" cy="2468880"/>
           </a:xfrm>
           <a:prstGeom prst="roundRect">
             <a:avLst>
-              <a:gd name="adj" fmla="val 3721"/>
+              <a:gd name="adj" fmla="val 2963"/>
             </a:avLst>
           </a:prstGeom>
           <a:solidFill>
@@ -36745,7 +36931,7 @@
                 <a:ea typeface="SF Pro Display" pitchFamily="34" charset="-122"/>
                 <a:cs typeface="SF Pro Display" pitchFamily="34" charset="-120"/>
               </a:rPr>
-              <a:t>Suspended + DNR</a:t>
+              <a:t>CP Suspended + DNR</a:t>
             </a:r>
             <a:endParaRPr lang="en-US" sz="1200" dirty="0"/>
           </a:p>
@@ -36760,7 +36946,7 @@
         <p:spPr>
           <a:xfrm>
             <a:off x="6214872" y="2176272"/>
-            <a:ext cx="2353056" cy="978408"/>
+            <a:ext cx="2353056" cy="1481328"/>
           </a:xfrm>
           <a:prstGeom prst="rect">
             <a:avLst/>
@@ -36784,7 +36970,69 @@
                 <a:ea typeface="SF Pro Text" pitchFamily="34" charset="-122"/>
                 <a:cs typeface="SF Pro Text" pitchFamily="34" charset="-120"/>
               </a:rPr>
-              <a:t>Already DNR for repeat offenses? Refund the excess even without clear evidence.</a:t>
+              <a:t>Already DNR for repeat offenses?</a:t>
+            </a:r>
+            <a:endParaRPr lang="en-US" sz="950" dirty="0"/>
+          </a:p>
+          <a:p>
+            <a:pPr indent="0" marL="0">
+              <a:buNone/>
+            </a:pPr>
+            <a:r>
+              <a:rPr lang="en-US" sz="950" b="1" dirty="0">
+                <a:solidFill>
+                  <a:srgbClr val="1D1D1F"/>
+                </a:solidFill>
+                <a:latin typeface="SF Pro Text" pitchFamily="34" charset="0"/>
+                <a:ea typeface="SF Pro Text" pitchFamily="34" charset="-122"/>
+                <a:cs typeface="SF Pro Text" pitchFamily="34" charset="-120"/>
+              </a:rPr>
+              <a:t>Within 120 days: </a:t>
+            </a:r>
+            <a:pPr indent="0" marL="0">
+              <a:buNone/>
+            </a:pPr>
+            <a:r>
+              <a:rPr lang="en-US" sz="950" dirty="0">
+                <a:solidFill>
+                  <a:srgbClr val="6E6E73"/>
+                </a:solidFill>
+                <a:latin typeface="SF Pro Text" pitchFamily="34" charset="0"/>
+                <a:ea typeface="SF Pro Text" pitchFamily="34" charset="-122"/>
+                <a:cs typeface="SF Pro Text" pitchFamily="34" charset="-120"/>
+              </a:rPr>
+              <a:t>refund the excess even without clear evidence. No need to request evidence from the CP.</a:t>
+            </a:r>
+            <a:endParaRPr lang="en-US" sz="950" dirty="0"/>
+          </a:p>
+          <a:p>
+            <a:pPr indent="0" marL="0">
+              <a:buNone/>
+            </a:pPr>
+            <a:r>
+              <a:rPr lang="en-US" sz="950" b="1" dirty="0">
+                <a:solidFill>
+                  <a:srgbClr val="1D1D1F"/>
+                </a:solidFill>
+                <a:latin typeface="SF Pro Text" pitchFamily="34" charset="0"/>
+                <a:ea typeface="SF Pro Text" pitchFamily="34" charset="-122"/>
+                <a:cs typeface="SF Pro Text" pitchFamily="34" charset="-120"/>
+              </a:rPr>
+              <a:t>Beyond 120 days: </a:t>
+            </a:r>
+            <a:pPr indent="0" marL="0">
+              <a:buNone/>
+            </a:pPr>
+            <a:r>
+              <a:rPr lang="en-US" sz="950" dirty="0">
+                <a:solidFill>
+                  <a:srgbClr val="6E6E73"/>
+                </a:solidFill>
+                <a:latin typeface="SF Pro Text" pitchFamily="34" charset="0"/>
+                <a:ea typeface="SF Pro Text" pitchFamily="34" charset="-122"/>
+                <a:cs typeface="SF Pro Text" pitchFamily="34" charset="-120"/>
+              </a:rPr>
+              <a:t>refund the excess only when the issue is clearly proven.</a:t>
             </a:r>
             <a:endParaRPr lang="en-US" sz="950" dirty="0"/>
           </a:p>
@@ -38540,6 +38788,89 @@
           </a:p>
         </p:txBody>
       </p:sp>
+      <p:sp>
+        <p:nvSpPr>
+          <p:cNvPr id="5" name="Shape 2"/>
+          <p:cNvSpPr/>
+          <p:nvPr/>
+        </p:nvSpPr>
+        <p:spPr>
+          <a:xfrm>
+            <a:off x="411480" y="1051560"/>
+            <a:ext cx="4983480" cy="566928"/>
+          </a:xfrm>
+          <a:prstGeom prst="roundRect">
+            <a:avLst>
+              <a:gd name="adj" fmla="val 12903"/>
+            </a:avLst>
+          </a:prstGeom>
+          <a:solidFill>
+            <a:srgbClr val="0B7A6F"/>
+          </a:solidFill>
+          <a:ln w="9525">
+            <a:solidFill>
+              <a:srgbClr val="0B7A6F"/>
+            </a:solidFill>
+            <a:prstDash val="solid"/>
+          </a:ln>
+        </p:spPr>
+      </p:sp>
+      <p:sp>
+        <p:nvSpPr>
+          <p:cNvPr id="6" name="Text 3"/>
+          <p:cNvSpPr txBox="1"/>
+          <p:nvPr/>
+        </p:nvSpPr>
+        <p:spPr>
+          <a:xfrm>
+            <a:off x="539496" y="1051560"/>
+            <a:ext cx="4727448" cy="566928"/>
+          </a:xfrm>
+          <a:prstGeom prst="rect">
+            <a:avLst/>
+          </a:prstGeom>
+          <a:noFill/>
+          <a:ln/>
+        </p:spPr>
+        <p:txBody>
+          <a:bodyPr wrap="square" lIns="0" tIns="0" rIns="0" bIns="0" rtlCol="0" anchor="ctr"/>
+          <a:lstStyle/>
+          <a:p>
+            <a:pPr indent="0" marL="0">
+              <a:buNone/>
+            </a:pPr>
+            <a:r>
+              <a:rPr lang="en-US" sz="1150" b="1" dirty="0">
+                <a:solidFill>
+                  <a:srgbClr val="FFFFFF"/>
+                </a:solidFill>
+                <a:latin typeface="SF Pro Display" pitchFamily="34" charset="0"/>
+                <a:ea typeface="SF Pro Display" pitchFamily="34" charset="-122"/>
+                <a:cs typeface="SF Pro Display" pitchFamily="34" charset="-120"/>
+              </a:rPr>
+              <a:t>Branch A: clear evidence present</a:t>
+            </a:r>
+            <a:endParaRPr lang="en-US" sz="1150" dirty="0"/>
+          </a:p>
+          <a:p>
+            <a:pPr indent="0" marL="0">
+              <a:buNone/>
+            </a:pPr>
+            <a:r>
+              <a:rPr lang="en-US" sz="850" dirty="0">
+                <a:solidFill>
+                  <a:srgbClr val="FFFFFF"/>
+                </a:solidFill>
+                <a:latin typeface="SF Pro Text" pitchFamily="34" charset="0"/>
+                <a:ea typeface="SF Pro Text" pitchFamily="34" charset="-122"/>
+                <a:cs typeface="SF Pro Text" pitchFamily="34" charset="-120"/>
+              </a:rPr>
+              <a:t>Refund, check for a Premium fee, then the 30-minute rule.</a:t>
+            </a:r>
+            <a:endParaRPr lang="en-US" sz="1150" dirty="0"/>
+          </a:p>
+        </p:txBody>
+      </p:sp>
       <p:graphicFrame>
         <p:nvGraphicFramePr>
           <p:cNvPr id="9" name="Table 0"/>
@@ -38555,18 +38886,18 @@
           </p:nvPr>
         </p:nvGraphicFramePr>
         <p:xfrm>
-          <a:off x="411480" y="1143000"/>
-          <a:ext cx="8321040" cy="914400"/>
+          <a:off x="411480" y="1691640"/>
+          <a:ext cx="4983480" cy="914400"/>
         </p:xfrm>
         <a:graphic>
           <a:graphicData uri="http://schemas.openxmlformats.org/drawingml/2006/table">
             <a:tbl>
               <a:tblPr/>
               <a:tblGrid>
-                <a:gridCol w="5486400"/>
+                <a:gridCol w="2148840"/>
                 <a:gridCol w="2834640"/>
               </a:tblGrid>
-              <a:tr h="384048">
+              <a:tr h="0">
                 <a:tc>
                   <a:txBody>
                     <a:bodyPr/>
@@ -38576,7 +38907,7 @@
                         <a:buNone/>
                       </a:pPr>
                       <a:r>
-                        <a:rPr lang="en-US" sz="950" b="1" dirty="0">
+                        <a:rPr lang="en-US" sz="800" b="1" dirty="0">
                           <a:solidFill>
                             <a:srgbClr val="0B7A6F"/>
                           </a:solidFill>
@@ -38586,14 +38917,14 @@
                         </a:rPr>
                         <a:t>What you find</a:t>
                       </a:r>
-                      <a:endParaRPr lang="en-US" sz="950" dirty="0">
+                      <a:endParaRPr lang="en-US" sz="800" dirty="0">
                         <a:latin typeface="SF Pro Display" charset="0"/>
                         <a:ea typeface="SF Pro Display" charset="0"/>
                         <a:cs typeface="SF Pro Display" charset="0"/>
                       </a:endParaRPr>
                     </a:p>
                   </a:txBody>
-                  <a:tcPr marL="91440" marR="91440" marT="27432" marB="27432" anchor="ctr">
+                  <a:tcPr marL="73152" marR="73152" marT="27432" marB="27432" anchor="ctr">
                     <a:lnL w="9525" cap="flat" cmpd="sng" algn="ctr">
                       <a:solidFill>
                         <a:srgbClr val="DCE1E7"/>
@@ -38644,7 +38975,7 @@
                         <a:buNone/>
                       </a:pPr>
                       <a:r>
-                        <a:rPr lang="en-US" sz="950" b="1" dirty="0">
+                        <a:rPr lang="en-US" sz="800" b="1" dirty="0">
                           <a:solidFill>
                             <a:srgbClr val="0B7A6F"/>
                           </a:solidFill>
@@ -38652,16 +38983,16 @@
                           <a:ea typeface="SF Pro Display" pitchFamily="34" charset="-122"/>
                           <a:cs typeface="SF Pro Display" pitchFamily="34" charset="-120"/>
                         </a:rPr>
-                        <a:t>Go to</a:t>
+                        <a:t>What it means</a:t>
                       </a:r>
-                      <a:endParaRPr lang="en-US" sz="950" dirty="0">
+                      <a:endParaRPr lang="en-US" sz="800" dirty="0">
                         <a:latin typeface="SF Pro Display" charset="0"/>
                         <a:ea typeface="SF Pro Display" charset="0"/>
                         <a:cs typeface="SF Pro Display" charset="0"/>
                       </a:endParaRPr>
                     </a:p>
                   </a:txBody>
-                  <a:tcPr marL="91440" marR="91440" marT="27432" marB="27432" anchor="ctr">
+                  <a:tcPr marL="73152" marR="73152" marT="27432" marB="27432" anchor="ctr">
                     <a:lnL w="9525" cap="flat" cmpd="sng" algn="ctr">
                       <a:solidFill>
                         <a:srgbClr val="DCE1E7"/>
@@ -38704,7 +39035,7 @@
                   </a:tcPr>
                 </a:tc>
               </a:tr>
-              <a:tr h="384048">
+              <a:tr h="0">
                 <a:tc>
                   <a:txBody>
                     <a:bodyPr/>
@@ -38714,7 +39045,7 @@
                         <a:buNone/>
                       </a:pPr>
                       <a:r>
-                        <a:rPr lang="en-US" sz="950" b="1" dirty="0">
+                        <a:rPr lang="en-US" sz="800" b="1" dirty="0">
                           <a:solidFill>
                             <a:srgbClr val="1D1D1F"/>
                           </a:solidFill>
@@ -38722,16 +39053,16 @@
                           <a:ea typeface="SF Pro Text" pitchFamily="34" charset="-122"/>
                           <a:cs typeface="SF Pro Text" pitchFamily="34" charset="-120"/>
                         </a:rPr>
-                        <a:t>CTJ shorter than the hours invoiced</a:t>
+                        <a:t>CTJ shorter than hours invoiced</a:t>
                       </a:r>
-                      <a:endParaRPr lang="en-US" sz="950" dirty="0">
+                      <a:endParaRPr lang="en-US" sz="800" dirty="0">
                         <a:latin typeface="SF Pro Text" charset="0"/>
                         <a:ea typeface="SF Pro Text" charset="0"/>
                         <a:cs typeface="SF Pro Text" charset="0"/>
                       </a:endParaRPr>
                     </a:p>
                   </a:txBody>
-                  <a:tcPr marL="91440" marR="91440" marT="27432" marB="27432" anchor="ctr">
+                  <a:tcPr marL="73152" marR="73152" marT="27432" marB="27432" anchor="ctr">
                     <a:lnL w="9525" cap="flat" cmpd="sng" algn="ctr">
                       <a:solidFill>
                         <a:srgbClr val="DCE1E7"/>
@@ -38782,7 +39113,7 @@
                         <a:buNone/>
                       </a:pPr>
                       <a:r>
-                        <a:rPr lang="en-US" sz="950" dirty="0">
+                        <a:rPr lang="en-US" sz="800" dirty="0">
                           <a:solidFill>
                             <a:srgbClr val="6E6E73"/>
                           </a:solidFill>
@@ -38790,16 +39121,16 @@
                           <a:ea typeface="SF Pro Text" pitchFamily="34" charset="-122"/>
                           <a:cs typeface="SF Pro Text" pitchFamily="34" charset="-120"/>
                         </a:rPr>
-                        <a:t>Branch A</a:t>
+                        <a:t>Clear evidence of overcharge → go to Branch A</a:t>
                       </a:r>
-                      <a:endParaRPr lang="en-US" sz="950" dirty="0">
+                      <a:endParaRPr lang="en-US" sz="800" dirty="0">
                         <a:latin typeface="SF Pro Text" charset="0"/>
                         <a:ea typeface="SF Pro Text" charset="0"/>
                         <a:cs typeface="SF Pro Text" charset="0"/>
                       </a:endParaRPr>
                     </a:p>
                   </a:txBody>
-                  <a:tcPr marL="91440" marR="91440" marT="27432" marB="27432" anchor="ctr">
+                  <a:tcPr marL="73152" marR="73152" marT="27432" marB="27432" anchor="ctr">
                     <a:lnL w="9525" cap="flat" cmpd="sng" algn="ctr">
                       <a:solidFill>
                         <a:srgbClr val="DCE1E7"/>
@@ -38842,7 +39173,7 @@
                   </a:tcPr>
                 </a:tc>
               </a:tr>
-              <a:tr h="384048">
+              <a:tr h="0">
                 <a:tc>
                   <a:txBody>
                     <a:bodyPr/>
@@ -38852,7 +39183,7 @@
                         <a:buNone/>
                       </a:pPr>
                       <a:r>
-                        <a:rPr lang="en-US" sz="950" b="1" dirty="0">
+                        <a:rPr lang="en-US" sz="800" b="1" dirty="0">
                           <a:solidFill>
                             <a:srgbClr val="1D1D1F"/>
                           </a:solidFill>
@@ -38860,16 +39191,16 @@
                           <a:ea typeface="SF Pro Text" pitchFamily="34" charset="-122"/>
                           <a:cs typeface="SF Pro Text" pitchFamily="34" charset="-120"/>
                         </a:rPr>
-                        <a:t>Customer sends valid proof of the actual duration (Ring clip, timestamped photo)</a:t>
+                        <a:t>Customer supplies valid evidence of the actual duration (e.g. Ring camera, timestamped photo)</a:t>
                       </a:r>
-                      <a:endParaRPr lang="en-US" sz="950" dirty="0">
+                      <a:endParaRPr lang="en-US" sz="800" dirty="0">
                         <a:latin typeface="SF Pro Text" charset="0"/>
                         <a:ea typeface="SF Pro Text" charset="0"/>
                         <a:cs typeface="SF Pro Text" charset="0"/>
                       </a:endParaRPr>
                     </a:p>
                   </a:txBody>
-                  <a:tcPr marL="91440" marR="91440" marT="27432" marB="27432" anchor="ctr">
+                  <a:tcPr marL="73152" marR="73152" marT="27432" marB="27432" anchor="ctr">
                     <a:lnL w="9525" cap="flat" cmpd="sng" algn="ctr">
                       <a:solidFill>
                         <a:srgbClr val="DCE1E7"/>
@@ -38920,7 +39251,7 @@
                         <a:buNone/>
                       </a:pPr>
                       <a:r>
-                        <a:rPr lang="en-US" sz="950" dirty="0">
+                        <a:rPr lang="en-US" sz="800" dirty="0">
                           <a:solidFill>
                             <a:srgbClr val="6E6E73"/>
                           </a:solidFill>
@@ -38928,16 +39259,16 @@
                           <a:ea typeface="SF Pro Text" pitchFamily="34" charset="-122"/>
                           <a:cs typeface="SF Pro Text" pitchFamily="34" charset="-120"/>
                         </a:rPr>
-                        <a:t>Branch A: refund only what it supports</a:t>
+                        <a:t>Treat it as you would a CTJ record → go to Branch A, refunding only the hours the evidence supports</a:t>
                       </a:r>
-                      <a:endParaRPr lang="en-US" sz="950" dirty="0">
+                      <a:endParaRPr lang="en-US" sz="800" dirty="0">
                         <a:latin typeface="SF Pro Text" charset="0"/>
                         <a:ea typeface="SF Pro Text" charset="0"/>
                         <a:cs typeface="SF Pro Text" charset="0"/>
                       </a:endParaRPr>
                     </a:p>
                   </a:txBody>
-                  <a:tcPr marL="91440" marR="91440" marT="27432" marB="27432" anchor="ctr">
+                  <a:tcPr marL="73152" marR="73152" marT="27432" marB="27432" anchor="ctr">
                     <a:lnL w="9525" cap="flat" cmpd="sng" algn="ctr">
                       <a:solidFill>
                         <a:srgbClr val="DCE1E7"/>
@@ -38980,7 +39311,7 @@
                   </a:tcPr>
                 </a:tc>
               </a:tr>
-              <a:tr h="384048">
+              <a:tr h="0">
                 <a:tc>
                   <a:txBody>
                     <a:bodyPr/>
@@ -38990,7 +39321,7 @@
                         <a:buNone/>
                       </a:pPr>
                       <a:r>
-                        <a:rPr lang="en-US" sz="950" b="1" dirty="0">
+                        <a:rPr lang="en-US" sz="800" b="1" dirty="0">
                           <a:solidFill>
                             <a:srgbClr val="1D1D1F"/>
                           </a:solidFill>
@@ -38998,16 +39329,16 @@
                           <a:ea typeface="SF Pro Text" pitchFamily="34" charset="-122"/>
                           <a:cs typeface="SF Pro Text" pitchFamily="34" charset="-120"/>
                         </a:rPr>
-                        <a:t>Cleaner admits the overcharge in messages</a:t>
+                        <a:t>Cleaner acknowledges overcharge in messages</a:t>
                       </a:r>
-                      <a:endParaRPr lang="en-US" sz="950" dirty="0">
+                      <a:endParaRPr lang="en-US" sz="800" dirty="0">
                         <a:latin typeface="SF Pro Text" charset="0"/>
                         <a:ea typeface="SF Pro Text" charset="0"/>
                         <a:cs typeface="SF Pro Text" charset="0"/>
                       </a:endParaRPr>
                     </a:p>
                   </a:txBody>
-                  <a:tcPr marL="91440" marR="91440" marT="27432" marB="27432" anchor="ctr">
+                  <a:tcPr marL="73152" marR="73152" marT="27432" marB="27432" anchor="ctr">
                     <a:lnL w="9525" cap="flat" cmpd="sng" algn="ctr">
                       <a:solidFill>
                         <a:srgbClr val="DCE1E7"/>
@@ -39058,7 +39389,7 @@
                         <a:buNone/>
                       </a:pPr>
                       <a:r>
-                        <a:rPr lang="en-US" sz="950" dirty="0">
+                        <a:rPr lang="en-US" sz="800" dirty="0">
                           <a:solidFill>
                             <a:srgbClr val="6E6E73"/>
                           </a:solidFill>
@@ -39066,16 +39397,16 @@
                           <a:ea typeface="SF Pro Text" pitchFamily="34" charset="-122"/>
                           <a:cs typeface="SF Pro Text" pitchFamily="34" charset="-120"/>
                         </a:rPr>
-                        <a:t>Branch A</a:t>
+                        <a:t>Clear evidence → go to Branch A</a:t>
                       </a:r>
-                      <a:endParaRPr lang="en-US" sz="950" dirty="0">
+                      <a:endParaRPr lang="en-US" sz="800" dirty="0">
                         <a:latin typeface="SF Pro Text" charset="0"/>
                         <a:ea typeface="SF Pro Text" charset="0"/>
                         <a:cs typeface="SF Pro Text" charset="0"/>
                       </a:endParaRPr>
                     </a:p>
                   </a:txBody>
-                  <a:tcPr marL="91440" marR="91440" marT="27432" marB="27432" anchor="ctr">
+                  <a:tcPr marL="73152" marR="73152" marT="27432" marB="27432" anchor="ctr">
                     <a:lnL w="9525" cap="flat" cmpd="sng" algn="ctr">
                       <a:solidFill>
                         <a:srgbClr val="DCE1E7"/>
@@ -39118,7 +39449,7 @@
                   </a:tcPr>
                 </a:tc>
               </a:tr>
-              <a:tr h="384048">
+              <a:tr h="0">
                 <a:tc>
                   <a:txBody>
                     <a:bodyPr/>
@@ -39128,7 +39459,7 @@
                         <a:buNone/>
                       </a:pPr>
                       <a:r>
-                        <a:rPr lang="en-US" sz="950" b="1" dirty="0">
+                        <a:rPr lang="en-US" sz="800" b="1" dirty="0">
                           <a:solidFill>
                             <a:srgbClr val="1D1D1F"/>
                           </a:solidFill>
@@ -39136,16 +39467,16 @@
                           <a:ea typeface="SF Pro Text" pitchFamily="34" charset="-122"/>
                           <a:cs typeface="SF Pro Text" pitchFamily="34" charset="-120"/>
                         </a:rPr>
-                        <a:t>Cleaner already refunded after the complaint</a:t>
+                        <a:t>Cleaner already issued a refund in response to the complaint</a:t>
                       </a:r>
-                      <a:endParaRPr lang="en-US" sz="950" dirty="0">
+                      <a:endParaRPr lang="en-US" sz="800" dirty="0">
                         <a:latin typeface="SF Pro Text" charset="0"/>
                         <a:ea typeface="SF Pro Text" charset="0"/>
                         <a:cs typeface="SF Pro Text" charset="0"/>
                       </a:endParaRPr>
                     </a:p>
                   </a:txBody>
-                  <a:tcPr marL="91440" marR="91440" marT="27432" marB="27432" anchor="ctr">
+                  <a:tcPr marL="73152" marR="73152" marT="27432" marB="27432" anchor="ctr">
                     <a:lnL w="9525" cap="flat" cmpd="sng" algn="ctr">
                       <a:solidFill>
                         <a:srgbClr val="DCE1E7"/>
@@ -39196,7 +39527,7 @@
                         <a:buNone/>
                       </a:pPr>
                       <a:r>
-                        <a:rPr lang="en-US" sz="950" dirty="0">
+                        <a:rPr lang="en-US" sz="800" dirty="0">
                           <a:solidFill>
                             <a:srgbClr val="6E6E73"/>
                           </a:solidFill>
@@ -39204,16 +39535,16 @@
                           <a:ea typeface="SF Pro Text" pitchFamily="34" charset="-122"/>
                           <a:cs typeface="SF Pro Text" pitchFamily="34" charset="-120"/>
                         </a:rPr>
-                        <a:t>Branch A</a:t>
+                        <a:t>Supports the overcharge claim (people rarely refund for something they didn't do) → go to Branch A</a:t>
                       </a:r>
-                      <a:endParaRPr lang="en-US" sz="950" dirty="0">
+                      <a:endParaRPr lang="en-US" sz="800" dirty="0">
                         <a:latin typeface="SF Pro Text" charset="0"/>
                         <a:ea typeface="SF Pro Text" charset="0"/>
                         <a:cs typeface="SF Pro Text" charset="0"/>
                       </a:endParaRPr>
                     </a:p>
                   </a:txBody>
-                  <a:tcPr marL="91440" marR="91440" marT="27432" marB="27432" anchor="ctr">
+                  <a:tcPr marL="73152" marR="73152" marT="27432" marB="27432" anchor="ctr">
                     <a:lnL w="9525" cap="flat" cmpd="sng" algn="ctr">
                       <a:solidFill>
                         <a:srgbClr val="DCE1E7"/>
@@ -39256,7 +39587,7 @@
                   </a:tcPr>
                 </a:tc>
               </a:tr>
-              <a:tr h="384048">
+              <a:tr h="0">
                 <a:tc>
                   <a:txBody>
                     <a:bodyPr/>
@@ -39266,7 +39597,7 @@
                         <a:buNone/>
                       </a:pPr>
                       <a:r>
-                        <a:rPr lang="en-US" sz="950" b="1" dirty="0">
+                        <a:rPr lang="en-US" sz="800" b="1" dirty="0">
                           <a:solidFill>
                             <a:srgbClr val="1D1D1F"/>
                           </a:solidFill>
@@ -39274,16 +39605,16 @@
                           <a:ea typeface="SF Pro Text" pitchFamily="34" charset="-122"/>
                           <a:cs typeface="SF Pro Text" pitchFamily="34" charset="-120"/>
                         </a:rPr>
-                        <a:t>CTJ matches the hours invoiced</a:t>
+                        <a:t>Customer claims a shorter cleaning duration than what you found during your investigation</a:t>
                       </a:r>
-                      <a:endParaRPr lang="en-US" sz="950" dirty="0">
+                      <a:endParaRPr lang="en-US" sz="800" dirty="0">
                         <a:latin typeface="SF Pro Text" charset="0"/>
                         <a:ea typeface="SF Pro Text" charset="0"/>
                         <a:cs typeface="SF Pro Text" charset="0"/>
                       </a:endParaRPr>
                     </a:p>
                   </a:txBody>
-                  <a:tcPr marL="91440" marR="91440" marT="27432" marB="27432" anchor="ctr">
+                  <a:tcPr marL="73152" marR="73152" marT="27432" marB="27432" anchor="ctr">
                     <a:lnL w="9525" cap="flat" cmpd="sng" algn="ctr">
                       <a:solidFill>
                         <a:srgbClr val="DCE1E7"/>
@@ -39334,7 +39665,7 @@
                         <a:buNone/>
                       </a:pPr>
                       <a:r>
-                        <a:rPr lang="en-US" sz="950" dirty="0">
+                        <a:rPr lang="en-US" sz="800" dirty="0">
                           <a:solidFill>
                             <a:srgbClr val="6E6E73"/>
                           </a:solidFill>
@@ -39342,16 +39673,16 @@
                           <a:ea typeface="SF Pro Text" pitchFamily="34" charset="-122"/>
                           <a:cs typeface="SF Pro Text" pitchFamily="34" charset="-120"/>
                         </a:rPr>
-                        <a:t>Stop: no refund. Address other concerns</a:t>
+                        <a:t>CTJ confirms there is an overcharge, regardless of whether it matches the hours reported by the customer → go to Branch A (only refund the hours that are clearly supported by the CTJ)</a:t>
                       </a:r>
-                      <a:endParaRPr lang="en-US" sz="950" dirty="0">
+                      <a:endParaRPr lang="en-US" sz="800" dirty="0">
                         <a:latin typeface="SF Pro Text" charset="0"/>
                         <a:ea typeface="SF Pro Text" charset="0"/>
                         <a:cs typeface="SF Pro Text" charset="0"/>
                       </a:endParaRPr>
                     </a:p>
                   </a:txBody>
-                  <a:tcPr marL="91440" marR="91440" marT="27432" marB="27432" anchor="ctr">
+                  <a:tcPr marL="73152" marR="73152" marT="27432" marB="27432" anchor="ctr">
                     <a:lnL w="9525" cap="flat" cmpd="sng" algn="ctr">
                       <a:solidFill>
                         <a:srgbClr val="DCE1E7"/>
@@ -39394,7 +39725,120 @@
                   </a:tcPr>
                 </a:tc>
               </a:tr>
-              <a:tr h="384048">
+            </a:tbl>
+          </a:graphicData>
+        </a:graphic>
+      </p:graphicFrame>
+      <p:sp>
+        <p:nvSpPr>
+          <p:cNvPr id="8" name="Shape 4"/>
+          <p:cNvSpPr/>
+          <p:nvPr/>
+        </p:nvSpPr>
+        <p:spPr>
+          <a:xfrm>
+            <a:off x="5532120" y="1051560"/>
+            <a:ext cx="3200400" cy="566928"/>
+          </a:xfrm>
+          <a:prstGeom prst="roundRect">
+            <a:avLst>
+              <a:gd name="adj" fmla="val 12903"/>
+            </a:avLst>
+          </a:prstGeom>
+          <a:solidFill>
+            <a:srgbClr val="0B7A6F"/>
+          </a:solidFill>
+          <a:ln w="9525">
+            <a:solidFill>
+              <a:srgbClr val="0B7A6F"/>
+            </a:solidFill>
+            <a:prstDash val="solid"/>
+          </a:ln>
+        </p:spPr>
+      </p:sp>
+      <p:sp>
+        <p:nvSpPr>
+          <p:cNvPr id="9" name="Text 5"/>
+          <p:cNvSpPr txBox="1"/>
+          <p:nvPr/>
+        </p:nvSpPr>
+        <p:spPr>
+          <a:xfrm>
+            <a:off x="5660136" y="1051560"/>
+            <a:ext cx="2944368" cy="566928"/>
+          </a:xfrm>
+          <a:prstGeom prst="rect">
+            <a:avLst/>
+          </a:prstGeom>
+          <a:noFill/>
+          <a:ln/>
+        </p:spPr>
+        <p:txBody>
+          <a:bodyPr wrap="square" lIns="0" tIns="0" rIns="0" bIns="0" rtlCol="0" anchor="ctr"/>
+          <a:lstStyle/>
+          <a:p>
+            <a:pPr indent="0" marL="0">
+              <a:buNone/>
+            </a:pPr>
+            <a:r>
+              <a:rPr lang="en-US" sz="1150" b="1" dirty="0">
+                <a:solidFill>
+                  <a:srgbClr val="FFFFFF"/>
+                </a:solidFill>
+                <a:latin typeface="SF Pro Display" pitchFamily="34" charset="0"/>
+                <a:ea typeface="SF Pro Display" pitchFamily="34" charset="-122"/>
+                <a:cs typeface="SF Pro Display" pitchFamily="34" charset="-120"/>
+              </a:rPr>
+              <a:t>Branch B: no clear evidence present</a:t>
+            </a:r>
+            <a:endParaRPr lang="en-US" sz="1150" dirty="0"/>
+          </a:p>
+          <a:p>
+            <a:pPr indent="0" marL="0">
+              <a:buNone/>
+            </a:pPr>
+            <a:r>
+              <a:rPr lang="en-US" sz="850" dirty="0">
+                <a:solidFill>
+                  <a:srgbClr val="FFFFFF"/>
+                </a:solidFill>
+                <a:latin typeface="SF Pro Text" pitchFamily="34" charset="0"/>
+                <a:ea typeface="SF Pro Text" pitchFamily="34" charset="-122"/>
+                <a:cs typeface="SF Pro Text" pitchFamily="34" charset="-120"/>
+              </a:rPr>
+              <a:t>Request documentation, then wait for the Timed Reminder.</a:t>
+            </a:r>
+            <a:endParaRPr lang="en-US" sz="1150" dirty="0"/>
+          </a:p>
+        </p:txBody>
+      </p:sp>
+      <p:graphicFrame>
+        <p:nvGraphicFramePr>
+          <p:cNvPr id="17" name="Table 1"/>
+          <p:cNvGraphicFramePr>
+            <a:graphicFrameLocks noGrp="1"/>
+          </p:cNvGraphicFramePr>
+          <p:nvPr>
+            <p:extLst>
+              <p:ext uri="{D42A27DB-BD31-4B8C-83A1-F6EECF244321}">
+                <p14:modId xmlns:p14="http://schemas.microsoft.com/office/powerpoint/2010/main" val="1579011935"/>
+              </p:ext>
+            </p:extLst>
+          </p:nvPr>
+        </p:nvGraphicFramePr>
+        <p:xfrm>
+          <a:off x="5532120" y="1691640"/>
+          <a:ext cx="3200400" cy="914400"/>
+        </p:xfrm>
+        <a:graphic>
+          <a:graphicData uri="http://schemas.openxmlformats.org/drawingml/2006/table">
+            <a:tbl>
+              <a:tblPr/>
+              <a:tblGrid>
+                <a:gridCol w="1417320"/>
+                <a:gridCol w="1783080"/>
+              </a:tblGrid>
+              <a:tr h="0">
                 <a:tc>
                   <a:txBody>
                     <a:bodyPr/>
@@ -39404,7 +39848,145 @@
                         <a:buNone/>
                       </a:pPr>
                       <a:r>
-                        <a:rPr lang="en-US" sz="950" b="1" dirty="0">
+                        <a:rPr lang="en-US" sz="800" b="1" dirty="0">
+                          <a:solidFill>
+                            <a:srgbClr val="0B7A6F"/>
+                          </a:solidFill>
+                          <a:latin typeface="SF Pro Display" pitchFamily="34" charset="0"/>
+                          <a:ea typeface="SF Pro Display" pitchFamily="34" charset="-122"/>
+                          <a:cs typeface="SF Pro Display" pitchFamily="34" charset="-120"/>
+                        </a:rPr>
+                        <a:t>What you find</a:t>
+                      </a:r>
+                      <a:endParaRPr lang="en-US" sz="800" dirty="0">
+                        <a:latin typeface="SF Pro Display" charset="0"/>
+                        <a:ea typeface="SF Pro Display" charset="0"/>
+                        <a:cs typeface="SF Pro Display" charset="0"/>
+                      </a:endParaRPr>
+                    </a:p>
+                  </a:txBody>
+                  <a:tcPr marL="73152" marR="73152" marT="27432" marB="27432" anchor="ctr">
+                    <a:lnL w="9525" cap="flat" cmpd="sng" algn="ctr">
+                      <a:solidFill>
+                        <a:srgbClr val="DCE1E7"/>
+                      </a:solidFill>
+                      <a:prstDash val="solid"/>
+                      <a:round/>
+                      <a:headEnd type="none" w="med" len="med"/>
+                      <a:tailEnd type="none" w="med" len="med"/>
+                    </a:lnL>
+                    <a:lnR w="9525" cap="flat" cmpd="sng" algn="ctr">
+                      <a:solidFill>
+                        <a:srgbClr val="DCE1E7"/>
+                      </a:solidFill>
+                      <a:prstDash val="solid"/>
+                      <a:round/>
+                      <a:headEnd type="none" w="med" len="med"/>
+                      <a:tailEnd type="none" w="med" len="med"/>
+                    </a:lnR>
+                    <a:lnT w="9525" cap="flat" cmpd="sng" algn="ctr">
+                      <a:solidFill>
+                        <a:srgbClr val="DCE1E7"/>
+                      </a:solidFill>
+                      <a:prstDash val="solid"/>
+                      <a:round/>
+                      <a:headEnd type="none" w="med" len="med"/>
+                      <a:tailEnd type="none" w="med" len="med"/>
+                    </a:lnT>
+                    <a:lnB w="9525" cap="flat" cmpd="sng" algn="ctr">
+                      <a:solidFill>
+                        <a:srgbClr val="DCE1E7"/>
+                      </a:solidFill>
+                      <a:prstDash val="solid"/>
+                      <a:round/>
+                      <a:headEnd type="none" w="med" len="med"/>
+                      <a:tailEnd type="none" w="med" len="med"/>
+                    </a:lnB>
+                    <a:solidFill>
+                      <a:srgbClr val="E3F4F1"/>
+                    </a:solidFill>
+                  </a:tcPr>
+                </a:tc>
+                <a:tc>
+                  <a:txBody>
+                    <a:bodyPr/>
+                    <a:lstStyle/>
+                    <a:p>
+                      <a:pPr indent="0" marL="0">
+                        <a:buNone/>
+                      </a:pPr>
+                      <a:r>
+                        <a:rPr lang="en-US" sz="800" b="1" dirty="0">
+                          <a:solidFill>
+                            <a:srgbClr val="0B7A6F"/>
+                          </a:solidFill>
+                          <a:latin typeface="SF Pro Display" pitchFamily="34" charset="0"/>
+                          <a:ea typeface="SF Pro Display" pitchFamily="34" charset="-122"/>
+                          <a:cs typeface="SF Pro Display" pitchFamily="34" charset="-120"/>
+                        </a:rPr>
+                        <a:t>What it means</a:t>
+                      </a:r>
+                      <a:endParaRPr lang="en-US" sz="800" dirty="0">
+                        <a:latin typeface="SF Pro Display" charset="0"/>
+                        <a:ea typeface="SF Pro Display" charset="0"/>
+                        <a:cs typeface="SF Pro Display" charset="0"/>
+                      </a:endParaRPr>
+                    </a:p>
+                  </a:txBody>
+                  <a:tcPr marL="73152" marR="73152" marT="27432" marB="27432" anchor="ctr">
+                    <a:lnL w="9525" cap="flat" cmpd="sng" algn="ctr">
+                      <a:solidFill>
+                        <a:srgbClr val="DCE1E7"/>
+                      </a:solidFill>
+                      <a:prstDash val="solid"/>
+                      <a:round/>
+                      <a:headEnd type="none" w="med" len="med"/>
+                      <a:tailEnd type="none" w="med" len="med"/>
+                    </a:lnL>
+                    <a:lnR w="9525" cap="flat" cmpd="sng" algn="ctr">
+                      <a:solidFill>
+                        <a:srgbClr val="DCE1E7"/>
+                      </a:solidFill>
+                      <a:prstDash val="solid"/>
+                      <a:round/>
+                      <a:headEnd type="none" w="med" len="med"/>
+                      <a:tailEnd type="none" w="med" len="med"/>
+                    </a:lnR>
+                    <a:lnT w="9525" cap="flat" cmpd="sng" algn="ctr">
+                      <a:solidFill>
+                        <a:srgbClr val="DCE1E7"/>
+                      </a:solidFill>
+                      <a:prstDash val="solid"/>
+                      <a:round/>
+                      <a:headEnd type="none" w="med" len="med"/>
+                      <a:tailEnd type="none" w="med" len="med"/>
+                    </a:lnT>
+                    <a:lnB w="9525" cap="flat" cmpd="sng" algn="ctr">
+                      <a:solidFill>
+                        <a:srgbClr val="DCE1E7"/>
+                      </a:solidFill>
+                      <a:prstDash val="solid"/>
+                      <a:round/>
+                      <a:headEnd type="none" w="med" len="med"/>
+                      <a:tailEnd type="none" w="med" len="med"/>
+                    </a:lnB>
+                    <a:solidFill>
+                      <a:srgbClr val="E3F4F1"/>
+                    </a:solidFill>
+                  </a:tcPr>
+                </a:tc>
+              </a:tr>
+              <a:tr h="0">
+                <a:tc>
+                  <a:txBody>
+                    <a:bodyPr/>
+                    <a:lstStyle/>
+                    <a:p>
+                      <a:pPr indent="0" marL="0">
+                        <a:buNone/>
+                      </a:pPr>
+                      <a:r>
+                        <a:rPr lang="en-US" sz="800" b="1" dirty="0">
                           <a:solidFill>
                             <a:srgbClr val="1D1D1F"/>
                           </a:solidFill>
@@ -39412,16 +39994,16 @@
                           <a:ea typeface="SF Pro Text" pitchFamily="34" charset="-122"/>
                           <a:cs typeface="SF Pro Text" pitchFamily="34" charset="-120"/>
                         </a:rPr>
-                        <a:t>Customer's claim backed only by job history or message timestamps</a:t>
+                        <a:t>Customer claims a shorter cleaning duration than what you found during your investigation</a:t>
                       </a:r>
-                      <a:endParaRPr lang="en-US" sz="950" dirty="0">
+                      <a:endParaRPr lang="en-US" sz="800" dirty="0">
                         <a:latin typeface="SF Pro Text" charset="0"/>
                         <a:ea typeface="SF Pro Text" charset="0"/>
                         <a:cs typeface="SF Pro Text" charset="0"/>
                       </a:endParaRPr>
                     </a:p>
                   </a:txBody>
-                  <a:tcPr marL="91440" marR="91440" marT="27432" marB="27432" anchor="ctr">
+                  <a:tcPr marL="73152" marR="73152" marT="27432" marB="27432" anchor="ctr">
                     <a:lnL w="9525" cap="flat" cmpd="sng" algn="ctr">
                       <a:solidFill>
                         <a:srgbClr val="DCE1E7"/>
@@ -39472,7 +40054,7 @@
                         <a:buNone/>
                       </a:pPr>
                       <a:r>
-                        <a:rPr lang="en-US" sz="950" dirty="0">
+                        <a:rPr lang="en-US" sz="800" dirty="0">
                           <a:solidFill>
                             <a:srgbClr val="6E6E73"/>
                           </a:solidFill>
@@ -39480,16 +40062,16 @@
                           <a:ea typeface="SF Pro Text" pitchFamily="34" charset="-122"/>
                           <a:cs typeface="SF Pro Text" pitchFamily="34" charset="-120"/>
                         </a:rPr>
-                        <a:t>Branch B</a:t>
+                        <a:t>Job history or other information sources (e.g., C/CP message timestamps) → go to Branch B</a:t>
                       </a:r>
-                      <a:endParaRPr lang="en-US" sz="950" dirty="0">
+                      <a:endParaRPr lang="en-US" sz="800" dirty="0">
                         <a:latin typeface="SF Pro Text" charset="0"/>
                         <a:ea typeface="SF Pro Text" charset="0"/>
                         <a:cs typeface="SF Pro Text" charset="0"/>
                       </a:endParaRPr>
                     </a:p>
                   </a:txBody>
-                  <a:tcPr marL="91440" marR="91440" marT="27432" marB="27432" anchor="ctr">
+                  <a:tcPr marL="73152" marR="73152" marT="27432" marB="27432" anchor="ctr">
                     <a:lnL w="9525" cap="flat" cmpd="sng" algn="ctr">
                       <a:solidFill>
                         <a:srgbClr val="DCE1E7"/>
@@ -39532,7 +40114,7 @@
                   </a:tcPr>
                 </a:tc>
               </a:tr>
-              <a:tr h="384048">
+              <a:tr h="0">
                 <a:tc>
                   <a:txBody>
                     <a:bodyPr/>
@@ -39542,7 +40124,7 @@
                         <a:buNone/>
                       </a:pPr>
                       <a:r>
-                        <a:rPr lang="en-US" sz="950" b="1" dirty="0">
+                        <a:rPr lang="en-US" sz="800" b="1" dirty="0">
                           <a:solidFill>
                             <a:srgbClr val="1D1D1F"/>
                           </a:solidFill>
@@ -39550,16 +40132,16 @@
                           <a:ea typeface="SF Pro Text" pitchFamily="34" charset="-122"/>
                           <a:cs typeface="SF Pro Text" pitchFamily="34" charset="-120"/>
                         </a:rPr>
-                        <a:t>None of the above</a:t>
+                        <a:t>None of the above found</a:t>
                       </a:r>
-                      <a:endParaRPr lang="en-US" sz="950" dirty="0">
+                      <a:endParaRPr lang="en-US" sz="800" dirty="0">
                         <a:latin typeface="SF Pro Text" charset="0"/>
                         <a:ea typeface="SF Pro Text" charset="0"/>
                         <a:cs typeface="SF Pro Text" charset="0"/>
                       </a:endParaRPr>
                     </a:p>
                   </a:txBody>
-                  <a:tcPr marL="91440" marR="91440" marT="27432" marB="27432" anchor="ctr">
+                  <a:tcPr marL="73152" marR="73152" marT="27432" marB="27432" anchor="ctr">
                     <a:lnL w="9525" cap="flat" cmpd="sng" algn="ctr">
                       <a:solidFill>
                         <a:srgbClr val="DCE1E7"/>
@@ -39610,7 +40192,7 @@
                         <a:buNone/>
                       </a:pPr>
                       <a:r>
-                        <a:rPr lang="en-US" sz="950" dirty="0">
+                        <a:rPr lang="en-US" sz="800" dirty="0">
                           <a:solidFill>
                             <a:srgbClr val="6E6E73"/>
                           </a:solidFill>
@@ -39618,16 +40200,16 @@
                           <a:ea typeface="SF Pro Text" pitchFamily="34" charset="-122"/>
                           <a:cs typeface="SF Pro Text" pitchFamily="34" charset="-120"/>
                         </a:rPr>
-                        <a:t>Branch B</a:t>
+                        <a:t>No clear evidence → go to Branch B</a:t>
                       </a:r>
-                      <a:endParaRPr lang="en-US" sz="950" dirty="0">
+                      <a:endParaRPr lang="en-US" sz="800" dirty="0">
                         <a:latin typeface="SF Pro Text" charset="0"/>
                         <a:ea typeface="SF Pro Text" charset="0"/>
                         <a:cs typeface="SF Pro Text" charset="0"/>
                       </a:endParaRPr>
                     </a:p>
                   </a:txBody>
-                  <a:tcPr marL="91440" marR="91440" marT="27432" marB="27432" anchor="ctr">
+                  <a:tcPr marL="73152" marR="73152" marT="27432" marB="27432" anchor="ctr">
                     <a:lnL w="9525" cap="flat" cmpd="sng" algn="ctr">
                       <a:solidFill>
                         <a:srgbClr val="DCE1E7"/>
@@ -39676,18 +40258,18 @@
       </p:graphicFrame>
       <p:sp>
         <p:nvSpPr>
-          <p:cNvPr id="6" name="Shape 2"/>
+          <p:cNvPr id="11" name="Shape 6"/>
           <p:cNvSpPr/>
           <p:nvPr/>
         </p:nvSpPr>
         <p:spPr>
           <a:xfrm>
-            <a:off x="411480" y="4160520"/>
-            <a:ext cx="8321040" cy="384048"/>
+            <a:off x="5532120" y="3703320"/>
+            <a:ext cx="3200400" cy="868680"/>
           </a:xfrm>
           <a:prstGeom prst="roundRect">
             <a:avLst>
-              <a:gd name="adj" fmla="val 19048"/>
+              <a:gd name="adj" fmla="val 8421"/>
             </a:avLst>
           </a:prstGeom>
           <a:solidFill>
@@ -39701,56 +40283,32 @@
           </a:ln>
         </p:spPr>
       </p:sp>
-      <p:pic>
-        <p:nvPicPr>
-          <p:cNvPr id="7" name="Image 0" descr="preencoded.png">    </p:cNvPr>
-          <p:cNvPicPr>
-            <a:picLocks noChangeAspect="1"/>
-          </p:cNvPicPr>
-          <p:nvPr/>
-        </p:nvPicPr>
-        <p:blipFill>
-          <a:blip r:embed="rId1"/>
-          <a:stretch>
-            <a:fillRect/>
-          </a:stretch>
-        </p:blipFill>
-        <p:spPr>
-          <a:xfrm>
-            <a:off x="566928" y="4270248"/>
-            <a:ext cx="164592" cy="164592"/>
-          </a:xfrm>
-          <a:prstGeom prst="rect">
-            <a:avLst/>
-          </a:prstGeom>
-        </p:spPr>
-      </p:pic>
-      <p:sp>
-        <p:nvSpPr>
-          <p:cNvPr id="8" name="Text 3"/>
-          <p:cNvSpPr txBox="1"/>
-          <p:nvPr/>
-        </p:nvSpPr>
-        <p:spPr>
-          <a:xfrm>
-            <a:off x="822960" y="4261104"/>
-            <a:ext cx="7772400" cy="201168"/>
-          </a:xfrm>
-          <a:prstGeom prst="rect">
-            <a:avLst/>
-          </a:prstGeom>
-          <a:noFill/>
-          <a:ln/>
-        </p:spPr>
-        <p:txBody>
-          <a:bodyPr wrap="square" lIns="0" tIns="0" rIns="0" bIns="0" rtlCol="0" anchor="t"/>
+      <p:sp>
+        <p:nvSpPr>
+          <p:cNvPr id="12" name="Text 7"/>
+          <p:cNvSpPr txBox="1"/>
+          <p:nvPr/>
+        </p:nvSpPr>
+        <p:spPr>
+          <a:xfrm>
+            <a:off x="5641848" y="3703320"/>
+            <a:ext cx="2999232" cy="868680"/>
+          </a:xfrm>
+          <a:prstGeom prst="rect">
+            <a:avLst/>
+          </a:prstGeom>
+          <a:noFill/>
+          <a:ln/>
+        </p:spPr>
+        <p:txBody>
+          <a:bodyPr wrap="square" lIns="0" tIns="0" rIns="0" bIns="0" rtlCol="0" anchor="ctr"/>
           <a:lstStyle/>
           <a:p>
             <a:pPr indent="0" marL="0">
               <a:buNone/>
             </a:pPr>
             <a:r>
-              <a:rPr lang="en-US" sz="1000" b="1" dirty="0">
+              <a:rPr lang="en-US" sz="850" b="1" dirty="0">
                 <a:solidFill>
                   <a:srgbClr val="9A6410"/>
                 </a:solidFill>
@@ -39758,13 +40316,16 @@
                 <a:ea typeface="SF Pro Text" pitchFamily="34" charset="-122"/>
                 <a:cs typeface="SF Pro Text" pitchFamily="34" charset="-120"/>
               </a:rPr>
-              <a:t>Known bug:  </a:t>
-            </a:r>
+              <a:t>CTJ matches hours invoiced</a:t>
+            </a:r>
+            <a:endParaRPr lang="en-US" sz="850" dirty="0"/>
+          </a:p>
+          <a:p>
             <a:pPr indent="0" marL="0">
               <a:buNone/>
             </a:pPr>
             <a:r>
-              <a:rPr lang="en-US" sz="1000" dirty="0">
+              <a:rPr lang="en-US" sz="850" dirty="0">
                 <a:solidFill>
                   <a:srgbClr val="1D1D1F"/>
                 </a:solidFill>
@@ -39772,9 +40333,9 @@
                 <a:ea typeface="SF Pro Text" pitchFamily="34" charset="-122"/>
                 <a:cs typeface="SF Pro Text" pitchFamily="34" charset="-120"/>
               </a:rPr>
-              <a:t>a very short CTJ visit (30 min or less) alone is inconclusive, not clear evidence.</a:t>
-            </a:r>
-            <a:endParaRPr lang="en-US" sz="1000" dirty="0"/>
+              <a:t>Clear evidence NO overcharge occurred → stop, no refund, address other concerns</a:t>
+            </a:r>
+            <a:endParaRPr lang="en-US" sz="850" dirty="0"/>
           </a:p>
         </p:txBody>
       </p:sp>
@@ -39923,7 +40484,7 @@
                 <a:ea typeface="SF Pro Display" pitchFamily="34" charset="-122"/>
                 <a:cs typeface="SF Pro Display" pitchFamily="34" charset="-120"/>
               </a:rPr>
-              <a:t>Branch A: clear evidence</a:t>
+              <a:t>Branch A: clear evidence present</a:t>
             </a:r>
             <a:endParaRPr lang="en-US" sz="2400" dirty="0"/>
           </a:p>
@@ -39962,7 +40523,7 @@
                 <a:ea typeface="SF Pro Text" pitchFamily="34" charset="-122"/>
                 <a:cs typeface="SF Pro Text" pitchFamily="34" charset="-120"/>
               </a:rPr>
-              <a:t>A straight line: refund, check Premium, then the 30-minute rule.</a:t>
+              <a:t>A straight line once you're in it: refund, check for a Premium fee, then split on the 30-minute rule.</a:t>
             </a:r>
             <a:endParaRPr lang="en-US" sz="1200" dirty="0"/>
           </a:p>
@@ -39976,18 +40537,502 @@
         </p:nvSpPr>
         <p:spPr>
           <a:xfrm>
-            <a:off x="411480" y="1280160"/>
-            <a:ext cx="2682240" cy="1371600"/>
+            <a:off x="3337560" y="1325880"/>
+            <a:ext cx="2468880" cy="420624"/>
           </a:xfrm>
           <a:prstGeom prst="roundRect">
             <a:avLst>
-              <a:gd name="adj" fmla="val 5333"/>
+              <a:gd name="adj" fmla="val 17391"/>
+            </a:avLst>
+          </a:prstGeom>
+          <a:solidFill>
+            <a:srgbClr val="0B7A6F"/>
+          </a:solidFill>
+          <a:ln w="12700">
+            <a:solidFill>
+              <a:srgbClr val="0B7A6F"/>
+            </a:solidFill>
+            <a:prstDash val="solid"/>
+          </a:ln>
+        </p:spPr>
+      </p:sp>
+      <p:sp>
+        <p:nvSpPr>
+          <p:cNvPr id="7" name="Text 4"/>
+          <p:cNvSpPr txBox="1"/>
+          <p:nvPr/>
+        </p:nvSpPr>
+        <p:spPr>
+          <a:xfrm>
+            <a:off x="3337560" y="1325880"/>
+            <a:ext cx="2468880" cy="420624"/>
+          </a:xfrm>
+          <a:prstGeom prst="rect">
+            <a:avLst/>
+          </a:prstGeom>
+          <a:noFill/>
+          <a:ln/>
+        </p:spPr>
+        <p:txBody>
+          <a:bodyPr wrap="square" lIns="0" tIns="0" rIns="0" bIns="0" rtlCol="0" anchor="ctr"/>
+          <a:lstStyle/>
+          <a:p>
+            <a:pPr algn="ctr" indent="0" marL="0">
+              <a:buNone/>
+            </a:pPr>
+            <a:r>
+              <a:rPr lang="en-US" sz="1000" b="1" dirty="0">
+                <a:solidFill>
+                  <a:srgbClr val="FFFFFF"/>
+                </a:solidFill>
+                <a:latin typeface="SF Pro Display" pitchFamily="34" charset="0"/>
+                <a:ea typeface="SF Pro Display" pitchFamily="34" charset="-122"/>
+                <a:cs typeface="SF Pro Display" pitchFamily="34" charset="-120"/>
+              </a:rPr>
+              <a:t>Refund via CP Dashboard</a:t>
+            </a:r>
+            <a:endParaRPr lang="en-US" sz="1000" dirty="0"/>
+          </a:p>
+        </p:txBody>
+      </p:sp>
+      <p:sp>
+        <p:nvSpPr>
+          <p:cNvPr id="8" name="Shape 5"/>
+          <p:cNvSpPr/>
+          <p:nvPr/>
+        </p:nvSpPr>
+        <p:spPr>
+          <a:xfrm>
+            <a:off x="4572000" y="1746504"/>
+            <a:ext cx="0" cy="155448"/>
+          </a:xfrm>
+          <a:prstGeom prst="line">
+            <a:avLst/>
+          </a:prstGeom>
+          <a:noFill/>
+          <a:ln w="12700">
+            <a:solidFill>
+              <a:srgbClr val="6E6E73"/>
+            </a:solidFill>
+            <a:prstDash val="solid"/>
+            <a:tailEnd type="triangle"/>
+          </a:ln>
+        </p:spPr>
+      </p:sp>
+      <p:sp>
+        <p:nvSpPr>
+          <p:cNvPr id="9" name="Shape 6"/>
+          <p:cNvSpPr/>
+          <p:nvPr/>
+        </p:nvSpPr>
+        <p:spPr>
+          <a:xfrm>
+            <a:off x="3337560" y="1901952"/>
+            <a:ext cx="2468880" cy="420624"/>
+          </a:xfrm>
+          <a:prstGeom prst="roundRect">
+            <a:avLst>
+              <a:gd name="adj" fmla="val 17391"/>
+            </a:avLst>
+          </a:prstGeom>
+          <a:solidFill>
+            <a:srgbClr val="0B7A6F"/>
+          </a:solidFill>
+          <a:ln w="12700">
+            <a:solidFill>
+              <a:srgbClr val="0B7A6F"/>
+            </a:solidFill>
+            <a:prstDash val="solid"/>
+          </a:ln>
+        </p:spPr>
+      </p:sp>
+      <p:sp>
+        <p:nvSpPr>
+          <p:cNvPr id="10" name="Text 7"/>
+          <p:cNvSpPr txBox="1"/>
+          <p:nvPr/>
+        </p:nvSpPr>
+        <p:spPr>
+          <a:xfrm>
+            <a:off x="3337560" y="1901952"/>
+            <a:ext cx="2468880" cy="420624"/>
+          </a:xfrm>
+          <a:prstGeom prst="rect">
+            <a:avLst/>
+          </a:prstGeom>
+          <a:noFill/>
+          <a:ln/>
+        </p:spPr>
+        <p:txBody>
+          <a:bodyPr wrap="square" lIns="0" tIns="0" rIns="0" bIns="0" rtlCol="0" anchor="ctr"/>
+          <a:lstStyle/>
+          <a:p>
+            <a:pPr algn="ctr" indent="0" marL="0">
+              <a:buNone/>
+            </a:pPr>
+            <a:r>
+              <a:rPr lang="en-US" sz="1000" b="1" dirty="0">
+                <a:solidFill>
+                  <a:srgbClr val="FFFFFF"/>
+                </a:solidFill>
+                <a:latin typeface="SF Pro Display" pitchFamily="34" charset="0"/>
+                <a:ea typeface="SF Pro Display" pitchFamily="34" charset="-122"/>
+                <a:cs typeface="SF Pro Display" pitchFamily="34" charset="-120"/>
+              </a:rPr>
+              <a:t>Check for Premium fee</a:t>
+            </a:r>
+            <a:endParaRPr lang="en-US" sz="1000" dirty="0"/>
+          </a:p>
+        </p:txBody>
+      </p:sp>
+      <p:sp>
+        <p:nvSpPr>
+          <p:cNvPr id="11" name="Shape 8"/>
+          <p:cNvSpPr/>
+          <p:nvPr/>
+        </p:nvSpPr>
+        <p:spPr>
+          <a:xfrm>
+            <a:off x="4572000" y="2322576"/>
+            <a:ext cx="0" cy="155448"/>
+          </a:xfrm>
+          <a:prstGeom prst="line">
+            <a:avLst/>
+          </a:prstGeom>
+          <a:noFill/>
+          <a:ln w="12700">
+            <a:solidFill>
+              <a:srgbClr val="6E6E73"/>
+            </a:solidFill>
+            <a:prstDash val="solid"/>
+            <a:tailEnd type="triangle"/>
+          </a:ln>
+        </p:spPr>
+      </p:sp>
+      <p:sp>
+        <p:nvSpPr>
+          <p:cNvPr id="12" name="Shape 9"/>
+          <p:cNvSpPr/>
+          <p:nvPr/>
+        </p:nvSpPr>
+        <p:spPr>
+          <a:xfrm>
+            <a:off x="3337560" y="2478024"/>
+            <a:ext cx="2468880" cy="420624"/>
+          </a:xfrm>
+          <a:prstGeom prst="roundRect">
+            <a:avLst>
+              <a:gd name="adj" fmla="val 17391"/>
+            </a:avLst>
+          </a:prstGeom>
+          <a:solidFill>
+            <a:srgbClr val="FFF3D6"/>
+          </a:solidFill>
+          <a:ln w="12700">
+            <a:solidFill>
+              <a:srgbClr val="9A6410"/>
+            </a:solidFill>
+            <a:prstDash val="solid"/>
+          </a:ln>
+        </p:spPr>
+      </p:sp>
+      <p:sp>
+        <p:nvSpPr>
+          <p:cNvPr id="13" name="Text 10"/>
+          <p:cNvSpPr txBox="1"/>
+          <p:nvPr/>
+        </p:nvSpPr>
+        <p:spPr>
+          <a:xfrm>
+            <a:off x="3337560" y="2478024"/>
+            <a:ext cx="2468880" cy="420624"/>
+          </a:xfrm>
+          <a:prstGeom prst="rect">
+            <a:avLst/>
+          </a:prstGeom>
+          <a:noFill/>
+          <a:ln/>
+        </p:spPr>
+        <p:txBody>
+          <a:bodyPr wrap="square" lIns="0" tIns="0" rIns="0" bIns="0" rtlCol="0" anchor="ctr"/>
+          <a:lstStyle/>
+          <a:p>
+            <a:pPr algn="ctr" indent="0" marL="0">
+              <a:buNone/>
+            </a:pPr>
+            <a:r>
+              <a:rPr lang="en-US" sz="1000" b="1" dirty="0">
+                <a:solidFill>
+                  <a:srgbClr val="9A6410"/>
+                </a:solidFill>
+                <a:latin typeface="SF Pro Display" pitchFamily="34" charset="0"/>
+                <a:ea typeface="SF Pro Display" pitchFamily="34" charset="-122"/>
+                <a:cs typeface="SF Pro Display" pitchFamily="34" charset="-120"/>
+              </a:rPr>
+              <a:t>Overcharged ≥ 30 min?</a:t>
+            </a:r>
+            <a:endParaRPr lang="en-US" sz="1000" dirty="0"/>
+          </a:p>
+        </p:txBody>
+      </p:sp>
+      <p:sp>
+        <p:nvSpPr>
+          <p:cNvPr id="14" name="Shape 11"/>
+          <p:cNvSpPr/>
+          <p:nvPr/>
+        </p:nvSpPr>
+        <p:spPr>
+          <a:xfrm>
+            <a:off x="4572000" y="2898648"/>
+            <a:ext cx="0" cy="228600"/>
+          </a:xfrm>
+          <a:prstGeom prst="line">
+            <a:avLst/>
+          </a:prstGeom>
+          <a:noFill/>
+          <a:ln w="12700">
+            <a:solidFill>
+              <a:srgbClr val="6E6E73"/>
+            </a:solidFill>
+            <a:prstDash val="solid"/>
+          </a:ln>
+        </p:spPr>
+      </p:sp>
+      <p:sp>
+        <p:nvSpPr>
+          <p:cNvPr id="15" name="Shape 12"/>
+          <p:cNvSpPr/>
+          <p:nvPr/>
+        </p:nvSpPr>
+        <p:spPr>
+          <a:xfrm>
+            <a:off x="2240280" y="3127248"/>
+            <a:ext cx="4663440" cy="0"/>
+          </a:xfrm>
+          <a:prstGeom prst="line">
+            <a:avLst/>
+          </a:prstGeom>
+          <a:noFill/>
+          <a:ln w="12700">
+            <a:solidFill>
+              <a:srgbClr val="6E6E73"/>
+            </a:solidFill>
+            <a:prstDash val="solid"/>
+          </a:ln>
+        </p:spPr>
+      </p:sp>
+      <p:sp>
+        <p:nvSpPr>
+          <p:cNvPr id="16" name="Shape 13"/>
+          <p:cNvSpPr/>
+          <p:nvPr/>
+        </p:nvSpPr>
+        <p:spPr>
+          <a:xfrm>
+            <a:off x="2240280" y="3127248"/>
+            <a:ext cx="0" cy="301752"/>
+          </a:xfrm>
+          <a:prstGeom prst="line">
+            <a:avLst/>
+          </a:prstGeom>
+          <a:noFill/>
+          <a:ln w="12700">
+            <a:solidFill>
+              <a:srgbClr val="6E6E73"/>
+            </a:solidFill>
+            <a:prstDash val="solid"/>
+            <a:tailEnd type="triangle"/>
+          </a:ln>
+        </p:spPr>
+      </p:sp>
+      <p:sp>
+        <p:nvSpPr>
+          <p:cNvPr id="17" name="Shape 14"/>
+          <p:cNvSpPr/>
+          <p:nvPr/>
+        </p:nvSpPr>
+        <p:spPr>
+          <a:xfrm>
+            <a:off x="6903720" y="3127248"/>
+            <a:ext cx="0" cy="301752"/>
+          </a:xfrm>
+          <a:prstGeom prst="line">
+            <a:avLst/>
+          </a:prstGeom>
+          <a:noFill/>
+          <a:ln w="12700">
+            <a:solidFill>
+              <a:srgbClr val="6E6E73"/>
+            </a:solidFill>
+            <a:prstDash val="solid"/>
+            <a:tailEnd type="triangle"/>
+          </a:ln>
+        </p:spPr>
+      </p:sp>
+      <p:sp>
+        <p:nvSpPr>
+          <p:cNvPr id="18" name="Text 15"/>
+          <p:cNvSpPr txBox="1"/>
+          <p:nvPr/>
+        </p:nvSpPr>
+        <p:spPr>
+          <a:xfrm>
+            <a:off x="2313432" y="3145536"/>
+            <a:ext cx="548640" cy="201168"/>
+          </a:xfrm>
+          <a:prstGeom prst="rect">
+            <a:avLst/>
+          </a:prstGeom>
+          <a:noFill/>
+          <a:ln/>
+        </p:spPr>
+        <p:txBody>
+          <a:bodyPr wrap="square" lIns="0" tIns="0" rIns="0" bIns="0" rtlCol="0" anchor="t"/>
+          <a:lstStyle/>
+          <a:p>
+            <a:pPr indent="0" marL="0">
+              <a:buNone/>
+            </a:pPr>
+            <a:r>
+              <a:rPr lang="en-US" sz="850" b="1" dirty="0">
+                <a:solidFill>
+                  <a:srgbClr val="6E6E73"/>
+                </a:solidFill>
+                <a:latin typeface="SF Pro Text" pitchFamily="34" charset="0"/>
+                <a:ea typeface="SF Pro Text" pitchFamily="34" charset="-122"/>
+                <a:cs typeface="SF Pro Text" pitchFamily="34" charset="-120"/>
+              </a:rPr>
+              <a:t>Yes</a:t>
+            </a:r>
+            <a:endParaRPr lang="en-US" sz="850" dirty="0"/>
+          </a:p>
+        </p:txBody>
+      </p:sp>
+      <p:sp>
+        <p:nvSpPr>
+          <p:cNvPr id="19" name="Text 16"/>
+          <p:cNvSpPr txBox="1"/>
+          <p:nvPr/>
+        </p:nvSpPr>
+        <p:spPr>
+          <a:xfrm>
+            <a:off x="6976872" y="3145536"/>
+            <a:ext cx="548640" cy="201168"/>
+          </a:xfrm>
+          <a:prstGeom prst="rect">
+            <a:avLst/>
+          </a:prstGeom>
+          <a:noFill/>
+          <a:ln/>
+        </p:spPr>
+        <p:txBody>
+          <a:bodyPr wrap="square" lIns="0" tIns="0" rIns="0" bIns="0" rtlCol="0" anchor="t"/>
+          <a:lstStyle/>
+          <a:p>
+            <a:pPr indent="0" marL="0">
+              <a:buNone/>
+            </a:pPr>
+            <a:r>
+              <a:rPr lang="en-US" sz="850" b="1" dirty="0">
+                <a:solidFill>
+                  <a:srgbClr val="6E6E73"/>
+                </a:solidFill>
+                <a:latin typeface="SF Pro Text" pitchFamily="34" charset="0"/>
+                <a:ea typeface="SF Pro Text" pitchFamily="34" charset="-122"/>
+                <a:cs typeface="SF Pro Text" pitchFamily="34" charset="-120"/>
+              </a:rPr>
+              <a:t>No</a:t>
+            </a:r>
+            <a:endParaRPr lang="en-US" sz="850" dirty="0"/>
+          </a:p>
+        </p:txBody>
+      </p:sp>
+      <p:sp>
+        <p:nvSpPr>
+          <p:cNvPr id="20" name="Shape 17"/>
+          <p:cNvSpPr/>
+          <p:nvPr/>
+        </p:nvSpPr>
+        <p:spPr>
+          <a:xfrm>
+            <a:off x="1005840" y="3429000"/>
+            <a:ext cx="2468880" cy="420624"/>
+          </a:xfrm>
+          <a:prstGeom prst="roundRect">
+            <a:avLst>
+              <a:gd name="adj" fmla="val 17391"/>
+            </a:avLst>
+          </a:prstGeom>
+          <a:solidFill>
+            <a:srgbClr val="1D1D1F"/>
+          </a:solidFill>
+          <a:ln w="12700">
+            <a:solidFill>
+              <a:srgbClr val="1D1D1F"/>
+            </a:solidFill>
+            <a:prstDash val="solid"/>
+          </a:ln>
+        </p:spPr>
+      </p:sp>
+      <p:sp>
+        <p:nvSpPr>
+          <p:cNvPr id="21" name="Text 18"/>
+          <p:cNvSpPr txBox="1"/>
+          <p:nvPr/>
+        </p:nvSpPr>
+        <p:spPr>
+          <a:xfrm>
+            <a:off x="1005840" y="3429000"/>
+            <a:ext cx="2468880" cy="420624"/>
+          </a:xfrm>
+          <a:prstGeom prst="rect">
+            <a:avLst/>
+          </a:prstGeom>
+          <a:noFill/>
+          <a:ln/>
+        </p:spPr>
+        <p:txBody>
+          <a:bodyPr wrap="square" lIns="0" tIns="0" rIns="0" bIns="0" rtlCol="0" anchor="ctr"/>
+          <a:lstStyle/>
+          <a:p>
+            <a:pPr algn="ctr" indent="0" marL="0">
+              <a:buNone/>
+            </a:pPr>
+            <a:r>
+              <a:rPr lang="en-US" sz="1000" b="1" dirty="0">
+                <a:solidFill>
+                  <a:srgbClr val="FFFFFF"/>
+                </a:solidFill>
+                <a:latin typeface="SF Pro Display" pitchFamily="34" charset="0"/>
+                <a:ea typeface="SF Pro Display" pitchFamily="34" charset="-122"/>
+                <a:cs typeface="SF Pro Display" pitchFamily="34" charset="-120"/>
+              </a:rPr>
+              <a:t>Flag, ban, penalize</a:t>
+            </a:r>
+            <a:endParaRPr lang="en-US" sz="1000" dirty="0"/>
+          </a:p>
+        </p:txBody>
+      </p:sp>
+      <p:sp>
+        <p:nvSpPr>
+          <p:cNvPr id="22" name="Shape 19"/>
+          <p:cNvSpPr/>
+          <p:nvPr/>
+        </p:nvSpPr>
+        <p:spPr>
+          <a:xfrm>
+            <a:off x="5669280" y="3429000"/>
+            <a:ext cx="2468880" cy="420624"/>
+          </a:xfrm>
+          <a:prstGeom prst="roundRect">
+            <a:avLst>
+              <a:gd name="adj" fmla="val 17391"/>
             </a:avLst>
           </a:prstGeom>
           <a:solidFill>
             <a:srgbClr val="FFFFFF"/>
           </a:solidFill>
-          <a:ln w="9525">
+          <a:ln w="12700">
             <a:solidFill>
               <a:srgbClr val="DCE1E7"/>
             </a:solidFill>
@@ -39997,39 +41042,14 @@
       </p:sp>
       <p:sp>
         <p:nvSpPr>
-          <p:cNvPr id="7" name="Shape 4"/>
-          <p:cNvSpPr/>
-          <p:nvPr/>
-        </p:nvSpPr>
-        <p:spPr>
-          <a:xfrm>
-            <a:off x="576072" y="1463040"/>
-            <a:ext cx="274320" cy="274320"/>
-          </a:xfrm>
-          <a:prstGeom prst="ellipse">
-            <a:avLst/>
-          </a:prstGeom>
-          <a:solidFill>
-            <a:srgbClr val="E3F4F1"/>
-          </a:solidFill>
-          <a:ln w="12700">
-            <a:solidFill>
-              <a:srgbClr val="E3F4F1"/>
-            </a:solidFill>
-            <a:prstDash val="solid"/>
-          </a:ln>
-        </p:spPr>
-      </p:sp>
-      <p:sp>
-        <p:nvSpPr>
-          <p:cNvPr id="8" name="Text 5"/>
-          <p:cNvSpPr txBox="1"/>
-          <p:nvPr/>
-        </p:nvSpPr>
-        <p:spPr>
-          <a:xfrm>
-            <a:off x="576072" y="1463040"/>
-            <a:ext cx="274320" cy="274320"/>
+          <p:cNvPr id="23" name="Text 20"/>
+          <p:cNvSpPr txBox="1"/>
+          <p:nvPr/>
+        </p:nvSpPr>
+        <p:spPr>
+          <a:xfrm>
+            <a:off x="5669280" y="3429000"/>
+            <a:ext cx="2468880" cy="420624"/>
           </a:xfrm>
           <a:prstGeom prst="rect">
             <a:avLst/>
@@ -40045,30 +41065,30 @@
               <a:buNone/>
             </a:pPr>
             <a:r>
-              <a:rPr lang="en-US" sz="900" b="1" dirty="0">
-                <a:solidFill>
-                  <a:srgbClr val="0B7A6F"/>
+              <a:rPr lang="en-US" sz="1000" b="1" dirty="0">
+                <a:solidFill>
+                  <a:srgbClr val="1D1D1F"/>
                 </a:solidFill>
                 <a:latin typeface="SF Pro Display" pitchFamily="34" charset="0"/>
                 <a:ea typeface="SF Pro Display" pitchFamily="34" charset="-122"/>
                 <a:cs typeface="SF Pro Display" pitchFamily="34" charset="-120"/>
               </a:rPr>
-              <a:t>1</a:t>
-            </a:r>
-            <a:endParaRPr lang="en-US" sz="900" dirty="0"/>
-          </a:p>
-        </p:txBody>
-      </p:sp>
-      <p:sp>
-        <p:nvSpPr>
-          <p:cNvPr id="9" name="Text 6"/>
-          <p:cNvSpPr txBox="1"/>
-          <p:nvPr/>
-        </p:nvSpPr>
-        <p:spPr>
-          <a:xfrm>
-            <a:off x="576072" y="1883664"/>
-            <a:ext cx="2353056" cy="274320"/>
+              <a:t>Ban the pairing</a:t>
+            </a:r>
+            <a:endParaRPr lang="en-US" sz="1000" dirty="0"/>
+          </a:p>
+        </p:txBody>
+      </p:sp>
+      <p:sp>
+        <p:nvSpPr>
+          <p:cNvPr id="24" name="Text 21"/>
+          <p:cNvSpPr txBox="1"/>
+          <p:nvPr/>
+        </p:nvSpPr>
+        <p:spPr>
+          <a:xfrm>
+            <a:off x="777240" y="3904488"/>
+            <a:ext cx="2926080" cy="411480"/>
           </a:xfrm>
           <a:prstGeom prst="rect">
             <a:avLst/>
@@ -40080,50 +41100,11 @@
           <a:bodyPr wrap="square" lIns="0" tIns="0" rIns="0" bIns="0" rtlCol="0" anchor="t"/>
           <a:lstStyle/>
           <a:p>
-            <a:pPr indent="0" marL="0">
-              <a:buNone/>
-            </a:pPr>
-            <a:r>
-              <a:rPr lang="en-US" sz="1200" b="1" dirty="0">
-                <a:solidFill>
-                  <a:srgbClr val="1D1D1F"/>
-                </a:solidFill>
-                <a:latin typeface="SF Pro Display" pitchFamily="34" charset="0"/>
-                <a:ea typeface="SF Pro Display" pitchFamily="34" charset="-122"/>
-                <a:cs typeface="SF Pro Display" pitchFamily="34" charset="-120"/>
-              </a:rPr>
-              <a:t>Refund the hours</a:t>
-            </a:r>
-            <a:endParaRPr lang="en-US" sz="1200" dirty="0"/>
-          </a:p>
-        </p:txBody>
-      </p:sp>
-      <p:sp>
-        <p:nvSpPr>
-          <p:cNvPr id="10" name="Text 7"/>
-          <p:cNvSpPr txBox="1"/>
-          <p:nvPr/>
-        </p:nvSpPr>
-        <p:spPr>
-          <a:xfrm>
-            <a:off x="576072" y="2176272"/>
-            <a:ext cx="2353056" cy="384048"/>
-          </a:xfrm>
-          <a:prstGeom prst="rect">
-            <a:avLst/>
-          </a:prstGeom>
-          <a:noFill/>
-          <a:ln/>
-        </p:spPr>
-        <p:txBody>
-          <a:bodyPr wrap="square" lIns="0" tIns="0" rIns="0" bIns="0" rtlCol="0" anchor="t"/>
-          <a:lstStyle/>
-          <a:p>
-            <a:pPr indent="0" marL="0">
-              <a:buNone/>
-            </a:pPr>
-            <a:r>
-              <a:rPr lang="en-US" sz="950" dirty="0">
+            <a:pPr algn="ctr" indent="0" marL="0">
+              <a:buNone/>
+            </a:pPr>
+            <a:r>
+              <a:rPr lang="en-US" sz="850" dirty="0">
                 <a:solidFill>
                   <a:srgbClr val="6E6E73"/>
                 </a:solidFill>
@@ -40131,168 +41112,38 @@
                 <a:ea typeface="SF Pro Text" pitchFamily="34" charset="-122"/>
                 <a:cs typeface="SF Pro Text" pitchFamily="34" charset="-120"/>
               </a:rPr>
-              <a:t>Via the CP Dashboard.</a:t>
-            </a:r>
-            <a:endParaRPr lang="en-US" sz="950" dirty="0"/>
-          </a:p>
-        </p:txBody>
-      </p:sp>
-      <p:sp>
-        <p:nvSpPr>
-          <p:cNvPr id="11" name="Shape 8"/>
-          <p:cNvSpPr/>
-          <p:nvPr/>
-        </p:nvSpPr>
-        <p:spPr>
-          <a:xfrm>
-            <a:off x="3230880" y="1280160"/>
-            <a:ext cx="2682240" cy="1371600"/>
-          </a:xfrm>
-          <a:prstGeom prst="roundRect">
-            <a:avLst>
-              <a:gd name="adj" fmla="val 5333"/>
-            </a:avLst>
-          </a:prstGeom>
-          <a:solidFill>
-            <a:srgbClr val="FFFFFF"/>
-          </a:solidFill>
-          <a:ln w="9525">
-            <a:solidFill>
-              <a:srgbClr val="DCE1E7"/>
-            </a:solidFill>
-            <a:prstDash val="solid"/>
-          </a:ln>
-        </p:spPr>
-      </p:sp>
-      <p:sp>
-        <p:nvSpPr>
-          <p:cNvPr id="12" name="Shape 9"/>
-          <p:cNvSpPr/>
-          <p:nvPr/>
-        </p:nvSpPr>
-        <p:spPr>
-          <a:xfrm>
-            <a:off x="3395472" y="1463040"/>
-            <a:ext cx="274320" cy="274320"/>
-          </a:xfrm>
-          <a:prstGeom prst="ellipse">
-            <a:avLst/>
-          </a:prstGeom>
-          <a:solidFill>
-            <a:srgbClr val="E3F4F1"/>
-          </a:solidFill>
-          <a:ln w="12700">
-            <a:solidFill>
-              <a:srgbClr val="E3F4F1"/>
-            </a:solidFill>
-            <a:prstDash val="solid"/>
-          </a:ln>
-        </p:spPr>
-      </p:sp>
-      <p:sp>
-        <p:nvSpPr>
-          <p:cNvPr id="13" name="Text 10"/>
-          <p:cNvSpPr txBox="1"/>
-          <p:nvPr/>
-        </p:nvSpPr>
-        <p:spPr>
-          <a:xfrm>
-            <a:off x="3395472" y="1463040"/>
-            <a:ext cx="274320" cy="274320"/>
-          </a:xfrm>
-          <a:prstGeom prst="rect">
-            <a:avLst/>
-          </a:prstGeom>
-          <a:noFill/>
-          <a:ln/>
-        </p:spPr>
-        <p:txBody>
-          <a:bodyPr wrap="square" lIns="0" tIns="0" rIns="0" bIns="0" rtlCol="0" anchor="ctr"/>
+              <a:t>cp_overcharged_hours flag, ban the pairing, comms to both → Penalty section</a:t>
+            </a:r>
+            <a:endParaRPr lang="en-US" sz="850" dirty="0"/>
+          </a:p>
+        </p:txBody>
+      </p:sp>
+      <p:sp>
+        <p:nvSpPr>
+          <p:cNvPr id="25" name="Text 22"/>
+          <p:cNvSpPr txBox="1"/>
+          <p:nvPr/>
+        </p:nvSpPr>
+        <p:spPr>
+          <a:xfrm>
+            <a:off x="5440680" y="3904488"/>
+            <a:ext cx="2926080" cy="411480"/>
+          </a:xfrm>
+          <a:prstGeom prst="rect">
+            <a:avLst/>
+          </a:prstGeom>
+          <a:noFill/>
+          <a:ln/>
+        </p:spPr>
+        <p:txBody>
+          <a:bodyPr wrap="square" lIns="0" tIns="0" rIns="0" bIns="0" rtlCol="0" anchor="t"/>
           <a:lstStyle/>
           <a:p>
             <a:pPr algn="ctr" indent="0" marL="0">
               <a:buNone/>
             </a:pPr>
             <a:r>
-              <a:rPr lang="en-US" sz="900" b="1" dirty="0">
-                <a:solidFill>
-                  <a:srgbClr val="0B7A6F"/>
-                </a:solidFill>
-                <a:latin typeface="SF Pro Display" pitchFamily="34" charset="0"/>
-                <a:ea typeface="SF Pro Display" pitchFamily="34" charset="-122"/>
-                <a:cs typeface="SF Pro Display" pitchFamily="34" charset="-120"/>
-              </a:rPr>
-              <a:t>2</a:t>
-            </a:r>
-            <a:endParaRPr lang="en-US" sz="900" dirty="0"/>
-          </a:p>
-        </p:txBody>
-      </p:sp>
-      <p:sp>
-        <p:nvSpPr>
-          <p:cNvPr id="14" name="Text 11"/>
-          <p:cNvSpPr txBox="1"/>
-          <p:nvPr/>
-        </p:nvSpPr>
-        <p:spPr>
-          <a:xfrm>
-            <a:off x="3395472" y="1883664"/>
-            <a:ext cx="2353056" cy="274320"/>
-          </a:xfrm>
-          <a:prstGeom prst="rect">
-            <a:avLst/>
-          </a:prstGeom>
-          <a:noFill/>
-          <a:ln/>
-        </p:spPr>
-        <p:txBody>
-          <a:bodyPr wrap="square" lIns="0" tIns="0" rIns="0" bIns="0" rtlCol="0" anchor="t"/>
-          <a:lstStyle/>
-          <a:p>
-            <a:pPr indent="0" marL="0">
-              <a:buNone/>
-            </a:pPr>
-            <a:r>
-              <a:rPr lang="en-US" sz="1200" b="1" dirty="0">
-                <a:solidFill>
-                  <a:srgbClr val="1D1D1F"/>
-                </a:solidFill>
-                <a:latin typeface="SF Pro Display" pitchFamily="34" charset="0"/>
-                <a:ea typeface="SF Pro Display" pitchFamily="34" charset="-122"/>
-                <a:cs typeface="SF Pro Display" pitchFamily="34" charset="-120"/>
-              </a:rPr>
-              <a:t>Refund Premium</a:t>
-            </a:r>
-            <a:endParaRPr lang="en-US" sz="1200" dirty="0"/>
-          </a:p>
-        </p:txBody>
-      </p:sp>
-      <p:sp>
-        <p:nvSpPr>
-          <p:cNvPr id="15" name="Text 12"/>
-          <p:cNvSpPr txBox="1"/>
-          <p:nvPr/>
-        </p:nvSpPr>
-        <p:spPr>
-          <a:xfrm>
-            <a:off x="3395472" y="2176272"/>
-            <a:ext cx="2353056" cy="384048"/>
-          </a:xfrm>
-          <a:prstGeom prst="rect">
-            <a:avLst/>
-          </a:prstGeom>
-          <a:noFill/>
-          <a:ln/>
-        </p:spPr>
-        <p:txBody>
-          <a:bodyPr wrap="square" lIns="0" tIns="0" rIns="0" bIns="0" rtlCol="0" anchor="t"/>
-          <a:lstStyle/>
-          <a:p>
-            <a:pPr indent="0" marL="0">
-              <a:buNone/>
-            </a:pPr>
-            <a:r>
-              <a:rPr lang="en-US" sz="950" dirty="0">
+              <a:rPr lang="en-US" sz="850" dirty="0">
                 <a:solidFill>
                   <a:srgbClr val="6E6E73"/>
                 </a:solidFill>
@@ -40300,486 +41151,9 @@
                 <a:ea typeface="SF Pro Text" pitchFamily="34" charset="-122"/>
                 <a:cs typeface="SF Pro Text" pitchFamily="34" charset="-120"/>
               </a:rPr>
-              <a:t>If charged. No separate request needed.</a:t>
-            </a:r>
-            <a:endParaRPr lang="en-US" sz="950" dirty="0"/>
-          </a:p>
-        </p:txBody>
-      </p:sp>
-      <p:sp>
-        <p:nvSpPr>
-          <p:cNvPr id="16" name="Shape 13"/>
-          <p:cNvSpPr/>
-          <p:nvPr/>
-        </p:nvSpPr>
-        <p:spPr>
-          <a:xfrm>
-            <a:off x="6050280" y="1280160"/>
-            <a:ext cx="2682240" cy="1371600"/>
-          </a:xfrm>
-          <a:prstGeom prst="roundRect">
-            <a:avLst>
-              <a:gd name="adj" fmla="val 5333"/>
-            </a:avLst>
-          </a:prstGeom>
-          <a:solidFill>
-            <a:srgbClr val="FFFFFF"/>
-          </a:solidFill>
-          <a:ln w="9525">
-            <a:solidFill>
-              <a:srgbClr val="DCE1E7"/>
-            </a:solidFill>
-            <a:prstDash val="solid"/>
-          </a:ln>
-        </p:spPr>
-      </p:sp>
-      <p:sp>
-        <p:nvSpPr>
-          <p:cNvPr id="17" name="Shape 14"/>
-          <p:cNvSpPr/>
-          <p:nvPr/>
-        </p:nvSpPr>
-        <p:spPr>
-          <a:xfrm>
-            <a:off x="6214872" y="1463040"/>
-            <a:ext cx="274320" cy="274320"/>
-          </a:xfrm>
-          <a:prstGeom prst="ellipse">
-            <a:avLst/>
-          </a:prstGeom>
-          <a:solidFill>
-            <a:srgbClr val="E3F4F1"/>
-          </a:solidFill>
-          <a:ln w="12700">
-            <a:solidFill>
-              <a:srgbClr val="E3F4F1"/>
-            </a:solidFill>
-            <a:prstDash val="solid"/>
-          </a:ln>
-        </p:spPr>
-      </p:sp>
-      <p:sp>
-        <p:nvSpPr>
-          <p:cNvPr id="18" name="Text 15"/>
-          <p:cNvSpPr txBox="1"/>
-          <p:nvPr/>
-        </p:nvSpPr>
-        <p:spPr>
-          <a:xfrm>
-            <a:off x="6214872" y="1463040"/>
-            <a:ext cx="274320" cy="274320"/>
-          </a:xfrm>
-          <a:prstGeom prst="rect">
-            <a:avLst/>
-          </a:prstGeom>
-          <a:noFill/>
-          <a:ln/>
-        </p:spPr>
-        <p:txBody>
-          <a:bodyPr wrap="square" lIns="0" tIns="0" rIns="0" bIns="0" rtlCol="0" anchor="ctr"/>
-          <a:lstStyle/>
-          <a:p>
-            <a:pPr algn="ctr" indent="0" marL="0">
-              <a:buNone/>
-            </a:pPr>
-            <a:r>
-              <a:rPr lang="en-US" sz="900" b="1" dirty="0">
-                <a:solidFill>
-                  <a:srgbClr val="0B7A6F"/>
-                </a:solidFill>
-                <a:latin typeface="SF Pro Display" pitchFamily="34" charset="0"/>
-                <a:ea typeface="SF Pro Display" pitchFamily="34" charset="-122"/>
-                <a:cs typeface="SF Pro Display" pitchFamily="34" charset="-120"/>
-              </a:rPr>
-              <a:t>3</a:t>
-            </a:r>
-            <a:endParaRPr lang="en-US" sz="900" dirty="0"/>
-          </a:p>
-        </p:txBody>
-      </p:sp>
-      <p:sp>
-        <p:nvSpPr>
-          <p:cNvPr id="19" name="Text 16"/>
-          <p:cNvSpPr txBox="1"/>
-          <p:nvPr/>
-        </p:nvSpPr>
-        <p:spPr>
-          <a:xfrm>
-            <a:off x="6214872" y="1883664"/>
-            <a:ext cx="2353056" cy="274320"/>
-          </a:xfrm>
-          <a:prstGeom prst="rect">
-            <a:avLst/>
-          </a:prstGeom>
-          <a:noFill/>
-          <a:ln/>
-        </p:spPr>
-        <p:txBody>
-          <a:bodyPr wrap="square" lIns="0" tIns="0" rIns="0" bIns="0" rtlCol="0" anchor="t"/>
-          <a:lstStyle/>
-          <a:p>
-            <a:pPr indent="0" marL="0">
-              <a:buNone/>
-            </a:pPr>
-            <a:r>
-              <a:rPr lang="en-US" sz="1200" b="1" dirty="0">
-                <a:solidFill>
-                  <a:srgbClr val="1D1D1F"/>
-                </a:solidFill>
-                <a:latin typeface="SF Pro Display" pitchFamily="34" charset="0"/>
-                <a:ea typeface="SF Pro Display" pitchFamily="34" charset="-122"/>
-                <a:cs typeface="SF Pro Display" pitchFamily="34" charset="-120"/>
-              </a:rPr>
-              <a:t>How much?</a:t>
-            </a:r>
-            <a:endParaRPr lang="en-US" sz="1200" dirty="0"/>
-          </a:p>
-        </p:txBody>
-      </p:sp>
-      <p:sp>
-        <p:nvSpPr>
-          <p:cNvPr id="20" name="Text 17"/>
-          <p:cNvSpPr txBox="1"/>
-          <p:nvPr/>
-        </p:nvSpPr>
-        <p:spPr>
-          <a:xfrm>
-            <a:off x="6214872" y="2176272"/>
-            <a:ext cx="2353056" cy="384048"/>
-          </a:xfrm>
-          <a:prstGeom prst="rect">
-            <a:avLst/>
-          </a:prstGeom>
-          <a:noFill/>
-          <a:ln/>
-        </p:spPr>
-        <p:txBody>
-          <a:bodyPr wrap="square" lIns="0" tIns="0" rIns="0" bIns="0" rtlCol="0" anchor="t"/>
-          <a:lstStyle/>
-          <a:p>
-            <a:pPr indent="0" marL="0">
-              <a:buNone/>
-            </a:pPr>
-            <a:r>
-              <a:rPr lang="en-US" sz="950" dirty="0">
-                <a:solidFill>
-                  <a:srgbClr val="6E6E73"/>
-                </a:solidFill>
-                <a:latin typeface="SF Pro Text" pitchFamily="34" charset="0"/>
-                <a:ea typeface="SF Pro Text" pitchFamily="34" charset="-122"/>
-                <a:cs typeface="SF Pro Text" pitchFamily="34" charset="-120"/>
-              </a:rPr>
-              <a:t>The 30-minute rule decides what's next.</a:t>
-            </a:r>
-            <a:endParaRPr lang="en-US" sz="950" dirty="0"/>
-          </a:p>
-        </p:txBody>
-      </p:sp>
-      <p:sp>
-        <p:nvSpPr>
-          <p:cNvPr id="21" name="Shape 18"/>
-          <p:cNvSpPr/>
-          <p:nvPr/>
-        </p:nvSpPr>
-        <p:spPr>
-          <a:xfrm>
-            <a:off x="411480" y="2788920"/>
-            <a:ext cx="4091940" cy="1417320"/>
-          </a:xfrm>
-          <a:prstGeom prst="roundRect">
-            <a:avLst>
-              <a:gd name="adj" fmla="val 5161"/>
-            </a:avLst>
-          </a:prstGeom>
-          <a:solidFill>
-            <a:srgbClr val="FFFFFF"/>
-          </a:solidFill>
-          <a:ln w="9525">
-            <a:solidFill>
-              <a:srgbClr val="DCE1E7"/>
-            </a:solidFill>
-            <a:prstDash val="solid"/>
-          </a:ln>
-        </p:spPr>
-      </p:sp>
-      <p:sp>
-        <p:nvSpPr>
-          <p:cNvPr id="22" name="Shape 19"/>
-          <p:cNvSpPr/>
-          <p:nvPr/>
-        </p:nvSpPr>
-        <p:spPr>
-          <a:xfrm>
-            <a:off x="576072" y="2953512"/>
-            <a:ext cx="329184" cy="329184"/>
-          </a:xfrm>
-          <a:prstGeom prst="ellipse">
-            <a:avLst/>
-          </a:prstGeom>
-          <a:solidFill>
-            <a:srgbClr val="E3F4F1"/>
-          </a:solidFill>
-          <a:ln w="12700">
-            <a:solidFill>
-              <a:srgbClr val="E3F4F1"/>
-            </a:solidFill>
-            <a:prstDash val="solid"/>
-          </a:ln>
-        </p:spPr>
-      </p:sp>
-      <p:pic>
-        <p:nvPicPr>
-          <p:cNvPr id="23" name="Image 0" descr="preencoded.png">    </p:cNvPr>
-          <p:cNvPicPr>
-            <a:picLocks noChangeAspect="1"/>
-          </p:cNvPicPr>
-          <p:nvPr/>
-        </p:nvPicPr>
-        <p:blipFill>
-          <a:blip r:embed="rId1"/>
-          <a:stretch>
-            <a:fillRect/>
-          </a:stretch>
-        </p:blipFill>
-        <p:spPr>
-          <a:xfrm>
-            <a:off x="655076" y="3032516"/>
-            <a:ext cx="171176" cy="171176"/>
-          </a:xfrm>
-          <a:prstGeom prst="rect">
-            <a:avLst/>
-          </a:prstGeom>
-        </p:spPr>
-      </p:pic>
-      <p:sp>
-        <p:nvSpPr>
-          <p:cNvPr id="24" name="Text 20"/>
-          <p:cNvSpPr txBox="1"/>
-          <p:nvPr/>
-        </p:nvSpPr>
-        <p:spPr>
-          <a:xfrm>
-            <a:off x="576072" y="3392424"/>
-            <a:ext cx="3762756" cy="274320"/>
-          </a:xfrm>
-          <a:prstGeom prst="rect">
-            <a:avLst/>
-          </a:prstGeom>
-          <a:noFill/>
-          <a:ln/>
-        </p:spPr>
-        <p:txBody>
-          <a:bodyPr wrap="square" lIns="0" tIns="0" rIns="0" bIns="0" rtlCol="0" anchor="t"/>
-          <a:lstStyle/>
-          <a:p>
-            <a:pPr indent="0" marL="0">
-              <a:buNone/>
-            </a:pPr>
-            <a:r>
-              <a:rPr lang="en-US" sz="1200" b="1" dirty="0">
-                <a:solidFill>
-                  <a:srgbClr val="1D1D1F"/>
-                </a:solidFill>
-                <a:latin typeface="SF Pro Display" pitchFamily="34" charset="0"/>
-                <a:ea typeface="SF Pro Display" pitchFamily="34" charset="-122"/>
-                <a:cs typeface="SF Pro Display" pitchFamily="34" charset="-120"/>
-              </a:rPr>
-              <a:t>30 min or more</a:t>
-            </a:r>
-            <a:endParaRPr lang="en-US" sz="1200" dirty="0"/>
-          </a:p>
-        </p:txBody>
-      </p:sp>
-      <p:sp>
-        <p:nvSpPr>
-          <p:cNvPr id="25" name="Text 21"/>
-          <p:cNvSpPr txBox="1"/>
-          <p:nvPr/>
-        </p:nvSpPr>
-        <p:spPr>
-          <a:xfrm>
-            <a:off x="576072" y="3685032"/>
-            <a:ext cx="3762756" cy="429768"/>
-          </a:xfrm>
-          <a:prstGeom prst="rect">
-            <a:avLst/>
-          </a:prstGeom>
-          <a:noFill/>
-          <a:ln/>
-        </p:spPr>
-        <p:txBody>
-          <a:bodyPr wrap="square" lIns="0" tIns="0" rIns="0" bIns="0" rtlCol="0" anchor="t"/>
-          <a:lstStyle/>
-          <a:p>
-            <a:pPr indent="0" marL="0">
-              <a:buNone/>
-            </a:pPr>
-            <a:r>
-              <a:rPr lang="en-US" sz="950" dirty="0">
-                <a:solidFill>
-                  <a:srgbClr val="6E6E73"/>
-                </a:solidFill>
-                <a:latin typeface="SF Pro Text" pitchFamily="34" charset="0"/>
-                <a:ea typeface="SF Pro Text" pitchFamily="34" charset="-122"/>
-                <a:cs typeface="SF Pro Text" pitchFamily="34" charset="-120"/>
-              </a:rPr>
-              <a:t>cp_overcharged_hours flag, ban the pairing, comms to both, then the Penalty section.</a:t>
-            </a:r>
-            <a:endParaRPr lang="en-US" sz="950" dirty="0"/>
-          </a:p>
-        </p:txBody>
-      </p:sp>
-      <p:sp>
-        <p:nvSpPr>
-          <p:cNvPr id="26" name="Shape 22"/>
-          <p:cNvSpPr/>
-          <p:nvPr/>
-        </p:nvSpPr>
-        <p:spPr>
-          <a:xfrm>
-            <a:off x="4640580" y="2788920"/>
-            <a:ext cx="4091940" cy="1417320"/>
-          </a:xfrm>
-          <a:prstGeom prst="roundRect">
-            <a:avLst>
-              <a:gd name="adj" fmla="val 5161"/>
-            </a:avLst>
-          </a:prstGeom>
-          <a:solidFill>
-            <a:srgbClr val="FFFFFF"/>
-          </a:solidFill>
-          <a:ln w="9525">
-            <a:solidFill>
-              <a:srgbClr val="DCE1E7"/>
-            </a:solidFill>
-            <a:prstDash val="solid"/>
-          </a:ln>
-        </p:spPr>
-      </p:sp>
-      <p:sp>
-        <p:nvSpPr>
-          <p:cNvPr id="27" name="Shape 23"/>
-          <p:cNvSpPr/>
-          <p:nvPr/>
-        </p:nvSpPr>
-        <p:spPr>
-          <a:xfrm>
-            <a:off x="4805172" y="2953512"/>
-            <a:ext cx="329184" cy="329184"/>
-          </a:xfrm>
-          <a:prstGeom prst="ellipse">
-            <a:avLst/>
-          </a:prstGeom>
-          <a:solidFill>
-            <a:srgbClr val="E3F4F1"/>
-          </a:solidFill>
-          <a:ln w="12700">
-            <a:solidFill>
-              <a:srgbClr val="E3F4F1"/>
-            </a:solidFill>
-            <a:prstDash val="solid"/>
-          </a:ln>
-        </p:spPr>
-      </p:sp>
-      <p:pic>
-        <p:nvPicPr>
-          <p:cNvPr id="28" name="Image 1" descr="preencoded.png">    </p:cNvPr>
-          <p:cNvPicPr>
-            <a:picLocks noChangeAspect="1"/>
-          </p:cNvPicPr>
-          <p:nvPr/>
-        </p:nvPicPr>
-        <p:blipFill>
-          <a:blip r:embed="rId2"/>
-          <a:stretch>
-            <a:fillRect/>
-          </a:stretch>
-        </p:blipFill>
-        <p:spPr>
-          <a:xfrm>
-            <a:off x="4884176" y="3032516"/>
-            <a:ext cx="171176" cy="171176"/>
-          </a:xfrm>
-          <a:prstGeom prst="rect">
-            <a:avLst/>
-          </a:prstGeom>
-        </p:spPr>
-      </p:pic>
-      <p:sp>
-        <p:nvSpPr>
-          <p:cNvPr id="29" name="Text 24"/>
-          <p:cNvSpPr txBox="1"/>
-          <p:nvPr/>
-        </p:nvSpPr>
-        <p:spPr>
-          <a:xfrm>
-            <a:off x="4805172" y="3392424"/>
-            <a:ext cx="3762756" cy="274320"/>
-          </a:xfrm>
-          <a:prstGeom prst="rect">
-            <a:avLst/>
-          </a:prstGeom>
-          <a:noFill/>
-          <a:ln/>
-        </p:spPr>
-        <p:txBody>
-          <a:bodyPr wrap="square" lIns="0" tIns="0" rIns="0" bIns="0" rtlCol="0" anchor="t"/>
-          <a:lstStyle/>
-          <a:p>
-            <a:pPr indent="0" marL="0">
-              <a:buNone/>
-            </a:pPr>
-            <a:r>
-              <a:rPr lang="en-US" sz="1200" b="1" dirty="0">
-                <a:solidFill>
-                  <a:srgbClr val="1D1D1F"/>
-                </a:solidFill>
-                <a:latin typeface="SF Pro Display" pitchFamily="34" charset="0"/>
-                <a:ea typeface="SF Pro Display" pitchFamily="34" charset="-122"/>
-                <a:cs typeface="SF Pro Display" pitchFamily="34" charset="-120"/>
-              </a:rPr>
-              <a:t>Under 30 min</a:t>
-            </a:r>
-            <a:endParaRPr lang="en-US" sz="1200" dirty="0"/>
-          </a:p>
-        </p:txBody>
-      </p:sp>
-      <p:sp>
-        <p:nvSpPr>
-          <p:cNvPr id="30" name="Text 25"/>
-          <p:cNvSpPr txBox="1"/>
-          <p:nvPr/>
-        </p:nvSpPr>
-        <p:spPr>
-          <a:xfrm>
-            <a:off x="4805172" y="3685032"/>
-            <a:ext cx="3762756" cy="429768"/>
-          </a:xfrm>
-          <a:prstGeom prst="rect">
-            <a:avLst/>
-          </a:prstGeom>
-          <a:noFill/>
-          <a:ln/>
-        </p:spPr>
-        <p:txBody>
-          <a:bodyPr wrap="square" lIns="0" tIns="0" rIns="0" bIns="0" rtlCol="0" anchor="t"/>
-          <a:lstStyle/>
-          <a:p>
-            <a:pPr indent="0" marL="0">
-              <a:buNone/>
-            </a:pPr>
-            <a:r>
-              <a:rPr lang="en-US" sz="950" dirty="0">
-                <a:solidFill>
-                  <a:srgbClr val="6E6E73"/>
-                </a:solidFill>
-                <a:latin typeface="SF Pro Text" pitchFamily="34" charset="0"/>
-                <a:ea typeface="SF Pro Text" pitchFamily="34" charset="-122"/>
-                <a:cs typeface="SF Pro Text" pitchFamily="34" charset="-120"/>
-              </a:rPr>
-              <a:t>Ban the pairing, comms to both. Done: no flag, no penalty.</a:t>
-            </a:r>
-            <a:endParaRPr lang="en-US" sz="950" dirty="0"/>
+              <a:t>Comms to both. Done: no flag, no penalty.</a:t>
+            </a:r>
+            <a:endParaRPr lang="en-US" sz="850" dirty="0"/>
           </a:p>
         </p:txBody>
       </p:sp>

</xml_diff>

<commit_message>
OCH: Timed Reminder format on Branch B, specific related-scenario descriptions; carry over Google edits
Co-Authored-By: Claude Opus 5.5 <noreply@anthropic.com>
Claude-Session: https://claude.ai/code/session_01FEzv8wwqWDgTsXP8Yz6XYn
</commit_message>
<xml_diff>
--- a/billing-disputes/billing-disputes-cash-payments.pptx
+++ b/billing-disputes/billing-disputes-cash-payments.pptx
@@ -631,7 +631,7 @@
           <a:p>
             <a:r>
               <a:rPr lang="en-US" dirty="0"/>
-              <a:t>If the overcharge amount isn't known yet, ask the customer for detail first (B1). Is the CP suspended + DNR due to multiple overcharged hours? Yes: skip documentation and treat it as valid: go to Branch A from step 1. No: request documentation. Refund the Premium Upsell fee if charged; create a 72-hour Timed Reminder on the C side; tell the customer we'll follow up in 4-5 business days and the CP is blocked from their future requests (not penalized yet); block the pairing and tell the CP documentation is due within 3 days or the alleged hours will be refunded on their behalf. When the reminder triggers: valid proof from the CP: no refund (confirm the CP stays blocked from this customer). No or insufficient proof: refund the alleged hours via the CP Dashboard, check/refund Premium, log to the Ticket Tracker, then the penalty check. TRAINER: click (or press the right arrow) to open the penalty check. 30 minutes or more overcharged: add the cp_overcharged_hours flag + norequests + the Overcharged Hours macro series. Under 30 minutes: no flag, no penalty + the Overcharged Hours macro series.</a:t>
+              <a:t>If the overcharge amount isn't known yet, ask the customer for detail first (B1). Is the CP suspended + DNR due to multiple overcharged hours? Yes: skip documentation and treat it as valid: go to Branch A from step 1. No: request documentation. Refund the Premium Upsell fee if charged; create a 72-hour Timed Reminder on the C side; tell the customer we'll follow up in 4-5 business days and the CP is blocked from their future requests (not penalized yet); block the pairing and tell the CP documentation is due within 3 days or the alleged hours will be refunded on their behalf. When the reminder triggers: valid proof from the CP: no refund (confirm the CP stays blocked from this customer). No or insufficient proof: refund the alleged hours via the CP Dashboard, check/refund Premium, log to the Ticket Tracker, then the penalty check. Timed Reminder format: Action On: 72 hours from the time of ticket handling. Who Should Act: Any CS. Action: C &lt;C_ID&gt; reported that CP overcharged J &lt;JOB_ID&gt; for &lt;# OF OVERCHARGED HOURS&gt;. Follow When the Timed Reminder Triggers. TRAINER DEMO: show trainees how to add a Timed Reminder in the Legacy C CRM (Do &gt; TimedReminder &gt; Create): set it 72 hours out, assign Any CS, and paste the Action text with the real C ID, job ID and hours. TRAINER: click (or press the right arrow) to open the penalty check. 30 minutes or more overcharged: add the cp_overcharged_hours flag + norequests + the Overcharged Hours macro series. Under 30 minutes: no flag, no penalty + the Overcharged Hours macro series.</a:t>
             </a:r>
             <a:endParaRPr lang="en-US" dirty="0"/>
           </a:p>
@@ -6059,18 +6059,283 @@
       </p:sp>
       <p:sp>
         <p:nvSpPr>
-          <p:cNvPr id="31" name="step1Panel"/>
+          <p:cNvPr id="31" name="Shape 28"/>
           <p:cNvSpPr/>
           <p:nvPr/>
         </p:nvSpPr>
         <p:spPr>
           <a:xfrm>
-            <a:off x="5349240" y="2852928"/>
-            <a:ext cx="3383280" cy="1691640"/>
+            <a:off x="4434840" y="2724912"/>
+            <a:ext cx="4297680" cy="1207008"/>
           </a:xfrm>
           <a:prstGeom prst="roundRect">
             <a:avLst>
-              <a:gd name="adj" fmla="val 3243"/>
+              <a:gd name="adj" fmla="val 6061"/>
+            </a:avLst>
+          </a:prstGeom>
+          <a:solidFill>
+            <a:srgbClr val="FFFFFF"/>
+          </a:solidFill>
+          <a:ln w="9525">
+            <a:solidFill>
+              <a:srgbClr val="DCE1E7"/>
+            </a:solidFill>
+            <a:prstDash val="solid"/>
+          </a:ln>
+        </p:spPr>
+      </p:sp>
+      <p:sp>
+        <p:nvSpPr>
+          <p:cNvPr id="32" name="Text 29"/>
+          <p:cNvSpPr txBox="1"/>
+          <p:nvPr/>
+        </p:nvSpPr>
+        <p:spPr>
+          <a:xfrm>
+            <a:off x="4572000" y="2770632"/>
+            <a:ext cx="2743200" cy="256032"/>
+          </a:xfrm>
+          <a:prstGeom prst="rect">
+            <a:avLst/>
+          </a:prstGeom>
+          <a:noFill/>
+          <a:ln/>
+        </p:spPr>
+        <p:txBody>
+          <a:bodyPr wrap="square" lIns="0" tIns="0" rIns="0" bIns="0" rtlCol="0" anchor="ctr"/>
+          <a:lstStyle/>
+          <a:p>
+            <a:pPr indent="0" marL="0">
+              <a:buNone/>
+            </a:pPr>
+            <a:r>
+              <a:rPr lang="en-US" sz="1000" b="1" dirty="0">
+                <a:solidFill>
+                  <a:srgbClr val="0B7A6F"/>
+                </a:solidFill>
+                <a:latin typeface="SF Pro Display" pitchFamily="34" charset="0"/>
+                <a:ea typeface="SF Pro Display" pitchFamily="34" charset="-122"/>
+                <a:cs typeface="SF Pro Display" pitchFamily="34" charset="-120"/>
+              </a:rPr>
+              <a:t>Timed Reminder format</a:t>
+            </a:r>
+            <a:endParaRPr lang="en-US" sz="1000" dirty="0"/>
+          </a:p>
+        </p:txBody>
+      </p:sp>
+      <p:sp>
+        <p:nvSpPr>
+          <p:cNvPr id="33" name="Shape 30"/>
+          <p:cNvSpPr/>
+          <p:nvPr/>
+        </p:nvSpPr>
+        <p:spPr>
+          <a:xfrm>
+            <a:off x="7635240" y="2798064"/>
+            <a:ext cx="1005840" cy="219456"/>
+          </a:xfrm>
+          <a:prstGeom prst="roundRect">
+            <a:avLst>
+              <a:gd name="adj" fmla="val 33333"/>
+            </a:avLst>
+          </a:prstGeom>
+          <a:solidFill>
+            <a:srgbClr val="FFF3D6"/>
+          </a:solidFill>
+          <a:ln w="9525">
+            <a:solidFill>
+              <a:srgbClr val="FFF3D6"/>
+            </a:solidFill>
+            <a:prstDash val="solid"/>
+          </a:ln>
+        </p:spPr>
+      </p:sp>
+      <p:sp>
+        <p:nvSpPr>
+          <p:cNvPr id="34" name="Text 31"/>
+          <p:cNvSpPr txBox="1"/>
+          <p:nvPr/>
+        </p:nvSpPr>
+        <p:spPr>
+          <a:xfrm>
+            <a:off x="7635240" y="2798064"/>
+            <a:ext cx="1005840" cy="219456"/>
+          </a:xfrm>
+          <a:prstGeom prst="rect">
+            <a:avLst/>
+          </a:prstGeom>
+          <a:noFill/>
+          <a:ln/>
+        </p:spPr>
+        <p:txBody>
+          <a:bodyPr wrap="square" lIns="0" tIns="0" rIns="0" bIns="0" rtlCol="0" anchor="ctr"/>
+          <a:lstStyle/>
+          <a:p>
+            <a:pPr algn="ctr" indent="0" marL="0">
+              <a:buNone/>
+            </a:pPr>
+            <a:r>
+              <a:rPr lang="en-US" sz="750" b="1" dirty="0">
+                <a:solidFill>
+                  <a:srgbClr val="9A6410"/>
+                </a:solidFill>
+                <a:latin typeface="SF Pro Text" pitchFamily="34" charset="0"/>
+                <a:ea typeface="SF Pro Text" pitchFamily="34" charset="-122"/>
+                <a:cs typeface="SF Pro Text" pitchFamily="34" charset="-120"/>
+              </a:rPr>
+              <a:t>Trainer demo</a:t>
+            </a:r>
+            <a:endParaRPr lang="en-US" sz="750" dirty="0"/>
+          </a:p>
+        </p:txBody>
+      </p:sp>
+      <p:sp>
+        <p:nvSpPr>
+          <p:cNvPr id="35" name="Text 32"/>
+          <p:cNvSpPr txBox="1"/>
+          <p:nvPr/>
+        </p:nvSpPr>
+        <p:spPr>
+          <a:xfrm>
+            <a:off x="4572000" y="3044952"/>
+            <a:ext cx="4069080" cy="804672"/>
+          </a:xfrm>
+          <a:prstGeom prst="rect">
+            <a:avLst/>
+          </a:prstGeom>
+          <a:noFill/>
+          <a:ln/>
+        </p:spPr>
+        <p:txBody>
+          <a:bodyPr wrap="square" lIns="0" tIns="0" rIns="0" bIns="0" rtlCol="0" anchor="t"/>
+          <a:lstStyle/>
+          <a:p>
+            <a:pPr indent="0" marL="0">
+              <a:spcAft>
+                <a:spcPts val="200"/>
+              </a:spcAft>
+              <a:buNone/>
+            </a:pPr>
+            <a:r>
+              <a:rPr lang="en-US" sz="850" b="1" dirty="0">
+                <a:solidFill>
+                  <a:srgbClr val="1D1D1F"/>
+                </a:solidFill>
+                <a:latin typeface="SF Pro Text" pitchFamily="34" charset="0"/>
+                <a:ea typeface="SF Pro Text" pitchFamily="34" charset="-122"/>
+                <a:cs typeface="SF Pro Text" pitchFamily="34" charset="-120"/>
+              </a:rPr>
+              <a:t>Action On  </a:t>
+            </a:r>
+            <a:pPr indent="0" marL="0">
+              <a:spcAft>
+                <a:spcPts val="200"/>
+              </a:spcAft>
+              <a:buNone/>
+            </a:pPr>
+            <a:r>
+              <a:rPr lang="en-US" sz="850" dirty="0">
+                <a:solidFill>
+                  <a:srgbClr val="6E6E73"/>
+                </a:solidFill>
+                <a:latin typeface="SF Pro Text" pitchFamily="34" charset="0"/>
+                <a:ea typeface="SF Pro Text" pitchFamily="34" charset="-122"/>
+                <a:cs typeface="SF Pro Text" pitchFamily="34" charset="-120"/>
+              </a:rPr>
+              <a:t>72 hours from the time of ticket handling</a:t>
+            </a:r>
+            <a:endParaRPr lang="en-US" sz="850" dirty="0"/>
+          </a:p>
+          <a:p>
+            <a:pPr indent="0" marL="0">
+              <a:spcAft>
+                <a:spcPts val="200"/>
+              </a:spcAft>
+              <a:buNone/>
+            </a:pPr>
+            <a:r>
+              <a:rPr lang="en-US" sz="850" b="1" dirty="0">
+                <a:solidFill>
+                  <a:srgbClr val="1D1D1F"/>
+                </a:solidFill>
+                <a:latin typeface="SF Pro Text" pitchFamily="34" charset="0"/>
+                <a:ea typeface="SF Pro Text" pitchFamily="34" charset="-122"/>
+                <a:cs typeface="SF Pro Text" pitchFamily="34" charset="-120"/>
+              </a:rPr>
+              <a:t>Who Should Act  </a:t>
+            </a:r>
+            <a:pPr indent="0" marL="0">
+              <a:spcAft>
+                <a:spcPts val="200"/>
+              </a:spcAft>
+              <a:buNone/>
+            </a:pPr>
+            <a:r>
+              <a:rPr lang="en-US" sz="850" dirty="0">
+                <a:solidFill>
+                  <a:srgbClr val="6E6E73"/>
+                </a:solidFill>
+                <a:latin typeface="SF Pro Text" pitchFamily="34" charset="0"/>
+                <a:ea typeface="SF Pro Text" pitchFamily="34" charset="-122"/>
+                <a:cs typeface="SF Pro Text" pitchFamily="34" charset="-120"/>
+              </a:rPr>
+              <a:t>Any CS</a:t>
+            </a:r>
+            <a:endParaRPr lang="en-US" sz="850" dirty="0"/>
+          </a:p>
+          <a:p>
+            <a:pPr indent="0" marL="0">
+              <a:spcAft>
+                <a:spcPts val="200"/>
+              </a:spcAft>
+              <a:buNone/>
+            </a:pPr>
+            <a:r>
+              <a:rPr lang="en-US" sz="850" b="1" dirty="0">
+                <a:solidFill>
+                  <a:srgbClr val="1D1D1F"/>
+                </a:solidFill>
+                <a:latin typeface="SF Pro Text" pitchFamily="34" charset="0"/>
+                <a:ea typeface="SF Pro Text" pitchFamily="34" charset="-122"/>
+                <a:cs typeface="SF Pro Text" pitchFamily="34" charset="-120"/>
+              </a:rPr>
+              <a:t>Action  </a:t>
+            </a:r>
+            <a:pPr indent="0" marL="0">
+              <a:spcAft>
+                <a:spcPts val="200"/>
+              </a:spcAft>
+              <a:buNone/>
+            </a:pPr>
+            <a:r>
+              <a:rPr lang="en-US" sz="850" dirty="0">
+                <a:solidFill>
+                  <a:srgbClr val="6E6E73"/>
+                </a:solidFill>
+                <a:latin typeface="SF Pro Text" pitchFamily="34" charset="0"/>
+                <a:ea typeface="SF Pro Text" pitchFamily="34" charset="-122"/>
+                <a:cs typeface="SF Pro Text" pitchFamily="34" charset="-120"/>
+              </a:rPr>
+              <a:t>C &lt;C_ID&gt; reported that CP overcharged J &lt;JOB_ID&gt; for &lt;# OF OVERCHARGED HOURS&gt;</a:t>
+            </a:r>
+            <a:endParaRPr lang="en-US" sz="850" dirty="0"/>
+          </a:p>
+        </p:txBody>
+      </p:sp>
+      <p:sp>
+        <p:nvSpPr>
+          <p:cNvPr id="36" name="step1Panel"/>
+          <p:cNvSpPr/>
+          <p:nvPr/>
+        </p:nvSpPr>
+        <p:spPr>
+          <a:xfrm>
+            <a:off x="4434840" y="2724912"/>
+            <a:ext cx="4297680" cy="1207008"/>
+          </a:xfrm>
+          <a:prstGeom prst="roundRect">
+            <a:avLst>
+              <a:gd name="adj" fmla="val 4545"/>
             </a:avLst>
           </a:prstGeom>
           <a:solidFill>
@@ -6093,14 +6358,14 @@
       </p:sp>
       <p:sp>
         <p:nvSpPr>
-          <p:cNvPr id="32" name="step1Head"/>
+          <p:cNvPr id="37" name="step1Head"/>
           <p:cNvSpPr/>
           <p:nvPr/>
         </p:nvSpPr>
         <p:spPr>
           <a:xfrm>
-            <a:off x="5349240" y="2852928"/>
-            <a:ext cx="3383280" cy="347472"/>
+            <a:off x="4434840" y="2724912"/>
+            <a:ext cx="4297680" cy="292608"/>
           </a:xfrm>
           <a:prstGeom prst="rect">
             <a:avLst/>
@@ -6118,14 +6383,14 @@
       </p:sp>
       <p:sp>
         <p:nvSpPr>
-          <p:cNvPr id="33" name="step1Title"/>
-          <p:cNvSpPr txBox="1"/>
-          <p:nvPr/>
-        </p:nvSpPr>
-        <p:spPr>
-          <a:xfrm>
-            <a:off x="5486400" y="2852928"/>
-            <a:ext cx="3108960" cy="347472"/>
+          <p:cNvPr id="38" name="step1Title"/>
+          <p:cNvSpPr txBox="1"/>
+          <p:nvPr/>
+        </p:nvSpPr>
+        <p:spPr>
+          <a:xfrm>
+            <a:off x="4572000" y="2724912"/>
+            <a:ext cx="4023360" cy="292608"/>
           </a:xfrm>
           <a:prstGeom prst="rect">
             <a:avLst/>
@@ -6141,7 +6406,7 @@
               <a:buNone/>
             </a:pPr>
             <a:r>
-              <a:rPr lang="en-US" sz="1100" b="1" dirty="0">
+              <a:rPr lang="en-US" sz="1050" b="1" dirty="0">
                 <a:solidFill>
                   <a:srgbClr val="FFFFFF"/>
                 </a:solidFill>
@@ -6151,20 +6416,20 @@
               </a:rPr>
               <a:t>Penalty check</a:t>
             </a:r>
-            <a:endParaRPr lang="en-US" sz="1100" dirty="0"/>
-          </a:p>
-        </p:txBody>
-      </p:sp>
-      <p:sp>
-        <p:nvSpPr>
-          <p:cNvPr id="34" name="step1Body"/>
-          <p:cNvSpPr txBox="1"/>
-          <p:nvPr/>
-        </p:nvSpPr>
-        <p:spPr>
-          <a:xfrm>
-            <a:off x="5486400" y="3246120"/>
-            <a:ext cx="3154680" cy="1261872"/>
+            <a:endParaRPr lang="en-US" sz="1050" dirty="0"/>
+          </a:p>
+        </p:txBody>
+      </p:sp>
+      <p:sp>
+        <p:nvSpPr>
+          <p:cNvPr id="39" name="step1Body"/>
+          <p:cNvSpPr txBox="1"/>
+          <p:nvPr/>
+        </p:nvSpPr>
+        <p:spPr>
+          <a:xfrm>
+            <a:off x="4572000" y="3072384"/>
+            <a:ext cx="4069080" cy="822960"/>
           </a:xfrm>
           <a:prstGeom prst="rect">
             <a:avLst/>
@@ -6178,7 +6443,7 @@
           <a:p>
             <a:pPr indent="0" marL="0">
               <a:spcAft>
-                <a:spcPts val="300"/>
+                <a:spcPts val="500"/>
               </a:spcAft>
               <a:buNone/>
             </a:pPr>
@@ -6191,14 +6456,11 @@
                 <a:ea typeface="SF Pro Text" pitchFamily="34" charset="-122"/>
                 <a:cs typeface="SF Pro Text" pitchFamily="34" charset="-120"/>
               </a:rPr>
-              <a:t>≥ 30 minutes overcharged</a:t>
-            </a:r>
-            <a:endParaRPr lang="en-US" sz="900" dirty="0"/>
-          </a:p>
-          <a:p>
+              <a:t>≥ 30 minutes overcharged:  </a:t>
+            </a:r>
             <a:pPr indent="0" marL="0">
               <a:spcAft>
-                <a:spcPts val="300"/>
+                <a:spcPts val="500"/>
               </a:spcAft>
               <a:buNone/>
             </a:pPr>
@@ -6211,14 +6473,14 @@
                 <a:ea typeface="SF Pro Text" pitchFamily="34" charset="-122"/>
                 <a:cs typeface="SF Pro Text" pitchFamily="34" charset="-120"/>
               </a:rPr>
-              <a:t>Add flag cp_overcharged_hours + norequests + the Overcharged Hours macro series.</a:t>
+              <a:t>add flag cp_overcharged_hours + norequests + the Overcharged Hours macro series.</a:t>
             </a:r>
             <a:endParaRPr lang="en-US" sz="900" dirty="0"/>
           </a:p>
           <a:p>
             <a:pPr indent="0" marL="0">
               <a:spcAft>
-                <a:spcPts val="300"/>
+                <a:spcPts val="500"/>
               </a:spcAft>
               <a:buNone/>
             </a:pPr>
@@ -6231,14 +6493,11 @@
                 <a:ea typeface="SF Pro Text" pitchFamily="34" charset="-122"/>
                 <a:cs typeface="SF Pro Text" pitchFamily="34" charset="-120"/>
               </a:rPr>
-              <a:t>&lt; 30 minutes overcharged</a:t>
-            </a:r>
-            <a:endParaRPr lang="en-US" sz="900" dirty="0"/>
-          </a:p>
-          <a:p>
+              <a:t>&lt; 30 minutes overcharged:  </a:t>
+            </a:r>
             <a:pPr indent="0" marL="0">
               <a:spcAft>
-                <a:spcPts val="300"/>
+                <a:spcPts val="500"/>
               </a:spcAft>
               <a:buNone/>
             </a:pPr>
@@ -6251,7 +6510,7 @@
                 <a:ea typeface="SF Pro Text" pitchFamily="34" charset="-122"/>
                 <a:cs typeface="SF Pro Text" pitchFamily="34" charset="-120"/>
               </a:rPr>
-              <a:t>No flag, no penalty + the Overcharged Hours macro series.</a:t>
+              <a:t>no flag, no penalty + the Overcharged Hours macro series.</a:t>
             </a:r>
             <a:endParaRPr lang="en-US" sz="900" dirty="0"/>
           </a:p>
@@ -6344,7 +6603,7 @@
                                           </p:stCondLst>
                                         </p:cTn>
                                         <p:tgtEl>
-                                          <p:spTgt spid="31"/>
+                                          <p:spTgt spid="36"/>
                                         </p:tgtEl>
                                         <p:attrNameLst>
                                           <p:attrName>style.visibility</p:attrName>
@@ -6358,7 +6617,7 @@
                                       <p:cBhvr>
                                         <p:cTn id="7" dur="600"/>
                                         <p:tgtEl>
-                                          <p:spTgt spid="31"/>
+                                          <p:spTgt spid="36"/>
                                         </p:tgtEl>
                                       </p:cBhvr>
                                     </p:animEffect>
@@ -6379,7 +6638,7 @@
                                           </p:stCondLst>
                                         </p:cTn>
                                         <p:tgtEl>
-                                          <p:spTgt spid="32"/>
+                                          <p:spTgt spid="37"/>
                                         </p:tgtEl>
                                         <p:attrNameLst>
                                           <p:attrName>style.visibility</p:attrName>
@@ -6393,7 +6652,7 @@
                                       <p:cBhvr>
                                         <p:cTn id="10" dur="600"/>
                                         <p:tgtEl>
-                                          <p:spTgt spid="32"/>
+                                          <p:spTgt spid="37"/>
                                         </p:tgtEl>
                                       </p:cBhvr>
                                     </p:animEffect>
@@ -6414,7 +6673,7 @@
                                           </p:stCondLst>
                                         </p:cTn>
                                         <p:tgtEl>
-                                          <p:spTgt spid="33"/>
+                                          <p:spTgt spid="38"/>
                                         </p:tgtEl>
                                         <p:attrNameLst>
                                           <p:attrName>style.visibility</p:attrName>
@@ -6428,7 +6687,7 @@
                                       <p:cBhvr>
                                         <p:cTn id="13" dur="600"/>
                                         <p:tgtEl>
-                                          <p:spTgt spid="33"/>
+                                          <p:spTgt spid="38"/>
                                         </p:tgtEl>
                                       </p:cBhvr>
                                     </p:animEffect>
@@ -6449,7 +6708,7 @@
                                           </p:stCondLst>
                                         </p:cTn>
                                         <p:tgtEl>
-                                          <p:spTgt spid="34"/>
+                                          <p:spTgt spid="39"/>
                                         </p:tgtEl>
                                         <p:attrNameLst>
                                           <p:attrName>style.visibility</p:attrName>
@@ -6463,7 +6722,7 @@
                                       <p:cBhvr>
                                         <p:cTn id="16" dur="600"/>
                                         <p:tgtEl>
-                                          <p:spTgt spid="34"/>
+                                          <p:spTgt spid="39"/>
                                         </p:tgtEl>
                                       </p:cBhvr>
                                     </p:animEffect>
@@ -6498,10 +6757,10 @@
       </p:par>
     </p:tnLst>
     <p:bldLst>
-      <p:bldP spid="31" grpId="0" animBg="1"/>
-      <p:bldP spid="32" grpId="0" animBg="1"/>
-      <p:bldP spid="33" grpId="0" animBg="1"/>
-      <p:bldP spid="34" grpId="0" animBg="1"/>
+      <p:bldP spid="36" grpId="0" animBg="1"/>
+      <p:bldP spid="37" grpId="0" animBg="1"/>
+      <p:bldP spid="38" grpId="0" animBg="1"/>
+      <p:bldP spid="39" grpId="0" animBg="1"/>
     </p:bldLst>
   </p:timing>
 </p:sld>
@@ -9088,12 +9347,12 @@
         </p:nvSpPr>
         <p:spPr>
           <a:xfrm>
-            <a:off x="411480" y="1280160"/>
-            <a:ext cx="2682240" cy="2194560"/>
+            <a:off x="411480" y="1188720"/>
+            <a:ext cx="2682240" cy="3429000"/>
           </a:xfrm>
           <a:prstGeom prst="roundRect">
             <a:avLst>
-              <a:gd name="adj" fmla="val 3333"/>
+              <a:gd name="adj" fmla="val 2727"/>
             </a:avLst>
           </a:prstGeom>
           <a:solidFill>
@@ -9115,7 +9374,7 @@
         </p:nvSpPr>
         <p:spPr>
           <a:xfrm>
-            <a:off x="576072" y="1444752"/>
+            <a:off x="576072" y="1353312"/>
             <a:ext cx="329184" cy="329184"/>
           </a:xfrm>
           <a:prstGeom prst="ellipse">
@@ -9148,7 +9407,7 @@
         </p:blipFill>
         <p:spPr>
           <a:xfrm>
-            <a:off x="655076" y="1523756"/>
+            <a:off x="655076" y="1432316"/>
             <a:ext cx="171176" cy="171176"/>
           </a:xfrm>
           <a:prstGeom prst="rect">
@@ -9164,7 +9423,7 @@
         </p:nvSpPr>
         <p:spPr>
           <a:xfrm>
-            <a:off x="576072" y="1883664"/>
+            <a:off x="576072" y="1792224"/>
             <a:ext cx="2353056" cy="274320"/>
           </a:xfrm>
           <a:prstGeom prst="rect">
@@ -9189,7 +9448,7 @@
                 <a:ea typeface="SF Pro Display" pitchFamily="34" charset="-122"/>
                 <a:cs typeface="SF Pro Display" pitchFamily="34" charset="-120"/>
               </a:rPr>
-              <a:t>Helper, full charge</a:t>
+              <a:t>Helper, half the time</a:t>
             </a:r>
             <a:endParaRPr lang="en-US" sz="1200" dirty="0"/>
           </a:p>
@@ -9203,8 +9462,8 @@
         </p:nvSpPr>
         <p:spPr>
           <a:xfrm>
-            <a:off x="576072" y="2176272"/>
-            <a:ext cx="2353056" cy="1207008"/>
+            <a:off x="576072" y="2084832"/>
+            <a:ext cx="2353056" cy="2441448"/>
           </a:xfrm>
           <a:prstGeom prst="rect">
             <a:avLst/>
@@ -9228,7 +9487,69 @@
                 <a:ea typeface="SF Pro Text" pitchFamily="34" charset="-122"/>
                 <a:cs typeface="SF Pro Text" pitchFamily="34" charset="-120"/>
               </a:rPr>
-              <a:t>Customer authorized it? No penalty. If not: Branch B, and coach the cleaner.</a:t>
+              <a:t>The cleaner brought a helper, worked half the duration, and charged in full.</a:t>
+            </a:r>
+            <a:endParaRPr lang="en-US" sz="950" dirty="0"/>
+          </a:p>
+          <a:p>
+            <a:pPr indent="0" marL="0">
+              <a:buNone/>
+            </a:pPr>
+            <a:r>
+              <a:rPr lang="en-US" sz="950" b="1" dirty="0">
+                <a:solidFill>
+                  <a:srgbClr val="1D1D1F"/>
+                </a:solidFill>
+                <a:latin typeface="SF Pro Text" pitchFamily="34" charset="0"/>
+                <a:ea typeface="SF Pro Text" pitchFamily="34" charset="-122"/>
+                <a:cs typeface="SF Pro Text" pitchFamily="34" charset="-120"/>
+              </a:rPr>
+              <a:t>Customer authorized it: </a:t>
+            </a:r>
+            <a:pPr indent="0" marL="0">
+              <a:buNone/>
+            </a:pPr>
+            <a:r>
+              <a:rPr lang="en-US" sz="950" dirty="0">
+                <a:solidFill>
+                  <a:srgbClr val="6E6E73"/>
+                </a:solidFill>
+                <a:latin typeface="SF Pro Text" pitchFamily="34" charset="0"/>
+                <a:ea typeface="SF Pro Text" pitchFamily="34" charset="-122"/>
+                <a:cs typeface="SF Pro Text" pitchFamily="34" charset="-120"/>
+              </a:rPr>
+              <a:t>tell them records show they did, address other pain points. Don't penalize the cleaner.</a:t>
+            </a:r>
+            <a:endParaRPr lang="en-US" sz="950" dirty="0"/>
+          </a:p>
+          <a:p>
+            <a:pPr indent="0" marL="0">
+              <a:buNone/>
+            </a:pPr>
+            <a:r>
+              <a:rPr lang="en-US" sz="950" b="1" dirty="0">
+                <a:solidFill>
+                  <a:srgbClr val="1D1D1F"/>
+                </a:solidFill>
+                <a:latin typeface="SF Pro Text" pitchFamily="34" charset="0"/>
+                <a:ea typeface="SF Pro Text" pitchFamily="34" charset="-122"/>
+                <a:cs typeface="SF Pro Text" pitchFamily="34" charset="-120"/>
+              </a:rPr>
+              <a:t>Not authorized: </a:t>
+            </a:r>
+            <a:pPr indent="0" marL="0">
+              <a:buNone/>
+            </a:pPr>
+            <a:r>
+              <a:rPr lang="en-US" sz="950" dirty="0">
+                <a:solidFill>
+                  <a:srgbClr val="6E6E73"/>
+                </a:solidFill>
+                <a:latin typeface="SF Pro Text" pitchFamily="34" charset="0"/>
+                <a:ea typeface="SF Pro Text" pitchFamily="34" charset="-122"/>
+                <a:cs typeface="SF Pro Text" pitchFamily="34" charset="-120"/>
+              </a:rPr>
+              <a:t>go to Branch B and request documentation. Coach that helpers need permission and can't justify full-rate billing.</a:t>
             </a:r>
             <a:endParaRPr lang="en-US" sz="950" dirty="0"/>
           </a:p>
@@ -9242,12 +9563,12 @@
         </p:nvSpPr>
         <p:spPr>
           <a:xfrm>
-            <a:off x="3230880" y="1280160"/>
-            <a:ext cx="2682240" cy="2194560"/>
+            <a:off x="3230880" y="1188720"/>
+            <a:ext cx="2682240" cy="3429000"/>
           </a:xfrm>
           <a:prstGeom prst="roundRect">
             <a:avLst>
-              <a:gd name="adj" fmla="val 3333"/>
+              <a:gd name="adj" fmla="val 2727"/>
             </a:avLst>
           </a:prstGeom>
           <a:solidFill>
@@ -9269,7 +9590,7 @@
         </p:nvSpPr>
         <p:spPr>
           <a:xfrm>
-            <a:off x="3395472" y="1444752"/>
+            <a:off x="3395472" y="1353312"/>
             <a:ext cx="329184" cy="329184"/>
           </a:xfrm>
           <a:prstGeom prst="ellipse">
@@ -9302,7 +9623,7 @@
         </p:blipFill>
         <p:spPr>
           <a:xfrm>
-            <a:off x="3474476" y="1523756"/>
+            <a:off x="3474476" y="1432316"/>
             <a:ext cx="171176" cy="171176"/>
           </a:xfrm>
           <a:prstGeom prst="rect">
@@ -9318,7 +9639,7 @@
         </p:nvSpPr>
         <p:spPr>
           <a:xfrm>
-            <a:off x="3395472" y="1883664"/>
+            <a:off x="3395472" y="1792224"/>
             <a:ext cx="2353056" cy="274320"/>
           </a:xfrm>
           <a:prstGeom prst="rect">
@@ -9357,8 +9678,8 @@
         </p:nvSpPr>
         <p:spPr>
           <a:xfrm>
-            <a:off x="3395472" y="2176272"/>
-            <a:ext cx="2353056" cy="1207008"/>
+            <a:off x="3395472" y="2084832"/>
+            <a:ext cx="2353056" cy="2441448"/>
           </a:xfrm>
           <a:prstGeom prst="rect">
             <a:avLst/>
@@ -9382,7 +9703,86 @@
                 <a:ea typeface="SF Pro Text" pitchFamily="34" charset="-122"/>
                 <a:cs typeface="SF Pro Text" pitchFamily="34" charset="-120"/>
               </a:rPr>
-              <a:t>Treat it as confirmation. 30 min or more still gets the flag.</a:t>
+              <a:t>The cleaner refunds after being told about the report.</a:t>
+            </a:r>
+            <a:endParaRPr lang="en-US" sz="950" dirty="0"/>
+          </a:p>
+          <a:p>
+            <a:pPr indent="0" marL="0">
+              <a:buNone/>
+            </a:pPr>
+            <a:r>
+              <a:rPr lang="en-US" sz="950" dirty="0">
+                <a:solidFill>
+                  <a:srgbClr val="6E6E73"/>
+                </a:solidFill>
+                <a:latin typeface="SF Pro Text" pitchFamily="34" charset="0"/>
+                <a:ea typeface="SF Pro Text" pitchFamily="34" charset="-122"/>
+                <a:cs typeface="SF Pro Text" pitchFamily="34" charset="-120"/>
+              </a:rPr>
+              <a:t>Treat the refund as confirmation the overcharge happened, unless evidence proves otherwise.</a:t>
+            </a:r>
+            <a:endParaRPr lang="en-US" sz="950" dirty="0"/>
+          </a:p>
+          <a:p>
+            <a:pPr indent="0" marL="0">
+              <a:buNone/>
+            </a:pPr>
+            <a:r>
+              <a:rPr lang="en-US" sz="950" b="1" dirty="0">
+                <a:solidFill>
+                  <a:srgbClr val="1D1D1F"/>
+                </a:solidFill>
+                <a:latin typeface="SF Pro Text" pitchFamily="34" charset="0"/>
+                <a:ea typeface="SF Pro Text" pitchFamily="34" charset="-122"/>
+                <a:cs typeface="SF Pro Text" pitchFamily="34" charset="-120"/>
+              </a:rPr>
+              <a:t>30 min or more: </a:t>
+            </a:r>
+            <a:pPr indent="0" marL="0">
+              <a:buNone/>
+            </a:pPr>
+            <a:r>
+              <a:rPr lang="en-US" sz="950" dirty="0">
+                <a:solidFill>
+                  <a:srgbClr val="6E6E73"/>
+                </a:solidFill>
+                <a:latin typeface="SF Pro Text" pitchFamily="34" charset="0"/>
+                <a:ea typeface="SF Pro Text" pitchFamily="34" charset="-122"/>
+                <a:cs typeface="SF Pro Text" pitchFamily="34" charset="-120"/>
+              </a:rPr>
+              <a:t>still apply the cp_overcharged_hours flag.</a:t>
+            </a:r>
+            <a:endParaRPr lang="en-US" sz="950" dirty="0"/>
+          </a:p>
+          <a:p>
+            <a:pPr indent="0" marL="0">
+              <a:buNone/>
+            </a:pPr>
+            <a:r>
+              <a:rPr lang="en-US" sz="950" b="1" dirty="0">
+                <a:solidFill>
+                  <a:srgbClr val="1D1D1F"/>
+                </a:solidFill>
+                <a:latin typeface="SF Pro Text" pitchFamily="34" charset="0"/>
+                <a:ea typeface="SF Pro Text" pitchFamily="34" charset="-122"/>
+                <a:cs typeface="SF Pro Text" pitchFamily="34" charset="-120"/>
+              </a:rPr>
+              <a:t>Before the first-response Timed Reminder triggers: </a:t>
+            </a:r>
+            <a:pPr indent="0" marL="0">
+              <a:buNone/>
+            </a:pPr>
+            <a:r>
+              <a:rPr lang="en-US" sz="950" dirty="0">
+                <a:solidFill>
+                  <a:srgbClr val="6E6E73"/>
+                </a:solidFill>
+                <a:latin typeface="SF Pro Text" pitchFamily="34" charset="0"/>
+                <a:ea typeface="SF Pro Text" pitchFamily="34" charset="-122"/>
+                <a:cs typeface="SF Pro Text" pitchFamily="34" charset="-120"/>
+              </a:rPr>
+              <a:t>invalidate that reminder. Tell the customer the cleaner refunded.</a:t>
             </a:r>
             <a:endParaRPr lang="en-US" sz="950" dirty="0"/>
           </a:p>
@@ -9396,12 +9796,12 @@
         </p:nvSpPr>
         <p:spPr>
           <a:xfrm>
-            <a:off x="6050280" y="1280160"/>
-            <a:ext cx="2682240" cy="2194560"/>
+            <a:off x="6050280" y="1188720"/>
+            <a:ext cx="2682240" cy="3429000"/>
           </a:xfrm>
           <a:prstGeom prst="roundRect">
             <a:avLst>
-              <a:gd name="adj" fmla="val 3333"/>
+              <a:gd name="adj" fmla="val 2727"/>
             </a:avLst>
           </a:prstGeom>
           <a:solidFill>
@@ -9423,7 +9823,7 @@
         </p:nvSpPr>
         <p:spPr>
           <a:xfrm>
-            <a:off x="6214872" y="1444752"/>
+            <a:off x="6214872" y="1353312"/>
             <a:ext cx="329184" cy="329184"/>
           </a:xfrm>
           <a:prstGeom prst="ellipse">
@@ -9456,7 +9856,7 @@
         </p:blipFill>
         <p:spPr>
           <a:xfrm>
-            <a:off x="6293876" y="1523756"/>
+            <a:off x="6293876" y="1432316"/>
             <a:ext cx="171176" cy="171176"/>
           </a:xfrm>
           <a:prstGeom prst="rect">
@@ -9472,7 +9872,7 @@
         </p:nvSpPr>
         <p:spPr>
           <a:xfrm>
-            <a:off x="6214872" y="1883664"/>
+            <a:off x="6214872" y="1792224"/>
             <a:ext cx="2353056" cy="274320"/>
           </a:xfrm>
           <a:prstGeom prst="rect">
@@ -9511,8 +9911,8 @@
         </p:nvSpPr>
         <p:spPr>
           <a:xfrm>
-            <a:off x="6214872" y="2176272"/>
-            <a:ext cx="2353056" cy="1207008"/>
+            <a:off x="6214872" y="2084832"/>
+            <a:ext cx="2353056" cy="2441448"/>
           </a:xfrm>
           <a:prstGeom prst="rect">
             <a:avLst/>
@@ -9536,7 +9936,69 @@
                 <a:ea typeface="SF Pro Text" pitchFamily="34" charset="-122"/>
                 <a:cs typeface="SF Pro Text" pitchFamily="34" charset="-120"/>
               </a:rPr>
-              <a:t>Reach out proactively to confirm the hours worked.</a:t>
+              <a:t>A job looks overcharged, but the customer hasn't contacted us.</a:t>
+            </a:r>
+            <a:endParaRPr lang="en-US" sz="950" dirty="0"/>
+          </a:p>
+          <a:p>
+            <a:pPr indent="0" marL="0">
+              <a:buNone/>
+            </a:pPr>
+            <a:r>
+              <a:rPr lang="en-US" sz="950" b="1" dirty="0">
+                <a:solidFill>
+                  <a:srgbClr val="1D1D1F"/>
+                </a:solidFill>
+                <a:latin typeface="SF Pro Text" pitchFamily="34" charset="0"/>
+                <a:ea typeface="SF Pro Text" pitchFamily="34" charset="-122"/>
+                <a:cs typeface="SF Pro Text" pitchFamily="34" charset="-120"/>
+              </a:rPr>
+              <a:t>Don't wait: </a:t>
+            </a:r>
+            <a:pPr indent="0" marL="0">
+              <a:buNone/>
+            </a:pPr>
+            <a:r>
+              <a:rPr lang="en-US" sz="950" dirty="0">
+                <a:solidFill>
+                  <a:srgbClr val="6E6E73"/>
+                </a:solidFill>
+                <a:latin typeface="SF Pro Text" pitchFamily="34" charset="0"/>
+                <a:ea typeface="SF Pro Text" pitchFamily="34" charset="-122"/>
+                <a:cs typeface="SF Pro Text" pitchFamily="34" charset="-120"/>
+              </a:rPr>
+              <a:t>reach out to check how the cleaning went and confirm the number of hours worked.</a:t>
+            </a:r>
+            <a:endParaRPr lang="en-US" sz="950" dirty="0"/>
+          </a:p>
+          <a:p>
+            <a:pPr indent="0" marL="0">
+              <a:buNone/>
+            </a:pPr>
+            <a:r>
+              <a:rPr lang="en-US" sz="950" b="1" dirty="0">
+                <a:solidFill>
+                  <a:srgbClr val="1D1D1F"/>
+                </a:solidFill>
+                <a:latin typeface="SF Pro Text" pitchFamily="34" charset="0"/>
+                <a:ea typeface="SF Pro Text" pitchFamily="34" charset="-122"/>
+                <a:cs typeface="SF Pro Text" pitchFamily="34" charset="-120"/>
+              </a:rPr>
+              <a:t>Why: </a:t>
+            </a:r>
+            <a:pPr indent="0" marL="0">
+              <a:buNone/>
+            </a:pPr>
+            <a:r>
+              <a:rPr lang="en-US" sz="950" dirty="0">
+                <a:solidFill>
+                  <a:srgbClr val="6E6E73"/>
+                </a:solidFill>
+                <a:latin typeface="SF Pro Text" pitchFamily="34" charset="0"/>
+                <a:ea typeface="SF Pro Text" pitchFamily="34" charset="-122"/>
+                <a:cs typeface="SF Pro Text" pitchFamily="34" charset="-120"/>
+              </a:rPr>
+              <a:t>it builds trust and catches the discrepancy before it becomes a dispute.</a:t>
             </a:r>
             <a:endParaRPr lang="en-US" sz="950" dirty="0"/>
           </a:p>
@@ -11298,7 +11760,7 @@
                 <a:ea typeface="SF Pro Text" pitchFamily="34" charset="-122"/>
                 <a:cs typeface="SF Pro Text" pitchFamily="34" charset="-120"/>
               </a:rPr>
-              <a:t>No. Refund the difference. The customer entered the hours, so there's no penalty for the cleaner.</a:t>
+              <a:t>No. Just refund the difference. The customer billed the hours, so this is not the cleaner’s fault.</a:t>
             </a:r>
             <a:endParaRPr lang="en-US" sz="900" dirty="0"/>
           </a:p>
@@ -38852,23 +39314,6 @@
             </a:r>
             <a:endParaRPr lang="en-US" sz="1150" dirty="0"/>
           </a:p>
-          <a:p>
-            <a:pPr indent="0" marL="0">
-              <a:buNone/>
-            </a:pPr>
-            <a:r>
-              <a:rPr lang="en-US" sz="850" dirty="0">
-                <a:solidFill>
-                  <a:srgbClr val="FFFFFF"/>
-                </a:solidFill>
-                <a:latin typeface="SF Pro Text" pitchFamily="34" charset="0"/>
-                <a:ea typeface="SF Pro Text" pitchFamily="34" charset="-122"/>
-                <a:cs typeface="SF Pro Text" pitchFamily="34" charset="-120"/>
-              </a:rPr>
-              <a:t>Refund, check for a Premium fee, then the 30-minute rule.</a:t>
-            </a:r>
-            <a:endParaRPr lang="en-US" sz="1150" dirty="0"/>
-          </a:p>
         </p:txBody>
       </p:sp>
       <p:graphicFrame>
@@ -39789,24 +40234,7 @@
                 <a:ea typeface="SF Pro Display" pitchFamily="34" charset="-122"/>
                 <a:cs typeface="SF Pro Display" pitchFamily="34" charset="-120"/>
               </a:rPr>
-              <a:t>Branch B: no clear evidence present</a:t>
-            </a:r>
-            <a:endParaRPr lang="en-US" sz="1150" dirty="0"/>
-          </a:p>
-          <a:p>
-            <a:pPr indent="0" marL="0">
-              <a:buNone/>
-            </a:pPr>
-            <a:r>
-              <a:rPr lang="en-US" sz="850" dirty="0">
-                <a:solidFill>
-                  <a:srgbClr val="FFFFFF"/>
-                </a:solidFill>
-                <a:latin typeface="SF Pro Text" pitchFamily="34" charset="0"/>
-                <a:ea typeface="SF Pro Text" pitchFamily="34" charset="-122"/>
-                <a:cs typeface="SF Pro Text" pitchFamily="34" charset="-120"/>
-              </a:rPr>
-              <a:t>Request documentation, then wait for the Timed Reminder.</a:t>
+              <a:t>Branch B: no clear evidence</a:t>
             </a:r>
             <a:endParaRPr lang="en-US" sz="1150" dirty="0"/>
           </a:p>
@@ -41112,7 +41540,7 @@
                 <a:ea typeface="SF Pro Text" pitchFamily="34" charset="-122"/>
                 <a:cs typeface="SF Pro Text" pitchFamily="34" charset="-120"/>
               </a:rPr>
-              <a:t>cp_overcharged_hours flag, ban the pairing, comms to both → Penalty section</a:t>
+              <a:t>cp_overcharged_hours flag  → norequests status  → ban the pairing  → send comms to C &amp; CP</a:t>
             </a:r>
             <a:endParaRPr lang="en-US" sz="850" dirty="0"/>
           </a:p>

</xml_diff>

<commit_message>
Unauthorized Hours: process and helper scenario as flowcharts; drop helper card from OCH scenarios
Co-Authored-By: Claude Opus 5.5 <noreply@anthropic.com>
Claude-Session: https://claude.ai/code/session_01FEzv8wwqWDgTsXP8Yz6XYn
</commit_message>
<xml_diff>
--- a/billing-disputes/billing-disputes-cash-payments.pptx
+++ b/billing-disputes/billing-disputes-cash-payments.pptx
@@ -983,7 +983,7 @@
           <a:p>
             <a:r>
               <a:rPr lang="en-US" dirty="0"/>
-              <a:t>Cleaner brought a helper, worked half the duration, charged in full: if the customer authorized it, tell them records show they did, address other pain points, don't penalize. If not, go to Branch B: request documentation and coach that helpers need permission and can't justify full-rate billing. Cleaner refunds after being notified: treat the refund as a sign the overcharge happened unless evidence proves otherwise; if 30 minutes or more, still apply the flag (a voluntary refund confirms the violation, it doesn't erase it); if it happens before the first-response Timed Reminder triggers, invalidate that reminder; tell the customer the cleaner refunded. Spotted a likely overcharge before the customer reported it? Reach out proactively. Sample: "Just checking in to see how your recent cleaning with &lt;&lt;Cleaner Name&gt;&gt; on &lt;&lt;Date&gt;&gt; went. We also wanted to quickly confirm the number of hours worked during the visit, just to make sure everything looks right on your end. Let us know if you have any questions or if anything seems off - we're happy to help!"</a:t>
+              <a:t>Cleaner refunds after being notified: treat the refund as a sign the overcharge happened unless evidence proves otherwise; if 30 minutes or more, still apply the flag (a voluntary refund confirms the violation, it doesn't erase it); if it happens before the first-response Timed Reminder triggers, invalidate that reminder; tell the customer the cleaner refunded. Spotted a likely overcharge before the customer reported it? Reach out proactively. Sample: "Just checking in to see how your recent cleaning with &lt;&lt;Cleaner Name&gt;&gt; on &lt;&lt;Date&gt;&gt; went. We also wanted to quickly confirm the number of hours worked during the visit, just to make sure everything looks right on your end. Let us know if you have any questions or if anything seems off - we're happy to help!"</a:t>
             </a:r>
             <a:endParaRPr lang="en-US" dirty="0"/>
           </a:p>
@@ -1775,7 +1775,7 @@
           <a:p>
             <a:r>
               <a:rPr lang="en-US" dirty="0"/>
-              <a:t>Is there evidence the customer authorized the helper and the reduced hours? Yes: tell the customer records show they authorized it, address other pain points, don't penalize the cleaner. No: follow the main flow: request documentation from the cleaner and coach that helpers require permission and can't justify full-rate billing. If the cleaner's document wasn't just weak but faked, stop and go to AG - Fraud &gt; CP Document Fraud.</a:t>
+              <a:t>This is the one real fork in this topic. Example: the customer booked 4 hours; the CP arrived with a helper, the two of them finished in 2 hours, and the CP invoiced the full 4 hours. Ask: is there evidence the customer authorized the helper and the reduced hours (for example, a message where the customer agreed)? Yes: advise the customer that records show they authorized it; address other pain points; do not penalize the CP. No: follow the main flow: refund the unauthorized hours, request documentation from the CP (3 days), and coach that helpers require permission and can't justify full-rate billing. If the CP's document wasn't just weak but faked, stop and go to AG - Fraud &gt; CP Document Fraud: invalid evidence means the claim fails; faked evidence is a separate offence with a separate outcome.</a:t>
             </a:r>
             <a:endParaRPr lang="en-US" dirty="0"/>
           </a:p>
@@ -9348,11 +9348,11 @@
         <p:spPr>
           <a:xfrm>
             <a:off x="411480" y="1188720"/>
-            <a:ext cx="2682240" cy="3429000"/>
+            <a:ext cx="4091940" cy="2743200"/>
           </a:xfrm>
           <a:prstGeom prst="roundRect">
             <a:avLst>
-              <a:gd name="adj" fmla="val 2727"/>
+              <a:gd name="adj" fmla="val 2667"/>
             </a:avLst>
           </a:prstGeom>
           <a:solidFill>
@@ -9424,7 +9424,7 @@
         <p:spPr>
           <a:xfrm>
             <a:off x="576072" y="1792224"/>
-            <a:ext cx="2353056" cy="274320"/>
+            <a:ext cx="3762756" cy="274320"/>
           </a:xfrm>
           <a:prstGeom prst="rect">
             <a:avLst/>
@@ -9448,7 +9448,7 @@
                 <a:ea typeface="SF Pro Display" pitchFamily="34" charset="-122"/>
                 <a:cs typeface="SF Pro Display" pitchFamily="34" charset="-120"/>
               </a:rPr>
-              <a:t>Helper, half the time</a:t>
+              <a:t>Cleaner refunds first</a:t>
             </a:r>
             <a:endParaRPr lang="en-US" sz="1200" dirty="0"/>
           </a:p>
@@ -9463,7 +9463,7 @@
         <p:spPr>
           <a:xfrm>
             <a:off x="576072" y="2084832"/>
-            <a:ext cx="2353056" cy="2441448"/>
+            <a:ext cx="3762756" cy="1755648"/>
           </a:xfrm>
           <a:prstGeom prst="rect">
             <a:avLst/>
@@ -9487,7 +9487,7 @@
                 <a:ea typeface="SF Pro Text" pitchFamily="34" charset="-122"/>
                 <a:cs typeface="SF Pro Text" pitchFamily="34" charset="-120"/>
               </a:rPr>
-              <a:t>The cleaner brought a helper, worked half the duration, and charged in full.</a:t>
+              <a:t>The cleaner refunds after being told about the report.</a:t>
             </a:r>
             <a:endParaRPr lang="en-US" sz="950" dirty="0"/>
           </a:p>
@@ -9496,60 +9496,77 @@
               <a:buNone/>
             </a:pPr>
             <a:r>
-              <a:rPr lang="en-US" sz="950" b="1" dirty="0">
-                <a:solidFill>
-                  <a:srgbClr val="1D1D1F"/>
+              <a:rPr lang="en-US" sz="950" dirty="0">
+                <a:solidFill>
+                  <a:srgbClr val="6E6E73"/>
                 </a:solidFill>
                 <a:latin typeface="SF Pro Text" pitchFamily="34" charset="0"/>
                 <a:ea typeface="SF Pro Text" pitchFamily="34" charset="-122"/>
                 <a:cs typeface="SF Pro Text" pitchFamily="34" charset="-120"/>
               </a:rPr>
-              <a:t>Customer authorized it: </a:t>
-            </a:r>
+              <a:t>Treat the refund as confirmation the overcharge happened, unless evidence proves otherwise.</a:t>
+            </a:r>
+            <a:endParaRPr lang="en-US" sz="950" dirty="0"/>
+          </a:p>
+          <a:p>
             <a:pPr indent="0" marL="0">
               <a:buNone/>
             </a:pPr>
             <a:r>
-              <a:rPr lang="en-US" sz="950" dirty="0">
-                <a:solidFill>
-                  <a:srgbClr val="6E6E73"/>
+              <a:rPr lang="en-US" sz="950" b="1" dirty="0">
+                <a:solidFill>
+                  <a:srgbClr val="1D1D1F"/>
                 </a:solidFill>
                 <a:latin typeface="SF Pro Text" pitchFamily="34" charset="0"/>
                 <a:ea typeface="SF Pro Text" pitchFamily="34" charset="-122"/>
                 <a:cs typeface="SF Pro Text" pitchFamily="34" charset="-120"/>
               </a:rPr>
-              <a:t>tell them records show they did, address other pain points. Don't penalize the cleaner.</a:t>
-            </a:r>
-            <a:endParaRPr lang="en-US" sz="950" dirty="0"/>
-          </a:p>
-          <a:p>
+              <a:t>30 min or more: </a:t>
+            </a:r>
             <a:pPr indent="0" marL="0">
               <a:buNone/>
             </a:pPr>
             <a:r>
-              <a:rPr lang="en-US" sz="950" b="1" dirty="0">
-                <a:solidFill>
-                  <a:srgbClr val="1D1D1F"/>
+              <a:rPr lang="en-US" sz="950" dirty="0">
+                <a:solidFill>
+                  <a:srgbClr val="6E6E73"/>
                 </a:solidFill>
                 <a:latin typeface="SF Pro Text" pitchFamily="34" charset="0"/>
                 <a:ea typeface="SF Pro Text" pitchFamily="34" charset="-122"/>
                 <a:cs typeface="SF Pro Text" pitchFamily="34" charset="-120"/>
               </a:rPr>
-              <a:t>Not authorized: </a:t>
-            </a:r>
+              <a:t>still apply the cp_overcharged_hours flag.</a:t>
+            </a:r>
+            <a:endParaRPr lang="en-US" sz="950" dirty="0"/>
+          </a:p>
+          <a:p>
             <a:pPr indent="0" marL="0">
               <a:buNone/>
             </a:pPr>
             <a:r>
-              <a:rPr lang="en-US" sz="950" dirty="0">
-                <a:solidFill>
-                  <a:srgbClr val="6E6E73"/>
+              <a:rPr lang="en-US" sz="950" b="1" dirty="0">
+                <a:solidFill>
+                  <a:srgbClr val="1D1D1F"/>
                 </a:solidFill>
                 <a:latin typeface="SF Pro Text" pitchFamily="34" charset="0"/>
                 <a:ea typeface="SF Pro Text" pitchFamily="34" charset="-122"/>
                 <a:cs typeface="SF Pro Text" pitchFamily="34" charset="-120"/>
               </a:rPr>
-              <a:t>go to Branch B and request documentation. Coach that helpers need permission and can't justify full-rate billing.</a:t>
+              <a:t>Before the first-response Timed Reminder triggers: </a:t>
+            </a:r>
+            <a:pPr indent="0" marL="0">
+              <a:buNone/>
+            </a:pPr>
+            <a:r>
+              <a:rPr lang="en-US" sz="950" dirty="0">
+                <a:solidFill>
+                  <a:srgbClr val="6E6E73"/>
+                </a:solidFill>
+                <a:latin typeface="SF Pro Text" pitchFamily="34" charset="0"/>
+                <a:ea typeface="SF Pro Text" pitchFamily="34" charset="-122"/>
+                <a:cs typeface="SF Pro Text" pitchFamily="34" charset="-120"/>
+              </a:rPr>
+              <a:t>invalidate that reminder. Tell the customer the cleaner refunded.</a:t>
             </a:r>
             <a:endParaRPr lang="en-US" sz="950" dirty="0"/>
           </a:p>
@@ -9563,12 +9580,12 @@
         </p:nvSpPr>
         <p:spPr>
           <a:xfrm>
-            <a:off x="3230880" y="1188720"/>
-            <a:ext cx="2682240" cy="3429000"/>
+            <a:off x="4640580" y="1188720"/>
+            <a:ext cx="4091940" cy="2743200"/>
           </a:xfrm>
           <a:prstGeom prst="roundRect">
             <a:avLst>
-              <a:gd name="adj" fmla="val 2727"/>
+              <a:gd name="adj" fmla="val 2667"/>
             </a:avLst>
           </a:prstGeom>
           <a:solidFill>
@@ -9590,7 +9607,7 @@
         </p:nvSpPr>
         <p:spPr>
           <a:xfrm>
-            <a:off x="3395472" y="1353312"/>
+            <a:off x="4805172" y="1353312"/>
             <a:ext cx="329184" cy="329184"/>
           </a:xfrm>
           <a:prstGeom prst="ellipse">
@@ -9623,7 +9640,7 @@
         </p:blipFill>
         <p:spPr>
           <a:xfrm>
-            <a:off x="3474476" y="1432316"/>
+            <a:off x="4884176" y="1432316"/>
             <a:ext cx="171176" cy="171176"/>
           </a:xfrm>
           <a:prstGeom prst="rect">
@@ -9639,8 +9656,8 @@
         </p:nvSpPr>
         <p:spPr>
           <a:xfrm>
-            <a:off x="3395472" y="1792224"/>
-            <a:ext cx="2353056" cy="274320"/>
+            <a:off x="4805172" y="1792224"/>
+            <a:ext cx="3762756" cy="274320"/>
           </a:xfrm>
           <a:prstGeom prst="rect">
             <a:avLst/>
@@ -9664,7 +9681,7 @@
                 <a:ea typeface="SF Pro Display" pitchFamily="34" charset="-122"/>
                 <a:cs typeface="SF Pro Display" pitchFamily="34" charset="-120"/>
               </a:rPr>
-              <a:t>Cleaner refunds first</a:t>
+              <a:t>You spot it first</a:t>
             </a:r>
             <a:endParaRPr lang="en-US" sz="1200" dirty="0"/>
           </a:p>
@@ -9678,241 +9695,8 @@
         </p:nvSpPr>
         <p:spPr>
           <a:xfrm>
-            <a:off x="3395472" y="2084832"/>
-            <a:ext cx="2353056" cy="2441448"/>
-          </a:xfrm>
-          <a:prstGeom prst="rect">
-            <a:avLst/>
-          </a:prstGeom>
-          <a:noFill/>
-          <a:ln/>
-        </p:spPr>
-        <p:txBody>
-          <a:bodyPr wrap="square" lIns="0" tIns="0" rIns="0" bIns="0" rtlCol="0" anchor="t"/>
-          <a:lstStyle/>
-          <a:p>
-            <a:pPr indent="0" marL="0">
-              <a:buNone/>
-            </a:pPr>
-            <a:r>
-              <a:rPr lang="en-US" sz="950" dirty="0">
-                <a:solidFill>
-                  <a:srgbClr val="6E6E73"/>
-                </a:solidFill>
-                <a:latin typeface="SF Pro Text" pitchFamily="34" charset="0"/>
-                <a:ea typeface="SF Pro Text" pitchFamily="34" charset="-122"/>
-                <a:cs typeface="SF Pro Text" pitchFamily="34" charset="-120"/>
-              </a:rPr>
-              <a:t>The cleaner refunds after being told about the report.</a:t>
-            </a:r>
-            <a:endParaRPr lang="en-US" sz="950" dirty="0"/>
-          </a:p>
-          <a:p>
-            <a:pPr indent="0" marL="0">
-              <a:buNone/>
-            </a:pPr>
-            <a:r>
-              <a:rPr lang="en-US" sz="950" dirty="0">
-                <a:solidFill>
-                  <a:srgbClr val="6E6E73"/>
-                </a:solidFill>
-                <a:latin typeface="SF Pro Text" pitchFamily="34" charset="0"/>
-                <a:ea typeface="SF Pro Text" pitchFamily="34" charset="-122"/>
-                <a:cs typeface="SF Pro Text" pitchFamily="34" charset="-120"/>
-              </a:rPr>
-              <a:t>Treat the refund as confirmation the overcharge happened, unless evidence proves otherwise.</a:t>
-            </a:r>
-            <a:endParaRPr lang="en-US" sz="950" dirty="0"/>
-          </a:p>
-          <a:p>
-            <a:pPr indent="0" marL="0">
-              <a:buNone/>
-            </a:pPr>
-            <a:r>
-              <a:rPr lang="en-US" sz="950" b="1" dirty="0">
-                <a:solidFill>
-                  <a:srgbClr val="1D1D1F"/>
-                </a:solidFill>
-                <a:latin typeface="SF Pro Text" pitchFamily="34" charset="0"/>
-                <a:ea typeface="SF Pro Text" pitchFamily="34" charset="-122"/>
-                <a:cs typeface="SF Pro Text" pitchFamily="34" charset="-120"/>
-              </a:rPr>
-              <a:t>30 min or more: </a:t>
-            </a:r>
-            <a:pPr indent="0" marL="0">
-              <a:buNone/>
-            </a:pPr>
-            <a:r>
-              <a:rPr lang="en-US" sz="950" dirty="0">
-                <a:solidFill>
-                  <a:srgbClr val="6E6E73"/>
-                </a:solidFill>
-                <a:latin typeface="SF Pro Text" pitchFamily="34" charset="0"/>
-                <a:ea typeface="SF Pro Text" pitchFamily="34" charset="-122"/>
-                <a:cs typeface="SF Pro Text" pitchFamily="34" charset="-120"/>
-              </a:rPr>
-              <a:t>still apply the cp_overcharged_hours flag.</a:t>
-            </a:r>
-            <a:endParaRPr lang="en-US" sz="950" dirty="0"/>
-          </a:p>
-          <a:p>
-            <a:pPr indent="0" marL="0">
-              <a:buNone/>
-            </a:pPr>
-            <a:r>
-              <a:rPr lang="en-US" sz="950" b="1" dirty="0">
-                <a:solidFill>
-                  <a:srgbClr val="1D1D1F"/>
-                </a:solidFill>
-                <a:latin typeface="SF Pro Text" pitchFamily="34" charset="0"/>
-                <a:ea typeface="SF Pro Text" pitchFamily="34" charset="-122"/>
-                <a:cs typeface="SF Pro Text" pitchFamily="34" charset="-120"/>
-              </a:rPr>
-              <a:t>Before the first-response Timed Reminder triggers: </a:t>
-            </a:r>
-            <a:pPr indent="0" marL="0">
-              <a:buNone/>
-            </a:pPr>
-            <a:r>
-              <a:rPr lang="en-US" sz="950" dirty="0">
-                <a:solidFill>
-                  <a:srgbClr val="6E6E73"/>
-                </a:solidFill>
-                <a:latin typeface="SF Pro Text" pitchFamily="34" charset="0"/>
-                <a:ea typeface="SF Pro Text" pitchFamily="34" charset="-122"/>
-                <a:cs typeface="SF Pro Text" pitchFamily="34" charset="-120"/>
-              </a:rPr>
-              <a:t>invalidate that reminder. Tell the customer the cleaner refunded.</a:t>
-            </a:r>
-            <a:endParaRPr lang="en-US" sz="950" dirty="0"/>
-          </a:p>
-        </p:txBody>
-      </p:sp>
-      <p:sp>
-        <p:nvSpPr>
-          <p:cNvPr id="15" name="Shape 10"/>
-          <p:cNvSpPr/>
-          <p:nvPr/>
-        </p:nvSpPr>
-        <p:spPr>
-          <a:xfrm>
-            <a:off x="6050280" y="1188720"/>
-            <a:ext cx="2682240" cy="3429000"/>
-          </a:xfrm>
-          <a:prstGeom prst="roundRect">
-            <a:avLst>
-              <a:gd name="adj" fmla="val 2727"/>
-            </a:avLst>
-          </a:prstGeom>
-          <a:solidFill>
-            <a:srgbClr val="FFFFFF"/>
-          </a:solidFill>
-          <a:ln w="9525">
-            <a:solidFill>
-              <a:srgbClr val="DCE1E7"/>
-            </a:solidFill>
-            <a:prstDash val="solid"/>
-          </a:ln>
-        </p:spPr>
-      </p:sp>
-      <p:sp>
-        <p:nvSpPr>
-          <p:cNvPr id="16" name="Shape 11"/>
-          <p:cNvSpPr/>
-          <p:nvPr/>
-        </p:nvSpPr>
-        <p:spPr>
-          <a:xfrm>
-            <a:off x="6214872" y="1353312"/>
-            <a:ext cx="329184" cy="329184"/>
-          </a:xfrm>
-          <a:prstGeom prst="ellipse">
-            <a:avLst/>
-          </a:prstGeom>
-          <a:solidFill>
-            <a:srgbClr val="E3F4F1"/>
-          </a:solidFill>
-          <a:ln w="12700">
-            <a:solidFill>
-              <a:srgbClr val="E3F4F1"/>
-            </a:solidFill>
-            <a:prstDash val="solid"/>
-          </a:ln>
-        </p:spPr>
-      </p:sp>
-      <p:pic>
-        <p:nvPicPr>
-          <p:cNvPr id="17" name="Image 2" descr="preencoded.png">    </p:cNvPr>
-          <p:cNvPicPr>
-            <a:picLocks noChangeAspect="1"/>
-          </p:cNvPicPr>
-          <p:nvPr/>
-        </p:nvPicPr>
-        <p:blipFill>
-          <a:blip r:embed="rId3"/>
-          <a:stretch>
-            <a:fillRect/>
-          </a:stretch>
-        </p:blipFill>
-        <p:spPr>
-          <a:xfrm>
-            <a:off x="6293876" y="1432316"/>
-            <a:ext cx="171176" cy="171176"/>
-          </a:xfrm>
-          <a:prstGeom prst="rect">
-            <a:avLst/>
-          </a:prstGeom>
-        </p:spPr>
-      </p:pic>
-      <p:sp>
-        <p:nvSpPr>
-          <p:cNvPr id="18" name="Text 12"/>
-          <p:cNvSpPr txBox="1"/>
-          <p:nvPr/>
-        </p:nvSpPr>
-        <p:spPr>
-          <a:xfrm>
-            <a:off x="6214872" y="1792224"/>
-            <a:ext cx="2353056" cy="274320"/>
-          </a:xfrm>
-          <a:prstGeom prst="rect">
-            <a:avLst/>
-          </a:prstGeom>
-          <a:noFill/>
-          <a:ln/>
-        </p:spPr>
-        <p:txBody>
-          <a:bodyPr wrap="square" lIns="0" tIns="0" rIns="0" bIns="0" rtlCol="0" anchor="t"/>
-          <a:lstStyle/>
-          <a:p>
-            <a:pPr indent="0" marL="0">
-              <a:buNone/>
-            </a:pPr>
-            <a:r>
-              <a:rPr lang="en-US" sz="1200" b="1" dirty="0">
-                <a:solidFill>
-                  <a:srgbClr val="1D1D1F"/>
-                </a:solidFill>
-                <a:latin typeface="SF Pro Display" pitchFamily="34" charset="0"/>
-                <a:ea typeface="SF Pro Display" pitchFamily="34" charset="-122"/>
-                <a:cs typeface="SF Pro Display" pitchFamily="34" charset="-120"/>
-              </a:rPr>
-              <a:t>You spot it first</a:t>
-            </a:r>
-            <a:endParaRPr lang="en-US" sz="1200" dirty="0"/>
-          </a:p>
-        </p:txBody>
-      </p:sp>
-      <p:sp>
-        <p:nvSpPr>
-          <p:cNvPr id="19" name="Text 13"/>
-          <p:cNvSpPr txBox="1"/>
-          <p:nvPr/>
-        </p:nvSpPr>
-        <p:spPr>
-          <a:xfrm>
-            <a:off x="6214872" y="2084832"/>
-            <a:ext cx="2353056" cy="2441448"/>
+            <a:off x="4805172" y="2084832"/>
+            <a:ext cx="3762756" cy="1755648"/>
           </a:xfrm>
           <a:prstGeom prst="rect">
             <a:avLst/>
@@ -16185,20 +15969,20 @@
         </p:nvSpPr>
         <p:spPr>
           <a:xfrm>
-            <a:off x="411480" y="1280160"/>
-            <a:ext cx="1977390" cy="2011680"/>
+            <a:off x="548640" y="1371600"/>
+            <a:ext cx="2926080" cy="548640"/>
           </a:xfrm>
           <a:prstGeom prst="roundRect">
             <a:avLst>
-              <a:gd name="adj" fmla="val 3699"/>
+              <a:gd name="adj" fmla="val 13333"/>
             </a:avLst>
           </a:prstGeom>
           <a:solidFill>
-            <a:srgbClr val="FFFFFF"/>
+            <a:srgbClr val="0B7A6F"/>
           </a:solidFill>
-          <a:ln w="9525">
+          <a:ln w="12700">
             <a:solidFill>
-              <a:srgbClr val="DCE1E7"/>
+              <a:srgbClr val="0B7A6F"/>
             </a:solidFill>
             <a:prstDash val="solid"/>
           </a:ln>
@@ -16206,24 +15990,151 @@
       </p:sp>
       <p:sp>
         <p:nvSpPr>
-          <p:cNvPr id="7" name="Shape 4"/>
+          <p:cNvPr id="7" name="Text 4"/>
+          <p:cNvSpPr txBox="1"/>
+          <p:nvPr/>
+        </p:nvSpPr>
+        <p:spPr>
+          <a:xfrm>
+            <a:off x="548640" y="1371600"/>
+            <a:ext cx="2926080" cy="548640"/>
+          </a:xfrm>
+          <a:prstGeom prst="rect">
+            <a:avLst/>
+          </a:prstGeom>
+          <a:noFill/>
+          <a:ln/>
+        </p:spPr>
+        <p:txBody>
+          <a:bodyPr wrap="square" lIns="0" tIns="0" rIns="0" bIns="0" rtlCol="0" anchor="ctr"/>
+          <a:lstStyle/>
+          <a:p>
+            <a:pPr algn="ctr" indent="0" marL="0">
+              <a:buNone/>
+            </a:pPr>
+            <a:r>
+              <a:rPr lang="en-US" sz="1000" b="1" dirty="0">
+                <a:solidFill>
+                  <a:srgbClr val="FFFFFF"/>
+                </a:solidFill>
+                <a:latin typeface="SF Pro Display" pitchFamily="34" charset="0"/>
+                <a:ea typeface="SF Pro Display" pitchFamily="34" charset="-122"/>
+                <a:cs typeface="SF Pro Display" pitchFamily="34" charset="-120"/>
+              </a:rPr>
+              <a:t>Refund the unauthorized hours only</a:t>
+            </a:r>
+            <a:endParaRPr lang="en-US" sz="1000" dirty="0"/>
+          </a:p>
+        </p:txBody>
+      </p:sp>
+      <p:sp>
+        <p:nvSpPr>
+          <p:cNvPr id="8" name="Shape 5"/>
           <p:cNvSpPr/>
           <p:nvPr/>
         </p:nvSpPr>
         <p:spPr>
           <a:xfrm>
-            <a:off x="576072" y="1463040"/>
-            <a:ext cx="274320" cy="274320"/>
-          </a:xfrm>
-          <a:prstGeom prst="ellipse">
-            <a:avLst/>
+            <a:off x="2011680" y="1920240"/>
+            <a:ext cx="0" cy="246888"/>
+          </a:xfrm>
+          <a:prstGeom prst="line">
+            <a:avLst/>
+          </a:prstGeom>
+          <a:noFill/>
+          <a:ln w="12700">
+            <a:solidFill>
+              <a:srgbClr val="6E6E73"/>
+            </a:solidFill>
+            <a:prstDash val="solid"/>
+            <a:tailEnd type="triangle"/>
+          </a:ln>
+        </p:spPr>
+      </p:sp>
+      <p:sp>
+        <p:nvSpPr>
+          <p:cNvPr id="9" name="Shape 6"/>
+          <p:cNvSpPr/>
+          <p:nvPr/>
+        </p:nvSpPr>
+        <p:spPr>
+          <a:xfrm>
+            <a:off x="3474720" y="1645920"/>
+            <a:ext cx="274320" cy="0"/>
+          </a:xfrm>
+          <a:prstGeom prst="line">
+            <a:avLst/>
+          </a:prstGeom>
+          <a:noFill/>
+          <a:ln w="12700">
+            <a:solidFill>
+              <a:srgbClr val="6E6E73"/>
+            </a:solidFill>
+            <a:prstDash val="solid"/>
+          </a:ln>
+        </p:spPr>
+      </p:sp>
+      <p:sp>
+        <p:nvSpPr>
+          <p:cNvPr id="10" name="Text 7"/>
+          <p:cNvSpPr txBox="1"/>
+          <p:nvPr/>
+        </p:nvSpPr>
+        <p:spPr>
+          <a:xfrm>
+            <a:off x="3840480" y="1371600"/>
+            <a:ext cx="4709160" cy="548640"/>
+          </a:xfrm>
+          <a:prstGeom prst="rect">
+            <a:avLst/>
+          </a:prstGeom>
+          <a:noFill/>
+          <a:ln/>
+        </p:spPr>
+        <p:txBody>
+          <a:bodyPr wrap="square" lIns="0" tIns="0" rIns="0" bIns="0" rtlCol="0" anchor="ctr"/>
+          <a:lstStyle/>
+          <a:p>
+            <a:pPr indent="0" marL="0">
+              <a:buNone/>
+            </a:pPr>
+            <a:r>
+              <a:rPr lang="en-US" sz="950" dirty="0">
+                <a:solidFill>
+                  <a:srgbClr val="6E6E73"/>
+                </a:solidFill>
+                <a:latin typeface="SF Pro Text" pitchFamily="34" charset="0"/>
+                <a:ea typeface="SF Pro Text" pitchFamily="34" charset="-122"/>
+                <a:cs typeface="SF Pro Text" pitchFamily="34" charset="-120"/>
+              </a:rPr>
+              <a:t>Refund via the CP Dashboard for the alleged unauthorized hours only, not the full job. The booked time was authorized and worked.</a:t>
+            </a:r>
+            <a:endParaRPr lang="en-US" sz="950" dirty="0"/>
+          </a:p>
+        </p:txBody>
+      </p:sp>
+      <p:sp>
+        <p:nvSpPr>
+          <p:cNvPr id="11" name="Shape 8"/>
+          <p:cNvSpPr/>
+          <p:nvPr/>
+        </p:nvSpPr>
+        <p:spPr>
+          <a:xfrm>
+            <a:off x="548640" y="2167128"/>
+            <a:ext cx="2926080" cy="548640"/>
+          </a:xfrm>
+          <a:prstGeom prst="roundRect">
+            <a:avLst>
+              <a:gd name="adj" fmla="val 13333"/>
+            </a:avLst>
           </a:prstGeom>
           <a:solidFill>
-            <a:srgbClr val="E3F4F1"/>
+            <a:srgbClr val="0B7A6F"/>
           </a:solidFill>
           <a:ln w="12700">
             <a:solidFill>
-              <a:srgbClr val="E3F4F1"/>
+              <a:srgbClr val="0B7A6F"/>
             </a:solidFill>
             <a:prstDash val="solid"/>
           </a:ln>
@@ -16231,14 +16142,14 @@
       </p:sp>
       <p:sp>
         <p:nvSpPr>
-          <p:cNvPr id="8" name="Text 5"/>
-          <p:cNvSpPr txBox="1"/>
-          <p:nvPr/>
-        </p:nvSpPr>
-        <p:spPr>
-          <a:xfrm>
-            <a:off x="576072" y="1463040"/>
-            <a:ext cx="274320" cy="274320"/>
+          <p:cNvPr id="12" name="Text 9"/>
+          <p:cNvSpPr txBox="1"/>
+          <p:nvPr/>
+        </p:nvSpPr>
+        <p:spPr>
+          <a:xfrm>
+            <a:off x="548640" y="2167128"/>
+            <a:ext cx="2926080" cy="548640"/>
           </a:xfrm>
           <a:prstGeom prst="rect">
             <a:avLst/>
@@ -16254,78 +16165,238 @@
               <a:buNone/>
             </a:pPr>
             <a:r>
-              <a:rPr lang="en-US" sz="900" b="1" dirty="0">
-                <a:solidFill>
-                  <a:srgbClr val="0B7A6F"/>
+              <a:rPr lang="en-US" sz="1000" b="1" dirty="0">
+                <a:solidFill>
+                  <a:srgbClr val="FFFFFF"/>
                 </a:solidFill>
                 <a:latin typeface="SF Pro Display" pitchFamily="34" charset="0"/>
                 <a:ea typeface="SF Pro Display" pitchFamily="34" charset="-122"/>
                 <a:cs typeface="SF Pro Display" pitchFamily="34" charset="-120"/>
               </a:rPr>
-              <a:t>1</a:t>
-            </a:r>
-            <a:endParaRPr lang="en-US" sz="900" dirty="0"/>
-          </a:p>
-        </p:txBody>
-      </p:sp>
-      <p:sp>
-        <p:nvSpPr>
-          <p:cNvPr id="9" name="Text 6"/>
-          <p:cNvSpPr txBox="1"/>
-          <p:nvPr/>
-        </p:nvSpPr>
-        <p:spPr>
-          <a:xfrm>
-            <a:off x="576072" y="1883664"/>
-            <a:ext cx="1648206" cy="274320"/>
-          </a:xfrm>
-          <a:prstGeom prst="rect">
-            <a:avLst/>
-          </a:prstGeom>
-          <a:noFill/>
-          <a:ln/>
-        </p:spPr>
-        <p:txBody>
-          <a:bodyPr wrap="square" lIns="0" tIns="0" rIns="0" bIns="0" rtlCol="0" anchor="t"/>
+              <a:t>Coach CP + request evidence</a:t>
+            </a:r>
+            <a:endParaRPr lang="en-US" sz="1000" dirty="0"/>
+          </a:p>
+        </p:txBody>
+      </p:sp>
+      <p:sp>
+        <p:nvSpPr>
+          <p:cNvPr id="13" name="Shape 10"/>
+          <p:cNvSpPr/>
+          <p:nvPr/>
+        </p:nvSpPr>
+        <p:spPr>
+          <a:xfrm>
+            <a:off x="2011680" y="2715768"/>
+            <a:ext cx="0" cy="246888"/>
+          </a:xfrm>
+          <a:prstGeom prst="line">
+            <a:avLst/>
+          </a:prstGeom>
+          <a:noFill/>
+          <a:ln w="12700">
+            <a:solidFill>
+              <a:srgbClr val="6E6E73"/>
+            </a:solidFill>
+            <a:prstDash val="solid"/>
+            <a:tailEnd type="triangle"/>
+          </a:ln>
+        </p:spPr>
+      </p:sp>
+      <p:sp>
+        <p:nvSpPr>
+          <p:cNvPr id="14" name="Shape 11"/>
+          <p:cNvSpPr/>
+          <p:nvPr/>
+        </p:nvSpPr>
+        <p:spPr>
+          <a:xfrm>
+            <a:off x="3474720" y="2441448"/>
+            <a:ext cx="274320" cy="0"/>
+          </a:xfrm>
+          <a:prstGeom prst="line">
+            <a:avLst/>
+          </a:prstGeom>
+          <a:noFill/>
+          <a:ln w="12700">
+            <a:solidFill>
+              <a:srgbClr val="6E6E73"/>
+            </a:solidFill>
+            <a:prstDash val="solid"/>
+          </a:ln>
+        </p:spPr>
+      </p:sp>
+      <p:sp>
+        <p:nvSpPr>
+          <p:cNvPr id="15" name="Text 12"/>
+          <p:cNvSpPr txBox="1"/>
+          <p:nvPr/>
+        </p:nvSpPr>
+        <p:spPr>
+          <a:xfrm>
+            <a:off x="3840480" y="2167128"/>
+            <a:ext cx="4709160" cy="548640"/>
+          </a:xfrm>
+          <a:prstGeom prst="rect">
+            <a:avLst/>
+          </a:prstGeom>
+          <a:noFill/>
+          <a:ln/>
+        </p:spPr>
+        <p:txBody>
+          <a:bodyPr wrap="square" lIns="0" tIns="0" rIns="0" bIns="0" rtlCol="0" anchor="ctr"/>
           <a:lstStyle/>
           <a:p>
             <a:pPr indent="0" marL="0">
               <a:buNone/>
             </a:pPr>
             <a:r>
-              <a:rPr lang="en-US" sz="1200" b="1" dirty="0">
-                <a:solidFill>
-                  <a:srgbClr val="1D1D1F"/>
+              <a:rPr lang="en-US" sz="950" dirty="0">
+                <a:solidFill>
+                  <a:srgbClr val="6E6E73"/>
+                </a:solidFill>
+                <a:latin typeface="SF Pro Text" pitchFamily="34" charset="0"/>
+                <a:ea typeface="SF Pro Text" pitchFamily="34" charset="-122"/>
+                <a:cs typeface="SF Pro Text" pitchFamily="34" charset="-120"/>
+              </a:rPr>
+              <a:t>Coach the CP to ask before extending. Send comms about the action taken. The CP has 3 days to prove the customer authorized the extra hours.</a:t>
+            </a:r>
+            <a:endParaRPr lang="en-US" sz="950" dirty="0"/>
+          </a:p>
+        </p:txBody>
+      </p:sp>
+      <p:sp>
+        <p:nvSpPr>
+          <p:cNvPr id="16" name="Shape 13"/>
+          <p:cNvSpPr/>
+          <p:nvPr/>
+        </p:nvSpPr>
+        <p:spPr>
+          <a:xfrm>
+            <a:off x="548640" y="2962656"/>
+            <a:ext cx="2926080" cy="548640"/>
+          </a:xfrm>
+          <a:prstGeom prst="roundRect">
+            <a:avLst>
+              <a:gd name="adj" fmla="val 13333"/>
+            </a:avLst>
+          </a:prstGeom>
+          <a:solidFill>
+            <a:srgbClr val="FFF3D6"/>
+          </a:solidFill>
+          <a:ln w="12700">
+            <a:solidFill>
+              <a:srgbClr val="9A6410"/>
+            </a:solidFill>
+            <a:prstDash val="solid"/>
+          </a:ln>
+        </p:spPr>
+      </p:sp>
+      <p:sp>
+        <p:nvSpPr>
+          <p:cNvPr id="17" name="Text 14"/>
+          <p:cNvSpPr txBox="1"/>
+          <p:nvPr/>
+        </p:nvSpPr>
+        <p:spPr>
+          <a:xfrm>
+            <a:off x="548640" y="2962656"/>
+            <a:ext cx="2926080" cy="548640"/>
+          </a:xfrm>
+          <a:prstGeom prst="rect">
+            <a:avLst/>
+          </a:prstGeom>
+          <a:noFill/>
+          <a:ln/>
+        </p:spPr>
+        <p:txBody>
+          <a:bodyPr wrap="square" lIns="0" tIns="0" rIns="0" bIns="0" rtlCol="0" anchor="ctr"/>
+          <a:lstStyle/>
+          <a:p>
+            <a:pPr algn="ctr" indent="0" marL="0">
+              <a:buNone/>
+            </a:pPr>
+            <a:r>
+              <a:rPr lang="en-US" sz="1000" b="1" dirty="0">
+                <a:solidFill>
+                  <a:srgbClr val="9A6410"/>
                 </a:solidFill>
                 <a:latin typeface="SF Pro Display" pitchFamily="34" charset="0"/>
                 <a:ea typeface="SF Pro Display" pitchFamily="34" charset="-122"/>
                 <a:cs typeface="SF Pro Display" pitchFamily="34" charset="-120"/>
               </a:rPr>
-              <a:t>Refund added hours</a:t>
-            </a:r>
-            <a:endParaRPr lang="en-US" sz="1200" dirty="0"/>
-          </a:p>
-        </p:txBody>
-      </p:sp>
-      <p:sp>
-        <p:nvSpPr>
-          <p:cNvPr id="10" name="Text 7"/>
-          <p:cNvSpPr txBox="1"/>
-          <p:nvPr/>
-        </p:nvSpPr>
-        <p:spPr>
-          <a:xfrm>
-            <a:off x="576072" y="2176272"/>
-            <a:ext cx="1648206" cy="1024128"/>
-          </a:xfrm>
-          <a:prstGeom prst="rect">
-            <a:avLst/>
-          </a:prstGeom>
-          <a:noFill/>
-          <a:ln/>
-        </p:spPr>
-        <p:txBody>
-          <a:bodyPr wrap="square" lIns="0" tIns="0" rIns="0" bIns="0" rtlCol="0" anchor="t"/>
+              <a:t>Check for Premium charge</a:t>
+            </a:r>
+            <a:endParaRPr lang="en-US" sz="1000" dirty="0"/>
+          </a:p>
+        </p:txBody>
+      </p:sp>
+      <p:sp>
+        <p:nvSpPr>
+          <p:cNvPr id="18" name="Shape 15"/>
+          <p:cNvSpPr/>
+          <p:nvPr/>
+        </p:nvSpPr>
+        <p:spPr>
+          <a:xfrm>
+            <a:off x="2011680" y="3511296"/>
+            <a:ext cx="0" cy="246888"/>
+          </a:xfrm>
+          <a:prstGeom prst="line">
+            <a:avLst/>
+          </a:prstGeom>
+          <a:noFill/>
+          <a:ln w="12700">
+            <a:solidFill>
+              <a:srgbClr val="6E6E73"/>
+            </a:solidFill>
+            <a:prstDash val="solid"/>
+            <a:tailEnd type="triangle"/>
+          </a:ln>
+        </p:spPr>
+      </p:sp>
+      <p:sp>
+        <p:nvSpPr>
+          <p:cNvPr id="19" name="Shape 16"/>
+          <p:cNvSpPr/>
+          <p:nvPr/>
+        </p:nvSpPr>
+        <p:spPr>
+          <a:xfrm>
+            <a:off x="3474720" y="3236976"/>
+            <a:ext cx="274320" cy="0"/>
+          </a:xfrm>
+          <a:prstGeom prst="line">
+            <a:avLst/>
+          </a:prstGeom>
+          <a:noFill/>
+          <a:ln w="12700">
+            <a:solidFill>
+              <a:srgbClr val="6E6E73"/>
+            </a:solidFill>
+            <a:prstDash val="solid"/>
+          </a:ln>
+        </p:spPr>
+      </p:sp>
+      <p:sp>
+        <p:nvSpPr>
+          <p:cNvPr id="20" name="Text 17"/>
+          <p:cNvSpPr txBox="1"/>
+          <p:nvPr/>
+        </p:nvSpPr>
+        <p:spPr>
+          <a:xfrm>
+            <a:off x="3840480" y="2962656"/>
+            <a:ext cx="4709160" cy="548640"/>
+          </a:xfrm>
+          <a:prstGeom prst="rect">
+            <a:avLst/>
+          </a:prstGeom>
+          <a:noFill/>
+          <a:ln/>
+        </p:spPr>
+        <p:txBody>
+          <a:bodyPr wrap="square" lIns="0" tIns="0" rIns="0" bIns="0" rtlCol="0" anchor="ctr"/>
           <a:lstStyle/>
           <a:p>
             <a:pPr indent="0" marL="0">
@@ -16340,7 +16411,7 @@
                 <a:ea typeface="SF Pro Text" pitchFamily="34" charset="-122"/>
                 <a:cs typeface="SF Pro Text" pitchFamily="34" charset="-120"/>
               </a:rPr>
-              <a:t>Via the CP Dashboard. Only the added time, not the full job.</a:t>
+              <a:t>If a Premium fee was charged, refund it. Unauthorized hours is itself the service issue, so the customer doesn't need to ask.</a:t>
             </a:r>
             <a:endParaRPr lang="en-US" sz="950" dirty="0"/>
           </a:p>
@@ -16348,26 +16419,26 @@
       </p:sp>
       <p:sp>
         <p:nvSpPr>
-          <p:cNvPr id="11" name="Shape 8"/>
+          <p:cNvPr id="21" name="Shape 18"/>
           <p:cNvSpPr/>
           <p:nvPr/>
         </p:nvSpPr>
         <p:spPr>
           <a:xfrm>
-            <a:off x="2526030" y="1280160"/>
-            <a:ext cx="1977390" cy="2011680"/>
+            <a:off x="548640" y="3758184"/>
+            <a:ext cx="2926080" cy="548640"/>
           </a:xfrm>
           <a:prstGeom prst="roundRect">
             <a:avLst>
-              <a:gd name="adj" fmla="val 3699"/>
+              <a:gd name="adj" fmla="val 13333"/>
             </a:avLst>
           </a:prstGeom>
           <a:solidFill>
-            <a:srgbClr val="FFFFFF"/>
+            <a:srgbClr val="1D1D1F"/>
           </a:solidFill>
-          <a:ln w="9525">
+          <a:ln w="12700">
             <a:solidFill>
-              <a:srgbClr val="DCE1E7"/>
+              <a:srgbClr val="1D1D1F"/>
             </a:solidFill>
             <a:prstDash val="solid"/>
           </a:ln>
@@ -16375,24 +16446,61 @@
       </p:sp>
       <p:sp>
         <p:nvSpPr>
-          <p:cNvPr id="12" name="Shape 9"/>
+          <p:cNvPr id="22" name="Text 19"/>
+          <p:cNvSpPr txBox="1"/>
+          <p:nvPr/>
+        </p:nvSpPr>
+        <p:spPr>
+          <a:xfrm>
+            <a:off x="548640" y="3758184"/>
+            <a:ext cx="2926080" cy="548640"/>
+          </a:xfrm>
+          <a:prstGeom prst="rect">
+            <a:avLst/>
+          </a:prstGeom>
+          <a:noFill/>
+          <a:ln/>
+        </p:spPr>
+        <p:txBody>
+          <a:bodyPr wrap="square" lIns="0" tIns="0" rIns="0" bIns="0" rtlCol="0" anchor="ctr"/>
+          <a:lstStyle/>
+          <a:p>
+            <a:pPr algn="ctr" indent="0" marL="0">
+              <a:buNone/>
+            </a:pPr>
+            <a:r>
+              <a:rPr lang="en-US" sz="1000" b="1" dirty="0">
+                <a:solidFill>
+                  <a:srgbClr val="FFFFFF"/>
+                </a:solidFill>
+                <a:latin typeface="SF Pro Display" pitchFamily="34" charset="0"/>
+                <a:ea typeface="SF Pro Display" pitchFamily="34" charset="-122"/>
+                <a:cs typeface="SF Pro Display" pitchFamily="34" charset="-120"/>
+              </a:rPr>
+              <a:t>Close the loop with the customer, done</a:t>
+            </a:r>
+            <a:endParaRPr lang="en-US" sz="1000" dirty="0"/>
+          </a:p>
+        </p:txBody>
+      </p:sp>
+      <p:sp>
+        <p:nvSpPr>
+          <p:cNvPr id="23" name="Shape 20"/>
           <p:cNvSpPr/>
           <p:nvPr/>
         </p:nvSpPr>
         <p:spPr>
           <a:xfrm>
-            <a:off x="2690622" y="1463040"/>
-            <a:ext cx="274320" cy="274320"/>
-          </a:xfrm>
-          <a:prstGeom prst="ellipse">
-            <a:avLst/>
-          </a:prstGeom>
-          <a:solidFill>
-            <a:srgbClr val="E3F4F1"/>
-          </a:solidFill>
+            <a:off x="3474720" y="4032504"/>
+            <a:ext cx="274320" cy="0"/>
+          </a:xfrm>
+          <a:prstGeom prst="line">
+            <a:avLst/>
+          </a:prstGeom>
+          <a:noFill/>
           <a:ln w="12700">
             <a:solidFill>
-              <a:srgbClr val="E3F4F1"/>
+              <a:srgbClr val="6E6E73"/>
             </a:solidFill>
             <a:prstDash val="solid"/>
           </a:ln>
@@ -16400,14 +16508,14 @@
       </p:sp>
       <p:sp>
         <p:nvSpPr>
-          <p:cNvPr id="13" name="Text 10"/>
-          <p:cNvSpPr txBox="1"/>
-          <p:nvPr/>
-        </p:nvSpPr>
-        <p:spPr>
-          <a:xfrm>
-            <a:off x="2690622" y="1463040"/>
-            <a:ext cx="274320" cy="274320"/>
+          <p:cNvPr id="24" name="Text 21"/>
+          <p:cNvSpPr txBox="1"/>
+          <p:nvPr/>
+        </p:nvSpPr>
+        <p:spPr>
+          <a:xfrm>
+            <a:off x="3840480" y="3758184"/>
+            <a:ext cx="4709160" cy="548640"/>
           </a:xfrm>
           <a:prstGeom prst="rect">
             <a:avLst/>
@@ -16417,84 +16525,6 @@
         </p:spPr>
         <p:txBody>
           <a:bodyPr wrap="square" lIns="0" tIns="0" rIns="0" bIns="0" rtlCol="0" anchor="ctr"/>
-          <a:lstStyle/>
-          <a:p>
-            <a:pPr algn="ctr" indent="0" marL="0">
-              <a:buNone/>
-            </a:pPr>
-            <a:r>
-              <a:rPr lang="en-US" sz="900" b="1" dirty="0">
-                <a:solidFill>
-                  <a:srgbClr val="0B7A6F"/>
-                </a:solidFill>
-                <a:latin typeface="SF Pro Display" pitchFamily="34" charset="0"/>
-                <a:ea typeface="SF Pro Display" pitchFamily="34" charset="-122"/>
-                <a:cs typeface="SF Pro Display" pitchFamily="34" charset="-120"/>
-              </a:rPr>
-              <a:t>2</a:t>
-            </a:r>
-            <a:endParaRPr lang="en-US" sz="900" dirty="0"/>
-          </a:p>
-        </p:txBody>
-      </p:sp>
-      <p:sp>
-        <p:nvSpPr>
-          <p:cNvPr id="14" name="Text 11"/>
-          <p:cNvSpPr txBox="1"/>
-          <p:nvPr/>
-        </p:nvSpPr>
-        <p:spPr>
-          <a:xfrm>
-            <a:off x="2690622" y="1883664"/>
-            <a:ext cx="1648206" cy="274320"/>
-          </a:xfrm>
-          <a:prstGeom prst="rect">
-            <a:avLst/>
-          </a:prstGeom>
-          <a:noFill/>
-          <a:ln/>
-        </p:spPr>
-        <p:txBody>
-          <a:bodyPr wrap="square" lIns="0" tIns="0" rIns="0" bIns="0" rtlCol="0" anchor="t"/>
-          <a:lstStyle/>
-          <a:p>
-            <a:pPr indent="0" marL="0">
-              <a:buNone/>
-            </a:pPr>
-            <a:r>
-              <a:rPr lang="en-US" sz="1200" b="1" dirty="0">
-                <a:solidFill>
-                  <a:srgbClr val="1D1D1F"/>
-                </a:solidFill>
-                <a:latin typeface="SF Pro Display" pitchFamily="34" charset="0"/>
-                <a:ea typeface="SF Pro Display" pitchFamily="34" charset="-122"/>
-                <a:cs typeface="SF Pro Display" pitchFamily="34" charset="-120"/>
-              </a:rPr>
-              <a:t>Coach the cleaner</a:t>
-            </a:r>
-            <a:endParaRPr lang="en-US" sz="1200" dirty="0"/>
-          </a:p>
-        </p:txBody>
-      </p:sp>
-      <p:sp>
-        <p:nvSpPr>
-          <p:cNvPr id="15" name="Text 12"/>
-          <p:cNvSpPr txBox="1"/>
-          <p:nvPr/>
-        </p:nvSpPr>
-        <p:spPr>
-          <a:xfrm>
-            <a:off x="2690622" y="2176272"/>
-            <a:ext cx="1648206" cy="1024128"/>
-          </a:xfrm>
-          <a:prstGeom prst="rect">
-            <a:avLst/>
-          </a:prstGeom>
-          <a:noFill/>
-          <a:ln/>
-        </p:spPr>
-        <p:txBody>
-          <a:bodyPr wrap="square" lIns="0" tIns="0" rIns="0" bIns="0" rtlCol="0" anchor="t"/>
           <a:lstStyle/>
           <a:p>
             <a:pPr indent="0" marL="0">
@@ -16509,451 +16539,9 @@
                 <a:ea typeface="SF Pro Text" pitchFamily="34" charset="-122"/>
                 <a:cs typeface="SF Pro Text" pitchFamily="34" charset="-120"/>
               </a:rPr>
-              <a:t>Ask first, every time. They have 3 days to prove consent.</a:t>
+              <a:t>Tell the customer the refund was processed on their cleaner's behalf. Remind them to leave clear instructions for future cleaners. Block the C/CP pairing.</a:t>
             </a:r>
             <a:endParaRPr lang="en-US" sz="950" dirty="0"/>
-          </a:p>
-        </p:txBody>
-      </p:sp>
-      <p:sp>
-        <p:nvSpPr>
-          <p:cNvPr id="16" name="Shape 13"/>
-          <p:cNvSpPr/>
-          <p:nvPr/>
-        </p:nvSpPr>
-        <p:spPr>
-          <a:xfrm>
-            <a:off x="4640580" y="1280160"/>
-            <a:ext cx="1977390" cy="2011680"/>
-          </a:xfrm>
-          <a:prstGeom prst="roundRect">
-            <a:avLst>
-              <a:gd name="adj" fmla="val 3699"/>
-            </a:avLst>
-          </a:prstGeom>
-          <a:solidFill>
-            <a:srgbClr val="FFFFFF"/>
-          </a:solidFill>
-          <a:ln w="9525">
-            <a:solidFill>
-              <a:srgbClr val="DCE1E7"/>
-            </a:solidFill>
-            <a:prstDash val="solid"/>
-          </a:ln>
-        </p:spPr>
-      </p:sp>
-      <p:sp>
-        <p:nvSpPr>
-          <p:cNvPr id="17" name="Shape 14"/>
-          <p:cNvSpPr/>
-          <p:nvPr/>
-        </p:nvSpPr>
-        <p:spPr>
-          <a:xfrm>
-            <a:off x="4805172" y="1463040"/>
-            <a:ext cx="274320" cy="274320"/>
-          </a:xfrm>
-          <a:prstGeom prst="ellipse">
-            <a:avLst/>
-          </a:prstGeom>
-          <a:solidFill>
-            <a:srgbClr val="E3F4F1"/>
-          </a:solidFill>
-          <a:ln w="12700">
-            <a:solidFill>
-              <a:srgbClr val="E3F4F1"/>
-            </a:solidFill>
-            <a:prstDash val="solid"/>
-          </a:ln>
-        </p:spPr>
-      </p:sp>
-      <p:sp>
-        <p:nvSpPr>
-          <p:cNvPr id="18" name="Text 15"/>
-          <p:cNvSpPr txBox="1"/>
-          <p:nvPr/>
-        </p:nvSpPr>
-        <p:spPr>
-          <a:xfrm>
-            <a:off x="4805172" y="1463040"/>
-            <a:ext cx="274320" cy="274320"/>
-          </a:xfrm>
-          <a:prstGeom prst="rect">
-            <a:avLst/>
-          </a:prstGeom>
-          <a:noFill/>
-          <a:ln/>
-        </p:spPr>
-        <p:txBody>
-          <a:bodyPr wrap="square" lIns="0" tIns="0" rIns="0" bIns="0" rtlCol="0" anchor="ctr"/>
-          <a:lstStyle/>
-          <a:p>
-            <a:pPr algn="ctr" indent="0" marL="0">
-              <a:buNone/>
-            </a:pPr>
-            <a:r>
-              <a:rPr lang="en-US" sz="900" b="1" dirty="0">
-                <a:solidFill>
-                  <a:srgbClr val="0B7A6F"/>
-                </a:solidFill>
-                <a:latin typeface="SF Pro Display" pitchFamily="34" charset="0"/>
-                <a:ea typeface="SF Pro Display" pitchFamily="34" charset="-122"/>
-                <a:cs typeface="SF Pro Display" pitchFamily="34" charset="-120"/>
-              </a:rPr>
-              <a:t>3</a:t>
-            </a:r>
-            <a:endParaRPr lang="en-US" sz="900" dirty="0"/>
-          </a:p>
-        </p:txBody>
-      </p:sp>
-      <p:sp>
-        <p:nvSpPr>
-          <p:cNvPr id="19" name="Text 16"/>
-          <p:cNvSpPr txBox="1"/>
-          <p:nvPr/>
-        </p:nvSpPr>
-        <p:spPr>
-          <a:xfrm>
-            <a:off x="4805172" y="1883664"/>
-            <a:ext cx="1648206" cy="274320"/>
-          </a:xfrm>
-          <a:prstGeom prst="rect">
-            <a:avLst/>
-          </a:prstGeom>
-          <a:noFill/>
-          <a:ln/>
-        </p:spPr>
-        <p:txBody>
-          <a:bodyPr wrap="square" lIns="0" tIns="0" rIns="0" bIns="0" rtlCol="0" anchor="t"/>
-          <a:lstStyle/>
-          <a:p>
-            <a:pPr indent="0" marL="0">
-              <a:buNone/>
-            </a:pPr>
-            <a:r>
-              <a:rPr lang="en-US" sz="1200" b="1" dirty="0">
-                <a:solidFill>
-                  <a:srgbClr val="1D1D1F"/>
-                </a:solidFill>
-                <a:latin typeface="SF Pro Display" pitchFamily="34" charset="0"/>
-                <a:ea typeface="SF Pro Display" pitchFamily="34" charset="-122"/>
-                <a:cs typeface="SF Pro Display" pitchFamily="34" charset="-120"/>
-              </a:rPr>
-              <a:t>Refund Premium</a:t>
-            </a:r>
-            <a:endParaRPr lang="en-US" sz="1200" dirty="0"/>
-          </a:p>
-        </p:txBody>
-      </p:sp>
-      <p:sp>
-        <p:nvSpPr>
-          <p:cNvPr id="20" name="Text 17"/>
-          <p:cNvSpPr txBox="1"/>
-          <p:nvPr/>
-        </p:nvSpPr>
-        <p:spPr>
-          <a:xfrm>
-            <a:off x="4805172" y="2176272"/>
-            <a:ext cx="1648206" cy="1024128"/>
-          </a:xfrm>
-          <a:prstGeom prst="rect">
-            <a:avLst/>
-          </a:prstGeom>
-          <a:noFill/>
-          <a:ln/>
-        </p:spPr>
-        <p:txBody>
-          <a:bodyPr wrap="square" lIns="0" tIns="0" rIns="0" bIns="0" rtlCol="0" anchor="t"/>
-          <a:lstStyle/>
-          <a:p>
-            <a:pPr indent="0" marL="0">
-              <a:buNone/>
-            </a:pPr>
-            <a:r>
-              <a:rPr lang="en-US" sz="950" dirty="0">
-                <a:solidFill>
-                  <a:srgbClr val="6E6E73"/>
-                </a:solidFill>
-                <a:latin typeface="SF Pro Text" pitchFamily="34" charset="0"/>
-                <a:ea typeface="SF Pro Text" pitchFamily="34" charset="-122"/>
-                <a:cs typeface="SF Pro Text" pitchFamily="34" charset="-120"/>
-              </a:rPr>
-              <a:t>If charged. No separate request needed.</a:t>
-            </a:r>
-            <a:endParaRPr lang="en-US" sz="950" dirty="0"/>
-          </a:p>
-        </p:txBody>
-      </p:sp>
-      <p:sp>
-        <p:nvSpPr>
-          <p:cNvPr id="21" name="Shape 18"/>
-          <p:cNvSpPr/>
-          <p:nvPr/>
-        </p:nvSpPr>
-        <p:spPr>
-          <a:xfrm>
-            <a:off x="6755130" y="1280160"/>
-            <a:ext cx="1977390" cy="2011680"/>
-          </a:xfrm>
-          <a:prstGeom prst="roundRect">
-            <a:avLst>
-              <a:gd name="adj" fmla="val 3699"/>
-            </a:avLst>
-          </a:prstGeom>
-          <a:solidFill>
-            <a:srgbClr val="FFFFFF"/>
-          </a:solidFill>
-          <a:ln w="9525">
-            <a:solidFill>
-              <a:srgbClr val="DCE1E7"/>
-            </a:solidFill>
-            <a:prstDash val="solid"/>
-          </a:ln>
-        </p:spPr>
-      </p:sp>
-      <p:sp>
-        <p:nvSpPr>
-          <p:cNvPr id="22" name="Shape 19"/>
-          <p:cNvSpPr/>
-          <p:nvPr/>
-        </p:nvSpPr>
-        <p:spPr>
-          <a:xfrm>
-            <a:off x="6919722" y="1463040"/>
-            <a:ext cx="274320" cy="274320"/>
-          </a:xfrm>
-          <a:prstGeom prst="ellipse">
-            <a:avLst/>
-          </a:prstGeom>
-          <a:solidFill>
-            <a:srgbClr val="E3F4F1"/>
-          </a:solidFill>
-          <a:ln w="12700">
-            <a:solidFill>
-              <a:srgbClr val="E3F4F1"/>
-            </a:solidFill>
-            <a:prstDash val="solid"/>
-          </a:ln>
-        </p:spPr>
-      </p:sp>
-      <p:sp>
-        <p:nvSpPr>
-          <p:cNvPr id="23" name="Text 20"/>
-          <p:cNvSpPr txBox="1"/>
-          <p:nvPr/>
-        </p:nvSpPr>
-        <p:spPr>
-          <a:xfrm>
-            <a:off x="6919722" y="1463040"/>
-            <a:ext cx="274320" cy="274320"/>
-          </a:xfrm>
-          <a:prstGeom prst="rect">
-            <a:avLst/>
-          </a:prstGeom>
-          <a:noFill/>
-          <a:ln/>
-        </p:spPr>
-        <p:txBody>
-          <a:bodyPr wrap="square" lIns="0" tIns="0" rIns="0" bIns="0" rtlCol="0" anchor="ctr"/>
-          <a:lstStyle/>
-          <a:p>
-            <a:pPr algn="ctr" indent="0" marL="0">
-              <a:buNone/>
-            </a:pPr>
-            <a:r>
-              <a:rPr lang="en-US" sz="900" b="1" dirty="0">
-                <a:solidFill>
-                  <a:srgbClr val="0B7A6F"/>
-                </a:solidFill>
-                <a:latin typeface="SF Pro Display" pitchFamily="34" charset="0"/>
-                <a:ea typeface="SF Pro Display" pitchFamily="34" charset="-122"/>
-                <a:cs typeface="SF Pro Display" pitchFamily="34" charset="-120"/>
-              </a:rPr>
-              <a:t>4</a:t>
-            </a:r>
-            <a:endParaRPr lang="en-US" sz="900" dirty="0"/>
-          </a:p>
-        </p:txBody>
-      </p:sp>
-      <p:sp>
-        <p:nvSpPr>
-          <p:cNvPr id="24" name="Text 21"/>
-          <p:cNvSpPr txBox="1"/>
-          <p:nvPr/>
-        </p:nvSpPr>
-        <p:spPr>
-          <a:xfrm>
-            <a:off x="6919722" y="1883664"/>
-            <a:ext cx="1648206" cy="274320"/>
-          </a:xfrm>
-          <a:prstGeom prst="rect">
-            <a:avLst/>
-          </a:prstGeom>
-          <a:noFill/>
-          <a:ln/>
-        </p:spPr>
-        <p:txBody>
-          <a:bodyPr wrap="square" lIns="0" tIns="0" rIns="0" bIns="0" rtlCol="0" anchor="t"/>
-          <a:lstStyle/>
-          <a:p>
-            <a:pPr indent="0" marL="0">
-              <a:buNone/>
-            </a:pPr>
-            <a:r>
-              <a:rPr lang="en-US" sz="1200" b="1" dirty="0">
-                <a:solidFill>
-                  <a:srgbClr val="1D1D1F"/>
-                </a:solidFill>
-                <a:latin typeface="SF Pro Display" pitchFamily="34" charset="0"/>
-                <a:ea typeface="SF Pro Display" pitchFamily="34" charset="-122"/>
-                <a:cs typeface="SF Pro Display" pitchFamily="34" charset="-120"/>
-              </a:rPr>
-              <a:t>Close the loop</a:t>
-            </a:r>
-            <a:endParaRPr lang="en-US" sz="1200" dirty="0"/>
-          </a:p>
-        </p:txBody>
-      </p:sp>
-      <p:sp>
-        <p:nvSpPr>
-          <p:cNvPr id="25" name="Text 22"/>
-          <p:cNvSpPr txBox="1"/>
-          <p:nvPr/>
-        </p:nvSpPr>
-        <p:spPr>
-          <a:xfrm>
-            <a:off x="6919722" y="2176272"/>
-            <a:ext cx="1648206" cy="1024128"/>
-          </a:xfrm>
-          <a:prstGeom prst="rect">
-            <a:avLst/>
-          </a:prstGeom>
-          <a:noFill/>
-          <a:ln/>
-        </p:spPr>
-        <p:txBody>
-          <a:bodyPr wrap="square" lIns="0" tIns="0" rIns="0" bIns="0" rtlCol="0" anchor="t"/>
-          <a:lstStyle/>
-          <a:p>
-            <a:pPr indent="0" marL="0">
-              <a:buNone/>
-            </a:pPr>
-            <a:r>
-              <a:rPr lang="en-US" sz="950" dirty="0">
-                <a:solidFill>
-                  <a:srgbClr val="6E6E73"/>
-                </a:solidFill>
-                <a:latin typeface="SF Pro Text" pitchFamily="34" charset="0"/>
-                <a:ea typeface="SF Pro Text" pitchFamily="34" charset="-122"/>
-                <a:cs typeface="SF Pro Text" pitchFamily="34" charset="-120"/>
-              </a:rPr>
-              <a:t>Tell the customer, remind them to leave clear notes, block the pairing.</a:t>
-            </a:r>
-            <a:endParaRPr lang="en-US" sz="950" dirty="0"/>
-          </a:p>
-        </p:txBody>
-      </p:sp>
-      <p:sp>
-        <p:nvSpPr>
-          <p:cNvPr id="26" name="Shape 23"/>
-          <p:cNvSpPr/>
-          <p:nvPr/>
-        </p:nvSpPr>
-        <p:spPr>
-          <a:xfrm>
-            <a:off x="411480" y="3474720"/>
-            <a:ext cx="8321040" cy="384048"/>
-          </a:xfrm>
-          <a:prstGeom prst="roundRect">
-            <a:avLst>
-              <a:gd name="adj" fmla="val 19048"/>
-            </a:avLst>
-          </a:prstGeom>
-          <a:solidFill>
-            <a:srgbClr val="FFF3D6"/>
-          </a:solidFill>
-          <a:ln w="9525">
-            <a:solidFill>
-              <a:srgbClr val="FFF3D6"/>
-            </a:solidFill>
-            <a:prstDash val="solid"/>
-          </a:ln>
-        </p:spPr>
-      </p:sp>
-      <p:pic>
-        <p:nvPicPr>
-          <p:cNvPr id="27" name="Image 0" descr="preencoded.png">    </p:cNvPr>
-          <p:cNvPicPr>
-            <a:picLocks noChangeAspect="1"/>
-          </p:cNvPicPr>
-          <p:nvPr/>
-        </p:nvPicPr>
-        <p:blipFill>
-          <a:blip r:embed="rId1"/>
-          <a:stretch>
-            <a:fillRect/>
-          </a:stretch>
-        </p:blipFill>
-        <p:spPr>
-          <a:xfrm>
-            <a:off x="566928" y="3584448"/>
-            <a:ext cx="164592" cy="164592"/>
-          </a:xfrm>
-          <a:prstGeom prst="rect">
-            <a:avLst/>
-          </a:prstGeom>
-        </p:spPr>
-      </p:pic>
-      <p:sp>
-        <p:nvSpPr>
-          <p:cNvPr id="28" name="Text 24"/>
-          <p:cNvSpPr txBox="1"/>
-          <p:nvPr/>
-        </p:nvSpPr>
-        <p:spPr>
-          <a:xfrm>
-            <a:off x="822960" y="3575304"/>
-            <a:ext cx="7772400" cy="201168"/>
-          </a:xfrm>
-          <a:prstGeom prst="rect">
-            <a:avLst/>
-          </a:prstGeom>
-          <a:noFill/>
-          <a:ln/>
-        </p:spPr>
-        <p:txBody>
-          <a:bodyPr wrap="square" lIns="0" tIns="0" rIns="0" bIns="0" rtlCol="0" anchor="t"/>
-          <a:lstStyle/>
-          <a:p>
-            <a:pPr indent="0" marL="0">
-              <a:buNone/>
-            </a:pPr>
-            <a:r>
-              <a:rPr lang="en-US" sz="1000" b="1" dirty="0">
-                <a:solidFill>
-                  <a:srgbClr val="9A6410"/>
-                </a:solidFill>
-                <a:latin typeface="SF Pro Text" pitchFamily="34" charset="0"/>
-                <a:ea typeface="SF Pro Text" pitchFamily="34" charset="-122"/>
-                <a:cs typeface="SF Pro Text" pitchFamily="34" charset="-120"/>
-              </a:rPr>
-              <a:t>Why refund first?  </a:t>
-            </a:r>
-            <a:pPr indent="0" marL="0">
-              <a:buNone/>
-            </a:pPr>
-            <a:r>
-              <a:rPr lang="en-US" sz="1000" dirty="0">
-                <a:solidFill>
-                  <a:srgbClr val="1D1D1F"/>
-                </a:solidFill>
-                <a:latin typeface="SF Pro Text" pitchFamily="34" charset="0"/>
-                <a:ea typeface="SF Pro Text" pitchFamily="34" charset="-122"/>
-                <a:cs typeface="SF Pro Text" pitchFamily="34" charset="-120"/>
-              </a:rPr>
-              <a:t>it protects the customer's money without making them wait on an investigation.</a:t>
-            </a:r>
-            <a:endParaRPr lang="en-US" sz="1000" dirty="0"/>
           </a:p>
         </p:txBody>
       </p:sp>
@@ -17141,7 +16729,7 @@
                 <a:ea typeface="SF Pro Text" pitchFamily="34" charset="-122"/>
                 <a:cs typeface="SF Pro Text" pitchFamily="34" charset="-120"/>
               </a:rPr>
-              <a:t>The cleaner brought a helper, worked half the duration, and charged in full.</a:t>
+              <a:t>The CP brought a helper, worked half the duration, and charged in full.</a:t>
             </a:r>
             <a:endParaRPr lang="en-US" sz="1200" dirty="0"/>
           </a:p>
@@ -17155,18 +16743,273 @@
         </p:nvSpPr>
         <p:spPr>
           <a:xfrm>
-            <a:off x="411480" y="1325880"/>
-            <a:ext cx="4091940" cy="1737360"/>
+            <a:off x="2971800" y="1234440"/>
+            <a:ext cx="3200400" cy="530352"/>
           </a:xfrm>
           <a:prstGeom prst="roundRect">
             <a:avLst>
-              <a:gd name="adj" fmla="val 4211"/>
+              <a:gd name="adj" fmla="val 13793"/>
+            </a:avLst>
+          </a:prstGeom>
+          <a:solidFill>
+            <a:srgbClr val="FFF3D6"/>
+          </a:solidFill>
+          <a:ln w="12700">
+            <a:solidFill>
+              <a:srgbClr val="9A6410"/>
+            </a:solidFill>
+            <a:prstDash val="solid"/>
+          </a:ln>
+        </p:spPr>
+      </p:sp>
+      <p:sp>
+        <p:nvSpPr>
+          <p:cNvPr id="7" name="Text 4"/>
+          <p:cNvSpPr txBox="1"/>
+          <p:nvPr/>
+        </p:nvSpPr>
+        <p:spPr>
+          <a:xfrm>
+            <a:off x="2971800" y="1234440"/>
+            <a:ext cx="3200400" cy="530352"/>
+          </a:xfrm>
+          <a:prstGeom prst="rect">
+            <a:avLst/>
+          </a:prstGeom>
+          <a:noFill/>
+          <a:ln/>
+        </p:spPr>
+        <p:txBody>
+          <a:bodyPr wrap="square" lIns="0" tIns="0" rIns="0" bIns="0" rtlCol="0" anchor="ctr"/>
+          <a:lstStyle/>
+          <a:p>
+            <a:pPr algn="ctr" indent="0" marL="0">
+              <a:buNone/>
+            </a:pPr>
+            <a:r>
+              <a:rPr lang="en-US" sz="1000" b="1" dirty="0">
+                <a:solidFill>
+                  <a:srgbClr val="9A6410"/>
+                </a:solidFill>
+                <a:latin typeface="SF Pro Display" pitchFamily="34" charset="0"/>
+                <a:ea typeface="SF Pro Display" pitchFamily="34" charset="-122"/>
+                <a:cs typeface="SF Pro Display" pitchFamily="34" charset="-120"/>
+              </a:rPr>
+              <a:t>Evidence C authorized</a:t>
+            </a:r>
+            <a:endParaRPr lang="en-US" sz="1000" dirty="0"/>
+          </a:p>
+          <a:p>
+            <a:pPr algn="ctr" indent="0" marL="0">
+              <a:buNone/>
+            </a:pPr>
+            <a:r>
+              <a:rPr lang="en-US" sz="1000" b="1" dirty="0">
+                <a:solidFill>
+                  <a:srgbClr val="9A6410"/>
+                </a:solidFill>
+                <a:latin typeface="SF Pro Display" pitchFamily="34" charset="0"/>
+                <a:ea typeface="SF Pro Display" pitchFamily="34" charset="-122"/>
+                <a:cs typeface="SF Pro Display" pitchFamily="34" charset="-120"/>
+              </a:rPr>
+              <a:t>helper + reduced hours?</a:t>
+            </a:r>
+            <a:endParaRPr lang="en-US" sz="1000" dirty="0"/>
+          </a:p>
+        </p:txBody>
+      </p:sp>
+      <p:sp>
+        <p:nvSpPr>
+          <p:cNvPr id="8" name="Shape 5"/>
+          <p:cNvSpPr/>
+          <p:nvPr/>
+        </p:nvSpPr>
+        <p:spPr>
+          <a:xfrm>
+            <a:off x="4572000" y="1764792"/>
+            <a:ext cx="0" cy="292608"/>
+          </a:xfrm>
+          <a:prstGeom prst="line">
+            <a:avLst/>
+          </a:prstGeom>
+          <a:noFill/>
+          <a:ln w="12700">
+            <a:solidFill>
+              <a:srgbClr val="6E6E73"/>
+            </a:solidFill>
+            <a:prstDash val="solid"/>
+          </a:ln>
+        </p:spPr>
+      </p:sp>
+      <p:sp>
+        <p:nvSpPr>
+          <p:cNvPr id="9" name="Shape 6"/>
+          <p:cNvSpPr/>
+          <p:nvPr/>
+        </p:nvSpPr>
+        <p:spPr>
+          <a:xfrm>
+            <a:off x="2331720" y="2057400"/>
+            <a:ext cx="4480560" cy="0"/>
+          </a:xfrm>
+          <a:prstGeom prst="line">
+            <a:avLst/>
+          </a:prstGeom>
+          <a:noFill/>
+          <a:ln w="12700">
+            <a:solidFill>
+              <a:srgbClr val="6E6E73"/>
+            </a:solidFill>
+            <a:prstDash val="solid"/>
+          </a:ln>
+        </p:spPr>
+      </p:sp>
+      <p:sp>
+        <p:nvSpPr>
+          <p:cNvPr id="10" name="Shape 7"/>
+          <p:cNvSpPr/>
+          <p:nvPr/>
+        </p:nvSpPr>
+        <p:spPr>
+          <a:xfrm>
+            <a:off x="2331720" y="2057400"/>
+            <a:ext cx="0" cy="320040"/>
+          </a:xfrm>
+          <a:prstGeom prst="line">
+            <a:avLst/>
+          </a:prstGeom>
+          <a:noFill/>
+          <a:ln w="12700">
+            <a:solidFill>
+              <a:srgbClr val="6E6E73"/>
+            </a:solidFill>
+            <a:prstDash val="solid"/>
+            <a:tailEnd type="triangle"/>
+          </a:ln>
+        </p:spPr>
+      </p:sp>
+      <p:sp>
+        <p:nvSpPr>
+          <p:cNvPr id="11" name="Shape 8"/>
+          <p:cNvSpPr/>
+          <p:nvPr/>
+        </p:nvSpPr>
+        <p:spPr>
+          <a:xfrm>
+            <a:off x="6812280" y="2057400"/>
+            <a:ext cx="0" cy="320040"/>
+          </a:xfrm>
+          <a:prstGeom prst="line">
+            <a:avLst/>
+          </a:prstGeom>
+          <a:noFill/>
+          <a:ln w="12700">
+            <a:solidFill>
+              <a:srgbClr val="6E6E73"/>
+            </a:solidFill>
+            <a:prstDash val="solid"/>
+            <a:tailEnd type="triangle"/>
+          </a:ln>
+        </p:spPr>
+      </p:sp>
+      <p:sp>
+        <p:nvSpPr>
+          <p:cNvPr id="12" name="Text 9"/>
+          <p:cNvSpPr txBox="1"/>
+          <p:nvPr/>
+        </p:nvSpPr>
+        <p:spPr>
+          <a:xfrm>
+            <a:off x="2404872" y="2075688"/>
+            <a:ext cx="548640" cy="201168"/>
+          </a:xfrm>
+          <a:prstGeom prst="rect">
+            <a:avLst/>
+          </a:prstGeom>
+          <a:noFill/>
+          <a:ln/>
+        </p:spPr>
+        <p:txBody>
+          <a:bodyPr wrap="square" lIns="0" tIns="0" rIns="0" bIns="0" rtlCol="0" anchor="t"/>
+          <a:lstStyle/>
+          <a:p>
+            <a:pPr indent="0" marL="0">
+              <a:buNone/>
+            </a:pPr>
+            <a:r>
+              <a:rPr lang="en-US" sz="850" b="1" dirty="0">
+                <a:solidFill>
+                  <a:srgbClr val="6E6E73"/>
+                </a:solidFill>
+                <a:latin typeface="SF Pro Text" pitchFamily="34" charset="0"/>
+                <a:ea typeface="SF Pro Text" pitchFamily="34" charset="-122"/>
+                <a:cs typeface="SF Pro Text" pitchFamily="34" charset="-120"/>
+              </a:rPr>
+              <a:t>Yes</a:t>
+            </a:r>
+            <a:endParaRPr lang="en-US" sz="850" dirty="0"/>
+          </a:p>
+        </p:txBody>
+      </p:sp>
+      <p:sp>
+        <p:nvSpPr>
+          <p:cNvPr id="13" name="Text 10"/>
+          <p:cNvSpPr txBox="1"/>
+          <p:nvPr/>
+        </p:nvSpPr>
+        <p:spPr>
+          <a:xfrm>
+            <a:off x="6885432" y="2075688"/>
+            <a:ext cx="548640" cy="201168"/>
+          </a:xfrm>
+          <a:prstGeom prst="rect">
+            <a:avLst/>
+          </a:prstGeom>
+          <a:noFill/>
+          <a:ln/>
+        </p:spPr>
+        <p:txBody>
+          <a:bodyPr wrap="square" lIns="0" tIns="0" rIns="0" bIns="0" rtlCol="0" anchor="t"/>
+          <a:lstStyle/>
+          <a:p>
+            <a:pPr indent="0" marL="0">
+              <a:buNone/>
+            </a:pPr>
+            <a:r>
+              <a:rPr lang="en-US" sz="850" b="1" dirty="0">
+                <a:solidFill>
+                  <a:srgbClr val="6E6E73"/>
+                </a:solidFill>
+                <a:latin typeface="SF Pro Text" pitchFamily="34" charset="0"/>
+                <a:ea typeface="SF Pro Text" pitchFamily="34" charset="-122"/>
+                <a:cs typeface="SF Pro Text" pitchFamily="34" charset="-120"/>
+              </a:rPr>
+              <a:t>No</a:t>
+            </a:r>
+            <a:endParaRPr lang="en-US" sz="850" dirty="0"/>
+          </a:p>
+        </p:txBody>
+      </p:sp>
+      <p:sp>
+        <p:nvSpPr>
+          <p:cNvPr id="14" name="Shape 11"/>
+          <p:cNvSpPr/>
+          <p:nvPr/>
+        </p:nvSpPr>
+        <p:spPr>
+          <a:xfrm>
+            <a:off x="868680" y="2377440"/>
+            <a:ext cx="2926080" cy="502920"/>
+          </a:xfrm>
+          <a:prstGeom prst="roundRect">
+            <a:avLst>
+              <a:gd name="adj" fmla="val 14545"/>
             </a:avLst>
           </a:prstGeom>
           <a:solidFill>
             <a:srgbClr val="FFFFFF"/>
           </a:solidFill>
-          <a:ln w="9525">
+          <a:ln w="12700">
             <a:solidFill>
               <a:srgbClr val="DCE1E7"/>
             </a:solidFill>
@@ -17176,102 +17019,153 @@
       </p:sp>
       <p:sp>
         <p:nvSpPr>
-          <p:cNvPr id="7" name="Shape 4"/>
+          <p:cNvPr id="15" name="Text 12"/>
+          <p:cNvSpPr txBox="1"/>
+          <p:nvPr/>
+        </p:nvSpPr>
+        <p:spPr>
+          <a:xfrm>
+            <a:off x="868680" y="2377440"/>
+            <a:ext cx="2926080" cy="502920"/>
+          </a:xfrm>
+          <a:prstGeom prst="rect">
+            <a:avLst/>
+          </a:prstGeom>
+          <a:noFill/>
+          <a:ln/>
+        </p:spPr>
+        <p:txBody>
+          <a:bodyPr wrap="square" lIns="0" tIns="0" rIns="0" bIns="0" rtlCol="0" anchor="ctr"/>
+          <a:lstStyle/>
+          <a:p>
+            <a:pPr algn="ctr" indent="0" marL="0">
+              <a:buNone/>
+            </a:pPr>
+            <a:r>
+              <a:rPr lang="en-US" sz="1000" b="1" dirty="0">
+                <a:solidFill>
+                  <a:srgbClr val="1D1D1F"/>
+                </a:solidFill>
+                <a:latin typeface="SF Pro Display" pitchFamily="34" charset="0"/>
+                <a:ea typeface="SF Pro Display" pitchFamily="34" charset="-122"/>
+                <a:cs typeface="SF Pro Display" pitchFamily="34" charset="-120"/>
+              </a:rPr>
+              <a:t>No penalty</a:t>
+            </a:r>
+            <a:endParaRPr lang="en-US" sz="1000" dirty="0"/>
+          </a:p>
+          <a:p>
+            <a:pPr algn="ctr" indent="0" marL="0">
+              <a:buNone/>
+            </a:pPr>
+            <a:r>
+              <a:rPr lang="en-US" sz="1000" b="1" dirty="0">
+                <a:solidFill>
+                  <a:srgbClr val="1D1D1F"/>
+                </a:solidFill>
+                <a:latin typeface="SF Pro Display" pitchFamily="34" charset="0"/>
+                <a:ea typeface="SF Pro Display" pitchFamily="34" charset="-122"/>
+                <a:cs typeface="SF Pro Display" pitchFamily="34" charset="-120"/>
+              </a:rPr>
+              <a:t>C agreed to this</a:t>
+            </a:r>
+            <a:endParaRPr lang="en-US" sz="1000" dirty="0"/>
+          </a:p>
+        </p:txBody>
+      </p:sp>
+      <p:sp>
+        <p:nvSpPr>
+          <p:cNvPr id="16" name="Shape 13"/>
           <p:cNvSpPr/>
           <p:nvPr/>
         </p:nvSpPr>
         <p:spPr>
           <a:xfrm>
-            <a:off x="576072" y="1490472"/>
-            <a:ext cx="329184" cy="329184"/>
-          </a:xfrm>
-          <a:prstGeom prst="ellipse">
-            <a:avLst/>
+            <a:off x="5349240" y="2377440"/>
+            <a:ext cx="2926080" cy="502920"/>
+          </a:xfrm>
+          <a:prstGeom prst="roundRect">
+            <a:avLst>
+              <a:gd name="adj" fmla="val 14545"/>
+            </a:avLst>
           </a:prstGeom>
           <a:solidFill>
-            <a:srgbClr val="E3F4F1"/>
+            <a:srgbClr val="1D1D1F"/>
           </a:solidFill>
           <a:ln w="12700">
             <a:solidFill>
-              <a:srgbClr val="E3F4F1"/>
+              <a:srgbClr val="1D1D1F"/>
             </a:solidFill>
             <a:prstDash val="solid"/>
           </a:ln>
         </p:spPr>
       </p:sp>
-      <p:pic>
-        <p:nvPicPr>
-          <p:cNvPr id="8" name="Image 0" descr="preencoded.png">    </p:cNvPr>
-          <p:cNvPicPr>
-            <a:picLocks noChangeAspect="1"/>
-          </p:cNvPicPr>
-          <p:nvPr/>
-        </p:nvPicPr>
-        <p:blipFill>
-          <a:blip r:embed="rId1"/>
-          <a:stretch>
-            <a:fillRect/>
-          </a:stretch>
-        </p:blipFill>
-        <p:spPr>
-          <a:xfrm>
-            <a:off x="655076" y="1569476"/>
-            <a:ext cx="171176" cy="171176"/>
-          </a:xfrm>
-          <a:prstGeom prst="rect">
-            <a:avLst/>
-          </a:prstGeom>
-        </p:spPr>
-      </p:pic>
-      <p:sp>
-        <p:nvSpPr>
-          <p:cNvPr id="9" name="Text 5"/>
-          <p:cNvSpPr txBox="1"/>
-          <p:nvPr/>
-        </p:nvSpPr>
-        <p:spPr>
-          <a:xfrm>
-            <a:off x="576072" y="1929384"/>
-            <a:ext cx="3762756" cy="274320"/>
-          </a:xfrm>
-          <a:prstGeom prst="rect">
-            <a:avLst/>
-          </a:prstGeom>
-          <a:noFill/>
-          <a:ln/>
-        </p:spPr>
-        <p:txBody>
-          <a:bodyPr wrap="square" lIns="0" tIns="0" rIns="0" bIns="0" rtlCol="0" anchor="t"/>
-          <a:lstStyle/>
-          <a:p>
-            <a:pPr indent="0" marL="0">
-              <a:buNone/>
-            </a:pPr>
-            <a:r>
-              <a:rPr lang="en-US" sz="1200" b="1" dirty="0">
-                <a:solidFill>
-                  <a:srgbClr val="1D1D1F"/>
+      <p:sp>
+        <p:nvSpPr>
+          <p:cNvPr id="17" name="Text 14"/>
+          <p:cNvSpPr txBox="1"/>
+          <p:nvPr/>
+        </p:nvSpPr>
+        <p:spPr>
+          <a:xfrm>
+            <a:off x="5349240" y="2377440"/>
+            <a:ext cx="2926080" cy="502920"/>
+          </a:xfrm>
+          <a:prstGeom prst="rect">
+            <a:avLst/>
+          </a:prstGeom>
+          <a:noFill/>
+          <a:ln/>
+        </p:spPr>
+        <p:txBody>
+          <a:bodyPr wrap="square" lIns="0" tIns="0" rIns="0" bIns="0" rtlCol="0" anchor="ctr"/>
+          <a:lstStyle/>
+          <a:p>
+            <a:pPr algn="ctr" indent="0" marL="0">
+              <a:buNone/>
+            </a:pPr>
+            <a:r>
+              <a:rPr lang="en-US" sz="1000" b="1" dirty="0">
+                <a:solidFill>
+                  <a:srgbClr val="FFFFFF"/>
                 </a:solidFill>
                 <a:latin typeface="SF Pro Display" pitchFamily="34" charset="0"/>
                 <a:ea typeface="SF Pro Display" pitchFamily="34" charset="-122"/>
                 <a:cs typeface="SF Pro Display" pitchFamily="34" charset="-120"/>
               </a:rPr>
-              <a:t>Customer authorized it</a:t>
-            </a:r>
-            <a:endParaRPr lang="en-US" sz="1200" dirty="0"/>
-          </a:p>
-        </p:txBody>
-      </p:sp>
-      <p:sp>
-        <p:nvSpPr>
-          <p:cNvPr id="10" name="Text 6"/>
-          <p:cNvSpPr txBox="1"/>
-          <p:nvPr/>
-        </p:nvSpPr>
-        <p:spPr>
-          <a:xfrm>
-            <a:off x="576072" y="2221992"/>
-            <a:ext cx="3762756" cy="749808"/>
+              <a:t>Request documentation</a:t>
+            </a:r>
+            <a:endParaRPr lang="en-US" sz="1000" dirty="0"/>
+          </a:p>
+          <a:p>
+            <a:pPr algn="ctr" indent="0" marL="0">
+              <a:buNone/>
+            </a:pPr>
+            <a:r>
+              <a:rPr lang="en-US" sz="1000" b="1" dirty="0">
+                <a:solidFill>
+                  <a:srgbClr val="FFFFFF"/>
+                </a:solidFill>
+                <a:latin typeface="SF Pro Display" pitchFamily="34" charset="0"/>
+                <a:ea typeface="SF Pro Display" pitchFamily="34" charset="-122"/>
+                <a:cs typeface="SF Pro Display" pitchFamily="34" charset="-120"/>
+              </a:rPr>
+              <a:t>Same as the main flow</a:t>
+            </a:r>
+            <a:endParaRPr lang="en-US" sz="1000" dirty="0"/>
+          </a:p>
+        </p:txBody>
+      </p:sp>
+      <p:sp>
+        <p:nvSpPr>
+          <p:cNvPr id="18" name="Text 15"/>
+          <p:cNvSpPr txBox="1"/>
+          <p:nvPr/>
+        </p:nvSpPr>
+        <p:spPr>
+          <a:xfrm>
+            <a:off x="868680" y="2999232"/>
+            <a:ext cx="2926080" cy="1143000"/>
           </a:xfrm>
           <a:prstGeom prst="rect">
             <a:avLst/>
@@ -17284,164 +17178,30 @@
           <a:lstStyle/>
           <a:p>
             <a:pPr indent="0" marL="0">
-              <a:buNone/>
-            </a:pPr>
-            <a:r>
-              <a:rPr lang="en-US" sz="950" dirty="0">
-                <a:solidFill>
-                  <a:srgbClr val="6E6E73"/>
+              <a:spcAft>
+                <a:spcPts val="300"/>
+              </a:spcAft>
+              <a:buNone/>
+            </a:pPr>
+            <a:r>
+              <a:rPr lang="en-US" sz="900" b="1" dirty="0">
+                <a:solidFill>
+                  <a:srgbClr val="1D1D1F"/>
                 </a:solidFill>
                 <a:latin typeface="SF Pro Text" pitchFamily="34" charset="0"/>
                 <a:ea typeface="SF Pro Text" pitchFamily="34" charset="-122"/>
                 <a:cs typeface="SF Pro Text" pitchFamily="34" charset="-120"/>
               </a:rPr>
-              <a:t>Tell them records show they did. Address other pain points. No penalty.</a:t>
-            </a:r>
-            <a:endParaRPr lang="en-US" sz="950" dirty="0"/>
-          </a:p>
-        </p:txBody>
-      </p:sp>
-      <p:sp>
-        <p:nvSpPr>
-          <p:cNvPr id="11" name="Shape 7"/>
-          <p:cNvSpPr/>
-          <p:nvPr/>
-        </p:nvSpPr>
-        <p:spPr>
-          <a:xfrm>
-            <a:off x="4640580" y="1325880"/>
-            <a:ext cx="4091940" cy="1737360"/>
-          </a:xfrm>
-          <a:prstGeom prst="roundRect">
-            <a:avLst>
-              <a:gd name="adj" fmla="val 4211"/>
-            </a:avLst>
-          </a:prstGeom>
-          <a:solidFill>
-            <a:srgbClr val="FFFFFF"/>
-          </a:solidFill>
-          <a:ln w="9525">
-            <a:solidFill>
-              <a:srgbClr val="DCE1E7"/>
-            </a:solidFill>
-            <a:prstDash val="solid"/>
-          </a:ln>
-        </p:spPr>
-      </p:sp>
-      <p:sp>
-        <p:nvSpPr>
-          <p:cNvPr id="12" name="Shape 8"/>
-          <p:cNvSpPr/>
-          <p:nvPr/>
-        </p:nvSpPr>
-        <p:spPr>
-          <a:xfrm>
-            <a:off x="4805172" y="1490472"/>
-            <a:ext cx="329184" cy="329184"/>
-          </a:xfrm>
-          <a:prstGeom prst="ellipse">
-            <a:avLst/>
-          </a:prstGeom>
-          <a:solidFill>
-            <a:srgbClr val="E3F4F1"/>
-          </a:solidFill>
-          <a:ln w="12700">
-            <a:solidFill>
-              <a:srgbClr val="E3F4F1"/>
-            </a:solidFill>
-            <a:prstDash val="solid"/>
-          </a:ln>
-        </p:spPr>
-      </p:sp>
-      <p:pic>
-        <p:nvPicPr>
-          <p:cNvPr id="13" name="Image 1" descr="preencoded.png">    </p:cNvPr>
-          <p:cNvPicPr>
-            <a:picLocks noChangeAspect="1"/>
-          </p:cNvPicPr>
-          <p:nvPr/>
-        </p:nvPicPr>
-        <p:blipFill>
-          <a:blip r:embed="rId2"/>
-          <a:stretch>
-            <a:fillRect/>
-          </a:stretch>
-        </p:blipFill>
-        <p:spPr>
-          <a:xfrm>
-            <a:off x="4884176" y="1569476"/>
-            <a:ext cx="171176" cy="171176"/>
-          </a:xfrm>
-          <a:prstGeom prst="rect">
-            <a:avLst/>
-          </a:prstGeom>
-        </p:spPr>
-      </p:pic>
-      <p:sp>
-        <p:nvSpPr>
-          <p:cNvPr id="14" name="Text 9"/>
-          <p:cNvSpPr txBox="1"/>
-          <p:nvPr/>
-        </p:nvSpPr>
-        <p:spPr>
-          <a:xfrm>
-            <a:off x="4805172" y="1929384"/>
-            <a:ext cx="3762756" cy="274320"/>
-          </a:xfrm>
-          <a:prstGeom prst="rect">
-            <a:avLst/>
-          </a:prstGeom>
-          <a:noFill/>
-          <a:ln/>
-        </p:spPr>
-        <p:txBody>
-          <a:bodyPr wrap="square" lIns="0" tIns="0" rIns="0" bIns="0" rtlCol="0" anchor="t"/>
-          <a:lstStyle/>
-          <a:p>
+              <a:t>Tell the customer </a:t>
+            </a:r>
             <a:pPr indent="0" marL="0">
-              <a:buNone/>
-            </a:pPr>
-            <a:r>
-              <a:rPr lang="en-US" sz="1200" b="1" dirty="0">
-                <a:solidFill>
-                  <a:srgbClr val="1D1D1F"/>
-                </a:solidFill>
-                <a:latin typeface="SF Pro Display" pitchFamily="34" charset="0"/>
-                <a:ea typeface="SF Pro Display" pitchFamily="34" charset="-122"/>
-                <a:cs typeface="SF Pro Display" pitchFamily="34" charset="-120"/>
-              </a:rPr>
-              <a:t>No authorization</a:t>
-            </a:r>
-            <a:endParaRPr lang="en-US" sz="1200" dirty="0"/>
-          </a:p>
-        </p:txBody>
-      </p:sp>
-      <p:sp>
-        <p:nvSpPr>
-          <p:cNvPr id="15" name="Text 10"/>
-          <p:cNvSpPr txBox="1"/>
-          <p:nvPr/>
-        </p:nvSpPr>
-        <p:spPr>
-          <a:xfrm>
-            <a:off x="4805172" y="2221992"/>
-            <a:ext cx="3762756" cy="749808"/>
-          </a:xfrm>
-          <a:prstGeom prst="rect">
-            <a:avLst/>
-          </a:prstGeom>
-          <a:noFill/>
-          <a:ln/>
-        </p:spPr>
-        <p:txBody>
-          <a:bodyPr wrap="square" lIns="0" tIns="0" rIns="0" bIns="0" rtlCol="0" anchor="t"/>
-          <a:lstStyle/>
-          <a:p>
-            <a:pPr indent="0" marL="0">
-              <a:buNone/>
-            </a:pPr>
-            <a:r>
-              <a:rPr lang="en-US" sz="950" dirty="0">
+              <a:spcAft>
+                <a:spcPts val="300"/>
+              </a:spcAft>
+              <a:buNone/>
+            </a:pPr>
+            <a:r>
+              <a:rPr lang="en-US" sz="900" dirty="0">
                 <a:solidFill>
                   <a:srgbClr val="6E6E73"/>
                 </a:solidFill>
@@ -17449,21 +17209,228 @@
                 <a:ea typeface="SF Pro Text" pitchFamily="34" charset="-122"/>
                 <a:cs typeface="SF Pro Text" pitchFamily="34" charset="-120"/>
               </a:rPr>
-              <a:t>Main flow: request documentation. Coach: helpers need permission.</a:t>
-            </a:r>
-            <a:endParaRPr lang="en-US" sz="950" dirty="0"/>
-          </a:p>
-        </p:txBody>
-      </p:sp>
-      <p:sp>
-        <p:nvSpPr>
-          <p:cNvPr id="16" name="Shape 11"/>
+              <a:t>records show they authorized the helper and the shorter time.</a:t>
+            </a:r>
+            <a:endParaRPr lang="en-US" sz="900" dirty="0"/>
+          </a:p>
+          <a:p>
+            <a:pPr indent="0" marL="0">
+              <a:spcAft>
+                <a:spcPts val="300"/>
+              </a:spcAft>
+              <a:buNone/>
+            </a:pPr>
+            <a:r>
+              <a:rPr lang="en-US" sz="900" b="1" dirty="0">
+                <a:solidFill>
+                  <a:srgbClr val="1D1D1F"/>
+                </a:solidFill>
+                <a:latin typeface="SF Pro Text" pitchFamily="34" charset="0"/>
+                <a:ea typeface="SF Pro Text" pitchFamily="34" charset="-122"/>
+                <a:cs typeface="SF Pro Text" pitchFamily="34" charset="-120"/>
+              </a:rPr>
+              <a:t>Address </a:t>
+            </a:r>
+            <a:pPr indent="0" marL="0">
+              <a:spcAft>
+                <a:spcPts val="300"/>
+              </a:spcAft>
+              <a:buNone/>
+            </a:pPr>
+            <a:r>
+              <a:rPr lang="en-US" sz="900" dirty="0">
+                <a:solidFill>
+                  <a:srgbClr val="6E6E73"/>
+                </a:solidFill>
+                <a:latin typeface="SF Pro Text" pitchFamily="34" charset="0"/>
+                <a:ea typeface="SF Pro Text" pitchFamily="34" charset="-122"/>
+                <a:cs typeface="SF Pro Text" pitchFamily="34" charset="-120"/>
+              </a:rPr>
+              <a:t>any other pain points.</a:t>
+            </a:r>
+            <a:endParaRPr lang="en-US" sz="900" dirty="0"/>
+          </a:p>
+          <a:p>
+            <a:pPr indent="0" marL="0">
+              <a:spcAft>
+                <a:spcPts val="300"/>
+              </a:spcAft>
+              <a:buNone/>
+            </a:pPr>
+            <a:r>
+              <a:rPr lang="en-US" sz="900" b="1" dirty="0">
+                <a:solidFill>
+                  <a:srgbClr val="1D1D1F"/>
+                </a:solidFill>
+                <a:latin typeface="SF Pro Text" pitchFamily="34" charset="0"/>
+                <a:ea typeface="SF Pro Text" pitchFamily="34" charset="-122"/>
+                <a:cs typeface="SF Pro Text" pitchFamily="34" charset="-120"/>
+              </a:rPr>
+              <a:t>Don't </a:t>
+            </a:r>
+            <a:pPr indent="0" marL="0">
+              <a:spcAft>
+                <a:spcPts val="300"/>
+              </a:spcAft>
+              <a:buNone/>
+            </a:pPr>
+            <a:r>
+              <a:rPr lang="en-US" sz="900" dirty="0">
+                <a:solidFill>
+                  <a:srgbClr val="6E6E73"/>
+                </a:solidFill>
+                <a:latin typeface="SF Pro Text" pitchFamily="34" charset="0"/>
+                <a:ea typeface="SF Pro Text" pitchFamily="34" charset="-122"/>
+                <a:cs typeface="SF Pro Text" pitchFamily="34" charset="-120"/>
+              </a:rPr>
+              <a:t>penalize the CP.</a:t>
+            </a:r>
+            <a:endParaRPr lang="en-US" sz="900" dirty="0"/>
+          </a:p>
+        </p:txBody>
+      </p:sp>
+      <p:sp>
+        <p:nvSpPr>
+          <p:cNvPr id="19" name="Text 16"/>
+          <p:cNvSpPr txBox="1"/>
+          <p:nvPr/>
+        </p:nvSpPr>
+        <p:spPr>
+          <a:xfrm>
+            <a:off x="5349240" y="2999232"/>
+            <a:ext cx="2926080" cy="1143000"/>
+          </a:xfrm>
+          <a:prstGeom prst="rect">
+            <a:avLst/>
+          </a:prstGeom>
+          <a:noFill/>
+          <a:ln/>
+        </p:spPr>
+        <p:txBody>
+          <a:bodyPr wrap="square" lIns="0" tIns="0" rIns="0" bIns="0" rtlCol="0" anchor="t"/>
+          <a:lstStyle/>
+          <a:p>
+            <a:pPr indent="0" marL="0">
+              <a:spcAft>
+                <a:spcPts val="300"/>
+              </a:spcAft>
+              <a:buNone/>
+            </a:pPr>
+            <a:r>
+              <a:rPr lang="en-US" sz="900" b="1" dirty="0">
+                <a:solidFill>
+                  <a:srgbClr val="1D1D1F"/>
+                </a:solidFill>
+                <a:latin typeface="SF Pro Text" pitchFamily="34" charset="0"/>
+                <a:ea typeface="SF Pro Text" pitchFamily="34" charset="-122"/>
+                <a:cs typeface="SF Pro Text" pitchFamily="34" charset="-120"/>
+              </a:rPr>
+              <a:t>Refund </a:t>
+            </a:r>
+            <a:pPr indent="0" marL="0">
+              <a:spcAft>
+                <a:spcPts val="300"/>
+              </a:spcAft>
+              <a:buNone/>
+            </a:pPr>
+            <a:r>
+              <a:rPr lang="en-US" sz="900" dirty="0">
+                <a:solidFill>
+                  <a:srgbClr val="6E6E73"/>
+                </a:solidFill>
+                <a:latin typeface="SF Pro Text" pitchFamily="34" charset="0"/>
+                <a:ea typeface="SF Pro Text" pitchFamily="34" charset="-122"/>
+                <a:cs typeface="SF Pro Text" pitchFamily="34" charset="-120"/>
+              </a:rPr>
+              <a:t>the unauthorized hours via the CP Dashboard.</a:t>
+            </a:r>
+            <a:endParaRPr lang="en-US" sz="900" dirty="0"/>
+          </a:p>
+          <a:p>
+            <a:pPr indent="0" marL="0">
+              <a:spcAft>
+                <a:spcPts val="300"/>
+              </a:spcAft>
+              <a:buNone/>
+            </a:pPr>
+            <a:r>
+              <a:rPr lang="en-US" sz="900" b="1" dirty="0">
+                <a:solidFill>
+                  <a:srgbClr val="1D1D1F"/>
+                </a:solidFill>
+                <a:latin typeface="SF Pro Text" pitchFamily="34" charset="0"/>
+                <a:ea typeface="SF Pro Text" pitchFamily="34" charset="-122"/>
+                <a:cs typeface="SF Pro Text" pitchFamily="34" charset="-120"/>
+              </a:rPr>
+              <a:t>Request </a:t>
+            </a:r>
+            <a:pPr indent="0" marL="0">
+              <a:spcAft>
+                <a:spcPts val="300"/>
+              </a:spcAft>
+              <a:buNone/>
+            </a:pPr>
+            <a:r>
+              <a:rPr lang="en-US" sz="900" dirty="0">
+                <a:solidFill>
+                  <a:srgbClr val="6E6E73"/>
+                </a:solidFill>
+                <a:latin typeface="SF Pro Text" pitchFamily="34" charset="0"/>
+                <a:ea typeface="SF Pro Text" pitchFamily="34" charset="-122"/>
+                <a:cs typeface="SF Pro Text" pitchFamily="34" charset="-120"/>
+              </a:rPr>
+              <a:t>documentation from the CP (3 days).</a:t>
+            </a:r>
+            <a:endParaRPr lang="en-US" sz="900" dirty="0"/>
+          </a:p>
+          <a:p>
+            <a:pPr indent="0" marL="0">
+              <a:spcAft>
+                <a:spcPts val="300"/>
+              </a:spcAft>
+              <a:buNone/>
+            </a:pPr>
+            <a:r>
+              <a:rPr lang="en-US" sz="900" b="1" dirty="0">
+                <a:solidFill>
+                  <a:srgbClr val="1D1D1F"/>
+                </a:solidFill>
+                <a:latin typeface="SF Pro Text" pitchFamily="34" charset="0"/>
+                <a:ea typeface="SF Pro Text" pitchFamily="34" charset="-122"/>
+                <a:cs typeface="SF Pro Text" pitchFamily="34" charset="-120"/>
+              </a:rPr>
+              <a:t>Coach: </a:t>
+            </a:r>
+            <a:pPr indent="0" marL="0">
+              <a:spcAft>
+                <a:spcPts val="300"/>
+              </a:spcAft>
+              <a:buNone/>
+            </a:pPr>
+            <a:r>
+              <a:rPr lang="en-US" sz="900" dirty="0">
+                <a:solidFill>
+                  <a:srgbClr val="6E6E73"/>
+                </a:solidFill>
+                <a:latin typeface="SF Pro Text" pitchFamily="34" charset="0"/>
+                <a:ea typeface="SF Pro Text" pitchFamily="34" charset="-122"/>
+                <a:cs typeface="SF Pro Text" pitchFamily="34" charset="-120"/>
+              </a:rPr>
+              <a:t>helpers need permission and can't justify full-rate billing.</a:t>
+            </a:r>
+            <a:endParaRPr lang="en-US" sz="900" dirty="0"/>
+          </a:p>
+        </p:txBody>
+      </p:sp>
+      <p:sp>
+        <p:nvSpPr>
+          <p:cNvPr id="20" name="Shape 17"/>
           <p:cNvSpPr/>
           <p:nvPr/>
         </p:nvSpPr>
         <p:spPr>
           <a:xfrm>
-            <a:off x="411480" y="3246120"/>
+            <a:off x="411480" y="4206240"/>
             <a:ext cx="8321040" cy="384048"/>
           </a:xfrm>
           <a:prstGeom prst="roundRect">
@@ -17484,21 +17451,21 @@
       </p:sp>
       <p:pic>
         <p:nvPicPr>
-          <p:cNvPr id="17" name="Image 2" descr="preencoded.png">    </p:cNvPr>
+          <p:cNvPr id="21" name="Image 0" descr="preencoded.png">    </p:cNvPr>
           <p:cNvPicPr>
             <a:picLocks noChangeAspect="1"/>
           </p:cNvPicPr>
           <p:nvPr/>
         </p:nvPicPr>
         <p:blipFill>
-          <a:blip r:embed="rId3"/>
+          <a:blip r:embed="rId1"/>
           <a:stretch>
             <a:fillRect/>
           </a:stretch>
         </p:blipFill>
         <p:spPr>
           <a:xfrm>
-            <a:off x="566928" y="3355848"/>
+            <a:off x="566928" y="4315968"/>
             <a:ext cx="164592" cy="164592"/>
           </a:xfrm>
           <a:prstGeom prst="rect">
@@ -17508,13 +17475,13 @@
       </p:pic>
       <p:sp>
         <p:nvSpPr>
-          <p:cNvPr id="18" name="Text 12"/>
-          <p:cNvSpPr txBox="1"/>
-          <p:nvPr/>
-        </p:nvSpPr>
-        <p:spPr>
-          <a:xfrm>
-            <a:off x="822960" y="3346704"/>
+          <p:cNvPr id="22" name="Text 18"/>
+          <p:cNvSpPr txBox="1"/>
+          <p:nvPr/>
+        </p:nvSpPr>
+        <p:spPr>
+          <a:xfrm>
+            <a:off x="822960" y="4306824"/>
             <a:ext cx="7772400" cy="201168"/>
           </a:xfrm>
           <a:prstGeom prst="rect">
@@ -17553,7 +17520,7 @@
                 <a:ea typeface="SF Pro Text" pitchFamily="34" charset="-122"/>
                 <a:cs typeface="SF Pro Text" pitchFamily="34" charset="-120"/>
               </a:rPr>
-              <a:t>stop and go to AG – Fraud (CP Document Fraud).</a:t>
+              <a:t>stop and go to AG – Fraud (CP Document Fraud). It's a separate offence.</a:t>
             </a:r>
             <a:endParaRPr lang="en-US" sz="1000" dirty="0"/>
           </a:p>

</xml_diff>

<commit_message>
Hide flowchart descriptions on slides 21 and 30; reveal one per click with a Show details button
Co-Authored-By: Claude Opus 5.5 <noreply@anthropic.com>
Claude-Session: https://claude.ai/code/session_01FEzv8wwqWDgTsXP8Yz6XYn
</commit_message>
<xml_diff>
--- a/billing-disputes/billing-disputes-cash-payments.pptx
+++ b/billing-disputes/billing-disputes-cash-payments.pptx
@@ -1689,7 +1689,7 @@
           <a:p>
             <a:r>
               <a:rPr lang="en-US" dirty="0"/>
-              <a:t>Step 1: refund only the alleged unauthorized hours via the cleaner's dashboard, not the full job; the base appointment was authorized and worked. Step 2: coach the cleaner on asking permission before extending; send comms about the action taken; give them 3 days to provide documentation proving the customer authorized the extra hours. Refunding first protects the customer's money without making them wait on an investigation. Step 3: if a Premium fee was charged, refund it; unauthorized hours is itself the service issue. Step 4: tell the customer a refund was processed on their cleaner's behalf, remind them to leave clear instructions for future cleaners, and block the C/CP pairing. Macros: Unauthorized Addition of Hours (customer refund); Unauthorized Addition of Hours &gt; CP Coaching.</a:t>
+              <a:t>TRAINER: descriptions are hidden. Click Show details (or press the right arrow): each click types out the next step's description. Step 1: refund only the alleged unauthorized hours via the cleaner's dashboard, not the full job; the base appointment was authorized and worked. Step 2: coach the cleaner on asking permission before extending; send comms about the action taken; give them 3 days to provide documentation proving the customer authorized the extra hours. Refunding first protects the customer's money without making them wait on an investigation. Step 3: if a Premium fee was charged, refund it; unauthorized hours is itself the service issue. Step 4: tell the customer a refund was processed on their cleaner's behalf, remind them to leave clear instructions for future cleaners, and block the C/CP pairing. Macros: Unauthorized Addition of Hours (customer refund); Unauthorized Addition of Hours &gt; CP Coaching.</a:t>
             </a:r>
             <a:endParaRPr lang="en-US" dirty="0"/>
           </a:p>
@@ -2569,7 +2569,7 @@
           <a:p>
             <a:r>
               <a:rPr lang="en-US" dirty="0"/>
-              <a:t>1) Issue a full refund via the CP Dashboard. 2) Check the cleaner's Flags table for an existing cp_false_invoice flag on this job. 3) If the system already flagged it, validate that the Job ID matches; on the flag's Django page set Value to {"admin": "&lt;YOUR CRM NAME&gt;", "admin_flag_comments": "&lt;THE ID TRIPLET&gt;", "cp_false_invoice_job_id": &lt;THE JOB ID&gt;}. If no flag exists, add one: CP CRM &gt; Do &gt; Flag &gt; cp_false_invoice. Always include the ID triplet (Customer ID | CP ID | Job ID) and a short summary. 4) Check the Issues Table for prior false invoice / overcharge history and penalize accordingly. Reason: cpq_false_invoice Customer &lt;C'S NAME&gt; reported incorrect hours charged. Submit reactivation appeal. 5) Coach the cleaner: don't claim jobs you can't complete or invoice without working; ask the customer to reschedule, or cancel from your dashboard if they disagree. Guardian Angel or Tier 10 banner with pending items: acknowledge, don't clear, reassign to allentolentino. 6) Refund the Premium fee if charged (AG - Refund: Premium Upsell). 7) Block the C/CP pairing unless the customer wants the same cleaner. 8) Tell the customer the refund was issued and arrives in 5-10 business days; address other pain points. Macros: False Invoice (C-facing); False Invoice (With Penalty) (CP-facing). Final step: confirm the refund with the customer and offer a priority booking.</a:t>
+              <a:t>TRAINER: descriptions are hidden. Click Show details (or press the right arrow): each click types out the next step's description. 1) Issue a full refund via the CP Dashboard. 2) Check the cleaner's Flags table for an existing cp_false_invoice flag on this job. 3) If the system already flagged it, validate that the Job ID matches; on the flag's Django page set Value to {"admin": "&lt;YOUR CRM NAME&gt;", "admin_flag_comments": "&lt;THE ID TRIPLET&gt;", "cp_false_invoice_job_id": &lt;THE JOB ID&gt;}. If no flag exists, add one: CP CRM &gt; Do &gt; Flag &gt; cp_false_invoice. Always include the ID triplet (Customer ID | CP ID | Job ID) and a short summary. 4) Check the Issues Table for prior false invoice / overcharge history and penalize accordingly. Reason: cpq_false_invoice Customer &lt;C'S NAME&gt; reported incorrect hours charged. Submit reactivation appeal. 5) Coach the cleaner: don't claim jobs you can't complete or invoice without working; ask the customer to reschedule, or cancel from your dashboard if they disagree. Guardian Angel or Tier 10 banner with pending items: acknowledge, don't clear, reassign to allentolentino. 6) Refund the Premium fee if charged (AG - Refund: Premium Upsell). 7) Block the C/CP pairing unless the customer wants the same cleaner. 8) Tell the customer the refund was issued and arrives in 5-10 business days; address other pain points. Macros: False Invoice (C-facing); False Invoice (With Penalty) (CP-facing). Final step: confirm the refund with the customer and offer a priority booking.</a:t>
             </a:r>
             <a:endParaRPr lang="en-US" dirty="0"/>
           </a:p>
@@ -16147,12 +16147,12 @@
         </p:nvSpPr>
         <p:spPr>
           <a:xfrm>
-            <a:off x="548640" y="1371600"/>
-            <a:ext cx="2926080" cy="548640"/>
+            <a:off x="6949440" y="868680"/>
+            <a:ext cx="1783080" cy="365760"/>
           </a:xfrm>
           <a:prstGeom prst="roundRect">
             <a:avLst>
-              <a:gd name="adj" fmla="val 13333"/>
+              <a:gd name="adj" fmla="val 20000"/>
             </a:avLst>
           </a:prstGeom>
           <a:solidFill>
@@ -16166,16 +16166,40 @@
           </a:ln>
         </p:spPr>
       </p:sp>
-      <p:sp>
-        <p:nvSpPr>
-          <p:cNvPr id="7" name="Text 4"/>
-          <p:cNvSpPr txBox="1"/>
-          <p:nvPr/>
-        </p:nvSpPr>
-        <p:spPr>
-          <a:xfrm>
-            <a:off x="548640" y="1371600"/>
-            <a:ext cx="2926080" cy="548640"/>
+      <p:pic>
+        <p:nvPicPr>
+          <p:cNvPr id="7" name="Image 0" descr="preencoded.png">    </p:cNvPr>
+          <p:cNvPicPr>
+            <a:picLocks noChangeAspect="1"/>
+          </p:cNvPicPr>
+          <p:nvPr/>
+        </p:nvPicPr>
+        <p:blipFill>
+          <a:blip r:embed="rId1"/>
+          <a:stretch>
+            <a:fillRect/>
+          </a:stretch>
+        </p:blipFill>
+        <p:spPr>
+          <a:xfrm>
+            <a:off x="7086600" y="960120"/>
+            <a:ext cx="182880" cy="182880"/>
+          </a:xfrm>
+          <a:prstGeom prst="rect">
+            <a:avLst/>
+          </a:prstGeom>
+        </p:spPr>
+      </p:pic>
+      <p:sp>
+        <p:nvSpPr>
+          <p:cNvPr id="8" name="Text 4"/>
+          <p:cNvSpPr txBox="1"/>
+          <p:nvPr/>
+        </p:nvSpPr>
+        <p:spPr>
+          <a:xfrm>
+            <a:off x="7333488" y="868680"/>
+            <a:ext cx="1325880" cy="365760"/>
           </a:xfrm>
           <a:prstGeom prst="rect">
             <a:avLst/>
@@ -16187,11 +16211,11 @@
           <a:bodyPr wrap="square" lIns="0" tIns="0" rIns="0" bIns="0" rtlCol="0" anchor="ctr"/>
           <a:lstStyle/>
           <a:p>
-            <a:pPr algn="ctr" indent="0" marL="0">
-              <a:buNone/>
-            </a:pPr>
-            <a:r>
-              <a:rPr lang="en-US" sz="1000" b="1" dirty="0">
+            <a:pPr indent="0" marL="0">
+              <a:buNone/>
+            </a:pPr>
+            <a:r>
+              <a:rPr lang="en-US" sz="1100" b="1" dirty="0">
                 <a:solidFill>
                   <a:srgbClr val="FFFFFF"/>
                 </a:solidFill>
@@ -16199,107 +16223,21 @@
                 <a:ea typeface="SF Pro Display" pitchFamily="34" charset="-122"/>
                 <a:cs typeface="SF Pro Display" pitchFamily="34" charset="-120"/>
               </a:rPr>
-              <a:t>Refund the unauthorized hours only</a:t>
-            </a:r>
-            <a:endParaRPr lang="en-US" sz="1000" dirty="0"/>
-          </a:p>
-        </p:txBody>
-      </p:sp>
-      <p:sp>
-        <p:nvSpPr>
-          <p:cNvPr id="8" name="Shape 5"/>
+              <a:t>Show details</a:t>
+            </a:r>
+            <a:endParaRPr lang="en-US" sz="1100" dirty="0"/>
+          </a:p>
+        </p:txBody>
+      </p:sp>
+      <p:sp>
+        <p:nvSpPr>
+          <p:cNvPr id="9" name="Shape 5"/>
           <p:cNvSpPr/>
           <p:nvPr/>
         </p:nvSpPr>
         <p:spPr>
           <a:xfrm>
-            <a:off x="2011680" y="1920240"/>
-            <a:ext cx="0" cy="246888"/>
-          </a:xfrm>
-          <a:prstGeom prst="line">
-            <a:avLst/>
-          </a:prstGeom>
-          <a:noFill/>
-          <a:ln w="12700">
-            <a:solidFill>
-              <a:srgbClr val="6E6E73"/>
-            </a:solidFill>
-            <a:prstDash val="solid"/>
-            <a:tailEnd type="triangle"/>
-          </a:ln>
-        </p:spPr>
-      </p:sp>
-      <p:sp>
-        <p:nvSpPr>
-          <p:cNvPr id="9" name="Shape 6"/>
-          <p:cNvSpPr/>
-          <p:nvPr/>
-        </p:nvSpPr>
-        <p:spPr>
-          <a:xfrm>
-            <a:off x="3474720" y="1645920"/>
-            <a:ext cx="274320" cy="0"/>
-          </a:xfrm>
-          <a:prstGeom prst="line">
-            <a:avLst/>
-          </a:prstGeom>
-          <a:noFill/>
-          <a:ln w="12700">
-            <a:solidFill>
-              <a:srgbClr val="6E6E73"/>
-            </a:solidFill>
-            <a:prstDash val="solid"/>
-          </a:ln>
-        </p:spPr>
-      </p:sp>
-      <p:sp>
-        <p:nvSpPr>
-          <p:cNvPr id="10" name="Text 7"/>
-          <p:cNvSpPr txBox="1"/>
-          <p:nvPr/>
-        </p:nvSpPr>
-        <p:spPr>
-          <a:xfrm>
-            <a:off x="3840480" y="1371600"/>
-            <a:ext cx="4709160" cy="548640"/>
-          </a:xfrm>
-          <a:prstGeom prst="rect">
-            <a:avLst/>
-          </a:prstGeom>
-          <a:noFill/>
-          <a:ln/>
-        </p:spPr>
-        <p:txBody>
-          <a:bodyPr wrap="square" lIns="0" tIns="0" rIns="0" bIns="0" rtlCol="0" anchor="ctr"/>
-          <a:lstStyle/>
-          <a:p>
-            <a:pPr indent="0" marL="0">
-              <a:buNone/>
-            </a:pPr>
-            <a:r>
-              <a:rPr lang="en-US" sz="950" dirty="0">
-                <a:solidFill>
-                  <a:srgbClr val="6E6E73"/>
-                </a:solidFill>
-                <a:latin typeface="SF Pro Text" pitchFamily="34" charset="0"/>
-                <a:ea typeface="SF Pro Text" pitchFamily="34" charset="-122"/>
-                <a:cs typeface="SF Pro Text" pitchFamily="34" charset="-120"/>
-              </a:rPr>
-              <a:t>Refund via the CP Dashboard for the alleged unauthorized hours only, not the full job.</a:t>
-            </a:r>
-            <a:endParaRPr lang="en-US" sz="950" dirty="0"/>
-          </a:p>
-        </p:txBody>
-      </p:sp>
-      <p:sp>
-        <p:nvSpPr>
-          <p:cNvPr id="11" name="Shape 8"/>
-          <p:cNvSpPr/>
-          <p:nvPr/>
-        </p:nvSpPr>
-        <p:spPr>
-          <a:xfrm>
-            <a:off x="548640" y="2167128"/>
+            <a:off x="548640" y="1371600"/>
             <a:ext cx="2926080" cy="548640"/>
           </a:xfrm>
           <a:prstGeom prst="roundRect">
@@ -16320,13 +16258,13 @@
       </p:sp>
       <p:sp>
         <p:nvSpPr>
-          <p:cNvPr id="12" name="Text 9"/>
-          <p:cNvSpPr txBox="1"/>
-          <p:nvPr/>
-        </p:nvSpPr>
-        <p:spPr>
-          <a:xfrm>
-            <a:off x="548640" y="2167128"/>
+          <p:cNvPr id="10" name="Text 6"/>
+          <p:cNvSpPr txBox="1"/>
+          <p:nvPr/>
+        </p:nvSpPr>
+        <p:spPr>
+          <a:xfrm>
+            <a:off x="548640" y="1371600"/>
             <a:ext cx="2926080" cy="548640"/>
           </a:xfrm>
           <a:prstGeom prst="rect">
@@ -16351,7 +16289,7 @@
                 <a:ea typeface="SF Pro Display" pitchFamily="34" charset="-122"/>
                 <a:cs typeface="SF Pro Display" pitchFamily="34" charset="-120"/>
               </a:rPr>
-              <a:t>Coach CP + request evidence</a:t>
+              <a:t>Refund the unauthorized hours only</a:t>
             </a:r>
             <a:endParaRPr lang="en-US" sz="1000" dirty="0"/>
           </a:p>
@@ -16359,13 +16297,13 @@
       </p:sp>
       <p:sp>
         <p:nvSpPr>
-          <p:cNvPr id="13" name="Shape 10"/>
+          <p:cNvPr id="11" name="Shape 7"/>
           <p:cNvSpPr/>
           <p:nvPr/>
         </p:nvSpPr>
         <p:spPr>
           <a:xfrm>
-            <a:off x="2011680" y="2715768"/>
+            <a:off x="2011680" y="1920240"/>
             <a:ext cx="0" cy="246888"/>
           </a:xfrm>
           <a:prstGeom prst="line">
@@ -16383,13 +16321,13 @@
       </p:sp>
       <p:sp>
         <p:nvSpPr>
-          <p:cNvPr id="14" name="Shape 11"/>
+          <p:cNvPr id="12" name="Shape 8"/>
           <p:cNvSpPr/>
           <p:nvPr/>
         </p:nvSpPr>
         <p:spPr>
           <a:xfrm>
-            <a:off x="3474720" y="2441448"/>
+            <a:off x="3474720" y="1645920"/>
             <a:ext cx="274320" cy="0"/>
           </a:xfrm>
           <a:prstGeom prst="line">
@@ -16406,13 +16344,13 @@
       </p:sp>
       <p:sp>
         <p:nvSpPr>
-          <p:cNvPr id="15" name="Text 12"/>
-          <p:cNvSpPr txBox="1"/>
-          <p:nvPr/>
-        </p:nvSpPr>
-        <p:spPr>
-          <a:xfrm>
-            <a:off x="3840480" y="2167128"/>
+          <p:cNvPr id="13" name="type1Desc"/>
+          <p:cNvSpPr txBox="1"/>
+          <p:nvPr/>
+        </p:nvSpPr>
+        <p:spPr>
+          <a:xfrm>
+            <a:off x="3840480" y="1371600"/>
             <a:ext cx="4709160" cy="548640"/>
           </a:xfrm>
           <a:prstGeom prst="rect">
@@ -16437,6 +16375,158 @@
                 <a:ea typeface="SF Pro Text" pitchFamily="34" charset="-122"/>
                 <a:cs typeface="SF Pro Text" pitchFamily="34" charset="-120"/>
               </a:rPr>
+              <a:t>Refund via the CP Dashboard for the alleged unauthorized hours only, not the full job.</a:t>
+            </a:r>
+            <a:endParaRPr lang="en-US" sz="950" dirty="0"/>
+          </a:p>
+        </p:txBody>
+      </p:sp>
+      <p:sp>
+        <p:nvSpPr>
+          <p:cNvPr id="14" name="Shape 10"/>
+          <p:cNvSpPr/>
+          <p:nvPr/>
+        </p:nvSpPr>
+        <p:spPr>
+          <a:xfrm>
+            <a:off x="548640" y="2167128"/>
+            <a:ext cx="2926080" cy="548640"/>
+          </a:xfrm>
+          <a:prstGeom prst="roundRect">
+            <a:avLst>
+              <a:gd name="adj" fmla="val 13333"/>
+            </a:avLst>
+          </a:prstGeom>
+          <a:solidFill>
+            <a:srgbClr val="0B7A6F"/>
+          </a:solidFill>
+          <a:ln w="12700">
+            <a:solidFill>
+              <a:srgbClr val="0B7A6F"/>
+            </a:solidFill>
+            <a:prstDash val="solid"/>
+          </a:ln>
+        </p:spPr>
+      </p:sp>
+      <p:sp>
+        <p:nvSpPr>
+          <p:cNvPr id="15" name="Text 11"/>
+          <p:cNvSpPr txBox="1"/>
+          <p:nvPr/>
+        </p:nvSpPr>
+        <p:spPr>
+          <a:xfrm>
+            <a:off x="548640" y="2167128"/>
+            <a:ext cx="2926080" cy="548640"/>
+          </a:xfrm>
+          <a:prstGeom prst="rect">
+            <a:avLst/>
+          </a:prstGeom>
+          <a:noFill/>
+          <a:ln/>
+        </p:spPr>
+        <p:txBody>
+          <a:bodyPr wrap="square" lIns="0" tIns="0" rIns="0" bIns="0" rtlCol="0" anchor="ctr"/>
+          <a:lstStyle/>
+          <a:p>
+            <a:pPr algn="ctr" indent="0" marL="0">
+              <a:buNone/>
+            </a:pPr>
+            <a:r>
+              <a:rPr lang="en-US" sz="1000" b="1" dirty="0">
+                <a:solidFill>
+                  <a:srgbClr val="FFFFFF"/>
+                </a:solidFill>
+                <a:latin typeface="SF Pro Display" pitchFamily="34" charset="0"/>
+                <a:ea typeface="SF Pro Display" pitchFamily="34" charset="-122"/>
+                <a:cs typeface="SF Pro Display" pitchFamily="34" charset="-120"/>
+              </a:rPr>
+              <a:t>Coach CP + request evidence</a:t>
+            </a:r>
+            <a:endParaRPr lang="en-US" sz="1000" dirty="0"/>
+          </a:p>
+        </p:txBody>
+      </p:sp>
+      <p:sp>
+        <p:nvSpPr>
+          <p:cNvPr id="16" name="Shape 12"/>
+          <p:cNvSpPr/>
+          <p:nvPr/>
+        </p:nvSpPr>
+        <p:spPr>
+          <a:xfrm>
+            <a:off x="2011680" y="2715768"/>
+            <a:ext cx="0" cy="246888"/>
+          </a:xfrm>
+          <a:prstGeom prst="line">
+            <a:avLst/>
+          </a:prstGeom>
+          <a:noFill/>
+          <a:ln w="12700">
+            <a:solidFill>
+              <a:srgbClr val="6E6E73"/>
+            </a:solidFill>
+            <a:prstDash val="solid"/>
+            <a:tailEnd type="triangle"/>
+          </a:ln>
+        </p:spPr>
+      </p:sp>
+      <p:sp>
+        <p:nvSpPr>
+          <p:cNvPr id="17" name="Shape 13"/>
+          <p:cNvSpPr/>
+          <p:nvPr/>
+        </p:nvSpPr>
+        <p:spPr>
+          <a:xfrm>
+            <a:off x="3474720" y="2441448"/>
+            <a:ext cx="274320" cy="0"/>
+          </a:xfrm>
+          <a:prstGeom prst="line">
+            <a:avLst/>
+          </a:prstGeom>
+          <a:noFill/>
+          <a:ln w="12700">
+            <a:solidFill>
+              <a:srgbClr val="6E6E73"/>
+            </a:solidFill>
+            <a:prstDash val="solid"/>
+          </a:ln>
+        </p:spPr>
+      </p:sp>
+      <p:sp>
+        <p:nvSpPr>
+          <p:cNvPr id="18" name="type2Desc"/>
+          <p:cNvSpPr txBox="1"/>
+          <p:nvPr/>
+        </p:nvSpPr>
+        <p:spPr>
+          <a:xfrm>
+            <a:off x="3840480" y="2167128"/>
+            <a:ext cx="4709160" cy="548640"/>
+          </a:xfrm>
+          <a:prstGeom prst="rect">
+            <a:avLst/>
+          </a:prstGeom>
+          <a:noFill/>
+          <a:ln/>
+        </p:spPr>
+        <p:txBody>
+          <a:bodyPr wrap="square" lIns="0" tIns="0" rIns="0" bIns="0" rtlCol="0" anchor="ctr"/>
+          <a:lstStyle/>
+          <a:p>
+            <a:pPr indent="0" marL="0">
+              <a:buNone/>
+            </a:pPr>
+            <a:r>
+              <a:rPr lang="en-US" sz="950" dirty="0">
+                <a:solidFill>
+                  <a:srgbClr val="6E6E73"/>
+                </a:solidFill>
+                <a:latin typeface="SF Pro Text" pitchFamily="34" charset="0"/>
+                <a:ea typeface="SF Pro Text" pitchFamily="34" charset="-122"/>
+                <a:cs typeface="SF Pro Text" pitchFamily="34" charset="-120"/>
+              </a:rPr>
               <a:t>Coach the CP to ask before extending. Send comms about the action taken. The CP has 3 days to prove the customer authorized the extra hours.</a:t>
             </a:r>
             <a:endParaRPr lang="en-US" sz="950" dirty="0"/>
@@ -16445,7 +16535,7 @@
       </p:sp>
       <p:sp>
         <p:nvSpPr>
-          <p:cNvPr id="16" name="Shape 13"/>
+          <p:cNvPr id="19" name="Shape 15"/>
           <p:cNvSpPr/>
           <p:nvPr/>
         </p:nvSpPr>
@@ -16472,7 +16562,7 @@
       </p:sp>
       <p:sp>
         <p:nvSpPr>
-          <p:cNvPr id="17" name="Text 14"/>
+          <p:cNvPr id="20" name="Text 16"/>
           <p:cNvSpPr txBox="1"/>
           <p:nvPr/>
         </p:nvSpPr>
@@ -16511,7 +16601,7 @@
       </p:sp>
       <p:sp>
         <p:nvSpPr>
-          <p:cNvPr id="18" name="Shape 15"/>
+          <p:cNvPr id="21" name="Shape 17"/>
           <p:cNvSpPr/>
           <p:nvPr/>
         </p:nvSpPr>
@@ -16535,7 +16625,7 @@
       </p:sp>
       <p:sp>
         <p:nvSpPr>
-          <p:cNvPr id="19" name="Shape 16"/>
+          <p:cNvPr id="22" name="Shape 18"/>
           <p:cNvSpPr/>
           <p:nvPr/>
         </p:nvSpPr>
@@ -16558,7 +16648,7 @@
       </p:sp>
       <p:sp>
         <p:nvSpPr>
-          <p:cNvPr id="20" name="Text 17"/>
+          <p:cNvPr id="23" name="type3Desc"/>
           <p:cNvSpPr txBox="1"/>
           <p:nvPr/>
         </p:nvSpPr>
@@ -16597,7 +16687,7 @@
       </p:sp>
       <p:sp>
         <p:nvSpPr>
-          <p:cNvPr id="21" name="Shape 18"/>
+          <p:cNvPr id="24" name="Shape 20"/>
           <p:cNvSpPr/>
           <p:nvPr/>
         </p:nvSpPr>
@@ -16624,7 +16714,7 @@
       </p:sp>
       <p:sp>
         <p:nvSpPr>
-          <p:cNvPr id="22" name="Text 19"/>
+          <p:cNvPr id="25" name="Text 21"/>
           <p:cNvSpPr txBox="1"/>
           <p:nvPr/>
         </p:nvSpPr>
@@ -16663,7 +16753,7 @@
       </p:sp>
       <p:sp>
         <p:nvSpPr>
-          <p:cNvPr id="23" name="Shape 20"/>
+          <p:cNvPr id="26" name="Shape 22"/>
           <p:cNvSpPr/>
           <p:nvPr/>
         </p:nvSpPr>
@@ -16686,7 +16776,7 @@
       </p:sp>
       <p:sp>
         <p:nvSpPr>
-          <p:cNvPr id="24" name="Text 21"/>
+          <p:cNvPr id="27" name="type4Desc"/>
           <p:cNvSpPr txBox="1"/>
           <p:nvPr/>
         </p:nvSpPr>
@@ -16776,6 +16866,234 @@
   <p:clrMapOvr>
     <a:masterClrMapping/>
   </p:clrMapOvr>
+  <p:timing>
+    <p:tnLst>
+      <p:par>
+        <p:cTn id="1" dur="indefinite" restart="never" nodeType="tmRoot">
+          <p:childTnLst>
+            <p:seq concurrent="1" nextAc="seek">
+              <p:cTn id="2" dur="indefinite" nodeType="mainSeq">
+                <p:childTnLst>
+                  <p:par>
+                    <p:cTn id="3" fill="hold">
+                      <p:stCondLst>
+                        <p:cond delay="indefinite"/>
+                      </p:stCondLst>
+                      <p:childTnLst>
+                        <p:par>
+                          <p:cTn id="4" fill="hold">
+                            <p:stCondLst>
+                              <p:cond delay="0"/>
+                            </p:stCondLst>
+                            <p:childTnLst>
+                              <p:par>
+                                <p:cTn id="5" presetID="1" presetClass="entr" presetSubtype="0" fill="hold" grpId="0" nodeType="clickEffect">
+                                  <p:stCondLst>
+                                    <p:cond delay="0"/>
+                                  </p:stCondLst>
+                                  <p:iterate type="lt">
+                                    <p:tmAbs val="40"/>
+                                  </p:iterate>
+                                  <p:childTnLst>
+                                    <p:set>
+                                      <p:cBhvr>
+                                        <p:cTn id="6" dur="1" fill="hold">
+                                          <p:stCondLst>
+                                            <p:cond delay="0"/>
+                                          </p:stCondLst>
+                                        </p:cTn>
+                                        <p:tgtEl>
+                                          <p:spTgt spid="13"/>
+                                        </p:tgtEl>
+                                        <p:attrNameLst>
+                                          <p:attrName>style.visibility</p:attrName>
+                                        </p:attrNameLst>
+                                      </p:cBhvr>
+                                      <p:to>
+                                        <p:strVal val="visible"/>
+                                      </p:to>
+                                    </p:set>
+                                  </p:childTnLst>
+                                </p:cTn>
+                              </p:par>
+                            </p:childTnLst>
+                          </p:cTn>
+                        </p:par>
+                      </p:childTnLst>
+                    </p:cTn>
+                  </p:par>
+                  <p:par>
+                    <p:cTn id="7" fill="hold">
+                      <p:stCondLst>
+                        <p:cond delay="indefinite"/>
+                      </p:stCondLst>
+                      <p:childTnLst>
+                        <p:par>
+                          <p:cTn id="8" fill="hold">
+                            <p:stCondLst>
+                              <p:cond delay="0"/>
+                            </p:stCondLst>
+                            <p:childTnLst>
+                              <p:par>
+                                <p:cTn id="9" presetID="1" presetClass="entr" presetSubtype="0" fill="hold" grpId="0" nodeType="clickEffect">
+                                  <p:stCondLst>
+                                    <p:cond delay="0"/>
+                                  </p:stCondLst>
+                                  <p:iterate type="lt">
+                                    <p:tmAbs val="40"/>
+                                  </p:iterate>
+                                  <p:childTnLst>
+                                    <p:set>
+                                      <p:cBhvr>
+                                        <p:cTn id="10" dur="1" fill="hold">
+                                          <p:stCondLst>
+                                            <p:cond delay="0"/>
+                                          </p:stCondLst>
+                                        </p:cTn>
+                                        <p:tgtEl>
+                                          <p:spTgt spid="18"/>
+                                        </p:tgtEl>
+                                        <p:attrNameLst>
+                                          <p:attrName>style.visibility</p:attrName>
+                                        </p:attrNameLst>
+                                      </p:cBhvr>
+                                      <p:to>
+                                        <p:strVal val="visible"/>
+                                      </p:to>
+                                    </p:set>
+                                  </p:childTnLst>
+                                </p:cTn>
+                              </p:par>
+                            </p:childTnLst>
+                          </p:cTn>
+                        </p:par>
+                      </p:childTnLst>
+                    </p:cTn>
+                  </p:par>
+                  <p:par>
+                    <p:cTn id="11" fill="hold">
+                      <p:stCondLst>
+                        <p:cond delay="indefinite"/>
+                      </p:stCondLst>
+                      <p:childTnLst>
+                        <p:par>
+                          <p:cTn id="12" fill="hold">
+                            <p:stCondLst>
+                              <p:cond delay="0"/>
+                            </p:stCondLst>
+                            <p:childTnLst>
+                              <p:par>
+                                <p:cTn id="13" presetID="1" presetClass="entr" presetSubtype="0" fill="hold" grpId="0" nodeType="clickEffect">
+                                  <p:stCondLst>
+                                    <p:cond delay="0"/>
+                                  </p:stCondLst>
+                                  <p:iterate type="lt">
+                                    <p:tmAbs val="40"/>
+                                  </p:iterate>
+                                  <p:childTnLst>
+                                    <p:set>
+                                      <p:cBhvr>
+                                        <p:cTn id="14" dur="1" fill="hold">
+                                          <p:stCondLst>
+                                            <p:cond delay="0"/>
+                                          </p:stCondLst>
+                                        </p:cTn>
+                                        <p:tgtEl>
+                                          <p:spTgt spid="23"/>
+                                        </p:tgtEl>
+                                        <p:attrNameLst>
+                                          <p:attrName>style.visibility</p:attrName>
+                                        </p:attrNameLst>
+                                      </p:cBhvr>
+                                      <p:to>
+                                        <p:strVal val="visible"/>
+                                      </p:to>
+                                    </p:set>
+                                  </p:childTnLst>
+                                </p:cTn>
+                              </p:par>
+                            </p:childTnLst>
+                          </p:cTn>
+                        </p:par>
+                      </p:childTnLst>
+                    </p:cTn>
+                  </p:par>
+                  <p:par>
+                    <p:cTn id="15" fill="hold">
+                      <p:stCondLst>
+                        <p:cond delay="indefinite"/>
+                      </p:stCondLst>
+                      <p:childTnLst>
+                        <p:par>
+                          <p:cTn id="16" fill="hold">
+                            <p:stCondLst>
+                              <p:cond delay="0"/>
+                            </p:stCondLst>
+                            <p:childTnLst>
+                              <p:par>
+                                <p:cTn id="17" presetID="1" presetClass="entr" presetSubtype="0" fill="hold" grpId="0" nodeType="clickEffect">
+                                  <p:stCondLst>
+                                    <p:cond delay="0"/>
+                                  </p:stCondLst>
+                                  <p:iterate type="lt">
+                                    <p:tmAbs val="40"/>
+                                  </p:iterate>
+                                  <p:childTnLst>
+                                    <p:set>
+                                      <p:cBhvr>
+                                        <p:cTn id="18" dur="1" fill="hold">
+                                          <p:stCondLst>
+                                            <p:cond delay="0"/>
+                                          </p:stCondLst>
+                                        </p:cTn>
+                                        <p:tgtEl>
+                                          <p:spTgt spid="27"/>
+                                        </p:tgtEl>
+                                        <p:attrNameLst>
+                                          <p:attrName>style.visibility</p:attrName>
+                                        </p:attrNameLst>
+                                      </p:cBhvr>
+                                      <p:to>
+                                        <p:strVal val="visible"/>
+                                      </p:to>
+                                    </p:set>
+                                  </p:childTnLst>
+                                </p:cTn>
+                              </p:par>
+                            </p:childTnLst>
+                          </p:cTn>
+                        </p:par>
+                      </p:childTnLst>
+                    </p:cTn>
+                  </p:par>
+                </p:childTnLst>
+              </p:cTn>
+              <p:prevCondLst>
+                <p:cond evt="onPrev" delay="0">
+                  <p:tgtEl>
+                    <p:sldTgt/>
+                  </p:tgtEl>
+                </p:cond>
+              </p:prevCondLst>
+              <p:nextCondLst>
+                <p:cond evt="onNext" delay="0">
+                  <p:tgtEl>
+                    <p:sldTgt/>
+                  </p:tgtEl>
+                </p:cond>
+              </p:nextCondLst>
+            </p:seq>
+          </p:childTnLst>
+        </p:cTn>
+      </p:par>
+    </p:tnLst>
+    <p:bldLst>
+      <p:bldP spid="13" grpId="0" animBg="1"/>
+      <p:bldP spid="18" grpId="0" animBg="1"/>
+      <p:bldP spid="23" grpId="0" animBg="1"/>
+      <p:bldP spid="27" grpId="0" animBg="1"/>
+    </p:bldLst>
+  </p:timing>
 </p:sld>
 </file>
 
@@ -24259,6 +24577,96 @@
         </p:nvSpPr>
         <p:spPr>
           <a:xfrm>
+            <a:off x="6949440" y="502920"/>
+            <a:ext cx="1783080" cy="365760"/>
+          </a:xfrm>
+          <a:prstGeom prst="roundRect">
+            <a:avLst>
+              <a:gd name="adj" fmla="val 20000"/>
+            </a:avLst>
+          </a:prstGeom>
+          <a:solidFill>
+            <a:srgbClr val="0B7A6F"/>
+          </a:solidFill>
+          <a:ln w="12700">
+            <a:solidFill>
+              <a:srgbClr val="0B7A6F"/>
+            </a:solidFill>
+            <a:prstDash val="solid"/>
+          </a:ln>
+        </p:spPr>
+      </p:sp>
+      <p:pic>
+        <p:nvPicPr>
+          <p:cNvPr id="6" name="Image 0" descr="preencoded.png">    </p:cNvPr>
+          <p:cNvPicPr>
+            <a:picLocks noChangeAspect="1"/>
+          </p:cNvPicPr>
+          <p:nvPr/>
+        </p:nvPicPr>
+        <p:blipFill>
+          <a:blip r:embed="rId1"/>
+          <a:stretch>
+            <a:fillRect/>
+          </a:stretch>
+        </p:blipFill>
+        <p:spPr>
+          <a:xfrm>
+            <a:off x="7086600" y="594360"/>
+            <a:ext cx="182880" cy="182880"/>
+          </a:xfrm>
+          <a:prstGeom prst="rect">
+            <a:avLst/>
+          </a:prstGeom>
+        </p:spPr>
+      </p:pic>
+      <p:sp>
+        <p:nvSpPr>
+          <p:cNvPr id="7" name="Text 3"/>
+          <p:cNvSpPr txBox="1"/>
+          <p:nvPr/>
+        </p:nvSpPr>
+        <p:spPr>
+          <a:xfrm>
+            <a:off x="7333488" y="502920"/>
+            <a:ext cx="1325880" cy="365760"/>
+          </a:xfrm>
+          <a:prstGeom prst="rect">
+            <a:avLst/>
+          </a:prstGeom>
+          <a:noFill/>
+          <a:ln/>
+        </p:spPr>
+        <p:txBody>
+          <a:bodyPr wrap="square" lIns="0" tIns="0" rIns="0" bIns="0" rtlCol="0" anchor="ctr"/>
+          <a:lstStyle/>
+          <a:p>
+            <a:pPr indent="0" marL="0">
+              <a:buNone/>
+            </a:pPr>
+            <a:r>
+              <a:rPr lang="en-US" sz="1100" b="1" dirty="0">
+                <a:solidFill>
+                  <a:srgbClr val="FFFFFF"/>
+                </a:solidFill>
+                <a:latin typeface="SF Pro Display" pitchFamily="34" charset="0"/>
+                <a:ea typeface="SF Pro Display" pitchFamily="34" charset="-122"/>
+                <a:cs typeface="SF Pro Display" pitchFamily="34" charset="-120"/>
+              </a:rPr>
+              <a:t>Show details</a:t>
+            </a:r>
+            <a:endParaRPr lang="en-US" sz="1100" dirty="0"/>
+          </a:p>
+        </p:txBody>
+      </p:sp>
+      <p:sp>
+        <p:nvSpPr>
+          <p:cNvPr id="8" name="Shape 4"/>
+          <p:cNvSpPr/>
+          <p:nvPr/>
+        </p:nvSpPr>
+        <p:spPr>
+          <a:xfrm>
             <a:off x="457200" y="1051560"/>
             <a:ext cx="3246120" cy="347472"/>
           </a:xfrm>
@@ -24280,7 +24688,7 @@
       </p:sp>
       <p:sp>
         <p:nvSpPr>
-          <p:cNvPr id="6" name="Text 3"/>
+          <p:cNvPr id="9" name="Text 5"/>
           <p:cNvSpPr txBox="1"/>
           <p:nvPr/>
         </p:nvSpPr>
@@ -24319,7 +24727,7 @@
       </p:sp>
       <p:sp>
         <p:nvSpPr>
-          <p:cNvPr id="7" name="Shape 4"/>
+          <p:cNvPr id="10" name="Shape 6"/>
           <p:cNvSpPr/>
           <p:nvPr/>
         </p:nvSpPr>
@@ -24343,7 +24751,7 @@
       </p:sp>
       <p:sp>
         <p:nvSpPr>
-          <p:cNvPr id="8" name="Shape 5"/>
+          <p:cNvPr id="11" name="Shape 7"/>
           <p:cNvSpPr/>
           <p:nvPr/>
         </p:nvSpPr>
@@ -24366,7 +24774,7 @@
       </p:sp>
       <p:sp>
         <p:nvSpPr>
-          <p:cNvPr id="9" name="Text 6"/>
+          <p:cNvPr id="12" name="type1Desc"/>
           <p:cNvSpPr txBox="1"/>
           <p:nvPr/>
         </p:nvSpPr>
@@ -24405,7 +24813,7 @@
       </p:sp>
       <p:sp>
         <p:nvSpPr>
-          <p:cNvPr id="10" name="Shape 7"/>
+          <p:cNvPr id="13" name="Shape 9"/>
           <p:cNvSpPr/>
           <p:nvPr/>
         </p:nvSpPr>
@@ -24432,7 +24840,7 @@
       </p:sp>
       <p:sp>
         <p:nvSpPr>
-          <p:cNvPr id="11" name="Text 8"/>
+          <p:cNvPr id="14" name="Text 10"/>
           <p:cNvSpPr txBox="1"/>
           <p:nvPr/>
         </p:nvSpPr>
@@ -24471,7 +24879,7 @@
       </p:sp>
       <p:sp>
         <p:nvSpPr>
-          <p:cNvPr id="12" name="Shape 9"/>
+          <p:cNvPr id="15" name="Shape 11"/>
           <p:cNvSpPr/>
           <p:nvPr/>
         </p:nvSpPr>
@@ -24495,7 +24903,7 @@
       </p:sp>
       <p:sp>
         <p:nvSpPr>
-          <p:cNvPr id="13" name="Shape 10"/>
+          <p:cNvPr id="16" name="Shape 12"/>
           <p:cNvSpPr/>
           <p:nvPr/>
         </p:nvSpPr>
@@ -24518,7 +24926,7 @@
       </p:sp>
       <p:sp>
         <p:nvSpPr>
-          <p:cNvPr id="14" name="Text 11"/>
+          <p:cNvPr id="17" name="type2Desc"/>
           <p:cNvSpPr txBox="1"/>
           <p:nvPr/>
         </p:nvSpPr>
@@ -24557,7 +24965,7 @@
       </p:sp>
       <p:sp>
         <p:nvSpPr>
-          <p:cNvPr id="15" name="Shape 12"/>
+          <p:cNvPr id="18" name="Shape 14"/>
           <p:cNvSpPr/>
           <p:nvPr/>
         </p:nvSpPr>
@@ -24584,7 +24992,7 @@
       </p:sp>
       <p:sp>
         <p:nvSpPr>
-          <p:cNvPr id="16" name="Text 13"/>
+          <p:cNvPr id="19" name="Text 15"/>
           <p:cNvSpPr txBox="1"/>
           <p:nvPr/>
         </p:nvSpPr>
@@ -24623,7 +25031,7 @@
       </p:sp>
       <p:sp>
         <p:nvSpPr>
-          <p:cNvPr id="17" name="Shape 14"/>
+          <p:cNvPr id="20" name="Shape 16"/>
           <p:cNvSpPr/>
           <p:nvPr/>
         </p:nvSpPr>
@@ -24647,7 +25055,7 @@
       </p:sp>
       <p:sp>
         <p:nvSpPr>
-          <p:cNvPr id="18" name="Shape 15"/>
+          <p:cNvPr id="21" name="Shape 17"/>
           <p:cNvSpPr/>
           <p:nvPr/>
         </p:nvSpPr>
@@ -24670,7 +25078,7 @@
       </p:sp>
       <p:sp>
         <p:nvSpPr>
-          <p:cNvPr id="19" name="Text 16"/>
+          <p:cNvPr id="22" name="type3Desc"/>
           <p:cNvSpPr txBox="1"/>
           <p:nvPr/>
         </p:nvSpPr>
@@ -24709,7 +25117,7 @@
       </p:sp>
       <p:sp>
         <p:nvSpPr>
-          <p:cNvPr id="20" name="Shape 17"/>
+          <p:cNvPr id="23" name="Shape 19"/>
           <p:cNvSpPr/>
           <p:nvPr/>
         </p:nvSpPr>
@@ -24736,7 +25144,7 @@
       </p:sp>
       <p:sp>
         <p:nvSpPr>
-          <p:cNvPr id="21" name="Text 18"/>
+          <p:cNvPr id="24" name="Text 20"/>
           <p:cNvSpPr txBox="1"/>
           <p:nvPr/>
         </p:nvSpPr>
@@ -24775,7 +25183,7 @@
       </p:sp>
       <p:sp>
         <p:nvSpPr>
-          <p:cNvPr id="22" name="Shape 19"/>
+          <p:cNvPr id="25" name="Shape 21"/>
           <p:cNvSpPr/>
           <p:nvPr/>
         </p:nvSpPr>
@@ -24799,7 +25207,7 @@
       </p:sp>
       <p:sp>
         <p:nvSpPr>
-          <p:cNvPr id="23" name="Shape 20"/>
+          <p:cNvPr id="26" name="Shape 22"/>
           <p:cNvSpPr/>
           <p:nvPr/>
         </p:nvSpPr>
@@ -24822,7 +25230,7 @@
       </p:sp>
       <p:sp>
         <p:nvSpPr>
-          <p:cNvPr id="24" name="Text 21"/>
+          <p:cNvPr id="27" name="type4Desc"/>
           <p:cNvSpPr txBox="1"/>
           <p:nvPr/>
         </p:nvSpPr>
@@ -24861,7 +25269,7 @@
       </p:sp>
       <p:sp>
         <p:nvSpPr>
-          <p:cNvPr id="25" name="Shape 22"/>
+          <p:cNvPr id="28" name="Shape 24"/>
           <p:cNvSpPr/>
           <p:nvPr/>
         </p:nvSpPr>
@@ -24888,7 +25296,7 @@
       </p:sp>
       <p:sp>
         <p:nvSpPr>
-          <p:cNvPr id="26" name="Text 23"/>
+          <p:cNvPr id="29" name="Text 25"/>
           <p:cNvSpPr txBox="1"/>
           <p:nvPr/>
         </p:nvSpPr>
@@ -24927,7 +25335,7 @@
       </p:sp>
       <p:sp>
         <p:nvSpPr>
-          <p:cNvPr id="27" name="Shape 24"/>
+          <p:cNvPr id="30" name="Shape 26"/>
           <p:cNvSpPr/>
           <p:nvPr/>
         </p:nvSpPr>
@@ -24951,7 +25359,7 @@
       </p:sp>
       <p:sp>
         <p:nvSpPr>
-          <p:cNvPr id="28" name="Shape 25"/>
+          <p:cNvPr id="31" name="Shape 27"/>
           <p:cNvSpPr/>
           <p:nvPr/>
         </p:nvSpPr>
@@ -24974,7 +25382,7 @@
       </p:sp>
       <p:sp>
         <p:nvSpPr>
-          <p:cNvPr id="29" name="Text 26"/>
+          <p:cNvPr id="32" name="type5Desc"/>
           <p:cNvSpPr txBox="1"/>
           <p:nvPr/>
         </p:nvSpPr>
@@ -25013,7 +25421,7 @@
       </p:sp>
       <p:sp>
         <p:nvSpPr>
-          <p:cNvPr id="30" name="Shape 27"/>
+          <p:cNvPr id="33" name="Shape 29"/>
           <p:cNvSpPr/>
           <p:nvPr/>
         </p:nvSpPr>
@@ -25040,7 +25448,7 @@
       </p:sp>
       <p:sp>
         <p:nvSpPr>
-          <p:cNvPr id="31" name="Text 28"/>
+          <p:cNvPr id="34" name="Text 30"/>
           <p:cNvSpPr txBox="1"/>
           <p:nvPr/>
         </p:nvSpPr>
@@ -25079,7 +25487,7 @@
       </p:sp>
       <p:sp>
         <p:nvSpPr>
-          <p:cNvPr id="32" name="Shape 29"/>
+          <p:cNvPr id="35" name="Shape 31"/>
           <p:cNvSpPr/>
           <p:nvPr/>
         </p:nvSpPr>
@@ -25103,7 +25511,7 @@
       </p:sp>
       <p:sp>
         <p:nvSpPr>
-          <p:cNvPr id="33" name="Shape 30"/>
+          <p:cNvPr id="36" name="Shape 32"/>
           <p:cNvSpPr/>
           <p:nvPr/>
         </p:nvSpPr>
@@ -25126,7 +25534,7 @@
       </p:sp>
       <p:sp>
         <p:nvSpPr>
-          <p:cNvPr id="34" name="Text 31"/>
+          <p:cNvPr id="37" name="type6Desc"/>
           <p:cNvSpPr txBox="1"/>
           <p:nvPr/>
         </p:nvSpPr>
@@ -25165,7 +25573,7 @@
       </p:sp>
       <p:sp>
         <p:nvSpPr>
-          <p:cNvPr id="35" name="Shape 32"/>
+          <p:cNvPr id="38" name="Shape 34"/>
           <p:cNvSpPr/>
           <p:nvPr/>
         </p:nvSpPr>
@@ -25192,7 +25600,7 @@
       </p:sp>
       <p:sp>
         <p:nvSpPr>
-          <p:cNvPr id="36" name="Text 33"/>
+          <p:cNvPr id="39" name="Text 35"/>
           <p:cNvSpPr txBox="1"/>
           <p:nvPr/>
         </p:nvSpPr>
@@ -25231,7 +25639,7 @@
       </p:sp>
       <p:sp>
         <p:nvSpPr>
-          <p:cNvPr id="37" name="Shape 34"/>
+          <p:cNvPr id="40" name="Shape 36"/>
           <p:cNvSpPr/>
           <p:nvPr/>
         </p:nvSpPr>
@@ -25255,7 +25663,7 @@
       </p:sp>
       <p:sp>
         <p:nvSpPr>
-          <p:cNvPr id="38" name="Shape 35"/>
+          <p:cNvPr id="41" name="Shape 37"/>
           <p:cNvSpPr/>
           <p:nvPr/>
         </p:nvSpPr>
@@ -25278,7 +25686,7 @@
       </p:sp>
       <p:sp>
         <p:nvSpPr>
-          <p:cNvPr id="39" name="Text 36"/>
+          <p:cNvPr id="42" name="type7Desc"/>
           <p:cNvSpPr txBox="1"/>
           <p:nvPr/>
         </p:nvSpPr>
@@ -25317,7 +25725,7 @@
       </p:sp>
       <p:sp>
         <p:nvSpPr>
-          <p:cNvPr id="40" name="Shape 37"/>
+          <p:cNvPr id="43" name="Shape 39"/>
           <p:cNvSpPr/>
           <p:nvPr/>
         </p:nvSpPr>
@@ -25344,7 +25752,7 @@
       </p:sp>
       <p:sp>
         <p:nvSpPr>
-          <p:cNvPr id="41" name="Text 38"/>
+          <p:cNvPr id="44" name="Text 40"/>
           <p:cNvSpPr txBox="1"/>
           <p:nvPr/>
         </p:nvSpPr>
@@ -25383,7 +25791,7 @@
       </p:sp>
       <p:sp>
         <p:nvSpPr>
-          <p:cNvPr id="42" name="Shape 39"/>
+          <p:cNvPr id="45" name="Shape 41"/>
           <p:cNvSpPr/>
           <p:nvPr/>
         </p:nvSpPr>
@@ -25406,7 +25814,7 @@
       </p:sp>
       <p:sp>
         <p:nvSpPr>
-          <p:cNvPr id="43" name="Text 40"/>
+          <p:cNvPr id="46" name="type8Desc"/>
           <p:cNvSpPr txBox="1"/>
           <p:nvPr/>
         </p:nvSpPr>
@@ -25496,6 +25904,430 @@
   <p:clrMapOvr>
     <a:masterClrMapping/>
   </p:clrMapOvr>
+  <p:timing>
+    <p:tnLst>
+      <p:par>
+        <p:cTn id="1" dur="indefinite" restart="never" nodeType="tmRoot">
+          <p:childTnLst>
+            <p:seq concurrent="1" nextAc="seek">
+              <p:cTn id="2" dur="indefinite" nodeType="mainSeq">
+                <p:childTnLst>
+                  <p:par>
+                    <p:cTn id="3" fill="hold">
+                      <p:stCondLst>
+                        <p:cond delay="indefinite"/>
+                      </p:stCondLst>
+                      <p:childTnLst>
+                        <p:par>
+                          <p:cTn id="4" fill="hold">
+                            <p:stCondLst>
+                              <p:cond delay="0"/>
+                            </p:stCondLst>
+                            <p:childTnLst>
+                              <p:par>
+                                <p:cTn id="5" presetID="1" presetClass="entr" presetSubtype="0" fill="hold" grpId="0" nodeType="clickEffect">
+                                  <p:stCondLst>
+                                    <p:cond delay="0"/>
+                                  </p:stCondLst>
+                                  <p:iterate type="lt">
+                                    <p:tmAbs val="40"/>
+                                  </p:iterate>
+                                  <p:childTnLst>
+                                    <p:set>
+                                      <p:cBhvr>
+                                        <p:cTn id="6" dur="1" fill="hold">
+                                          <p:stCondLst>
+                                            <p:cond delay="0"/>
+                                          </p:stCondLst>
+                                        </p:cTn>
+                                        <p:tgtEl>
+                                          <p:spTgt spid="12"/>
+                                        </p:tgtEl>
+                                        <p:attrNameLst>
+                                          <p:attrName>style.visibility</p:attrName>
+                                        </p:attrNameLst>
+                                      </p:cBhvr>
+                                      <p:to>
+                                        <p:strVal val="visible"/>
+                                      </p:to>
+                                    </p:set>
+                                  </p:childTnLst>
+                                </p:cTn>
+                              </p:par>
+                            </p:childTnLst>
+                          </p:cTn>
+                        </p:par>
+                      </p:childTnLst>
+                    </p:cTn>
+                  </p:par>
+                  <p:par>
+                    <p:cTn id="7" fill="hold">
+                      <p:stCondLst>
+                        <p:cond delay="indefinite"/>
+                      </p:stCondLst>
+                      <p:childTnLst>
+                        <p:par>
+                          <p:cTn id="8" fill="hold">
+                            <p:stCondLst>
+                              <p:cond delay="0"/>
+                            </p:stCondLst>
+                            <p:childTnLst>
+                              <p:par>
+                                <p:cTn id="9" presetID="1" presetClass="entr" presetSubtype="0" fill="hold" grpId="0" nodeType="clickEffect">
+                                  <p:stCondLst>
+                                    <p:cond delay="0"/>
+                                  </p:stCondLst>
+                                  <p:iterate type="lt">
+                                    <p:tmAbs val="40"/>
+                                  </p:iterate>
+                                  <p:childTnLst>
+                                    <p:set>
+                                      <p:cBhvr>
+                                        <p:cTn id="10" dur="1" fill="hold">
+                                          <p:stCondLst>
+                                            <p:cond delay="0"/>
+                                          </p:stCondLst>
+                                        </p:cTn>
+                                        <p:tgtEl>
+                                          <p:spTgt spid="17"/>
+                                        </p:tgtEl>
+                                        <p:attrNameLst>
+                                          <p:attrName>style.visibility</p:attrName>
+                                        </p:attrNameLst>
+                                      </p:cBhvr>
+                                      <p:to>
+                                        <p:strVal val="visible"/>
+                                      </p:to>
+                                    </p:set>
+                                  </p:childTnLst>
+                                </p:cTn>
+                              </p:par>
+                            </p:childTnLst>
+                          </p:cTn>
+                        </p:par>
+                      </p:childTnLst>
+                    </p:cTn>
+                  </p:par>
+                  <p:par>
+                    <p:cTn id="11" fill="hold">
+                      <p:stCondLst>
+                        <p:cond delay="indefinite"/>
+                      </p:stCondLst>
+                      <p:childTnLst>
+                        <p:par>
+                          <p:cTn id="12" fill="hold">
+                            <p:stCondLst>
+                              <p:cond delay="0"/>
+                            </p:stCondLst>
+                            <p:childTnLst>
+                              <p:par>
+                                <p:cTn id="13" presetID="1" presetClass="entr" presetSubtype="0" fill="hold" grpId="0" nodeType="clickEffect">
+                                  <p:stCondLst>
+                                    <p:cond delay="0"/>
+                                  </p:stCondLst>
+                                  <p:iterate type="lt">
+                                    <p:tmAbs val="40"/>
+                                  </p:iterate>
+                                  <p:childTnLst>
+                                    <p:set>
+                                      <p:cBhvr>
+                                        <p:cTn id="14" dur="1" fill="hold">
+                                          <p:stCondLst>
+                                            <p:cond delay="0"/>
+                                          </p:stCondLst>
+                                        </p:cTn>
+                                        <p:tgtEl>
+                                          <p:spTgt spid="22"/>
+                                        </p:tgtEl>
+                                        <p:attrNameLst>
+                                          <p:attrName>style.visibility</p:attrName>
+                                        </p:attrNameLst>
+                                      </p:cBhvr>
+                                      <p:to>
+                                        <p:strVal val="visible"/>
+                                      </p:to>
+                                    </p:set>
+                                  </p:childTnLst>
+                                </p:cTn>
+                              </p:par>
+                            </p:childTnLst>
+                          </p:cTn>
+                        </p:par>
+                      </p:childTnLst>
+                    </p:cTn>
+                  </p:par>
+                  <p:par>
+                    <p:cTn id="15" fill="hold">
+                      <p:stCondLst>
+                        <p:cond delay="indefinite"/>
+                      </p:stCondLst>
+                      <p:childTnLst>
+                        <p:par>
+                          <p:cTn id="16" fill="hold">
+                            <p:stCondLst>
+                              <p:cond delay="0"/>
+                            </p:stCondLst>
+                            <p:childTnLst>
+                              <p:par>
+                                <p:cTn id="17" presetID="1" presetClass="entr" presetSubtype="0" fill="hold" grpId="0" nodeType="clickEffect">
+                                  <p:stCondLst>
+                                    <p:cond delay="0"/>
+                                  </p:stCondLst>
+                                  <p:iterate type="lt">
+                                    <p:tmAbs val="40"/>
+                                  </p:iterate>
+                                  <p:childTnLst>
+                                    <p:set>
+                                      <p:cBhvr>
+                                        <p:cTn id="18" dur="1" fill="hold">
+                                          <p:stCondLst>
+                                            <p:cond delay="0"/>
+                                          </p:stCondLst>
+                                        </p:cTn>
+                                        <p:tgtEl>
+                                          <p:spTgt spid="27"/>
+                                        </p:tgtEl>
+                                        <p:attrNameLst>
+                                          <p:attrName>style.visibility</p:attrName>
+                                        </p:attrNameLst>
+                                      </p:cBhvr>
+                                      <p:to>
+                                        <p:strVal val="visible"/>
+                                      </p:to>
+                                    </p:set>
+                                  </p:childTnLst>
+                                </p:cTn>
+                              </p:par>
+                            </p:childTnLst>
+                          </p:cTn>
+                        </p:par>
+                      </p:childTnLst>
+                    </p:cTn>
+                  </p:par>
+                  <p:par>
+                    <p:cTn id="19" fill="hold">
+                      <p:stCondLst>
+                        <p:cond delay="indefinite"/>
+                      </p:stCondLst>
+                      <p:childTnLst>
+                        <p:par>
+                          <p:cTn id="20" fill="hold">
+                            <p:stCondLst>
+                              <p:cond delay="0"/>
+                            </p:stCondLst>
+                            <p:childTnLst>
+                              <p:par>
+                                <p:cTn id="21" presetID="1" presetClass="entr" presetSubtype="0" fill="hold" grpId="0" nodeType="clickEffect">
+                                  <p:stCondLst>
+                                    <p:cond delay="0"/>
+                                  </p:stCondLst>
+                                  <p:iterate type="lt">
+                                    <p:tmAbs val="40"/>
+                                  </p:iterate>
+                                  <p:childTnLst>
+                                    <p:set>
+                                      <p:cBhvr>
+                                        <p:cTn id="22" dur="1" fill="hold">
+                                          <p:stCondLst>
+                                            <p:cond delay="0"/>
+                                          </p:stCondLst>
+                                        </p:cTn>
+                                        <p:tgtEl>
+                                          <p:spTgt spid="32"/>
+                                        </p:tgtEl>
+                                        <p:attrNameLst>
+                                          <p:attrName>style.visibility</p:attrName>
+                                        </p:attrNameLst>
+                                      </p:cBhvr>
+                                      <p:to>
+                                        <p:strVal val="visible"/>
+                                      </p:to>
+                                    </p:set>
+                                  </p:childTnLst>
+                                </p:cTn>
+                              </p:par>
+                            </p:childTnLst>
+                          </p:cTn>
+                        </p:par>
+                      </p:childTnLst>
+                    </p:cTn>
+                  </p:par>
+                  <p:par>
+                    <p:cTn id="23" fill="hold">
+                      <p:stCondLst>
+                        <p:cond delay="indefinite"/>
+                      </p:stCondLst>
+                      <p:childTnLst>
+                        <p:par>
+                          <p:cTn id="24" fill="hold">
+                            <p:stCondLst>
+                              <p:cond delay="0"/>
+                            </p:stCondLst>
+                            <p:childTnLst>
+                              <p:par>
+                                <p:cTn id="25" presetID="1" presetClass="entr" presetSubtype="0" fill="hold" grpId="0" nodeType="clickEffect">
+                                  <p:stCondLst>
+                                    <p:cond delay="0"/>
+                                  </p:stCondLst>
+                                  <p:iterate type="lt">
+                                    <p:tmAbs val="40"/>
+                                  </p:iterate>
+                                  <p:childTnLst>
+                                    <p:set>
+                                      <p:cBhvr>
+                                        <p:cTn id="26" dur="1" fill="hold">
+                                          <p:stCondLst>
+                                            <p:cond delay="0"/>
+                                          </p:stCondLst>
+                                        </p:cTn>
+                                        <p:tgtEl>
+                                          <p:spTgt spid="37"/>
+                                        </p:tgtEl>
+                                        <p:attrNameLst>
+                                          <p:attrName>style.visibility</p:attrName>
+                                        </p:attrNameLst>
+                                      </p:cBhvr>
+                                      <p:to>
+                                        <p:strVal val="visible"/>
+                                      </p:to>
+                                    </p:set>
+                                  </p:childTnLst>
+                                </p:cTn>
+                              </p:par>
+                            </p:childTnLst>
+                          </p:cTn>
+                        </p:par>
+                      </p:childTnLst>
+                    </p:cTn>
+                  </p:par>
+                  <p:par>
+                    <p:cTn id="27" fill="hold">
+                      <p:stCondLst>
+                        <p:cond delay="indefinite"/>
+                      </p:stCondLst>
+                      <p:childTnLst>
+                        <p:par>
+                          <p:cTn id="28" fill="hold">
+                            <p:stCondLst>
+                              <p:cond delay="0"/>
+                            </p:stCondLst>
+                            <p:childTnLst>
+                              <p:par>
+                                <p:cTn id="29" presetID="1" presetClass="entr" presetSubtype="0" fill="hold" grpId="0" nodeType="clickEffect">
+                                  <p:stCondLst>
+                                    <p:cond delay="0"/>
+                                  </p:stCondLst>
+                                  <p:iterate type="lt">
+                                    <p:tmAbs val="40"/>
+                                  </p:iterate>
+                                  <p:childTnLst>
+                                    <p:set>
+                                      <p:cBhvr>
+                                        <p:cTn id="30" dur="1" fill="hold">
+                                          <p:stCondLst>
+                                            <p:cond delay="0"/>
+                                          </p:stCondLst>
+                                        </p:cTn>
+                                        <p:tgtEl>
+                                          <p:spTgt spid="42"/>
+                                        </p:tgtEl>
+                                        <p:attrNameLst>
+                                          <p:attrName>style.visibility</p:attrName>
+                                        </p:attrNameLst>
+                                      </p:cBhvr>
+                                      <p:to>
+                                        <p:strVal val="visible"/>
+                                      </p:to>
+                                    </p:set>
+                                  </p:childTnLst>
+                                </p:cTn>
+                              </p:par>
+                            </p:childTnLst>
+                          </p:cTn>
+                        </p:par>
+                      </p:childTnLst>
+                    </p:cTn>
+                  </p:par>
+                  <p:par>
+                    <p:cTn id="31" fill="hold">
+                      <p:stCondLst>
+                        <p:cond delay="indefinite"/>
+                      </p:stCondLst>
+                      <p:childTnLst>
+                        <p:par>
+                          <p:cTn id="32" fill="hold">
+                            <p:stCondLst>
+                              <p:cond delay="0"/>
+                            </p:stCondLst>
+                            <p:childTnLst>
+                              <p:par>
+                                <p:cTn id="33" presetID="1" presetClass="entr" presetSubtype="0" fill="hold" grpId="0" nodeType="clickEffect">
+                                  <p:stCondLst>
+                                    <p:cond delay="0"/>
+                                  </p:stCondLst>
+                                  <p:iterate type="lt">
+                                    <p:tmAbs val="40"/>
+                                  </p:iterate>
+                                  <p:childTnLst>
+                                    <p:set>
+                                      <p:cBhvr>
+                                        <p:cTn id="34" dur="1" fill="hold">
+                                          <p:stCondLst>
+                                            <p:cond delay="0"/>
+                                          </p:stCondLst>
+                                        </p:cTn>
+                                        <p:tgtEl>
+                                          <p:spTgt spid="46"/>
+                                        </p:tgtEl>
+                                        <p:attrNameLst>
+                                          <p:attrName>style.visibility</p:attrName>
+                                        </p:attrNameLst>
+                                      </p:cBhvr>
+                                      <p:to>
+                                        <p:strVal val="visible"/>
+                                      </p:to>
+                                    </p:set>
+                                  </p:childTnLst>
+                                </p:cTn>
+                              </p:par>
+                            </p:childTnLst>
+                          </p:cTn>
+                        </p:par>
+                      </p:childTnLst>
+                    </p:cTn>
+                  </p:par>
+                </p:childTnLst>
+              </p:cTn>
+              <p:prevCondLst>
+                <p:cond evt="onPrev" delay="0">
+                  <p:tgtEl>
+                    <p:sldTgt/>
+                  </p:tgtEl>
+                </p:cond>
+              </p:prevCondLst>
+              <p:nextCondLst>
+                <p:cond evt="onNext" delay="0">
+                  <p:tgtEl>
+                    <p:sldTgt/>
+                  </p:tgtEl>
+                </p:cond>
+              </p:nextCondLst>
+            </p:seq>
+          </p:childTnLst>
+        </p:cTn>
+      </p:par>
+    </p:tnLst>
+    <p:bldLst>
+      <p:bldP spid="12" grpId="0" animBg="1"/>
+      <p:bldP spid="17" grpId="0" animBg="1"/>
+      <p:bldP spid="22" grpId="0" animBg="1"/>
+      <p:bldP spid="27" grpId="0" animBg="1"/>
+      <p:bldP spid="32" grpId="0" animBg="1"/>
+      <p:bldP spid="37" grpId="0" animBg="1"/>
+      <p:bldP spid="42" grpId="0" animBg="1"/>
+      <p:bldP spid="46" grpId="0" animBg="1"/>
+    </p:bldLst>
+  </p:timing>
 </p:sld>
 </file>
 

</xml_diff>

<commit_message>
Cash Payment Branch B as click-to-reveal flowchart; carry over Google edits on slides 21, 30, 38, 41
Co-Authored-By: Claude Opus 5.5 <noreply@anthropic.com>
Claude-Session: https://claude.ai/code/session_01FEzv8wwqWDgTsXP8Yz6XYn
</commit_message>
<xml_diff>
--- a/billing-disputes/billing-disputes-cash-payments.pptx
+++ b/billing-disputes/billing-disputes-cash-payments.pptx
@@ -3625,7 +3625,7 @@
           <a:p>
             <a:r>
               <a:rPr lang="en-US" dirty="0"/>
-              <a:t>Report found, not yet actioned: resolve it yourself, no need to wait for the CP-side queue. Same amount gate as Branch A. Pending Invoice: cancel via the C CRM ("does not want the service"); if partial, invoice the remaining balance. Invoiced: refund via the CP Dashboard; if partial, admin refund the customer for the cash-paid portion (based on CP Pay) and apply a CP Holdback for the same amount. Soft ladder. Nothing on file: ask the customer for proof (encourage, don't require). Call the cleaner within business hours (8AM-8PM their local time); no answer, send an SMS; outside business hours, email. Set a 48-hour Timed Reminder. Customer provides proof: resolve per the job status, hard ladder. No proof but the cleaner admits it: resolve per the job status, soft ladder. Cleaner denies and no proof: no refund, no penalty; assess for retention: high-value or retention-likely (multiple completed jobs, high LTNR): voucher covering the full job hours; otherwise $20-$50 in platform credits; Internal Reason: cash_payment. Macros: Accepted Cash (Coaching); Accepted Cash (Warning + Account Adjustment); Refund confirmation: credit card refund processed.</a:t>
+              <a:t>TRAINER: descriptions are hidden. Click Show details (or press the right arrow): each click types out the next step's description. Report found, not yet actioned: resolve it yourself, no need to wait for the CP-side queue. Same amount gate as Branch A. Pending Invoice: cancel via the C CRM ("does not want the service"); if partial, invoice the remaining balance. Invoiced: refund via the CP Dashboard; if partial, admin refund the customer for the cash-paid portion (based on CP Pay) and apply a CP Holdback for the same amount. Soft ladder. Nothing on file: ask the customer for proof (encourage, don't require). Call the cleaner within business hours (8AM-8PM their local time); no answer, send an SMS; outside business hours, email. Set a 48-hour Timed Reminder. Customer provides proof: resolve per the job status, hard ladder. No proof but the cleaner admits it: resolve per the job status, soft ladder. Cleaner denies and no proof: no refund, no penalty; assess for retention: high-value or retention-likely (multiple completed jobs, high LTNR): voucher covering the full job hours; otherwise $20-$50 in platform credits; Internal Reason: cash_payment. Macros: Accepted Cash (Coaching); Accepted Cash (Warning + Account Adjustment); Refund confirmation: credit card refund processed.</a:t>
             </a:r>
             <a:endParaRPr lang="en-US" dirty="0"/>
           </a:p>
@@ -16527,7 +16527,7 @@
                 <a:ea typeface="SF Pro Text" pitchFamily="34" charset="-122"/>
                 <a:cs typeface="SF Pro Text" pitchFamily="34" charset="-120"/>
               </a:rPr>
-              <a:t>Coach the CP to ask before extending. Send comms about the action taken. The CP has 3 days to prove the customer authorized the extra hours.</a:t>
+              <a:t>Send coaching comms to the CP. The CP has 3 days to prove the customer authorized the extra hours.</a:t>
             </a:r>
             <a:endParaRPr lang="en-US" sz="950" dirty="0"/>
           </a:p>
@@ -16679,7 +16679,7 @@
                 <a:ea typeface="SF Pro Text" pitchFamily="34" charset="-122"/>
                 <a:cs typeface="SF Pro Text" pitchFamily="34" charset="-120"/>
               </a:rPr>
-              <a:t>If a Premium fee was charged, refund it. Unauthorized hours is itself the service issue, so the customer doesn't need to ask.</a:t>
+              <a:t>If a Premium fee was charged, refund it.</a:t>
             </a:r>
             <a:endParaRPr lang="en-US" sz="950" dirty="0"/>
           </a:p>
@@ -24805,7 +24805,7 @@
                 <a:ea typeface="SF Pro Text" pitchFamily="34" charset="-122"/>
                 <a:cs typeface="SF Pro Text" pitchFamily="34" charset="-120"/>
               </a:rPr>
-              <a:t>The CP invoiced a job they never cleaned. Confirm the CP, not the customer, invoiced it.</a:t>
+              <a:t>Confirm if it was the CP who invoiced the job.</a:t>
             </a:r>
             <a:endParaRPr lang="en-US" sz="850" dirty="0"/>
           </a:p>
@@ -25261,7 +25261,7 @@
                 <a:ea typeface="SF Pro Text" pitchFamily="34" charset="-122"/>
                 <a:cs typeface="SF Pro Text" pitchFamily="34" charset="-120"/>
               </a:rPr>
-              <a:t>Check the Issues Table for past false invoices or overcharges. Reason: cpq_false_invoice Customer &lt;C'S NAME&gt; reported incorrect hours charged.</a:t>
+              <a:t>If CP invoiced: penalty (cp facing reason cpq_false_invoice Customer &lt;C'S NAME&gt; reported incorrect hours charged) + false invoice flag</a:t>
             </a:r>
             <a:endParaRPr lang="en-US" sz="850" dirty="0"/>
           </a:p>
@@ -25413,7 +25413,7 @@
                 <a:ea typeface="SF Pro Text" pitchFamily="34" charset="-122"/>
                 <a:cs typeface="SF Pro Text" pitchFamily="34" charset="-120"/>
               </a:rPr>
-              <a:t>Don't claim jobs you can't do or invoice without working: reschedule, or cancel from your dashboard. GA/Tier 10 with pending items: reassign to allentolentino.</a:t>
+              <a:t>Send coaching comms to CP</a:t>
             </a:r>
             <a:endParaRPr lang="en-US" sz="850" dirty="0"/>
           </a:p>
@@ -32329,7 +32329,7 @@
         <p:spPr>
           <a:xfrm>
             <a:off x="411480" y="1280160"/>
-            <a:ext cx="1977390" cy="2057400"/>
+            <a:ext cx="1977390" cy="2377440"/>
           </a:xfrm>
           <a:prstGeom prst="roundRect">
             <a:avLst>
@@ -32405,7 +32405,7 @@
         <p:spPr>
           <a:xfrm>
             <a:off x="576072" y="1883664"/>
-            <a:ext cx="1648206" cy="274320"/>
+            <a:ext cx="1648206" cy="841248"/>
           </a:xfrm>
           <a:prstGeom prst="rect">
             <a:avLst/>
@@ -32429,7 +32429,7 @@
                 <a:ea typeface="SF Pro Display" pitchFamily="34" charset="-122"/>
                 <a:cs typeface="SF Pro Display" pitchFamily="34" charset="-120"/>
               </a:rPr>
-              <a:t>Not the customer</a:t>
+              <a:t>Don’t penalize the  customer</a:t>
             </a:r>
             <a:endParaRPr lang="en-US" sz="1200" dirty="0"/>
           </a:p>
@@ -32443,8 +32443,8 @@
         </p:nvSpPr>
         <p:spPr>
           <a:xfrm>
-            <a:off x="576072" y="2176272"/>
-            <a:ext cx="1648206" cy="1069848"/>
+            <a:off x="576072" y="2788920"/>
+            <a:ext cx="1648206" cy="822960"/>
           </a:xfrm>
           <a:prstGeom prst="rect">
             <a:avLst/>
@@ -32483,7 +32483,7 @@
         <p:spPr>
           <a:xfrm>
             <a:off x="2526030" y="1280160"/>
-            <a:ext cx="1977390" cy="2057400"/>
+            <a:ext cx="1977390" cy="2377440"/>
           </a:xfrm>
           <a:prstGeom prst="roundRect">
             <a:avLst>
@@ -32559,7 +32559,7 @@
         <p:spPr>
           <a:xfrm>
             <a:off x="2690622" y="1883664"/>
-            <a:ext cx="1648206" cy="274320"/>
+            <a:ext cx="1648206" cy="841248"/>
           </a:xfrm>
           <a:prstGeom prst="rect">
             <a:avLst/>
@@ -32583,7 +32583,7 @@
                 <a:ea typeface="SF Pro Display" pitchFamily="34" charset="-122"/>
                 <a:cs typeface="SF Pro Display" pitchFamily="34" charset="-120"/>
               </a:rPr>
-              <a:t>Nothing to go on?</a:t>
+              <a:t>Don’t act as investigator</a:t>
             </a:r>
             <a:endParaRPr lang="en-US" sz="1200" dirty="0"/>
           </a:p>
@@ -32597,8 +32597,8 @@
         </p:nvSpPr>
         <p:spPr>
           <a:xfrm>
-            <a:off x="2690622" y="2176272"/>
-            <a:ext cx="1648206" cy="1069848"/>
+            <a:off x="2690622" y="2788920"/>
+            <a:ext cx="1648206" cy="822960"/>
           </a:xfrm>
           <a:prstGeom prst="rect">
             <a:avLst/>
@@ -32637,7 +32637,7 @@
         <p:spPr>
           <a:xfrm>
             <a:off x="4640580" y="1280160"/>
-            <a:ext cx="1977390" cy="2057400"/>
+            <a:ext cx="1977390" cy="2377440"/>
           </a:xfrm>
           <a:prstGeom prst="roundRect">
             <a:avLst>
@@ -32713,7 +32713,7 @@
         <p:spPr>
           <a:xfrm>
             <a:off x="4805172" y="1883664"/>
-            <a:ext cx="1648206" cy="274320"/>
+            <a:ext cx="1648206" cy="841248"/>
           </a:xfrm>
           <a:prstGeom prst="rect">
             <a:avLst/>
@@ -32737,7 +32737,7 @@
                 <a:ea typeface="SF Pro Display" pitchFamily="34" charset="-122"/>
                 <a:cs typeface="SF Pro Display" pitchFamily="34" charset="-120"/>
               </a:rPr>
-              <a:t>Tone, not status</a:t>
+              <a:t>Coaching tone - based on how cash payment was confirmed</a:t>
             </a:r>
             <a:endParaRPr lang="en-US" sz="1200" dirty="0"/>
           </a:p>
@@ -32751,8 +32751,8 @@
         </p:nvSpPr>
         <p:spPr>
           <a:xfrm>
-            <a:off x="4805172" y="2176272"/>
-            <a:ext cx="1648206" cy="1069848"/>
+            <a:off x="4805172" y="2788920"/>
+            <a:ext cx="1648206" cy="822960"/>
           </a:xfrm>
           <a:prstGeom prst="rect">
             <a:avLst/>
@@ -32791,7 +32791,7 @@
         <p:spPr>
           <a:xfrm>
             <a:off x="6755130" y="1280160"/>
-            <a:ext cx="1977390" cy="2057400"/>
+            <a:ext cx="1977390" cy="2377440"/>
           </a:xfrm>
           <a:prstGeom prst="roundRect">
             <a:avLst>
@@ -32867,7 +32867,7 @@
         <p:spPr>
           <a:xfrm>
             <a:off x="6919722" y="1883664"/>
-            <a:ext cx="1648206" cy="274320"/>
+            <a:ext cx="1648206" cy="841248"/>
           </a:xfrm>
           <a:prstGeom prst="rect">
             <a:avLst/>
@@ -32891,7 +32891,7 @@
                 <a:ea typeface="SF Pro Display" pitchFamily="34" charset="-122"/>
                 <a:cs typeface="SF Pro Display" pitchFamily="34" charset="-120"/>
               </a:rPr>
-              <a:t>Remind the customer</a:t>
+              <a:t>Remind the customer where payment runs</a:t>
             </a:r>
             <a:endParaRPr lang="en-US" sz="1200" dirty="0"/>
           </a:p>
@@ -32905,8 +32905,8 @@
         </p:nvSpPr>
         <p:spPr>
           <a:xfrm>
-            <a:off x="6919722" y="2176272"/>
-            <a:ext cx="1648206" cy="1069848"/>
+            <a:off x="6919722" y="2788920"/>
+            <a:ext cx="1648206" cy="822960"/>
           </a:xfrm>
           <a:prstGeom prst="rect">
             <a:avLst/>
@@ -35758,98 +35758,34 @@
       </p:sp>
       <p:sp>
         <p:nvSpPr>
-          <p:cNvPr id="4" name="Text 2"/>
-          <p:cNvSpPr txBox="1"/>
-          <p:nvPr/>
-        </p:nvSpPr>
-        <p:spPr>
-          <a:xfrm>
-            <a:off x="438912" y="960120"/>
-            <a:ext cx="8229600" cy="274320"/>
-          </a:xfrm>
-          <a:prstGeom prst="rect">
-            <a:avLst/>
-          </a:prstGeom>
-          <a:noFill/>
-          <a:ln/>
-        </p:spPr>
-        <p:txBody>
-          <a:bodyPr wrap="square" lIns="0" tIns="0" rIns="0" bIns="0" rtlCol="0" anchor="t"/>
-          <a:lstStyle/>
-          <a:p>
-            <a:pPr indent="0" marL="0">
-              <a:buNone/>
-            </a:pPr>
-            <a:r>
-              <a:rPr lang="en-US" sz="1200" dirty="0">
-                <a:solidFill>
-                  <a:srgbClr val="6E6E73"/>
-                </a:solidFill>
-                <a:latin typeface="SF Pro Text" pitchFamily="34" charset="0"/>
-                <a:ea typeface="SF Pro Text" pitchFamily="34" charset="-122"/>
-                <a:cs typeface="SF Pro Text" pitchFamily="34" charset="-120"/>
-              </a:rPr>
-              <a:t>C-side agent. Check the CP CRM before anything else.</a:t>
-            </a:r>
-            <a:endParaRPr lang="en-US" sz="1200" dirty="0"/>
-          </a:p>
-        </p:txBody>
-      </p:sp>
-      <p:sp>
-        <p:nvSpPr>
-          <p:cNvPr id="6" name="Shape 3"/>
+          <p:cNvPr id="5" name="Shape 2"/>
           <p:cNvSpPr/>
           <p:nvPr/>
         </p:nvSpPr>
         <p:spPr>
           <a:xfrm>
-            <a:off x="411480" y="1280160"/>
-            <a:ext cx="4091940" cy="1325880"/>
+            <a:off x="6949440" y="502920"/>
+            <a:ext cx="1783080" cy="365760"/>
           </a:xfrm>
           <a:prstGeom prst="roundRect">
             <a:avLst>
-              <a:gd name="adj" fmla="val 5517"/>
+              <a:gd name="adj" fmla="val 20000"/>
             </a:avLst>
           </a:prstGeom>
           <a:solidFill>
-            <a:srgbClr val="FFFFFF"/>
+            <a:srgbClr val="0B7A6F"/>
           </a:solidFill>
-          <a:ln w="9525">
+          <a:ln w="12700">
             <a:solidFill>
-              <a:srgbClr val="DCE1E7"/>
+              <a:srgbClr val="0B7A6F"/>
             </a:solidFill>
             <a:prstDash val="solid"/>
           </a:ln>
         </p:spPr>
       </p:sp>
-      <p:sp>
-        <p:nvSpPr>
-          <p:cNvPr id="7" name="Shape 4"/>
-          <p:cNvSpPr/>
-          <p:nvPr/>
-        </p:nvSpPr>
-        <p:spPr>
-          <a:xfrm>
-            <a:off x="576072" y="1444752"/>
-            <a:ext cx="329184" cy="329184"/>
-          </a:xfrm>
-          <a:prstGeom prst="ellipse">
-            <a:avLst/>
-          </a:prstGeom>
-          <a:solidFill>
-            <a:srgbClr val="E3F4F1"/>
-          </a:solidFill>
-          <a:ln w="12700">
-            <a:solidFill>
-              <a:srgbClr val="E3F4F1"/>
-            </a:solidFill>
-            <a:prstDash val="solid"/>
-          </a:ln>
-        </p:spPr>
-      </p:sp>
       <p:pic>
         <p:nvPicPr>
-          <p:cNvPr id="8" name="Image 0" descr="preencoded.png">    </p:cNvPr>
+          <p:cNvPr id="6" name="Image 0" descr="preencoded.png">    </p:cNvPr>
           <p:cNvPicPr>
             <a:picLocks noChangeAspect="1"/>
           </p:cNvPicPr>
@@ -35863,8 +35799,8 @@
         </p:blipFill>
         <p:spPr>
           <a:xfrm>
-            <a:off x="655076" y="1523756"/>
-            <a:ext cx="171176" cy="171176"/>
+            <a:off x="7086600" y="594360"/>
+            <a:ext cx="182880" cy="182880"/>
           </a:xfrm>
           <a:prstGeom prst="rect">
             <a:avLst/>
@@ -35873,69 +35809,182 @@
       </p:pic>
       <p:sp>
         <p:nvSpPr>
-          <p:cNvPr id="9" name="Text 5"/>
-          <p:cNvSpPr txBox="1"/>
-          <p:nvPr/>
-        </p:nvSpPr>
-        <p:spPr>
-          <a:xfrm>
-            <a:off x="576072" y="1883664"/>
-            <a:ext cx="3762756" cy="274320"/>
-          </a:xfrm>
-          <a:prstGeom prst="rect">
-            <a:avLst/>
-          </a:prstGeom>
-          <a:noFill/>
-          <a:ln/>
-        </p:spPr>
-        <p:txBody>
-          <a:bodyPr wrap="square" lIns="0" tIns="0" rIns="0" bIns="0" rtlCol="0" anchor="t"/>
+          <p:cNvPr id="7" name="Text 3"/>
+          <p:cNvSpPr txBox="1"/>
+          <p:nvPr/>
+        </p:nvSpPr>
+        <p:spPr>
+          <a:xfrm>
+            <a:off x="7333488" y="502920"/>
+            <a:ext cx="1325880" cy="365760"/>
+          </a:xfrm>
+          <a:prstGeom prst="rect">
+            <a:avLst/>
+          </a:prstGeom>
+          <a:noFill/>
+          <a:ln/>
+        </p:spPr>
+        <p:txBody>
+          <a:bodyPr wrap="square" lIns="0" tIns="0" rIns="0" bIns="0" rtlCol="0" anchor="ctr"/>
           <a:lstStyle/>
           <a:p>
             <a:pPr indent="0" marL="0">
               <a:buNone/>
             </a:pPr>
             <a:r>
-              <a:rPr lang="en-US" sz="1200" b="1" dirty="0">
-                <a:solidFill>
-                  <a:srgbClr val="1D1D1F"/>
+              <a:rPr lang="en-US" sz="1100" b="1" dirty="0">
+                <a:solidFill>
+                  <a:srgbClr val="FFFFFF"/>
                 </a:solidFill>
                 <a:latin typeface="SF Pro Display" pitchFamily="34" charset="0"/>
                 <a:ea typeface="SF Pro Display" pitchFamily="34" charset="-122"/>
                 <a:cs typeface="SF Pro Display" pitchFamily="34" charset="-120"/>
               </a:rPr>
-              <a:t>Report on file</a:t>
-            </a:r>
-            <a:endParaRPr lang="en-US" sz="1200" dirty="0"/>
-          </a:p>
-        </p:txBody>
-      </p:sp>
-      <p:sp>
-        <p:nvSpPr>
-          <p:cNvPr id="10" name="Text 6"/>
-          <p:cNvSpPr txBox="1"/>
-          <p:nvPr/>
-        </p:nvSpPr>
-        <p:spPr>
-          <a:xfrm>
-            <a:off x="576072" y="2176272"/>
-            <a:ext cx="3762756" cy="338328"/>
-          </a:xfrm>
-          <a:prstGeom prst="rect">
-            <a:avLst/>
-          </a:prstGeom>
-          <a:noFill/>
-          <a:ln/>
-        </p:spPr>
-        <p:txBody>
-          <a:bodyPr wrap="square" lIns="0" tIns="0" rIns="0" bIns="0" rtlCol="0" anchor="t"/>
+              <a:t>Show details</a:t>
+            </a:r>
+            <a:endParaRPr lang="en-US" sz="1100" dirty="0"/>
+          </a:p>
+        </p:txBody>
+      </p:sp>
+      <p:sp>
+        <p:nvSpPr>
+          <p:cNvPr id="8" name="Shape 4"/>
+          <p:cNvSpPr/>
+          <p:nvPr/>
+        </p:nvSpPr>
+        <p:spPr>
+          <a:xfrm>
+            <a:off x="457200" y="1051560"/>
+            <a:ext cx="3246120" cy="310896"/>
+          </a:xfrm>
+          <a:prstGeom prst="roundRect">
+            <a:avLst>
+              <a:gd name="adj" fmla="val 23529"/>
+            </a:avLst>
+          </a:prstGeom>
+          <a:solidFill>
+            <a:srgbClr val="1D1D1F"/>
+          </a:solidFill>
+          <a:ln w="12700">
+            <a:solidFill>
+              <a:srgbClr val="1D1D1F"/>
+            </a:solidFill>
+            <a:prstDash val="solid"/>
+          </a:ln>
+        </p:spPr>
+      </p:sp>
+      <p:sp>
+        <p:nvSpPr>
+          <p:cNvPr id="9" name="Text 5"/>
+          <p:cNvSpPr txBox="1"/>
+          <p:nvPr/>
+        </p:nvSpPr>
+        <p:spPr>
+          <a:xfrm>
+            <a:off x="457200" y="1051560"/>
+            <a:ext cx="3246120" cy="310896"/>
+          </a:xfrm>
+          <a:prstGeom prst="rect">
+            <a:avLst/>
+          </a:prstGeom>
+          <a:noFill/>
+          <a:ln/>
+        </p:spPr>
+        <p:txBody>
+          <a:bodyPr wrap="square" lIns="0" tIns="0" rIns="0" bIns="0" rtlCol="0" anchor="ctr"/>
+          <a:lstStyle/>
+          <a:p>
+            <a:pPr algn="ctr" indent="0" marL="0">
+              <a:buNone/>
+            </a:pPr>
+            <a:r>
+              <a:rPr lang="en-US" sz="1000" b="1" dirty="0">
+                <a:solidFill>
+                  <a:srgbClr val="FFFFFF"/>
+                </a:solidFill>
+                <a:latin typeface="SF Pro Display" pitchFamily="34" charset="0"/>
+                <a:ea typeface="SF Pro Display" pitchFamily="34" charset="-122"/>
+                <a:cs typeface="SF Pro Display" pitchFamily="34" charset="-120"/>
+              </a:rPr>
+              <a:t>Customer says they paid the CP cash</a:t>
+            </a:r>
+            <a:endParaRPr lang="en-US" sz="1000" dirty="0"/>
+          </a:p>
+        </p:txBody>
+      </p:sp>
+      <p:sp>
+        <p:nvSpPr>
+          <p:cNvPr id="10" name="Shape 6"/>
+          <p:cNvSpPr/>
+          <p:nvPr/>
+        </p:nvSpPr>
+        <p:spPr>
+          <a:xfrm>
+            <a:off x="2080260" y="1362456"/>
+            <a:ext cx="0" cy="73152"/>
+          </a:xfrm>
+          <a:prstGeom prst="line">
+            <a:avLst/>
+          </a:prstGeom>
+          <a:noFill/>
+          <a:ln w="12700">
+            <a:solidFill>
+              <a:srgbClr val="6E6E73"/>
+            </a:solidFill>
+            <a:prstDash val="solid"/>
+            <a:tailEnd type="triangle"/>
+          </a:ln>
+        </p:spPr>
+      </p:sp>
+      <p:sp>
+        <p:nvSpPr>
+          <p:cNvPr id="11" name="Shape 7"/>
+          <p:cNvSpPr/>
+          <p:nvPr/>
+        </p:nvSpPr>
+        <p:spPr>
+          <a:xfrm>
+            <a:off x="3703320" y="1207008"/>
+            <a:ext cx="182880" cy="0"/>
+          </a:xfrm>
+          <a:prstGeom prst="line">
+            <a:avLst/>
+          </a:prstGeom>
+          <a:noFill/>
+          <a:ln w="12700">
+            <a:solidFill>
+              <a:srgbClr val="6E6E73"/>
+            </a:solidFill>
+            <a:prstDash val="solid"/>
+          </a:ln>
+        </p:spPr>
+      </p:sp>
+      <p:sp>
+        <p:nvSpPr>
+          <p:cNvPr id="12" name="type1Desc"/>
+          <p:cNvSpPr txBox="1"/>
+          <p:nvPr/>
+        </p:nvSpPr>
+        <p:spPr>
+          <a:xfrm>
+            <a:off x="3977640" y="1014984"/>
+            <a:ext cx="4983480" cy="384048"/>
+          </a:xfrm>
+          <a:prstGeom prst="rect">
+            <a:avLst/>
+          </a:prstGeom>
+          <a:noFill/>
+          <a:ln/>
+        </p:spPr>
+        <p:txBody>
+          <a:bodyPr wrap="square" lIns="0" tIns="0" rIns="0" bIns="0" rtlCol="0" anchor="ctr"/>
           <a:lstStyle/>
           <a:p>
             <a:pPr indent="0" marL="0">
               <a:buNone/>
             </a:pPr>
             <a:r>
-              <a:rPr lang="en-US" sz="950" dirty="0">
+              <a:rPr lang="en-US" sz="800" dirty="0">
                 <a:solidFill>
                   <a:srgbClr val="6E6E73"/>
                 </a:solidFill>
@@ -35943,32 +35992,1096 @@
                 <a:ea typeface="SF Pro Text" pitchFamily="34" charset="-122"/>
                 <a:cs typeface="SF Pro Text" pitchFamily="34" charset="-120"/>
               </a:rPr>
-              <a:t>Resolve it yourself. Get the amount, act on the status, soft ladder.</a:t>
-            </a:r>
-            <a:endParaRPr lang="en-US" sz="950" dirty="0"/>
-          </a:p>
-        </p:txBody>
-      </p:sp>
-      <p:sp>
-        <p:nvSpPr>
-          <p:cNvPr id="11" name="Shape 7"/>
+              <a:t>C-side agent: the customer contacted us first. The CP-side ticket may not be worked yet, or the CP never reported it.</a:t>
+            </a:r>
+            <a:endParaRPr lang="en-US" sz="800" dirty="0"/>
+          </a:p>
+        </p:txBody>
+      </p:sp>
+      <p:sp>
+        <p:nvSpPr>
+          <p:cNvPr id="13" name="Shape 9"/>
           <p:cNvSpPr/>
           <p:nvPr/>
         </p:nvSpPr>
         <p:spPr>
           <a:xfrm>
-            <a:off x="4640580" y="1280160"/>
-            <a:ext cx="4091940" cy="1325880"/>
+            <a:off x="457200" y="1435608"/>
+            <a:ext cx="3246120" cy="310896"/>
           </a:xfrm>
           <a:prstGeom prst="roundRect">
             <a:avLst>
-              <a:gd name="adj" fmla="val 5517"/>
+              <a:gd name="adj" fmla="val 23529"/>
+            </a:avLst>
+          </a:prstGeom>
+          <a:solidFill>
+            <a:srgbClr val="FFF3D6"/>
+          </a:solidFill>
+          <a:ln w="12700">
+            <a:solidFill>
+              <a:srgbClr val="9A6410"/>
+            </a:solidFill>
+            <a:prstDash val="solid"/>
+          </a:ln>
+        </p:spPr>
+      </p:sp>
+      <p:sp>
+        <p:nvSpPr>
+          <p:cNvPr id="14" name="Text 10"/>
+          <p:cNvSpPr txBox="1"/>
+          <p:nvPr/>
+        </p:nvSpPr>
+        <p:spPr>
+          <a:xfrm>
+            <a:off x="457200" y="1435608"/>
+            <a:ext cx="3246120" cy="310896"/>
+          </a:xfrm>
+          <a:prstGeom prst="rect">
+            <a:avLst/>
+          </a:prstGeom>
+          <a:noFill/>
+          <a:ln/>
+        </p:spPr>
+        <p:txBody>
+          <a:bodyPr wrap="square" lIns="0" tIns="0" rIns="0" bIns="0" rtlCol="0" anchor="ctr"/>
+          <a:lstStyle/>
+          <a:p>
+            <a:pPr algn="ctr" indent="0" marL="0">
+              <a:buNone/>
+            </a:pPr>
+            <a:r>
+              <a:rPr lang="en-US" sz="1000" b="1" dirty="0">
+                <a:solidFill>
+                  <a:srgbClr val="9A6410"/>
+                </a:solidFill>
+                <a:latin typeface="SF Pro Display" pitchFamily="34" charset="0"/>
+                <a:ea typeface="SF Pro Display" pitchFamily="34" charset="-122"/>
+                <a:cs typeface="SF Pro Display" pitchFamily="34" charset="-120"/>
+              </a:rPr>
+              <a:t>Check CP CRM for a cash report</a:t>
+            </a:r>
+            <a:endParaRPr lang="en-US" sz="1000" dirty="0"/>
+          </a:p>
+        </p:txBody>
+      </p:sp>
+      <p:sp>
+        <p:nvSpPr>
+          <p:cNvPr id="15" name="Shape 11"/>
+          <p:cNvSpPr/>
+          <p:nvPr/>
+        </p:nvSpPr>
+        <p:spPr>
+          <a:xfrm>
+            <a:off x="2080260" y="1746504"/>
+            <a:ext cx="0" cy="73152"/>
+          </a:xfrm>
+          <a:prstGeom prst="line">
+            <a:avLst/>
+          </a:prstGeom>
+          <a:noFill/>
+          <a:ln w="12700">
+            <a:solidFill>
+              <a:srgbClr val="6E6E73"/>
+            </a:solidFill>
+            <a:prstDash val="solid"/>
+            <a:tailEnd type="triangle"/>
+          </a:ln>
+        </p:spPr>
+      </p:sp>
+      <p:sp>
+        <p:nvSpPr>
+          <p:cNvPr id="16" name="Shape 12"/>
+          <p:cNvSpPr/>
+          <p:nvPr/>
+        </p:nvSpPr>
+        <p:spPr>
+          <a:xfrm>
+            <a:off x="3703320" y="1591056"/>
+            <a:ext cx="182880" cy="0"/>
+          </a:xfrm>
+          <a:prstGeom prst="line">
+            <a:avLst/>
+          </a:prstGeom>
+          <a:noFill/>
+          <a:ln w="12700">
+            <a:solidFill>
+              <a:srgbClr val="6E6E73"/>
+            </a:solidFill>
+            <a:prstDash val="solid"/>
+          </a:ln>
+        </p:spPr>
+      </p:sp>
+      <p:sp>
+        <p:nvSpPr>
+          <p:cNvPr id="17" name="type2Desc"/>
+          <p:cNvSpPr txBox="1"/>
+          <p:nvPr/>
+        </p:nvSpPr>
+        <p:spPr>
+          <a:xfrm>
+            <a:off x="3977640" y="1399032"/>
+            <a:ext cx="4983480" cy="384048"/>
+          </a:xfrm>
+          <a:prstGeom prst="rect">
+            <a:avLst/>
+          </a:prstGeom>
+          <a:noFill/>
+          <a:ln/>
+        </p:spPr>
+        <p:txBody>
+          <a:bodyPr wrap="square" lIns="0" tIns="0" rIns="0" bIns="0" rtlCol="0" anchor="ctr"/>
+          <a:lstStyle/>
+          <a:p>
+            <a:pPr indent="0" marL="0">
+              <a:buNone/>
+            </a:pPr>
+            <a:r>
+              <a:rPr lang="en-US" sz="800" dirty="0">
+                <a:solidFill>
+                  <a:srgbClr val="6E6E73"/>
+                </a:solidFill>
+                <a:latin typeface="SF Pro Text" pitchFamily="34" charset="0"/>
+                <a:ea typeface="SF Pro Text" pitchFamily="34" charset="-122"/>
+                <a:cs typeface="SF Pro Text" pitchFamily="34" charset="-120"/>
+              </a:rPr>
+              <a:t>Look for an existing cash-payment report on this job/CP before doing anything else.</a:t>
+            </a:r>
+            <a:endParaRPr lang="en-US" sz="800" dirty="0"/>
+          </a:p>
+        </p:txBody>
+      </p:sp>
+      <p:sp>
+        <p:nvSpPr>
+          <p:cNvPr id="18" name="Shape 14"/>
+          <p:cNvSpPr/>
+          <p:nvPr/>
+        </p:nvSpPr>
+        <p:spPr>
+          <a:xfrm>
+            <a:off x="457200" y="1819656"/>
+            <a:ext cx="3246120" cy="310896"/>
+          </a:xfrm>
+          <a:prstGeom prst="roundRect">
+            <a:avLst>
+              <a:gd name="adj" fmla="val 23529"/>
+            </a:avLst>
+          </a:prstGeom>
+          <a:solidFill>
+            <a:srgbClr val="0B7A6F"/>
+          </a:solidFill>
+          <a:ln w="12700">
+            <a:solidFill>
+              <a:srgbClr val="0B7A6F"/>
+            </a:solidFill>
+            <a:prstDash val="solid"/>
+          </a:ln>
+        </p:spPr>
+      </p:sp>
+      <p:sp>
+        <p:nvSpPr>
+          <p:cNvPr id="19" name="Text 15"/>
+          <p:cNvSpPr txBox="1"/>
+          <p:nvPr/>
+        </p:nvSpPr>
+        <p:spPr>
+          <a:xfrm>
+            <a:off x="457200" y="1819656"/>
+            <a:ext cx="3246120" cy="310896"/>
+          </a:xfrm>
+          <a:prstGeom prst="rect">
+            <a:avLst/>
+          </a:prstGeom>
+          <a:noFill/>
+          <a:ln/>
+        </p:spPr>
+        <p:txBody>
+          <a:bodyPr wrap="square" lIns="0" tIns="0" rIns="0" bIns="0" rtlCol="0" anchor="ctr"/>
+          <a:lstStyle/>
+          <a:p>
+            <a:pPr algn="ctr" indent="0" marL="0">
+              <a:buNone/>
+            </a:pPr>
+            <a:r>
+              <a:rPr lang="en-US" sz="1000" b="1" dirty="0">
+                <a:solidFill>
+                  <a:srgbClr val="FFFFFF"/>
+                </a:solidFill>
+                <a:latin typeface="SF Pro Display" pitchFamily="34" charset="0"/>
+                <a:ea typeface="SF Pro Display" pitchFamily="34" charset="-122"/>
+                <a:cs typeface="SF Pro Display" pitchFamily="34" charset="-120"/>
+              </a:rPr>
+              <a:t>Report on file, but not yet actioned</a:t>
+            </a:r>
+            <a:endParaRPr lang="en-US" sz="1000" dirty="0"/>
+          </a:p>
+        </p:txBody>
+      </p:sp>
+      <p:sp>
+        <p:nvSpPr>
+          <p:cNvPr id="20" name="Shape 16"/>
+          <p:cNvSpPr/>
+          <p:nvPr/>
+        </p:nvSpPr>
+        <p:spPr>
+          <a:xfrm>
+            <a:off x="2080260" y="2130552"/>
+            <a:ext cx="0" cy="73152"/>
+          </a:xfrm>
+          <a:prstGeom prst="line">
+            <a:avLst/>
+          </a:prstGeom>
+          <a:noFill/>
+          <a:ln w="12700">
+            <a:solidFill>
+              <a:srgbClr val="6E6E73"/>
+            </a:solidFill>
+            <a:prstDash val="solid"/>
+            <a:tailEnd type="triangle"/>
+          </a:ln>
+        </p:spPr>
+      </p:sp>
+      <p:sp>
+        <p:nvSpPr>
+          <p:cNvPr id="21" name="Shape 17"/>
+          <p:cNvSpPr/>
+          <p:nvPr/>
+        </p:nvSpPr>
+        <p:spPr>
+          <a:xfrm>
+            <a:off x="3703320" y="1975104"/>
+            <a:ext cx="182880" cy="0"/>
+          </a:xfrm>
+          <a:prstGeom prst="line">
+            <a:avLst/>
+          </a:prstGeom>
+          <a:noFill/>
+          <a:ln w="12700">
+            <a:solidFill>
+              <a:srgbClr val="6E6E73"/>
+            </a:solidFill>
+            <a:prstDash val="solid"/>
+          </a:ln>
+        </p:spPr>
+      </p:sp>
+      <p:sp>
+        <p:nvSpPr>
+          <p:cNvPr id="22" name="type3Desc"/>
+          <p:cNvSpPr txBox="1"/>
+          <p:nvPr/>
+        </p:nvSpPr>
+        <p:spPr>
+          <a:xfrm>
+            <a:off x="3977640" y="1783080"/>
+            <a:ext cx="4983480" cy="384048"/>
+          </a:xfrm>
+          <a:prstGeom prst="rect">
+            <a:avLst/>
+          </a:prstGeom>
+          <a:noFill/>
+          <a:ln/>
+        </p:spPr>
+        <p:txBody>
+          <a:bodyPr wrap="square" lIns="0" tIns="0" rIns="0" bIns="0" rtlCol="0" anchor="ctr"/>
+          <a:lstStyle/>
+          <a:p>
+            <a:pPr indent="0" marL="0">
+              <a:buNone/>
+            </a:pPr>
+            <a:r>
+              <a:rPr lang="en-US" sz="800" dirty="0">
+                <a:solidFill>
+                  <a:srgbClr val="6E6E73"/>
+                </a:solidFill>
+                <a:latin typeface="SF Pro Text" pitchFamily="34" charset="0"/>
+                <a:ea typeface="SF Pro Text" pitchFamily="34" charset="-122"/>
+                <a:cs typeface="SF Pro Text" pitchFamily="34" charset="-120"/>
+              </a:rPr>
+              <a:t>Resolve it yourself. Get the amount first (or a clear "paid in full"). Pending Invoice: cancel via C CRM, or invoice the balance if partial. Invoiced: refund via CP Dashboard. Soft ladder.</a:t>
+            </a:r>
+            <a:endParaRPr lang="en-US" sz="800" dirty="0"/>
+          </a:p>
+        </p:txBody>
+      </p:sp>
+      <p:sp>
+        <p:nvSpPr>
+          <p:cNvPr id="23" name="Shape 19"/>
+          <p:cNvSpPr/>
+          <p:nvPr/>
+        </p:nvSpPr>
+        <p:spPr>
+          <a:xfrm>
+            <a:off x="457200" y="2203704"/>
+            <a:ext cx="3246120" cy="310896"/>
+          </a:xfrm>
+          <a:prstGeom prst="roundRect">
+            <a:avLst>
+              <a:gd name="adj" fmla="val 23529"/>
+            </a:avLst>
+          </a:prstGeom>
+          <a:solidFill>
+            <a:srgbClr val="0B7A6F"/>
+          </a:solidFill>
+          <a:ln w="12700">
+            <a:solidFill>
+              <a:srgbClr val="0B7A6F"/>
+            </a:solidFill>
+            <a:prstDash val="solid"/>
+          </a:ln>
+        </p:spPr>
+      </p:sp>
+      <p:sp>
+        <p:nvSpPr>
+          <p:cNvPr id="24" name="Text 20"/>
+          <p:cNvSpPr txBox="1"/>
+          <p:nvPr/>
+        </p:nvSpPr>
+        <p:spPr>
+          <a:xfrm>
+            <a:off x="457200" y="2203704"/>
+            <a:ext cx="3246120" cy="310896"/>
+          </a:xfrm>
+          <a:prstGeom prst="rect">
+            <a:avLst/>
+          </a:prstGeom>
+          <a:noFill/>
+          <a:ln/>
+        </p:spPr>
+        <p:txBody>
+          <a:bodyPr wrap="square" lIns="0" tIns="0" rIns="0" bIns="0" rtlCol="0" anchor="ctr"/>
+          <a:lstStyle/>
+          <a:p>
+            <a:pPr algn="ctr" indent="0" marL="0">
+              <a:buNone/>
+            </a:pPr>
+            <a:r>
+              <a:rPr lang="en-US" sz="1000" b="1" dirty="0">
+                <a:solidFill>
+                  <a:srgbClr val="FFFFFF"/>
+                </a:solidFill>
+                <a:latin typeface="SF Pro Display" pitchFamily="34" charset="0"/>
+                <a:ea typeface="SF Pro Display" pitchFamily="34" charset="-122"/>
+                <a:cs typeface="SF Pro Display" pitchFamily="34" charset="-120"/>
+              </a:rPr>
+              <a:t>Nothing on file: ask C for proof</a:t>
+            </a:r>
+            <a:endParaRPr lang="en-US" sz="1000" dirty="0"/>
+          </a:p>
+        </p:txBody>
+      </p:sp>
+      <p:sp>
+        <p:nvSpPr>
+          <p:cNvPr id="25" name="Shape 21"/>
+          <p:cNvSpPr/>
+          <p:nvPr/>
+        </p:nvSpPr>
+        <p:spPr>
+          <a:xfrm>
+            <a:off x="2080260" y="2514600"/>
+            <a:ext cx="0" cy="73152"/>
+          </a:xfrm>
+          <a:prstGeom prst="line">
+            <a:avLst/>
+          </a:prstGeom>
+          <a:noFill/>
+          <a:ln w="12700">
+            <a:solidFill>
+              <a:srgbClr val="6E6E73"/>
+            </a:solidFill>
+            <a:prstDash val="solid"/>
+            <a:tailEnd type="triangle"/>
+          </a:ln>
+        </p:spPr>
+      </p:sp>
+      <p:sp>
+        <p:nvSpPr>
+          <p:cNvPr id="26" name="Shape 22"/>
+          <p:cNvSpPr/>
+          <p:nvPr/>
+        </p:nvSpPr>
+        <p:spPr>
+          <a:xfrm>
+            <a:off x="3703320" y="2359152"/>
+            <a:ext cx="182880" cy="0"/>
+          </a:xfrm>
+          <a:prstGeom prst="line">
+            <a:avLst/>
+          </a:prstGeom>
+          <a:noFill/>
+          <a:ln w="12700">
+            <a:solidFill>
+              <a:srgbClr val="6E6E73"/>
+            </a:solidFill>
+            <a:prstDash val="solid"/>
+          </a:ln>
+        </p:spPr>
+      </p:sp>
+      <p:sp>
+        <p:nvSpPr>
+          <p:cNvPr id="27" name="type4Desc"/>
+          <p:cNvSpPr txBox="1"/>
+          <p:nvPr/>
+        </p:nvSpPr>
+        <p:spPr>
+          <a:xfrm>
+            <a:off x="3977640" y="2167128"/>
+            <a:ext cx="4983480" cy="384048"/>
+          </a:xfrm>
+          <a:prstGeom prst="rect">
+            <a:avLst/>
+          </a:prstGeom>
+          <a:noFill/>
+          <a:ln/>
+        </p:spPr>
+        <p:txBody>
+          <a:bodyPr wrap="square" lIns="0" tIns="0" rIns="0" bIns="0" rtlCol="0" anchor="ctr"/>
+          <a:lstStyle/>
+          <a:p>
+            <a:pPr indent="0" marL="0">
+              <a:buNone/>
+            </a:pPr>
+            <a:r>
+              <a:rPr lang="en-US" sz="800" dirty="0">
+                <a:solidFill>
+                  <a:srgbClr val="6E6E73"/>
+                </a:solidFill>
+                <a:latin typeface="SF Pro Text" pitchFamily="34" charset="0"/>
+                <a:ea typeface="SF Pro Text" pitchFamily="34" charset="-122"/>
+                <a:cs typeface="SF Pro Text" pitchFamily="34" charset="-120"/>
+              </a:rPr>
+              <a:t>Encourage proof, don't require it.</a:t>
+            </a:r>
+            <a:endParaRPr lang="en-US" sz="800" dirty="0"/>
+          </a:p>
+        </p:txBody>
+      </p:sp>
+      <p:sp>
+        <p:nvSpPr>
+          <p:cNvPr id="28" name="Shape 24"/>
+          <p:cNvSpPr/>
+          <p:nvPr/>
+        </p:nvSpPr>
+        <p:spPr>
+          <a:xfrm>
+            <a:off x="457200" y="2587752"/>
+            <a:ext cx="3246120" cy="310896"/>
+          </a:xfrm>
+          <a:prstGeom prst="roundRect">
+            <a:avLst>
+              <a:gd name="adj" fmla="val 23529"/>
+            </a:avLst>
+          </a:prstGeom>
+          <a:solidFill>
+            <a:srgbClr val="0B7A6F"/>
+          </a:solidFill>
+          <a:ln w="12700">
+            <a:solidFill>
+              <a:srgbClr val="0B7A6F"/>
+            </a:solidFill>
+            <a:prstDash val="solid"/>
+          </a:ln>
+        </p:spPr>
+      </p:sp>
+      <p:sp>
+        <p:nvSpPr>
+          <p:cNvPr id="29" name="Text 25"/>
+          <p:cNvSpPr txBox="1"/>
+          <p:nvPr/>
+        </p:nvSpPr>
+        <p:spPr>
+          <a:xfrm>
+            <a:off x="457200" y="2587752"/>
+            <a:ext cx="3246120" cy="310896"/>
+          </a:xfrm>
+          <a:prstGeom prst="rect">
+            <a:avLst/>
+          </a:prstGeom>
+          <a:noFill/>
+          <a:ln/>
+        </p:spPr>
+        <p:txBody>
+          <a:bodyPr wrap="square" lIns="0" tIns="0" rIns="0" bIns="0" rtlCol="0" anchor="ctr"/>
+          <a:lstStyle/>
+          <a:p>
+            <a:pPr algn="ctr" indent="0" marL="0">
+              <a:buNone/>
+            </a:pPr>
+            <a:r>
+              <a:rPr lang="en-US" sz="1000" b="1" dirty="0">
+                <a:solidFill>
+                  <a:srgbClr val="FFFFFF"/>
+                </a:solidFill>
+                <a:latin typeface="SF Pro Display" pitchFamily="34" charset="0"/>
+                <a:ea typeface="SF Pro Display" pitchFamily="34" charset="-122"/>
+                <a:cs typeface="SF Pro Display" pitchFamily="34" charset="-120"/>
+              </a:rPr>
+              <a:t>Contact the CP</a:t>
+            </a:r>
+            <a:endParaRPr lang="en-US" sz="1000" dirty="0"/>
+          </a:p>
+        </p:txBody>
+      </p:sp>
+      <p:sp>
+        <p:nvSpPr>
+          <p:cNvPr id="30" name="Shape 26"/>
+          <p:cNvSpPr/>
+          <p:nvPr/>
+        </p:nvSpPr>
+        <p:spPr>
+          <a:xfrm>
+            <a:off x="2080260" y="2898648"/>
+            <a:ext cx="0" cy="73152"/>
+          </a:xfrm>
+          <a:prstGeom prst="line">
+            <a:avLst/>
+          </a:prstGeom>
+          <a:noFill/>
+          <a:ln w="12700">
+            <a:solidFill>
+              <a:srgbClr val="6E6E73"/>
+            </a:solidFill>
+            <a:prstDash val="solid"/>
+            <a:tailEnd type="triangle"/>
+          </a:ln>
+        </p:spPr>
+      </p:sp>
+      <p:sp>
+        <p:nvSpPr>
+          <p:cNvPr id="31" name="Shape 27"/>
+          <p:cNvSpPr/>
+          <p:nvPr/>
+        </p:nvSpPr>
+        <p:spPr>
+          <a:xfrm>
+            <a:off x="3703320" y="2743200"/>
+            <a:ext cx="182880" cy="0"/>
+          </a:xfrm>
+          <a:prstGeom prst="line">
+            <a:avLst/>
+          </a:prstGeom>
+          <a:noFill/>
+          <a:ln w="12700">
+            <a:solidFill>
+              <a:srgbClr val="6E6E73"/>
+            </a:solidFill>
+            <a:prstDash val="solid"/>
+          </a:ln>
+        </p:spPr>
+      </p:sp>
+      <p:sp>
+        <p:nvSpPr>
+          <p:cNvPr id="32" name="type5Desc"/>
+          <p:cNvSpPr txBox="1"/>
+          <p:nvPr/>
+        </p:nvSpPr>
+        <p:spPr>
+          <a:xfrm>
+            <a:off x="3977640" y="2551176"/>
+            <a:ext cx="4983480" cy="384048"/>
+          </a:xfrm>
+          <a:prstGeom prst="rect">
+            <a:avLst/>
+          </a:prstGeom>
+          <a:noFill/>
+          <a:ln/>
+        </p:spPr>
+        <p:txBody>
+          <a:bodyPr wrap="square" lIns="0" tIns="0" rIns="0" bIns="0" rtlCol="0" anchor="ctr"/>
+          <a:lstStyle/>
+          <a:p>
+            <a:pPr indent="0" marL="0">
+              <a:buNone/>
+            </a:pPr>
+            <a:r>
+              <a:rPr lang="en-US" sz="800" dirty="0">
+                <a:solidFill>
+                  <a:srgbClr val="6E6E73"/>
+                </a:solidFill>
+                <a:latin typeface="SF Pro Text" pitchFamily="34" charset="0"/>
+                <a:ea typeface="SF Pro Text" pitchFamily="34" charset="-122"/>
+                <a:cs typeface="SF Pro Text" pitchFamily="34" charset="-120"/>
+              </a:rPr>
+              <a:t>Call within business hours (8AM–8PM CP local time). No answer: SMS. Outside business hours: email.</a:t>
+            </a:r>
+            <a:endParaRPr lang="en-US" sz="800" dirty="0"/>
+          </a:p>
+        </p:txBody>
+      </p:sp>
+      <p:sp>
+        <p:nvSpPr>
+          <p:cNvPr id="33" name="Shape 29"/>
+          <p:cNvSpPr/>
+          <p:nvPr/>
+        </p:nvSpPr>
+        <p:spPr>
+          <a:xfrm>
+            <a:off x="457200" y="2971800"/>
+            <a:ext cx="3246120" cy="310896"/>
+          </a:xfrm>
+          <a:prstGeom prst="roundRect">
+            <a:avLst>
+              <a:gd name="adj" fmla="val 23529"/>
+            </a:avLst>
+          </a:prstGeom>
+          <a:solidFill>
+            <a:srgbClr val="0B7A6F"/>
+          </a:solidFill>
+          <a:ln w="12700">
+            <a:solidFill>
+              <a:srgbClr val="0B7A6F"/>
+            </a:solidFill>
+            <a:prstDash val="solid"/>
+          </a:ln>
+        </p:spPr>
+      </p:sp>
+      <p:sp>
+        <p:nvSpPr>
+          <p:cNvPr id="34" name="Text 30"/>
+          <p:cNvSpPr txBox="1"/>
+          <p:nvPr/>
+        </p:nvSpPr>
+        <p:spPr>
+          <a:xfrm>
+            <a:off x="457200" y="2971800"/>
+            <a:ext cx="3246120" cy="310896"/>
+          </a:xfrm>
+          <a:prstGeom prst="rect">
+            <a:avLst/>
+          </a:prstGeom>
+          <a:noFill/>
+          <a:ln/>
+        </p:spPr>
+        <p:txBody>
+          <a:bodyPr wrap="square" lIns="0" tIns="0" rIns="0" bIns="0" rtlCol="0" anchor="ctr"/>
+          <a:lstStyle/>
+          <a:p>
+            <a:pPr algn="ctr" indent="0" marL="0">
+              <a:buNone/>
+            </a:pPr>
+            <a:r>
+              <a:rPr lang="en-US" sz="1000" b="1" dirty="0">
+                <a:solidFill>
+                  <a:srgbClr val="FFFFFF"/>
+                </a:solidFill>
+                <a:latin typeface="SF Pro Display" pitchFamily="34" charset="0"/>
+                <a:ea typeface="SF Pro Display" pitchFamily="34" charset="-122"/>
+                <a:cs typeface="SF Pro Display" pitchFamily="34" charset="-120"/>
+              </a:rPr>
+              <a:t>Set a 48-hour Timed Reminder</a:t>
+            </a:r>
+            <a:endParaRPr lang="en-US" sz="1000" dirty="0"/>
+          </a:p>
+        </p:txBody>
+      </p:sp>
+      <p:sp>
+        <p:nvSpPr>
+          <p:cNvPr id="35" name="Shape 31"/>
+          <p:cNvSpPr/>
+          <p:nvPr/>
+        </p:nvSpPr>
+        <p:spPr>
+          <a:xfrm>
+            <a:off x="2080260" y="3282696"/>
+            <a:ext cx="0" cy="73152"/>
+          </a:xfrm>
+          <a:prstGeom prst="line">
+            <a:avLst/>
+          </a:prstGeom>
+          <a:noFill/>
+          <a:ln w="12700">
+            <a:solidFill>
+              <a:srgbClr val="6E6E73"/>
+            </a:solidFill>
+            <a:prstDash val="solid"/>
+            <a:tailEnd type="triangle"/>
+          </a:ln>
+        </p:spPr>
+      </p:sp>
+      <p:sp>
+        <p:nvSpPr>
+          <p:cNvPr id="36" name="Shape 32"/>
+          <p:cNvSpPr/>
+          <p:nvPr/>
+        </p:nvSpPr>
+        <p:spPr>
+          <a:xfrm>
+            <a:off x="3703320" y="3127248"/>
+            <a:ext cx="182880" cy="0"/>
+          </a:xfrm>
+          <a:prstGeom prst="line">
+            <a:avLst/>
+          </a:prstGeom>
+          <a:noFill/>
+          <a:ln w="12700">
+            <a:solidFill>
+              <a:srgbClr val="6E6E73"/>
+            </a:solidFill>
+            <a:prstDash val="solid"/>
+          </a:ln>
+        </p:spPr>
+      </p:sp>
+      <p:sp>
+        <p:nvSpPr>
+          <p:cNvPr id="37" name="type6Desc"/>
+          <p:cNvSpPr txBox="1"/>
+          <p:nvPr/>
+        </p:nvSpPr>
+        <p:spPr>
+          <a:xfrm>
+            <a:off x="3977640" y="2935224"/>
+            <a:ext cx="4983480" cy="384048"/>
+          </a:xfrm>
+          <a:prstGeom prst="rect">
+            <a:avLst/>
+          </a:prstGeom>
+          <a:noFill/>
+          <a:ln/>
+        </p:spPr>
+        <p:txBody>
+          <a:bodyPr wrap="square" lIns="0" tIns="0" rIns="0" bIns="0" rtlCol="0" anchor="ctr"/>
+          <a:lstStyle/>
+          <a:p>
+            <a:pPr indent="0" marL="0">
+              <a:buNone/>
+            </a:pPr>
+            <a:r>
+              <a:rPr lang="en-US" sz="800" dirty="0">
+                <a:solidFill>
+                  <a:srgbClr val="6E6E73"/>
+                </a:solidFill>
+                <a:latin typeface="SF Pro Text" pitchFamily="34" charset="0"/>
+                <a:ea typeface="SF Pro Text" pitchFamily="34" charset="-122"/>
+                <a:cs typeface="SF Pro Text" pitchFamily="34" charset="-120"/>
+              </a:rPr>
+              <a:t>Pick the ticket back up when it triggers.</a:t>
+            </a:r>
+            <a:endParaRPr lang="en-US" sz="800" dirty="0"/>
+          </a:p>
+        </p:txBody>
+      </p:sp>
+      <p:sp>
+        <p:nvSpPr>
+          <p:cNvPr id="38" name="Shape 34"/>
+          <p:cNvSpPr/>
+          <p:nvPr/>
+        </p:nvSpPr>
+        <p:spPr>
+          <a:xfrm>
+            <a:off x="457200" y="3355848"/>
+            <a:ext cx="3246120" cy="310896"/>
+          </a:xfrm>
+          <a:prstGeom prst="roundRect">
+            <a:avLst>
+              <a:gd name="adj" fmla="val 23529"/>
+            </a:avLst>
+          </a:prstGeom>
+          <a:solidFill>
+            <a:srgbClr val="0B7A6F"/>
+          </a:solidFill>
+          <a:ln w="12700">
+            <a:solidFill>
+              <a:srgbClr val="0B7A6F"/>
+            </a:solidFill>
+            <a:prstDash val="solid"/>
+          </a:ln>
+        </p:spPr>
+      </p:sp>
+      <p:sp>
+        <p:nvSpPr>
+          <p:cNvPr id="39" name="Text 35"/>
+          <p:cNvSpPr txBox="1"/>
+          <p:nvPr/>
+        </p:nvSpPr>
+        <p:spPr>
+          <a:xfrm>
+            <a:off x="457200" y="3355848"/>
+            <a:ext cx="3246120" cy="310896"/>
+          </a:xfrm>
+          <a:prstGeom prst="rect">
+            <a:avLst/>
+          </a:prstGeom>
+          <a:noFill/>
+          <a:ln/>
+        </p:spPr>
+        <p:txBody>
+          <a:bodyPr wrap="square" lIns="0" tIns="0" rIns="0" bIns="0" rtlCol="0" anchor="ctr"/>
+          <a:lstStyle/>
+          <a:p>
+            <a:pPr algn="ctr" indent="0" marL="0">
+              <a:buNone/>
+            </a:pPr>
+            <a:r>
+              <a:rPr lang="en-US" sz="1000" b="1" dirty="0">
+                <a:solidFill>
+                  <a:srgbClr val="FFFFFF"/>
+                </a:solidFill>
+                <a:latin typeface="SF Pro Display" pitchFamily="34" charset="0"/>
+                <a:ea typeface="SF Pro Display" pitchFamily="34" charset="-122"/>
+                <a:cs typeface="SF Pro Display" pitchFamily="34" charset="-120"/>
+              </a:rPr>
+              <a:t>C provides proof → hard ladder</a:t>
+            </a:r>
+            <a:endParaRPr lang="en-US" sz="1000" dirty="0"/>
+          </a:p>
+        </p:txBody>
+      </p:sp>
+      <p:sp>
+        <p:nvSpPr>
+          <p:cNvPr id="40" name="Shape 36"/>
+          <p:cNvSpPr/>
+          <p:nvPr/>
+        </p:nvSpPr>
+        <p:spPr>
+          <a:xfrm>
+            <a:off x="2080260" y="3666744"/>
+            <a:ext cx="0" cy="73152"/>
+          </a:xfrm>
+          <a:prstGeom prst="line">
+            <a:avLst/>
+          </a:prstGeom>
+          <a:noFill/>
+          <a:ln w="12700">
+            <a:solidFill>
+              <a:srgbClr val="6E6E73"/>
+            </a:solidFill>
+            <a:prstDash val="solid"/>
+            <a:tailEnd type="triangle"/>
+          </a:ln>
+        </p:spPr>
+      </p:sp>
+      <p:sp>
+        <p:nvSpPr>
+          <p:cNvPr id="41" name="Shape 37"/>
+          <p:cNvSpPr/>
+          <p:nvPr/>
+        </p:nvSpPr>
+        <p:spPr>
+          <a:xfrm>
+            <a:off x="3703320" y="3511296"/>
+            <a:ext cx="182880" cy="0"/>
+          </a:xfrm>
+          <a:prstGeom prst="line">
+            <a:avLst/>
+          </a:prstGeom>
+          <a:noFill/>
+          <a:ln w="12700">
+            <a:solidFill>
+              <a:srgbClr val="6E6E73"/>
+            </a:solidFill>
+            <a:prstDash val="solid"/>
+          </a:ln>
+        </p:spPr>
+      </p:sp>
+      <p:sp>
+        <p:nvSpPr>
+          <p:cNvPr id="42" name="type7Desc"/>
+          <p:cNvSpPr txBox="1"/>
+          <p:nvPr/>
+        </p:nvSpPr>
+        <p:spPr>
+          <a:xfrm>
+            <a:off x="3977640" y="3319272"/>
+            <a:ext cx="4983480" cy="384048"/>
+          </a:xfrm>
+          <a:prstGeom prst="rect">
+            <a:avLst/>
+          </a:prstGeom>
+          <a:noFill/>
+          <a:ln/>
+        </p:spPr>
+        <p:txBody>
+          <a:bodyPr wrap="square" lIns="0" tIns="0" rIns="0" bIns="0" rtlCol="0" anchor="ctr"/>
+          <a:lstStyle/>
+          <a:p>
+            <a:pPr indent="0" marL="0">
+              <a:buNone/>
+            </a:pPr>
+            <a:r>
+              <a:rPr lang="en-US" sz="800" dirty="0">
+                <a:solidFill>
+                  <a:srgbClr val="6E6E73"/>
+                </a:solidFill>
+                <a:latin typeface="SF Pro Text" pitchFamily="34" charset="0"/>
+                <a:ea typeface="SF Pro Text" pitchFamily="34" charset="-122"/>
+                <a:cs typeface="SF Pro Text" pitchFamily="34" charset="-120"/>
+              </a:rPr>
+              <a:t>Resolve per job status, whatever the CP says. It's treated as getting caught, not disclosing.</a:t>
+            </a:r>
+            <a:endParaRPr lang="en-US" sz="800" dirty="0"/>
+          </a:p>
+        </p:txBody>
+      </p:sp>
+      <p:sp>
+        <p:nvSpPr>
+          <p:cNvPr id="43" name="Shape 39"/>
+          <p:cNvSpPr/>
+          <p:nvPr/>
+        </p:nvSpPr>
+        <p:spPr>
+          <a:xfrm>
+            <a:off x="457200" y="3739896"/>
+            <a:ext cx="3246120" cy="310896"/>
+          </a:xfrm>
+          <a:prstGeom prst="roundRect">
+            <a:avLst>
+              <a:gd name="adj" fmla="val 23529"/>
+            </a:avLst>
+          </a:prstGeom>
+          <a:solidFill>
+            <a:srgbClr val="0B7A6F"/>
+          </a:solidFill>
+          <a:ln w="12700">
+            <a:solidFill>
+              <a:srgbClr val="0B7A6F"/>
+            </a:solidFill>
+            <a:prstDash val="solid"/>
+          </a:ln>
+        </p:spPr>
+      </p:sp>
+      <p:sp>
+        <p:nvSpPr>
+          <p:cNvPr id="44" name="Text 40"/>
+          <p:cNvSpPr txBox="1"/>
+          <p:nvPr/>
+        </p:nvSpPr>
+        <p:spPr>
+          <a:xfrm>
+            <a:off x="457200" y="3739896"/>
+            <a:ext cx="3246120" cy="310896"/>
+          </a:xfrm>
+          <a:prstGeom prst="rect">
+            <a:avLst/>
+          </a:prstGeom>
+          <a:noFill/>
+          <a:ln/>
+        </p:spPr>
+        <p:txBody>
+          <a:bodyPr wrap="square" lIns="0" tIns="0" rIns="0" bIns="0" rtlCol="0" anchor="ctr"/>
+          <a:lstStyle/>
+          <a:p>
+            <a:pPr algn="ctr" indent="0" marL="0">
+              <a:buNone/>
+            </a:pPr>
+            <a:r>
+              <a:rPr lang="en-US" sz="1000" b="1" dirty="0">
+                <a:solidFill>
+                  <a:srgbClr val="FFFFFF"/>
+                </a:solidFill>
+                <a:latin typeface="SF Pro Display" pitchFamily="34" charset="0"/>
+                <a:ea typeface="SF Pro Display" pitchFamily="34" charset="-122"/>
+                <a:cs typeface="SF Pro Display" pitchFamily="34" charset="-120"/>
+              </a:rPr>
+              <a:t>CP admits it → soft ladder</a:t>
+            </a:r>
+            <a:endParaRPr lang="en-US" sz="1000" dirty="0"/>
+          </a:p>
+        </p:txBody>
+      </p:sp>
+      <p:sp>
+        <p:nvSpPr>
+          <p:cNvPr id="45" name="Shape 41"/>
+          <p:cNvSpPr/>
+          <p:nvPr/>
+        </p:nvSpPr>
+        <p:spPr>
+          <a:xfrm>
+            <a:off x="2080260" y="4050792"/>
+            <a:ext cx="0" cy="73152"/>
+          </a:xfrm>
+          <a:prstGeom prst="line">
+            <a:avLst/>
+          </a:prstGeom>
+          <a:noFill/>
+          <a:ln w="12700">
+            <a:solidFill>
+              <a:srgbClr val="6E6E73"/>
+            </a:solidFill>
+            <a:prstDash val="solid"/>
+            <a:tailEnd type="triangle"/>
+          </a:ln>
+        </p:spPr>
+      </p:sp>
+      <p:sp>
+        <p:nvSpPr>
+          <p:cNvPr id="46" name="Shape 42"/>
+          <p:cNvSpPr/>
+          <p:nvPr/>
+        </p:nvSpPr>
+        <p:spPr>
+          <a:xfrm>
+            <a:off x="3703320" y="3895344"/>
+            <a:ext cx="182880" cy="0"/>
+          </a:xfrm>
+          <a:prstGeom prst="line">
+            <a:avLst/>
+          </a:prstGeom>
+          <a:noFill/>
+          <a:ln w="12700">
+            <a:solidFill>
+              <a:srgbClr val="6E6E73"/>
+            </a:solidFill>
+            <a:prstDash val="solid"/>
+          </a:ln>
+        </p:spPr>
+      </p:sp>
+      <p:sp>
+        <p:nvSpPr>
+          <p:cNvPr id="47" name="type8Desc"/>
+          <p:cNvSpPr txBox="1"/>
+          <p:nvPr/>
+        </p:nvSpPr>
+        <p:spPr>
+          <a:xfrm>
+            <a:off x="3977640" y="3703320"/>
+            <a:ext cx="4983480" cy="384048"/>
+          </a:xfrm>
+          <a:prstGeom prst="rect">
+            <a:avLst/>
+          </a:prstGeom>
+          <a:noFill/>
+          <a:ln/>
+        </p:spPr>
+        <p:txBody>
+          <a:bodyPr wrap="square" lIns="0" tIns="0" rIns="0" bIns="0" rtlCol="0" anchor="ctr"/>
+          <a:lstStyle/>
+          <a:p>
+            <a:pPr indent="0" marL="0">
+              <a:buNone/>
+            </a:pPr>
+            <a:r>
+              <a:rPr lang="en-US" sz="800" dirty="0">
+                <a:solidFill>
+                  <a:srgbClr val="6E6E73"/>
+                </a:solidFill>
+                <a:latin typeface="SF Pro Text" pitchFamily="34" charset="0"/>
+                <a:ea typeface="SF Pro Text" pitchFamily="34" charset="-122"/>
+                <a:cs typeface="SF Pro Text" pitchFamily="34" charset="-120"/>
+              </a:rPr>
+              <a:t>Resolve per job status. It's still an admission, just a later one.</a:t>
+            </a:r>
+            <a:endParaRPr lang="en-US" sz="800" dirty="0"/>
+          </a:p>
+        </p:txBody>
+      </p:sp>
+      <p:sp>
+        <p:nvSpPr>
+          <p:cNvPr id="48" name="Shape 44"/>
+          <p:cNvSpPr/>
+          <p:nvPr/>
+        </p:nvSpPr>
+        <p:spPr>
+          <a:xfrm>
+            <a:off x="457200" y="4123944"/>
+            <a:ext cx="3246120" cy="310896"/>
+          </a:xfrm>
+          <a:prstGeom prst="roundRect">
+            <a:avLst>
+              <a:gd name="adj" fmla="val 23529"/>
             </a:avLst>
           </a:prstGeom>
           <a:solidFill>
             <a:srgbClr val="FFFFFF"/>
           </a:solidFill>
-          <a:ln w="9525">
+          <a:ln w="12700">
             <a:solidFill>
               <a:srgbClr val="DCE1E7"/>
             </a:solidFill>
@@ -35978,118 +37091,92 @@
       </p:sp>
       <p:sp>
         <p:nvSpPr>
-          <p:cNvPr id="12" name="Shape 8"/>
+          <p:cNvPr id="49" name="Text 45"/>
+          <p:cNvSpPr txBox="1"/>
+          <p:nvPr/>
+        </p:nvSpPr>
+        <p:spPr>
+          <a:xfrm>
+            <a:off x="457200" y="4123944"/>
+            <a:ext cx="3246120" cy="310896"/>
+          </a:xfrm>
+          <a:prstGeom prst="rect">
+            <a:avLst/>
+          </a:prstGeom>
+          <a:noFill/>
+          <a:ln/>
+        </p:spPr>
+        <p:txBody>
+          <a:bodyPr wrap="square" lIns="0" tIns="0" rIns="0" bIns="0" rtlCol="0" anchor="ctr"/>
+          <a:lstStyle/>
+          <a:p>
+            <a:pPr algn="ctr" indent="0" marL="0">
+              <a:buNone/>
+            </a:pPr>
+            <a:r>
+              <a:rPr lang="en-US" sz="1000" b="1" dirty="0">
+                <a:solidFill>
+                  <a:srgbClr val="1D1D1F"/>
+                </a:solidFill>
+                <a:latin typeface="SF Pro Display" pitchFamily="34" charset="0"/>
+                <a:ea typeface="SF Pro Display" pitchFamily="34" charset="-122"/>
+                <a:cs typeface="SF Pro Display" pitchFamily="34" charset="-120"/>
+              </a:rPr>
+              <a:t>CP denies, no proof → retention</a:t>
+            </a:r>
+            <a:endParaRPr lang="en-US" sz="1000" dirty="0"/>
+          </a:p>
+        </p:txBody>
+      </p:sp>
+      <p:sp>
+        <p:nvSpPr>
+          <p:cNvPr id="50" name="Shape 46"/>
           <p:cNvSpPr/>
           <p:nvPr/>
         </p:nvSpPr>
         <p:spPr>
           <a:xfrm>
-            <a:off x="4805172" y="1444752"/>
-            <a:ext cx="329184" cy="329184"/>
-          </a:xfrm>
-          <a:prstGeom prst="ellipse">
-            <a:avLst/>
-          </a:prstGeom>
-          <a:solidFill>
-            <a:srgbClr val="E3F4F1"/>
-          </a:solidFill>
+            <a:off x="3703320" y="4279392"/>
+            <a:ext cx="182880" cy="0"/>
+          </a:xfrm>
+          <a:prstGeom prst="line">
+            <a:avLst/>
+          </a:prstGeom>
+          <a:noFill/>
           <a:ln w="12700">
             <a:solidFill>
-              <a:srgbClr val="E3F4F1"/>
+              <a:srgbClr val="6E6E73"/>
             </a:solidFill>
             <a:prstDash val="solid"/>
           </a:ln>
         </p:spPr>
       </p:sp>
-      <p:pic>
-        <p:nvPicPr>
-          <p:cNvPr id="13" name="Image 1" descr="preencoded.png">    </p:cNvPr>
-          <p:cNvPicPr>
-            <a:picLocks noChangeAspect="1"/>
-          </p:cNvPicPr>
-          <p:nvPr/>
-        </p:nvPicPr>
-        <p:blipFill>
-          <a:blip r:embed="rId2"/>
-          <a:stretch>
-            <a:fillRect/>
-          </a:stretch>
-        </p:blipFill>
-        <p:spPr>
-          <a:xfrm>
-            <a:off x="4884176" y="1523756"/>
-            <a:ext cx="171176" cy="171176"/>
-          </a:xfrm>
-          <a:prstGeom prst="rect">
-            <a:avLst/>
-          </a:prstGeom>
-        </p:spPr>
-      </p:pic>
-      <p:sp>
-        <p:nvSpPr>
-          <p:cNvPr id="14" name="Text 9"/>
-          <p:cNvSpPr txBox="1"/>
-          <p:nvPr/>
-        </p:nvSpPr>
-        <p:spPr>
-          <a:xfrm>
-            <a:off x="4805172" y="1883664"/>
-            <a:ext cx="3762756" cy="274320"/>
-          </a:xfrm>
-          <a:prstGeom prst="rect">
-            <a:avLst/>
-          </a:prstGeom>
-          <a:noFill/>
-          <a:ln/>
-        </p:spPr>
-        <p:txBody>
-          <a:bodyPr wrap="square" lIns="0" tIns="0" rIns="0" bIns="0" rtlCol="0" anchor="t"/>
+      <p:sp>
+        <p:nvSpPr>
+          <p:cNvPr id="51" name="type9Desc"/>
+          <p:cNvSpPr txBox="1"/>
+          <p:nvPr/>
+        </p:nvSpPr>
+        <p:spPr>
+          <a:xfrm>
+            <a:off x="3977640" y="4087368"/>
+            <a:ext cx="4983480" cy="384048"/>
+          </a:xfrm>
+          <a:prstGeom prst="rect">
+            <a:avLst/>
+          </a:prstGeom>
+          <a:noFill/>
+          <a:ln/>
+        </p:spPr>
+        <p:txBody>
+          <a:bodyPr wrap="square" lIns="0" tIns="0" rIns="0" bIns="0" rtlCol="0" anchor="ctr"/>
           <a:lstStyle/>
           <a:p>
             <a:pPr indent="0" marL="0">
               <a:buNone/>
             </a:pPr>
             <a:r>
-              <a:rPr lang="en-US" sz="1200" b="1" dirty="0">
-                <a:solidFill>
-                  <a:srgbClr val="1D1D1F"/>
-                </a:solidFill>
-                <a:latin typeface="SF Pro Display" pitchFamily="34" charset="0"/>
-                <a:ea typeface="SF Pro Display" pitchFamily="34" charset="-122"/>
-                <a:cs typeface="SF Pro Display" pitchFamily="34" charset="-120"/>
-              </a:rPr>
-              <a:t>Nothing on file</a:t>
-            </a:r>
-            <a:endParaRPr lang="en-US" sz="1200" dirty="0"/>
-          </a:p>
-        </p:txBody>
-      </p:sp>
-      <p:sp>
-        <p:nvSpPr>
-          <p:cNvPr id="15" name="Text 10"/>
-          <p:cNvSpPr txBox="1"/>
-          <p:nvPr/>
-        </p:nvSpPr>
-        <p:spPr>
-          <a:xfrm>
-            <a:off x="4805172" y="2176272"/>
-            <a:ext cx="3762756" cy="338328"/>
-          </a:xfrm>
-          <a:prstGeom prst="rect">
-            <a:avLst/>
-          </a:prstGeom>
-          <a:noFill/>
-          <a:ln/>
-        </p:spPr>
-        <p:txBody>
-          <a:bodyPr wrap="square" lIns="0" tIns="0" rIns="0" bIns="0" rtlCol="0" anchor="t"/>
-          <a:lstStyle/>
-          <a:p>
-            <a:pPr indent="0" marL="0">
-              <a:buNone/>
-            </a:pPr>
-            <a:r>
-              <a:rPr lang="en-US" sz="950" dirty="0">
+              <a:rPr lang="en-US" sz="800" dirty="0">
                 <a:solidFill>
                   <a:srgbClr val="6E6E73"/>
                 </a:solidFill>
@@ -36097,594 +37184,12 @@
                 <a:ea typeface="SF Pro Text" pitchFamily="34" charset="-122"/>
                 <a:cs typeface="SF Pro Text" pitchFamily="34" charset="-120"/>
               </a:rPr>
-              <a:t>Ask the customer for proof. Call or text the cleaner. 48-hr Timed Reminder.</a:t>
-            </a:r>
-            <a:endParaRPr lang="en-US" sz="950" dirty="0"/>
-          </a:p>
-        </p:txBody>
-      </p:sp>
-      <p:graphicFrame>
-        <p:nvGraphicFramePr>
-          <p:cNvPr id="42" name="Table 0"/>
-          <p:cNvGraphicFramePr>
-            <a:graphicFrameLocks noGrp="1"/>
-          </p:cNvGraphicFramePr>
-          <p:nvPr>
-            <p:extLst>
-              <p:ext uri="{D42A27DB-BD31-4B8C-83A1-F6EECF244321}">
-                <p14:modId xmlns:p14="http://schemas.microsoft.com/office/powerpoint/2010/main" val="1579011935"/>
-              </p:ext>
-            </p:extLst>
-          </p:nvPr>
-        </p:nvGraphicFramePr>
-        <p:xfrm>
-          <a:off x="411480" y="2743200"/>
-          <a:ext cx="8321040" cy="914400"/>
-        </p:xfrm>
-        <a:graphic>
-          <a:graphicData uri="http://schemas.openxmlformats.org/drawingml/2006/table">
-            <a:tbl>
-              <a:tblPr/>
-              <a:tblGrid>
-                <a:gridCol w="2560320"/>
-                <a:gridCol w="5760720"/>
-              </a:tblGrid>
-              <a:tr h="365760">
-                <a:tc>
-                  <a:txBody>
-                    <a:bodyPr/>
-                    <a:lstStyle/>
-                    <a:p>
-                      <a:pPr indent="0" marL="0">
-                        <a:buNone/>
-                      </a:pPr>
-                      <a:r>
-                        <a:rPr lang="en-US" sz="950" b="1" dirty="0">
-                          <a:solidFill>
-                            <a:srgbClr val="0B7A6F"/>
-                          </a:solidFill>
-                          <a:latin typeface="SF Pro Display" pitchFamily="34" charset="0"/>
-                          <a:ea typeface="SF Pro Display" pitchFamily="34" charset="-122"/>
-                          <a:cs typeface="SF Pro Display" pitchFamily="34" charset="-120"/>
-                        </a:rPr>
-                        <a:t>Outcome</a:t>
-                      </a:r>
-                      <a:endParaRPr lang="en-US" sz="950" dirty="0">
-                        <a:latin typeface="SF Pro Display" charset="0"/>
-                        <a:ea typeface="SF Pro Display" charset="0"/>
-                        <a:cs typeface="SF Pro Display" charset="0"/>
-                      </a:endParaRPr>
-                    </a:p>
-                  </a:txBody>
-                  <a:tcPr marL="91440" marR="91440" marT="27432" marB="27432" anchor="ctr">
-                    <a:lnL w="9525" cap="flat" cmpd="sng" algn="ctr">
-                      <a:solidFill>
-                        <a:srgbClr val="DCE1E7"/>
-                      </a:solidFill>
-                      <a:prstDash val="solid"/>
-                      <a:round/>
-                      <a:headEnd type="none" w="med" len="med"/>
-                      <a:tailEnd type="none" w="med" len="med"/>
-                    </a:lnL>
-                    <a:lnR w="9525" cap="flat" cmpd="sng" algn="ctr">
-                      <a:solidFill>
-                        <a:srgbClr val="DCE1E7"/>
-                      </a:solidFill>
-                      <a:prstDash val="solid"/>
-                      <a:round/>
-                      <a:headEnd type="none" w="med" len="med"/>
-                      <a:tailEnd type="none" w="med" len="med"/>
-                    </a:lnR>
-                    <a:lnT w="9525" cap="flat" cmpd="sng" algn="ctr">
-                      <a:solidFill>
-                        <a:srgbClr val="DCE1E7"/>
-                      </a:solidFill>
-                      <a:prstDash val="solid"/>
-                      <a:round/>
-                      <a:headEnd type="none" w="med" len="med"/>
-                      <a:tailEnd type="none" w="med" len="med"/>
-                    </a:lnT>
-                    <a:lnB w="9525" cap="flat" cmpd="sng" algn="ctr">
-                      <a:solidFill>
-                        <a:srgbClr val="DCE1E7"/>
-                      </a:solidFill>
-                      <a:prstDash val="solid"/>
-                      <a:round/>
-                      <a:headEnd type="none" w="med" len="med"/>
-                      <a:tailEnd type="none" w="med" len="med"/>
-                    </a:lnB>
-                    <a:solidFill>
-                      <a:srgbClr val="E3F4F1"/>
-                    </a:solidFill>
-                  </a:tcPr>
-                </a:tc>
-                <a:tc>
-                  <a:txBody>
-                    <a:bodyPr/>
-                    <a:lstStyle/>
-                    <a:p>
-                      <a:pPr indent="0" marL="0">
-                        <a:buNone/>
-                      </a:pPr>
-                      <a:r>
-                        <a:rPr lang="en-US" sz="950" b="1" dirty="0">
-                          <a:solidFill>
-                            <a:srgbClr val="0B7A6F"/>
-                          </a:solidFill>
-                          <a:latin typeface="SF Pro Display" pitchFamily="34" charset="0"/>
-                          <a:ea typeface="SF Pro Display" pitchFamily="34" charset="-122"/>
-                          <a:cs typeface="SF Pro Display" pitchFamily="34" charset="-120"/>
-                        </a:rPr>
-                        <a:t>What to do</a:t>
-                      </a:r>
-                      <a:endParaRPr lang="en-US" sz="950" dirty="0">
-                        <a:latin typeface="SF Pro Display" charset="0"/>
-                        <a:ea typeface="SF Pro Display" charset="0"/>
-                        <a:cs typeface="SF Pro Display" charset="0"/>
-                      </a:endParaRPr>
-                    </a:p>
-                  </a:txBody>
-                  <a:tcPr marL="91440" marR="91440" marT="27432" marB="27432" anchor="ctr">
-                    <a:lnL w="9525" cap="flat" cmpd="sng" algn="ctr">
-                      <a:solidFill>
-                        <a:srgbClr val="DCE1E7"/>
-                      </a:solidFill>
-                      <a:prstDash val="solid"/>
-                      <a:round/>
-                      <a:headEnd type="none" w="med" len="med"/>
-                      <a:tailEnd type="none" w="med" len="med"/>
-                    </a:lnL>
-                    <a:lnR w="9525" cap="flat" cmpd="sng" algn="ctr">
-                      <a:solidFill>
-                        <a:srgbClr val="DCE1E7"/>
-                      </a:solidFill>
-                      <a:prstDash val="solid"/>
-                      <a:round/>
-                      <a:headEnd type="none" w="med" len="med"/>
-                      <a:tailEnd type="none" w="med" len="med"/>
-                    </a:lnR>
-                    <a:lnT w="9525" cap="flat" cmpd="sng" algn="ctr">
-                      <a:solidFill>
-                        <a:srgbClr val="DCE1E7"/>
-                      </a:solidFill>
-                      <a:prstDash val="solid"/>
-                      <a:round/>
-                      <a:headEnd type="none" w="med" len="med"/>
-                      <a:tailEnd type="none" w="med" len="med"/>
-                    </a:lnT>
-                    <a:lnB w="9525" cap="flat" cmpd="sng" algn="ctr">
-                      <a:solidFill>
-                        <a:srgbClr val="DCE1E7"/>
-                      </a:solidFill>
-                      <a:prstDash val="solid"/>
-                      <a:round/>
-                      <a:headEnd type="none" w="med" len="med"/>
-                      <a:tailEnd type="none" w="med" len="med"/>
-                    </a:lnB>
-                    <a:solidFill>
-                      <a:srgbClr val="E3F4F1"/>
-                    </a:solidFill>
-                  </a:tcPr>
-                </a:tc>
-              </a:tr>
-              <a:tr h="365760">
-                <a:tc>
-                  <a:txBody>
-                    <a:bodyPr/>
-                    <a:lstStyle/>
-                    <a:p>
-                      <a:pPr indent="0" marL="0">
-                        <a:buNone/>
-                      </a:pPr>
-                      <a:r>
-                        <a:rPr lang="en-US" sz="950" b="1" dirty="0">
-                          <a:solidFill>
-                            <a:srgbClr val="1D1D1F"/>
-                          </a:solidFill>
-                          <a:latin typeface="SF Pro Text" pitchFamily="34" charset="0"/>
-                          <a:ea typeface="SF Pro Text" pitchFamily="34" charset="-122"/>
-                          <a:cs typeface="SF Pro Text" pitchFamily="34" charset="-120"/>
-                        </a:rPr>
-                        <a:t>Customer provides proof</a:t>
-                      </a:r>
-                      <a:endParaRPr lang="en-US" sz="950" dirty="0">
-                        <a:latin typeface="SF Pro Text" charset="0"/>
-                        <a:ea typeface="SF Pro Text" charset="0"/>
-                        <a:cs typeface="SF Pro Text" charset="0"/>
-                      </a:endParaRPr>
-                    </a:p>
-                  </a:txBody>
-                  <a:tcPr marL="91440" marR="91440" marT="27432" marB="27432" anchor="ctr">
-                    <a:lnL w="9525" cap="flat" cmpd="sng" algn="ctr">
-                      <a:solidFill>
-                        <a:srgbClr val="DCE1E7"/>
-                      </a:solidFill>
-                      <a:prstDash val="solid"/>
-                      <a:round/>
-                      <a:headEnd type="none" w="med" len="med"/>
-                      <a:tailEnd type="none" w="med" len="med"/>
-                    </a:lnL>
-                    <a:lnR w="9525" cap="flat" cmpd="sng" algn="ctr">
-                      <a:solidFill>
-                        <a:srgbClr val="DCE1E7"/>
-                      </a:solidFill>
-                      <a:prstDash val="solid"/>
-                      <a:round/>
-                      <a:headEnd type="none" w="med" len="med"/>
-                      <a:tailEnd type="none" w="med" len="med"/>
-                    </a:lnR>
-                    <a:lnT w="9525" cap="flat" cmpd="sng" algn="ctr">
-                      <a:solidFill>
-                        <a:srgbClr val="DCE1E7"/>
-                      </a:solidFill>
-                      <a:prstDash val="solid"/>
-                      <a:round/>
-                      <a:headEnd type="none" w="med" len="med"/>
-                      <a:tailEnd type="none" w="med" len="med"/>
-                    </a:lnT>
-                    <a:lnB w="9525" cap="flat" cmpd="sng" algn="ctr">
-                      <a:solidFill>
-                        <a:srgbClr val="DCE1E7"/>
-                      </a:solidFill>
-                      <a:prstDash val="solid"/>
-                      <a:round/>
-                      <a:headEnd type="none" w="med" len="med"/>
-                      <a:tailEnd type="none" w="med" len="med"/>
-                    </a:lnB>
-                    <a:solidFill>
-                      <a:srgbClr val="FFFFFF"/>
-                    </a:solidFill>
-                  </a:tcPr>
-                </a:tc>
-                <a:tc>
-                  <a:txBody>
-                    <a:bodyPr/>
-                    <a:lstStyle/>
-                    <a:p>
-                      <a:pPr indent="0" marL="0">
-                        <a:buNone/>
-                      </a:pPr>
-                      <a:r>
-                        <a:rPr lang="en-US" sz="950" dirty="0">
-                          <a:solidFill>
-                            <a:srgbClr val="6E6E73"/>
-                          </a:solidFill>
-                          <a:latin typeface="SF Pro Text" pitchFamily="34" charset="0"/>
-                          <a:ea typeface="SF Pro Text" pitchFamily="34" charset="-122"/>
-                          <a:cs typeface="SF Pro Text" pitchFamily="34" charset="-120"/>
-                        </a:rPr>
-                        <a:t>Resolve per job status. Hard ladder</a:t>
-                      </a:r>
-                      <a:endParaRPr lang="en-US" sz="950" dirty="0">
-                        <a:latin typeface="SF Pro Text" charset="0"/>
-                        <a:ea typeface="SF Pro Text" charset="0"/>
-                        <a:cs typeface="SF Pro Text" charset="0"/>
-                      </a:endParaRPr>
-                    </a:p>
-                  </a:txBody>
-                  <a:tcPr marL="91440" marR="91440" marT="27432" marB="27432" anchor="ctr">
-                    <a:lnL w="9525" cap="flat" cmpd="sng" algn="ctr">
-                      <a:solidFill>
-                        <a:srgbClr val="DCE1E7"/>
-                      </a:solidFill>
-                      <a:prstDash val="solid"/>
-                      <a:round/>
-                      <a:headEnd type="none" w="med" len="med"/>
-                      <a:tailEnd type="none" w="med" len="med"/>
-                    </a:lnL>
-                    <a:lnR w="9525" cap="flat" cmpd="sng" algn="ctr">
-                      <a:solidFill>
-                        <a:srgbClr val="DCE1E7"/>
-                      </a:solidFill>
-                      <a:prstDash val="solid"/>
-                      <a:round/>
-                      <a:headEnd type="none" w="med" len="med"/>
-                      <a:tailEnd type="none" w="med" len="med"/>
-                    </a:lnR>
-                    <a:lnT w="9525" cap="flat" cmpd="sng" algn="ctr">
-                      <a:solidFill>
-                        <a:srgbClr val="DCE1E7"/>
-                      </a:solidFill>
-                      <a:prstDash val="solid"/>
-                      <a:round/>
-                      <a:headEnd type="none" w="med" len="med"/>
-                      <a:tailEnd type="none" w="med" len="med"/>
-                    </a:lnT>
-                    <a:lnB w="9525" cap="flat" cmpd="sng" algn="ctr">
-                      <a:solidFill>
-                        <a:srgbClr val="DCE1E7"/>
-                      </a:solidFill>
-                      <a:prstDash val="solid"/>
-                      <a:round/>
-                      <a:headEnd type="none" w="med" len="med"/>
-                      <a:tailEnd type="none" w="med" len="med"/>
-                    </a:lnB>
-                    <a:solidFill>
-                      <a:srgbClr val="FFFFFF"/>
-                    </a:solidFill>
-                  </a:tcPr>
-                </a:tc>
-              </a:tr>
-              <a:tr h="365760">
-                <a:tc>
-                  <a:txBody>
-                    <a:bodyPr/>
-                    <a:lstStyle/>
-                    <a:p>
-                      <a:pPr indent="0" marL="0">
-                        <a:buNone/>
-                      </a:pPr>
-                      <a:r>
-                        <a:rPr lang="en-US" sz="950" b="1" dirty="0">
-                          <a:solidFill>
-                            <a:srgbClr val="1D1D1F"/>
-                          </a:solidFill>
-                          <a:latin typeface="SF Pro Text" pitchFamily="34" charset="0"/>
-                          <a:ea typeface="SF Pro Text" pitchFamily="34" charset="-122"/>
-                          <a:cs typeface="SF Pro Text" pitchFamily="34" charset="-120"/>
-                        </a:rPr>
-                        <a:t>Cleaner admits it</a:t>
-                      </a:r>
-                      <a:endParaRPr lang="en-US" sz="950" dirty="0">
-                        <a:latin typeface="SF Pro Text" charset="0"/>
-                        <a:ea typeface="SF Pro Text" charset="0"/>
-                        <a:cs typeface="SF Pro Text" charset="0"/>
-                      </a:endParaRPr>
-                    </a:p>
-                  </a:txBody>
-                  <a:tcPr marL="91440" marR="91440" marT="27432" marB="27432" anchor="ctr">
-                    <a:lnL w="9525" cap="flat" cmpd="sng" algn="ctr">
-                      <a:solidFill>
-                        <a:srgbClr val="DCE1E7"/>
-                      </a:solidFill>
-                      <a:prstDash val="solid"/>
-                      <a:round/>
-                      <a:headEnd type="none" w="med" len="med"/>
-                      <a:tailEnd type="none" w="med" len="med"/>
-                    </a:lnL>
-                    <a:lnR w="9525" cap="flat" cmpd="sng" algn="ctr">
-                      <a:solidFill>
-                        <a:srgbClr val="DCE1E7"/>
-                      </a:solidFill>
-                      <a:prstDash val="solid"/>
-                      <a:round/>
-                      <a:headEnd type="none" w="med" len="med"/>
-                      <a:tailEnd type="none" w="med" len="med"/>
-                    </a:lnR>
-                    <a:lnT w="9525" cap="flat" cmpd="sng" algn="ctr">
-                      <a:solidFill>
-                        <a:srgbClr val="DCE1E7"/>
-                      </a:solidFill>
-                      <a:prstDash val="solid"/>
-                      <a:round/>
-                      <a:headEnd type="none" w="med" len="med"/>
-                      <a:tailEnd type="none" w="med" len="med"/>
-                    </a:lnT>
-                    <a:lnB w="9525" cap="flat" cmpd="sng" algn="ctr">
-                      <a:solidFill>
-                        <a:srgbClr val="DCE1E7"/>
-                      </a:solidFill>
-                      <a:prstDash val="solid"/>
-                      <a:round/>
-                      <a:headEnd type="none" w="med" len="med"/>
-                      <a:tailEnd type="none" w="med" len="med"/>
-                    </a:lnB>
-                    <a:solidFill>
-                      <a:srgbClr val="FFFFFF"/>
-                    </a:solidFill>
-                  </a:tcPr>
-                </a:tc>
-                <a:tc>
-                  <a:txBody>
-                    <a:bodyPr/>
-                    <a:lstStyle/>
-                    <a:p>
-                      <a:pPr indent="0" marL="0">
-                        <a:buNone/>
-                      </a:pPr>
-                      <a:r>
-                        <a:rPr lang="en-US" sz="950" dirty="0">
-                          <a:solidFill>
-                            <a:srgbClr val="6E6E73"/>
-                          </a:solidFill>
-                          <a:latin typeface="SF Pro Text" pitchFamily="34" charset="0"/>
-                          <a:ea typeface="SF Pro Text" pitchFamily="34" charset="-122"/>
-                          <a:cs typeface="SF Pro Text" pitchFamily="34" charset="-120"/>
-                        </a:rPr>
-                        <a:t>Resolve per job status. Soft ladder</a:t>
-                      </a:r>
-                      <a:endParaRPr lang="en-US" sz="950" dirty="0">
-                        <a:latin typeface="SF Pro Text" charset="0"/>
-                        <a:ea typeface="SF Pro Text" charset="0"/>
-                        <a:cs typeface="SF Pro Text" charset="0"/>
-                      </a:endParaRPr>
-                    </a:p>
-                  </a:txBody>
-                  <a:tcPr marL="91440" marR="91440" marT="27432" marB="27432" anchor="ctr">
-                    <a:lnL w="9525" cap="flat" cmpd="sng" algn="ctr">
-                      <a:solidFill>
-                        <a:srgbClr val="DCE1E7"/>
-                      </a:solidFill>
-                      <a:prstDash val="solid"/>
-                      <a:round/>
-                      <a:headEnd type="none" w="med" len="med"/>
-                      <a:tailEnd type="none" w="med" len="med"/>
-                    </a:lnL>
-                    <a:lnR w="9525" cap="flat" cmpd="sng" algn="ctr">
-                      <a:solidFill>
-                        <a:srgbClr val="DCE1E7"/>
-                      </a:solidFill>
-                      <a:prstDash val="solid"/>
-                      <a:round/>
-                      <a:headEnd type="none" w="med" len="med"/>
-                      <a:tailEnd type="none" w="med" len="med"/>
-                    </a:lnR>
-                    <a:lnT w="9525" cap="flat" cmpd="sng" algn="ctr">
-                      <a:solidFill>
-                        <a:srgbClr val="DCE1E7"/>
-                      </a:solidFill>
-                      <a:prstDash val="solid"/>
-                      <a:round/>
-                      <a:headEnd type="none" w="med" len="med"/>
-                      <a:tailEnd type="none" w="med" len="med"/>
-                    </a:lnT>
-                    <a:lnB w="9525" cap="flat" cmpd="sng" algn="ctr">
-                      <a:solidFill>
-                        <a:srgbClr val="DCE1E7"/>
-                      </a:solidFill>
-                      <a:prstDash val="solid"/>
-                      <a:round/>
-                      <a:headEnd type="none" w="med" len="med"/>
-                      <a:tailEnd type="none" w="med" len="med"/>
-                    </a:lnB>
-                    <a:solidFill>
-                      <a:srgbClr val="FFFFFF"/>
-                    </a:solidFill>
-                  </a:tcPr>
-                </a:tc>
-              </a:tr>
-              <a:tr h="365760">
-                <a:tc>
-                  <a:txBody>
-                    <a:bodyPr/>
-                    <a:lstStyle/>
-                    <a:p>
-                      <a:pPr indent="0" marL="0">
-                        <a:buNone/>
-                      </a:pPr>
-                      <a:r>
-                        <a:rPr lang="en-US" sz="950" b="1" dirty="0">
-                          <a:solidFill>
-                            <a:srgbClr val="1D1D1F"/>
-                          </a:solidFill>
-                          <a:latin typeface="SF Pro Text" pitchFamily="34" charset="0"/>
-                          <a:ea typeface="SF Pro Text" pitchFamily="34" charset="-122"/>
-                          <a:cs typeface="SF Pro Text" pitchFamily="34" charset="-120"/>
-                        </a:rPr>
-                        <a:t>Cleaner denies, no proof</a:t>
-                      </a:r>
-                      <a:endParaRPr lang="en-US" sz="950" dirty="0">
-                        <a:latin typeface="SF Pro Text" charset="0"/>
-                        <a:ea typeface="SF Pro Text" charset="0"/>
-                        <a:cs typeface="SF Pro Text" charset="0"/>
-                      </a:endParaRPr>
-                    </a:p>
-                  </a:txBody>
-                  <a:tcPr marL="91440" marR="91440" marT="27432" marB="27432" anchor="ctr">
-                    <a:lnL w="9525" cap="flat" cmpd="sng" algn="ctr">
-                      <a:solidFill>
-                        <a:srgbClr val="DCE1E7"/>
-                      </a:solidFill>
-                      <a:prstDash val="solid"/>
-                      <a:round/>
-                      <a:headEnd type="none" w="med" len="med"/>
-                      <a:tailEnd type="none" w="med" len="med"/>
-                    </a:lnL>
-                    <a:lnR w="9525" cap="flat" cmpd="sng" algn="ctr">
-                      <a:solidFill>
-                        <a:srgbClr val="DCE1E7"/>
-                      </a:solidFill>
-                      <a:prstDash val="solid"/>
-                      <a:round/>
-                      <a:headEnd type="none" w="med" len="med"/>
-                      <a:tailEnd type="none" w="med" len="med"/>
-                    </a:lnR>
-                    <a:lnT w="9525" cap="flat" cmpd="sng" algn="ctr">
-                      <a:solidFill>
-                        <a:srgbClr val="DCE1E7"/>
-                      </a:solidFill>
-                      <a:prstDash val="solid"/>
-                      <a:round/>
-                      <a:headEnd type="none" w="med" len="med"/>
-                      <a:tailEnd type="none" w="med" len="med"/>
-                    </a:lnT>
-                    <a:lnB w="9525" cap="flat" cmpd="sng" algn="ctr">
-                      <a:solidFill>
-                        <a:srgbClr val="DCE1E7"/>
-                      </a:solidFill>
-                      <a:prstDash val="solid"/>
-                      <a:round/>
-                      <a:headEnd type="none" w="med" len="med"/>
-                      <a:tailEnd type="none" w="med" len="med"/>
-                    </a:lnB>
-                    <a:solidFill>
-                      <a:srgbClr val="FFFFFF"/>
-                    </a:solidFill>
-                  </a:tcPr>
-                </a:tc>
-                <a:tc>
-                  <a:txBody>
-                    <a:bodyPr/>
-                    <a:lstStyle/>
-                    <a:p>
-                      <a:pPr indent="0" marL="0">
-                        <a:buNone/>
-                      </a:pPr>
-                      <a:r>
-                        <a:rPr lang="en-US" sz="950" dirty="0">
-                          <a:solidFill>
-                            <a:srgbClr val="6E6E73"/>
-                          </a:solidFill>
-                          <a:latin typeface="SF Pro Text" pitchFamily="34" charset="0"/>
-                          <a:ea typeface="SF Pro Text" pitchFamily="34" charset="-122"/>
-                          <a:cs typeface="SF Pro Text" pitchFamily="34" charset="-120"/>
-                        </a:rPr>
-                        <a:t>No refund, no penalty. Retention: voucher (high value) or $20–$50 credits</a:t>
-                      </a:r>
-                      <a:endParaRPr lang="en-US" sz="950" dirty="0">
-                        <a:latin typeface="SF Pro Text" charset="0"/>
-                        <a:ea typeface="SF Pro Text" charset="0"/>
-                        <a:cs typeface="SF Pro Text" charset="0"/>
-                      </a:endParaRPr>
-                    </a:p>
-                  </a:txBody>
-                  <a:tcPr marL="91440" marR="91440" marT="27432" marB="27432" anchor="ctr">
-                    <a:lnL w="9525" cap="flat" cmpd="sng" algn="ctr">
-                      <a:solidFill>
-                        <a:srgbClr val="DCE1E7"/>
-                      </a:solidFill>
-                      <a:prstDash val="solid"/>
-                      <a:round/>
-                      <a:headEnd type="none" w="med" len="med"/>
-                      <a:tailEnd type="none" w="med" len="med"/>
-                    </a:lnL>
-                    <a:lnR w="9525" cap="flat" cmpd="sng" algn="ctr">
-                      <a:solidFill>
-                        <a:srgbClr val="DCE1E7"/>
-                      </a:solidFill>
-                      <a:prstDash val="solid"/>
-                      <a:round/>
-                      <a:headEnd type="none" w="med" len="med"/>
-                      <a:tailEnd type="none" w="med" len="med"/>
-                    </a:lnR>
-                    <a:lnT w="9525" cap="flat" cmpd="sng" algn="ctr">
-                      <a:solidFill>
-                        <a:srgbClr val="DCE1E7"/>
-                      </a:solidFill>
-                      <a:prstDash val="solid"/>
-                      <a:round/>
-                      <a:headEnd type="none" w="med" len="med"/>
-                      <a:tailEnd type="none" w="med" len="med"/>
-                    </a:lnT>
-                    <a:lnB w="9525" cap="flat" cmpd="sng" algn="ctr">
-                      <a:solidFill>
-                        <a:srgbClr val="DCE1E7"/>
-                      </a:solidFill>
-                      <a:prstDash val="solid"/>
-                      <a:round/>
-                      <a:headEnd type="none" w="med" len="med"/>
-                      <a:tailEnd type="none" w="med" len="med"/>
-                    </a:lnB>
-                    <a:solidFill>
-                      <a:srgbClr val="FFFFFF"/>
-                    </a:solidFill>
-                  </a:tcPr>
-                </a:tc>
-              </a:tr>
-            </a:tbl>
-          </a:graphicData>
-        </a:graphic>
-      </p:graphicFrame>
+              <a:t>No refund, no penalty. High value: voucher for the full job hours. Otherwise $20–$50 credits. Reason: cash_payment.</a:t>
+            </a:r>
+            <a:endParaRPr lang="en-US" sz="800" dirty="0"/>
+          </a:p>
+        </p:txBody>
+      </p:sp>
       <p:sp>
         <p:nvSpPr>
           <p:cNvPr id="25" name="Slide Number Placeholder 0"/>
@@ -36738,6 +37243,479 @@
   <p:clrMapOvr>
     <a:masterClrMapping/>
   </p:clrMapOvr>
+  <p:timing>
+    <p:tnLst>
+      <p:par>
+        <p:cTn id="1" dur="indefinite" restart="never" nodeType="tmRoot">
+          <p:childTnLst>
+            <p:seq concurrent="1" nextAc="seek">
+              <p:cTn id="2" dur="indefinite" nodeType="mainSeq">
+                <p:childTnLst>
+                  <p:par>
+                    <p:cTn id="3" fill="hold">
+                      <p:stCondLst>
+                        <p:cond delay="indefinite"/>
+                      </p:stCondLst>
+                      <p:childTnLst>
+                        <p:par>
+                          <p:cTn id="4" fill="hold">
+                            <p:stCondLst>
+                              <p:cond delay="0"/>
+                            </p:stCondLst>
+                            <p:childTnLst>
+                              <p:par>
+                                <p:cTn id="5" presetID="1" presetClass="entr" presetSubtype="0" fill="hold" grpId="0" nodeType="clickEffect">
+                                  <p:stCondLst>
+                                    <p:cond delay="0"/>
+                                  </p:stCondLst>
+                                  <p:iterate type="lt">
+                                    <p:tmAbs val="40"/>
+                                  </p:iterate>
+                                  <p:childTnLst>
+                                    <p:set>
+                                      <p:cBhvr>
+                                        <p:cTn id="6" dur="1" fill="hold">
+                                          <p:stCondLst>
+                                            <p:cond delay="0"/>
+                                          </p:stCondLst>
+                                        </p:cTn>
+                                        <p:tgtEl>
+                                          <p:spTgt spid="12"/>
+                                        </p:tgtEl>
+                                        <p:attrNameLst>
+                                          <p:attrName>style.visibility</p:attrName>
+                                        </p:attrNameLst>
+                                      </p:cBhvr>
+                                      <p:to>
+                                        <p:strVal val="visible"/>
+                                      </p:to>
+                                    </p:set>
+                                  </p:childTnLst>
+                                </p:cTn>
+                              </p:par>
+                            </p:childTnLst>
+                          </p:cTn>
+                        </p:par>
+                      </p:childTnLst>
+                    </p:cTn>
+                  </p:par>
+                  <p:par>
+                    <p:cTn id="7" fill="hold">
+                      <p:stCondLst>
+                        <p:cond delay="indefinite"/>
+                      </p:stCondLst>
+                      <p:childTnLst>
+                        <p:par>
+                          <p:cTn id="8" fill="hold">
+                            <p:stCondLst>
+                              <p:cond delay="0"/>
+                            </p:stCondLst>
+                            <p:childTnLst>
+                              <p:par>
+                                <p:cTn id="9" presetID="1" presetClass="entr" presetSubtype="0" fill="hold" grpId="0" nodeType="clickEffect">
+                                  <p:stCondLst>
+                                    <p:cond delay="0"/>
+                                  </p:stCondLst>
+                                  <p:iterate type="lt">
+                                    <p:tmAbs val="40"/>
+                                  </p:iterate>
+                                  <p:childTnLst>
+                                    <p:set>
+                                      <p:cBhvr>
+                                        <p:cTn id="10" dur="1" fill="hold">
+                                          <p:stCondLst>
+                                            <p:cond delay="0"/>
+                                          </p:stCondLst>
+                                        </p:cTn>
+                                        <p:tgtEl>
+                                          <p:spTgt spid="17"/>
+                                        </p:tgtEl>
+                                        <p:attrNameLst>
+                                          <p:attrName>style.visibility</p:attrName>
+                                        </p:attrNameLst>
+                                      </p:cBhvr>
+                                      <p:to>
+                                        <p:strVal val="visible"/>
+                                      </p:to>
+                                    </p:set>
+                                  </p:childTnLst>
+                                </p:cTn>
+                              </p:par>
+                            </p:childTnLst>
+                          </p:cTn>
+                        </p:par>
+                      </p:childTnLst>
+                    </p:cTn>
+                  </p:par>
+                  <p:par>
+                    <p:cTn id="11" fill="hold">
+                      <p:stCondLst>
+                        <p:cond delay="indefinite"/>
+                      </p:stCondLst>
+                      <p:childTnLst>
+                        <p:par>
+                          <p:cTn id="12" fill="hold">
+                            <p:stCondLst>
+                              <p:cond delay="0"/>
+                            </p:stCondLst>
+                            <p:childTnLst>
+                              <p:par>
+                                <p:cTn id="13" presetID="1" presetClass="entr" presetSubtype="0" fill="hold" grpId="0" nodeType="clickEffect">
+                                  <p:stCondLst>
+                                    <p:cond delay="0"/>
+                                  </p:stCondLst>
+                                  <p:iterate type="lt">
+                                    <p:tmAbs val="40"/>
+                                  </p:iterate>
+                                  <p:childTnLst>
+                                    <p:set>
+                                      <p:cBhvr>
+                                        <p:cTn id="14" dur="1" fill="hold">
+                                          <p:stCondLst>
+                                            <p:cond delay="0"/>
+                                          </p:stCondLst>
+                                        </p:cTn>
+                                        <p:tgtEl>
+                                          <p:spTgt spid="22"/>
+                                        </p:tgtEl>
+                                        <p:attrNameLst>
+                                          <p:attrName>style.visibility</p:attrName>
+                                        </p:attrNameLst>
+                                      </p:cBhvr>
+                                      <p:to>
+                                        <p:strVal val="visible"/>
+                                      </p:to>
+                                    </p:set>
+                                  </p:childTnLst>
+                                </p:cTn>
+                              </p:par>
+                            </p:childTnLst>
+                          </p:cTn>
+                        </p:par>
+                      </p:childTnLst>
+                    </p:cTn>
+                  </p:par>
+                  <p:par>
+                    <p:cTn id="15" fill="hold">
+                      <p:stCondLst>
+                        <p:cond delay="indefinite"/>
+                      </p:stCondLst>
+                      <p:childTnLst>
+                        <p:par>
+                          <p:cTn id="16" fill="hold">
+                            <p:stCondLst>
+                              <p:cond delay="0"/>
+                            </p:stCondLst>
+                            <p:childTnLst>
+                              <p:par>
+                                <p:cTn id="17" presetID="1" presetClass="entr" presetSubtype="0" fill="hold" grpId="0" nodeType="clickEffect">
+                                  <p:stCondLst>
+                                    <p:cond delay="0"/>
+                                  </p:stCondLst>
+                                  <p:iterate type="lt">
+                                    <p:tmAbs val="40"/>
+                                  </p:iterate>
+                                  <p:childTnLst>
+                                    <p:set>
+                                      <p:cBhvr>
+                                        <p:cTn id="18" dur="1" fill="hold">
+                                          <p:stCondLst>
+                                            <p:cond delay="0"/>
+                                          </p:stCondLst>
+                                        </p:cTn>
+                                        <p:tgtEl>
+                                          <p:spTgt spid="27"/>
+                                        </p:tgtEl>
+                                        <p:attrNameLst>
+                                          <p:attrName>style.visibility</p:attrName>
+                                        </p:attrNameLst>
+                                      </p:cBhvr>
+                                      <p:to>
+                                        <p:strVal val="visible"/>
+                                      </p:to>
+                                    </p:set>
+                                  </p:childTnLst>
+                                </p:cTn>
+                              </p:par>
+                            </p:childTnLst>
+                          </p:cTn>
+                        </p:par>
+                      </p:childTnLst>
+                    </p:cTn>
+                  </p:par>
+                  <p:par>
+                    <p:cTn id="19" fill="hold">
+                      <p:stCondLst>
+                        <p:cond delay="indefinite"/>
+                      </p:stCondLst>
+                      <p:childTnLst>
+                        <p:par>
+                          <p:cTn id="20" fill="hold">
+                            <p:stCondLst>
+                              <p:cond delay="0"/>
+                            </p:stCondLst>
+                            <p:childTnLst>
+                              <p:par>
+                                <p:cTn id="21" presetID="1" presetClass="entr" presetSubtype="0" fill="hold" grpId="0" nodeType="clickEffect">
+                                  <p:stCondLst>
+                                    <p:cond delay="0"/>
+                                  </p:stCondLst>
+                                  <p:iterate type="lt">
+                                    <p:tmAbs val="40"/>
+                                  </p:iterate>
+                                  <p:childTnLst>
+                                    <p:set>
+                                      <p:cBhvr>
+                                        <p:cTn id="22" dur="1" fill="hold">
+                                          <p:stCondLst>
+                                            <p:cond delay="0"/>
+                                          </p:stCondLst>
+                                        </p:cTn>
+                                        <p:tgtEl>
+                                          <p:spTgt spid="32"/>
+                                        </p:tgtEl>
+                                        <p:attrNameLst>
+                                          <p:attrName>style.visibility</p:attrName>
+                                        </p:attrNameLst>
+                                      </p:cBhvr>
+                                      <p:to>
+                                        <p:strVal val="visible"/>
+                                      </p:to>
+                                    </p:set>
+                                  </p:childTnLst>
+                                </p:cTn>
+                              </p:par>
+                            </p:childTnLst>
+                          </p:cTn>
+                        </p:par>
+                      </p:childTnLst>
+                    </p:cTn>
+                  </p:par>
+                  <p:par>
+                    <p:cTn id="23" fill="hold">
+                      <p:stCondLst>
+                        <p:cond delay="indefinite"/>
+                      </p:stCondLst>
+                      <p:childTnLst>
+                        <p:par>
+                          <p:cTn id="24" fill="hold">
+                            <p:stCondLst>
+                              <p:cond delay="0"/>
+                            </p:stCondLst>
+                            <p:childTnLst>
+                              <p:par>
+                                <p:cTn id="25" presetID="1" presetClass="entr" presetSubtype="0" fill="hold" grpId="0" nodeType="clickEffect">
+                                  <p:stCondLst>
+                                    <p:cond delay="0"/>
+                                  </p:stCondLst>
+                                  <p:iterate type="lt">
+                                    <p:tmAbs val="40"/>
+                                  </p:iterate>
+                                  <p:childTnLst>
+                                    <p:set>
+                                      <p:cBhvr>
+                                        <p:cTn id="26" dur="1" fill="hold">
+                                          <p:stCondLst>
+                                            <p:cond delay="0"/>
+                                          </p:stCondLst>
+                                        </p:cTn>
+                                        <p:tgtEl>
+                                          <p:spTgt spid="37"/>
+                                        </p:tgtEl>
+                                        <p:attrNameLst>
+                                          <p:attrName>style.visibility</p:attrName>
+                                        </p:attrNameLst>
+                                      </p:cBhvr>
+                                      <p:to>
+                                        <p:strVal val="visible"/>
+                                      </p:to>
+                                    </p:set>
+                                  </p:childTnLst>
+                                </p:cTn>
+                              </p:par>
+                            </p:childTnLst>
+                          </p:cTn>
+                        </p:par>
+                      </p:childTnLst>
+                    </p:cTn>
+                  </p:par>
+                  <p:par>
+                    <p:cTn id="27" fill="hold">
+                      <p:stCondLst>
+                        <p:cond delay="indefinite"/>
+                      </p:stCondLst>
+                      <p:childTnLst>
+                        <p:par>
+                          <p:cTn id="28" fill="hold">
+                            <p:stCondLst>
+                              <p:cond delay="0"/>
+                            </p:stCondLst>
+                            <p:childTnLst>
+                              <p:par>
+                                <p:cTn id="29" presetID="1" presetClass="entr" presetSubtype="0" fill="hold" grpId="0" nodeType="clickEffect">
+                                  <p:stCondLst>
+                                    <p:cond delay="0"/>
+                                  </p:stCondLst>
+                                  <p:iterate type="lt">
+                                    <p:tmAbs val="40"/>
+                                  </p:iterate>
+                                  <p:childTnLst>
+                                    <p:set>
+                                      <p:cBhvr>
+                                        <p:cTn id="30" dur="1" fill="hold">
+                                          <p:stCondLst>
+                                            <p:cond delay="0"/>
+                                          </p:stCondLst>
+                                        </p:cTn>
+                                        <p:tgtEl>
+                                          <p:spTgt spid="42"/>
+                                        </p:tgtEl>
+                                        <p:attrNameLst>
+                                          <p:attrName>style.visibility</p:attrName>
+                                        </p:attrNameLst>
+                                      </p:cBhvr>
+                                      <p:to>
+                                        <p:strVal val="visible"/>
+                                      </p:to>
+                                    </p:set>
+                                  </p:childTnLst>
+                                </p:cTn>
+                              </p:par>
+                            </p:childTnLst>
+                          </p:cTn>
+                        </p:par>
+                      </p:childTnLst>
+                    </p:cTn>
+                  </p:par>
+                  <p:par>
+                    <p:cTn id="31" fill="hold">
+                      <p:stCondLst>
+                        <p:cond delay="indefinite"/>
+                      </p:stCondLst>
+                      <p:childTnLst>
+                        <p:par>
+                          <p:cTn id="32" fill="hold">
+                            <p:stCondLst>
+                              <p:cond delay="0"/>
+                            </p:stCondLst>
+                            <p:childTnLst>
+                              <p:par>
+                                <p:cTn id="33" presetID="1" presetClass="entr" presetSubtype="0" fill="hold" grpId="0" nodeType="clickEffect">
+                                  <p:stCondLst>
+                                    <p:cond delay="0"/>
+                                  </p:stCondLst>
+                                  <p:iterate type="lt">
+                                    <p:tmAbs val="40"/>
+                                  </p:iterate>
+                                  <p:childTnLst>
+                                    <p:set>
+                                      <p:cBhvr>
+                                        <p:cTn id="34" dur="1" fill="hold">
+                                          <p:stCondLst>
+                                            <p:cond delay="0"/>
+                                          </p:stCondLst>
+                                        </p:cTn>
+                                        <p:tgtEl>
+                                          <p:spTgt spid="47"/>
+                                        </p:tgtEl>
+                                        <p:attrNameLst>
+                                          <p:attrName>style.visibility</p:attrName>
+                                        </p:attrNameLst>
+                                      </p:cBhvr>
+                                      <p:to>
+                                        <p:strVal val="visible"/>
+                                      </p:to>
+                                    </p:set>
+                                  </p:childTnLst>
+                                </p:cTn>
+                              </p:par>
+                            </p:childTnLst>
+                          </p:cTn>
+                        </p:par>
+                      </p:childTnLst>
+                    </p:cTn>
+                  </p:par>
+                  <p:par>
+                    <p:cTn id="35" fill="hold">
+                      <p:stCondLst>
+                        <p:cond delay="indefinite"/>
+                      </p:stCondLst>
+                      <p:childTnLst>
+                        <p:par>
+                          <p:cTn id="36" fill="hold">
+                            <p:stCondLst>
+                              <p:cond delay="0"/>
+                            </p:stCondLst>
+                            <p:childTnLst>
+                              <p:par>
+                                <p:cTn id="37" presetID="1" presetClass="entr" presetSubtype="0" fill="hold" grpId="0" nodeType="clickEffect">
+                                  <p:stCondLst>
+                                    <p:cond delay="0"/>
+                                  </p:stCondLst>
+                                  <p:iterate type="lt">
+                                    <p:tmAbs val="40"/>
+                                  </p:iterate>
+                                  <p:childTnLst>
+                                    <p:set>
+                                      <p:cBhvr>
+                                        <p:cTn id="38" dur="1" fill="hold">
+                                          <p:stCondLst>
+                                            <p:cond delay="0"/>
+                                          </p:stCondLst>
+                                        </p:cTn>
+                                        <p:tgtEl>
+                                          <p:spTgt spid="51"/>
+                                        </p:tgtEl>
+                                        <p:attrNameLst>
+                                          <p:attrName>style.visibility</p:attrName>
+                                        </p:attrNameLst>
+                                      </p:cBhvr>
+                                      <p:to>
+                                        <p:strVal val="visible"/>
+                                      </p:to>
+                                    </p:set>
+                                  </p:childTnLst>
+                                </p:cTn>
+                              </p:par>
+                            </p:childTnLst>
+                          </p:cTn>
+                        </p:par>
+                      </p:childTnLst>
+                    </p:cTn>
+                  </p:par>
+                </p:childTnLst>
+              </p:cTn>
+              <p:prevCondLst>
+                <p:cond evt="onPrev" delay="0">
+                  <p:tgtEl>
+                    <p:sldTgt/>
+                  </p:tgtEl>
+                </p:cond>
+              </p:prevCondLst>
+              <p:nextCondLst>
+                <p:cond evt="onNext" delay="0">
+                  <p:tgtEl>
+                    <p:sldTgt/>
+                  </p:tgtEl>
+                </p:cond>
+              </p:nextCondLst>
+            </p:seq>
+          </p:childTnLst>
+        </p:cTn>
+      </p:par>
+    </p:tnLst>
+    <p:bldLst>
+      <p:bldP spid="12" grpId="0" animBg="1"/>
+      <p:bldP spid="17" grpId="0" animBg="1"/>
+      <p:bldP spid="22" grpId="0" animBg="1"/>
+      <p:bldP spid="27" grpId="0" animBg="1"/>
+      <p:bldP spid="32" grpId="0" animBg="1"/>
+      <p:bldP spid="37" grpId="0" animBg="1"/>
+      <p:bldP spid="42" grpId="0" animBg="1"/>
+      <p:bldP spid="47" grpId="0" animBg="1"/>
+      <p:bldP spid="51" grpId="0" animBg="1"/>
+    </p:bldLst>
+  </p:timing>
 </p:sld>
 </file>
 

</xml_diff>

<commit_message>
Split Cash Payment Branch B into report-on-file and nothing-on-file flowcharts
Co-Authored-By: Claude Opus 5.5 <noreply@anthropic.com>
Claude-Session: https://claude.ai/code/session_01FEzv8wwqWDgTsXP8Yz6XYn
</commit_message>
<xml_diff>
--- a/billing-disputes/billing-disputes-cash-payments.pptx
+++ b/billing-disputes/billing-disputes-cash-payments.pptx
@@ -49,9 +49,10 @@
     <p:sldId id="297" r:id="rId43"/>
     <p:sldId id="298" r:id="rId44"/>
     <p:sldId id="299" r:id="rId45"/>
+    <p:sldId id="300" r:id="rId46"/>
   </p:sldIdLst>
   <p:notesMasterIdLst>
-    <p:notesMasterId r:id="rId46"/>
+    <p:notesMasterId r:id="rId47"/>
   </p:notesMasterIdLst>
   <p:sldSz cx="9144000" cy="5143500"/>
   <p:notesSz cx="5143500" cy="9144000"/>
@@ -3625,7 +3626,7 @@
           <a:p>
             <a:r>
               <a:rPr lang="en-US" dirty="0"/>
-              <a:t>TRAINER: descriptions are hidden. Click Show details (or press the right arrow): each click types out the next step's description. Report found, not yet actioned: resolve it yourself, no need to wait for the CP-side queue. Same amount gate as Branch A. Pending Invoice: cancel via the C CRM ("does not want the service"); if partial, invoice the remaining balance. Invoiced: refund via the CP Dashboard; if partial, admin refund the customer for the cash-paid portion (based on CP Pay) and apply a CP Holdback for the same amount. Soft ladder. Nothing on file: ask the customer for proof (encourage, don't require). Call the cleaner within business hours (8AM-8PM their local time); no answer, send an SMS; outside business hours, email. Set a 48-hour Timed Reminder. Customer provides proof: resolve per the job status, hard ladder. No proof but the cleaner admits it: resolve per the job status, soft ladder. Cleaner denies and no proof: no refund, no penalty; assess for retention: high-value or retention-likely (multiple completed jobs, high LTNR): voucher covering the full job hours; otherwise $20-$50 in platform credits; Internal Reason: cash_payment. Macros: Accepted Cash (Coaching); Accepted Cash (Warning + Account Adjustment); Refund confirmation: credit card refund processed.</a:t>
+              <a:t>TRAINER: descriptions are hidden. Click Show details (or press the right arrow): each click types out the next step's description. Report found in the CP CRM, not yet actioned: resolve it yourself, no need to wait for the CP-side queue. Amount: did the CP say how much they received in cash? If not, contact the CP and get a number (or a clear "I got paid in full") before doing anything else, same gate as Branch A. Job status: still Pending Invoice: cancel via C CRM, reason code "does not want the service"; if it was only a partial cash payment, invoice the remaining balance instead. Already Invoiced: refund via the CP Dashboard; if partial, admin refund the customer for the cash-paid portion (based on CP Pay, not C Price) and apply a CP Holdback for the same amount, so the CP isn't paid twice. Penalty: apply the soft ladder; this is still a CP admission, just one a C-side agent is closing out.</a:t>
             </a:r>
             <a:endParaRPr lang="en-US" dirty="0"/>
           </a:p>
@@ -3713,7 +3714,7 @@
           <a:p>
             <a:r>
               <a:rPr lang="en-US" dirty="0"/>
-              <a:t>Ask each question and let trainees answer before revealing. Each click reveals the next answer.</a:t>
+              <a:t>TRAINER: descriptions are hidden. Click Show details (or press the right arrow): each click types out the next step's description. Nothing on file in the CP CRM: nothing is confirmed yet, so treat it like any other unconfirmed claim. Ask the customer for proof (encourage it, don't require it). Call the CP if it's within business hours (8AM-8PM their local time); no answer during business hours: send an SMS; outside business hours: email instead. Set a Timed Reminder for 48 hours. Customer provides proof, whatever the CP says: resolve per the job status (C CRM cancellation or CP Dashboard refund) and apply the hard ladder; the customer's documentation confirmed it, so it's treated as getting caught, not disclosing. No proof, but the CP admits it when contacted: resolve per the job status and apply the soft ladder. CP denies and the customer never produces proof: no refund and no penalty, since nothing is confirmed; assess for retention: high-value / retention-likely (multiple completed jobs, high LTNR): voucher covering the full job hours, Internal Reason: cash_payment; not high-value: $20-$50 in platform credits, Internal Reason: cash_payment.</a:t>
             </a:r>
             <a:endParaRPr lang="en-US" dirty="0"/>
           </a:p>
@@ -3801,7 +3802,7 @@
           <a:p>
             <a:r>
               <a:rPr lang="en-US" dirty="0"/>
-              <a:t>TRAINER: recap the three takeaways, then open the floor for questions on Cash Payment.</a:t>
+              <a:t>Ask each question and let trainees answer before revealing. Each click reveals the next answer.</a:t>
             </a:r>
             <a:endParaRPr lang="en-US" dirty="0"/>
           </a:p>
@@ -3889,7 +3890,7 @@
           <a:p>
             <a:r>
               <a:rPr lang="en-US" dirty="0"/>
-              <a:t>Close the module. Recap: OCH (billed more than worked), Unauthorized Hours (worked but never asked), False Invoice (never showed, check who invoiced first), and Cash Payment (job status decides the action).</a:t>
+              <a:t>TRAINER: recap the three takeaways, then open the floor for questions on Cash Payment.</a:t>
             </a:r>
             <a:endParaRPr lang="en-US" dirty="0"/>
           </a:p>
@@ -3913,6 +3914,94 @@
             <a:fld id="{F7021451-1387-4CA6-816F-3879F97B5CBC}" type="slidenum">
               <a:rPr lang="en-US"/>
               <a:t>44</a:t>
+            </a:fld>
+            <a:endParaRPr lang="en-US"/>
+          </a:p>
+        </p:txBody>
+      </p:sp>
+    </p:spTree>
+    <p:extLst>
+      <p:ext uri="{BB962C8B-B14F-4D97-AF65-F5344CB8AC3E}">
+        <p14:creationId xmlns:p14="http://schemas.microsoft.com/office/powerpoint/2010/main" val="1024086991"/>
+      </p:ext>
+    </p:extLst>
+  </p:cSld>
+  <p:clrMapOvr>
+    <a:masterClrMapping/>
+  </p:clrMapOvr>
+</p:notes>
+</file>
+
+<file path=ppt/notesSlides/notesSlide45.xml><?xml version="1.0" encoding="utf-8"?>
+<p:notes xmlns:a="http://schemas.openxmlformats.org/drawingml/2006/main" xmlns:r="http://schemas.openxmlformats.org/officeDocument/2006/relationships" xmlns:p="http://schemas.openxmlformats.org/presentationml/2006/main">
+  <p:cSld>
+    <p:spTree>
+      <p:nvGrpSpPr>
+        <p:cNvPr id="1" name=""/>
+        <p:cNvGrpSpPr/>
+        <p:nvPr/>
+      </p:nvGrpSpPr>
+      <p:grpSpPr>
+        <a:xfrm>
+          <a:off x="0" y="0"/>
+          <a:ext cx="0" cy="0"/>
+          <a:chOff x="0" y="0"/>
+          <a:chExt cx="0" cy="0"/>
+        </a:xfrm>
+      </p:grpSpPr>
+      <p:sp>
+        <p:nvSpPr>
+          <p:cNvPr id="2" name="Slide Image Placeholder 1"/>
+          <p:cNvSpPr>
+            <a:spLocks noGrp="1" noRot="1" noChangeAspect="1"/>
+          </p:cNvSpPr>
+          <p:nvPr>
+            <p:ph type="sldImg"/>
+          </p:nvPr>
+        </p:nvSpPr>
+        <p:spPr/>
+      </p:sp>
+      <p:sp>
+        <p:nvSpPr>
+          <p:cNvPr id="3" name="Notes Placeholder 2"/>
+          <p:cNvSpPr>
+            <a:spLocks noGrp="1"/>
+          </p:cNvSpPr>
+          <p:nvPr>
+            <p:ph type="body" idx="1"/>
+          </p:nvPr>
+        </p:nvSpPr>
+        <p:spPr/>
+        <p:txBody>
+          <a:bodyPr/>
+          <a:lstStyle/>
+          <a:p>
+            <a:r>
+              <a:rPr lang="en-US" dirty="0"/>
+              <a:t>Close the module. Recap: OCH (billed more than worked), Unauthorized Hours (worked but never asked), False Invoice (never showed, check who invoiced first), and Cash Payment (job status decides the action).</a:t>
+            </a:r>
+            <a:endParaRPr lang="en-US" dirty="0"/>
+          </a:p>
+        </p:txBody>
+      </p:sp>
+      <p:sp>
+        <p:nvSpPr>
+          <p:cNvPr id="4" name="Slide Number Placeholder 3"/>
+          <p:cNvSpPr>
+            <a:spLocks noGrp="1"/>
+          </p:cNvSpPr>
+          <p:nvPr>
+            <p:ph type="sldNum" sz="quarter" idx="10"/>
+          </p:nvPr>
+        </p:nvSpPr>
+        <p:spPr/>
+        <p:txBody>
+          <a:bodyPr/>
+          <a:lstStyle/>
+          <a:p>
+            <a:fld id="{F7021451-1387-4CA6-816F-3879F97B5CBC}" type="slidenum">
+              <a:rPr lang="en-US"/>
+              <a:t>45</a:t>
             </a:fld>
             <a:endParaRPr lang="en-US"/>
           </a:p>
@@ -35750,7 +35839,7 @@
                 <a:ea typeface="SF Pro Display" pitchFamily="34" charset="-122"/>
                 <a:cs typeface="SF Pro Display" pitchFamily="34" charset="-120"/>
               </a:rPr>
-              <a:t>Branch B: the customer told us first</a:t>
+              <a:t>Branch B: report on file</a:t>
             </a:r>
             <a:endParaRPr lang="en-US" sz="2400" dirty="0"/>
           </a:p>
@@ -35854,12 +35943,12 @@
         </p:nvSpPr>
         <p:spPr>
           <a:xfrm>
-            <a:off x="457200" y="1051560"/>
-            <a:ext cx="3246120" cy="310896"/>
+            <a:off x="457200" y="1097280"/>
+            <a:ext cx="3246120" cy="384048"/>
           </a:xfrm>
           <a:prstGeom prst="roundRect">
             <a:avLst>
-              <a:gd name="adj" fmla="val 23529"/>
+              <a:gd name="adj" fmla="val 19048"/>
             </a:avLst>
           </a:prstGeom>
           <a:solidFill>
@@ -35881,8 +35970,8 @@
         </p:nvSpPr>
         <p:spPr>
           <a:xfrm>
-            <a:off x="457200" y="1051560"/>
-            <a:ext cx="3246120" cy="310896"/>
+            <a:off x="457200" y="1097280"/>
+            <a:ext cx="3246120" cy="384048"/>
           </a:xfrm>
           <a:prstGeom prst="rect">
             <a:avLst/>
@@ -35920,8 +36009,8 @@
         </p:nvSpPr>
         <p:spPr>
           <a:xfrm>
-            <a:off x="2080260" y="1362456"/>
-            <a:ext cx="0" cy="73152"/>
+            <a:off x="2080260" y="1481328"/>
+            <a:ext cx="0" cy="91440"/>
           </a:xfrm>
           <a:prstGeom prst="line">
             <a:avLst/>
@@ -35944,7 +36033,7 @@
         </p:nvSpPr>
         <p:spPr>
           <a:xfrm>
-            <a:off x="3703320" y="1207008"/>
+            <a:off x="3703320" y="1289304"/>
             <a:ext cx="182880" cy="0"/>
           </a:xfrm>
           <a:prstGeom prst="line">
@@ -35967,8 +36056,8 @@
         </p:nvSpPr>
         <p:spPr>
           <a:xfrm>
-            <a:off x="3977640" y="1014984"/>
-            <a:ext cx="4983480" cy="384048"/>
+            <a:off x="3977640" y="1060704"/>
+            <a:ext cx="4983480" cy="457200"/>
           </a:xfrm>
           <a:prstGeom prst="rect">
             <a:avLst/>
@@ -35984,7 +36073,7 @@
               <a:buNone/>
             </a:pPr>
             <a:r>
-              <a:rPr lang="en-US" sz="800" dirty="0">
+              <a:rPr lang="en-US" sz="850" dirty="0">
                 <a:solidFill>
                   <a:srgbClr val="6E6E73"/>
                 </a:solidFill>
@@ -35994,7 +36083,7 @@
               </a:rPr>
               <a:t>C-side agent: the customer contacted us first. The CP-side ticket may not be worked yet, or the CP never reported it.</a:t>
             </a:r>
-            <a:endParaRPr lang="en-US" sz="800" dirty="0"/>
+            <a:endParaRPr lang="en-US" sz="850" dirty="0"/>
           </a:p>
         </p:txBody>
       </p:sp>
@@ -36006,12 +36095,12 @@
         </p:nvSpPr>
         <p:spPr>
           <a:xfrm>
-            <a:off x="457200" y="1435608"/>
-            <a:ext cx="3246120" cy="310896"/>
+            <a:off x="457200" y="1572768"/>
+            <a:ext cx="3246120" cy="384048"/>
           </a:xfrm>
           <a:prstGeom prst="roundRect">
             <a:avLst>
-              <a:gd name="adj" fmla="val 23529"/>
+              <a:gd name="adj" fmla="val 19048"/>
             </a:avLst>
           </a:prstGeom>
           <a:solidFill>
@@ -36033,8 +36122,8 @@
         </p:nvSpPr>
         <p:spPr>
           <a:xfrm>
-            <a:off x="457200" y="1435608"/>
-            <a:ext cx="3246120" cy="310896"/>
+            <a:off x="457200" y="1572768"/>
+            <a:ext cx="3246120" cy="384048"/>
           </a:xfrm>
           <a:prstGeom prst="rect">
             <a:avLst/>
@@ -36058,7 +36147,7 @@
                 <a:ea typeface="SF Pro Display" pitchFamily="34" charset="-122"/>
                 <a:cs typeface="SF Pro Display" pitchFamily="34" charset="-120"/>
               </a:rPr>
-              <a:t>Check CP CRM for a cash report</a:t>
+              <a:t>Check CP CRM: report found</a:t>
             </a:r>
             <a:endParaRPr lang="en-US" sz="1000" dirty="0"/>
           </a:p>
@@ -36072,8 +36161,8 @@
         </p:nvSpPr>
         <p:spPr>
           <a:xfrm>
-            <a:off x="2080260" y="1746504"/>
-            <a:ext cx="0" cy="73152"/>
+            <a:off x="2080260" y="1956816"/>
+            <a:ext cx="0" cy="91440"/>
           </a:xfrm>
           <a:prstGeom prst="line">
             <a:avLst/>
@@ -36096,7 +36185,7 @@
         </p:nvSpPr>
         <p:spPr>
           <a:xfrm>
-            <a:off x="3703320" y="1591056"/>
+            <a:off x="3703320" y="1764792"/>
             <a:ext cx="182880" cy="0"/>
           </a:xfrm>
           <a:prstGeom prst="line">
@@ -36119,8 +36208,8 @@
         </p:nvSpPr>
         <p:spPr>
           <a:xfrm>
-            <a:off x="3977640" y="1399032"/>
-            <a:ext cx="4983480" cy="384048"/>
+            <a:off x="3977640" y="1536192"/>
+            <a:ext cx="4983480" cy="457200"/>
           </a:xfrm>
           <a:prstGeom prst="rect">
             <a:avLst/>
@@ -36136,7 +36225,7 @@
               <a:buNone/>
             </a:pPr>
             <a:r>
-              <a:rPr lang="en-US" sz="800" dirty="0">
+              <a:rPr lang="en-US" sz="850" dirty="0">
                 <a:solidFill>
                   <a:srgbClr val="6E6E73"/>
                 </a:solidFill>
@@ -36144,9 +36233,9 @@
                 <a:ea typeface="SF Pro Text" pitchFamily="34" charset="-122"/>
                 <a:cs typeface="SF Pro Text" pitchFamily="34" charset="-120"/>
               </a:rPr>
-              <a:t>Look for an existing cash-payment report on this job/CP before doing anything else.</a:t>
-            </a:r>
-            <a:endParaRPr lang="en-US" sz="800" dirty="0"/>
+              <a:t>A cash-payment report is on file but not yet actioned. Resolve it yourself: no need to wait for the CP-side queue.</a:t>
+            </a:r>
+            <a:endParaRPr lang="en-US" sz="850" dirty="0"/>
           </a:p>
         </p:txBody>
       </p:sp>
@@ -36158,12 +36247,12 @@
         </p:nvSpPr>
         <p:spPr>
           <a:xfrm>
-            <a:off x="457200" y="1819656"/>
-            <a:ext cx="3246120" cy="310896"/>
+            <a:off x="457200" y="2048256"/>
+            <a:ext cx="3246120" cy="384048"/>
           </a:xfrm>
           <a:prstGeom prst="roundRect">
             <a:avLst>
-              <a:gd name="adj" fmla="val 23529"/>
+              <a:gd name="adj" fmla="val 19048"/>
             </a:avLst>
           </a:prstGeom>
           <a:solidFill>
@@ -36185,8 +36274,8 @@
         </p:nvSpPr>
         <p:spPr>
           <a:xfrm>
-            <a:off x="457200" y="1819656"/>
-            <a:ext cx="3246120" cy="310896"/>
+            <a:off x="457200" y="2048256"/>
+            <a:ext cx="3246120" cy="384048"/>
           </a:xfrm>
           <a:prstGeom prst="rect">
             <a:avLst/>
@@ -36210,7 +36299,7 @@
                 <a:ea typeface="SF Pro Display" pitchFamily="34" charset="-122"/>
                 <a:cs typeface="SF Pro Display" pitchFamily="34" charset="-120"/>
               </a:rPr>
-              <a:t>Report on file, but not yet actioned</a:t>
+              <a:t>Get the cash amount</a:t>
             </a:r>
             <a:endParaRPr lang="en-US" sz="1000" dirty="0"/>
           </a:p>
@@ -36224,8 +36313,8 @@
         </p:nvSpPr>
         <p:spPr>
           <a:xfrm>
-            <a:off x="2080260" y="2130552"/>
-            <a:ext cx="0" cy="73152"/>
+            <a:off x="2080260" y="2432304"/>
+            <a:ext cx="0" cy="91440"/>
           </a:xfrm>
           <a:prstGeom prst="line">
             <a:avLst/>
@@ -36248,7 +36337,7 @@
         </p:nvSpPr>
         <p:spPr>
           <a:xfrm>
-            <a:off x="3703320" y="1975104"/>
+            <a:off x="3703320" y="2240280"/>
             <a:ext cx="182880" cy="0"/>
           </a:xfrm>
           <a:prstGeom prst="line">
@@ -36271,8 +36360,8 @@
         </p:nvSpPr>
         <p:spPr>
           <a:xfrm>
-            <a:off x="3977640" y="1783080"/>
-            <a:ext cx="4983480" cy="384048"/>
+            <a:off x="3977640" y="2011680"/>
+            <a:ext cx="4983480" cy="457200"/>
           </a:xfrm>
           <a:prstGeom prst="rect">
             <a:avLst/>
@@ -36288,7 +36377,7 @@
               <a:buNone/>
             </a:pPr>
             <a:r>
-              <a:rPr lang="en-US" sz="800" dirty="0">
+              <a:rPr lang="en-US" sz="850" dirty="0">
                 <a:solidFill>
                   <a:srgbClr val="6E6E73"/>
                 </a:solidFill>
@@ -36296,9 +36385,9 @@
                 <a:ea typeface="SF Pro Text" pitchFamily="34" charset="-122"/>
                 <a:cs typeface="SF Pro Text" pitchFamily="34" charset="-120"/>
               </a:rPr>
-              <a:t>Resolve it yourself. Get the amount first (or a clear "paid in full"). Pending Invoice: cancel via C CRM, or invoice the balance if partial. Invoiced: refund via CP Dashboard. Soft ladder.</a:t>
-            </a:r>
-            <a:endParaRPr lang="en-US" sz="800" dirty="0"/>
+              <a:t>Did the CP say how much they received? If not, contact the CP for a number (or a clear "paid in full") before doing anything else.</a:t>
+            </a:r>
+            <a:endParaRPr lang="en-US" sz="850" dirty="0"/>
           </a:p>
         </p:txBody>
       </p:sp>
@@ -36310,12 +36399,921 @@
         </p:nvSpPr>
         <p:spPr>
           <a:xfrm>
-            <a:off x="457200" y="2203704"/>
-            <a:ext cx="3246120" cy="310896"/>
+            <a:off x="457200" y="2523744"/>
+            <a:ext cx="3246120" cy="384048"/>
           </a:xfrm>
           <a:prstGeom prst="roundRect">
             <a:avLst>
-              <a:gd name="adj" fmla="val 23529"/>
+              <a:gd name="adj" fmla="val 19048"/>
+            </a:avLst>
+          </a:prstGeom>
+          <a:solidFill>
+            <a:srgbClr val="FFF3D6"/>
+          </a:solidFill>
+          <a:ln w="12700">
+            <a:solidFill>
+              <a:srgbClr val="9A6410"/>
+            </a:solidFill>
+            <a:prstDash val="solid"/>
+          </a:ln>
+        </p:spPr>
+      </p:sp>
+      <p:sp>
+        <p:nvSpPr>
+          <p:cNvPr id="24" name="Text 20"/>
+          <p:cNvSpPr txBox="1"/>
+          <p:nvPr/>
+        </p:nvSpPr>
+        <p:spPr>
+          <a:xfrm>
+            <a:off x="457200" y="2523744"/>
+            <a:ext cx="3246120" cy="384048"/>
+          </a:xfrm>
+          <a:prstGeom prst="rect">
+            <a:avLst/>
+          </a:prstGeom>
+          <a:noFill/>
+          <a:ln/>
+        </p:spPr>
+        <p:txBody>
+          <a:bodyPr wrap="square" lIns="0" tIns="0" rIns="0" bIns="0" rtlCol="0" anchor="ctr"/>
+          <a:lstStyle/>
+          <a:p>
+            <a:pPr algn="ctr" indent="0" marL="0">
+              <a:buNone/>
+            </a:pPr>
+            <a:r>
+              <a:rPr lang="en-US" sz="1000" b="1" dirty="0">
+                <a:solidFill>
+                  <a:srgbClr val="9A6410"/>
+                </a:solidFill>
+                <a:latin typeface="SF Pro Display" pitchFamily="34" charset="0"/>
+                <a:ea typeface="SF Pro Display" pitchFamily="34" charset="-122"/>
+                <a:cs typeface="SF Pro Display" pitchFamily="34" charset="-120"/>
+              </a:rPr>
+              <a:t>Still Pending Invoice?</a:t>
+            </a:r>
+            <a:endParaRPr lang="en-US" sz="1000" dirty="0"/>
+          </a:p>
+        </p:txBody>
+      </p:sp>
+      <p:sp>
+        <p:nvSpPr>
+          <p:cNvPr id="25" name="Shape 21"/>
+          <p:cNvSpPr/>
+          <p:nvPr/>
+        </p:nvSpPr>
+        <p:spPr>
+          <a:xfrm>
+            <a:off x="2080260" y="2907792"/>
+            <a:ext cx="0" cy="91440"/>
+          </a:xfrm>
+          <a:prstGeom prst="line">
+            <a:avLst/>
+          </a:prstGeom>
+          <a:noFill/>
+          <a:ln w="12700">
+            <a:solidFill>
+              <a:srgbClr val="6E6E73"/>
+            </a:solidFill>
+            <a:prstDash val="solid"/>
+            <a:tailEnd type="triangle"/>
+          </a:ln>
+        </p:spPr>
+      </p:sp>
+      <p:sp>
+        <p:nvSpPr>
+          <p:cNvPr id="26" name="Shape 22"/>
+          <p:cNvSpPr/>
+          <p:nvPr/>
+        </p:nvSpPr>
+        <p:spPr>
+          <a:xfrm>
+            <a:off x="3703320" y="2715768"/>
+            <a:ext cx="182880" cy="0"/>
+          </a:xfrm>
+          <a:prstGeom prst="line">
+            <a:avLst/>
+          </a:prstGeom>
+          <a:noFill/>
+          <a:ln w="12700">
+            <a:solidFill>
+              <a:srgbClr val="6E6E73"/>
+            </a:solidFill>
+            <a:prstDash val="solid"/>
+          </a:ln>
+        </p:spPr>
+      </p:sp>
+      <p:sp>
+        <p:nvSpPr>
+          <p:cNvPr id="27" name="type4Desc"/>
+          <p:cNvSpPr txBox="1"/>
+          <p:nvPr/>
+        </p:nvSpPr>
+        <p:spPr>
+          <a:xfrm>
+            <a:off x="3977640" y="2487168"/>
+            <a:ext cx="4983480" cy="457200"/>
+          </a:xfrm>
+          <a:prstGeom prst="rect">
+            <a:avLst/>
+          </a:prstGeom>
+          <a:noFill/>
+          <a:ln/>
+        </p:spPr>
+        <p:txBody>
+          <a:bodyPr wrap="square" lIns="0" tIns="0" rIns="0" bIns="0" rtlCol="0" anchor="ctr"/>
+          <a:lstStyle/>
+          <a:p>
+            <a:pPr indent="0" marL="0">
+              <a:buNone/>
+            </a:pPr>
+            <a:r>
+              <a:rPr lang="en-US" sz="850" dirty="0">
+                <a:solidFill>
+                  <a:srgbClr val="6E6E73"/>
+                </a:solidFill>
+                <a:latin typeface="SF Pro Text" pitchFamily="34" charset="0"/>
+                <a:ea typeface="SF Pro Text" pitchFamily="34" charset="-122"/>
+                <a:cs typeface="SF Pro Text" pitchFamily="34" charset="-120"/>
+              </a:rPr>
+              <a:t>Cancel via C CRM, reason code "does not want the service". Partial cash: invoice the remaining balance instead.</a:t>
+            </a:r>
+            <a:endParaRPr lang="en-US" sz="850" dirty="0"/>
+          </a:p>
+        </p:txBody>
+      </p:sp>
+      <p:sp>
+        <p:nvSpPr>
+          <p:cNvPr id="28" name="Shape 24"/>
+          <p:cNvSpPr/>
+          <p:nvPr/>
+        </p:nvSpPr>
+        <p:spPr>
+          <a:xfrm>
+            <a:off x="457200" y="2999232"/>
+            <a:ext cx="3246120" cy="384048"/>
+          </a:xfrm>
+          <a:prstGeom prst="roundRect">
+            <a:avLst>
+              <a:gd name="adj" fmla="val 19048"/>
+            </a:avLst>
+          </a:prstGeom>
+          <a:solidFill>
+            <a:srgbClr val="FFF3D6"/>
+          </a:solidFill>
+          <a:ln w="12700">
+            <a:solidFill>
+              <a:srgbClr val="9A6410"/>
+            </a:solidFill>
+            <a:prstDash val="solid"/>
+          </a:ln>
+        </p:spPr>
+      </p:sp>
+      <p:sp>
+        <p:nvSpPr>
+          <p:cNvPr id="29" name="Text 25"/>
+          <p:cNvSpPr txBox="1"/>
+          <p:nvPr/>
+        </p:nvSpPr>
+        <p:spPr>
+          <a:xfrm>
+            <a:off x="457200" y="2999232"/>
+            <a:ext cx="3246120" cy="384048"/>
+          </a:xfrm>
+          <a:prstGeom prst="rect">
+            <a:avLst/>
+          </a:prstGeom>
+          <a:noFill/>
+          <a:ln/>
+        </p:spPr>
+        <p:txBody>
+          <a:bodyPr wrap="square" lIns="0" tIns="0" rIns="0" bIns="0" rtlCol="0" anchor="ctr"/>
+          <a:lstStyle/>
+          <a:p>
+            <a:pPr algn="ctr" indent="0" marL="0">
+              <a:buNone/>
+            </a:pPr>
+            <a:r>
+              <a:rPr lang="en-US" sz="1000" b="1" dirty="0">
+                <a:solidFill>
+                  <a:srgbClr val="9A6410"/>
+                </a:solidFill>
+                <a:latin typeface="SF Pro Display" pitchFamily="34" charset="0"/>
+                <a:ea typeface="SF Pro Display" pitchFamily="34" charset="-122"/>
+                <a:cs typeface="SF Pro Display" pitchFamily="34" charset="-120"/>
+              </a:rPr>
+              <a:t>Already Invoiced?</a:t>
+            </a:r>
+            <a:endParaRPr lang="en-US" sz="1000" dirty="0"/>
+          </a:p>
+        </p:txBody>
+      </p:sp>
+      <p:sp>
+        <p:nvSpPr>
+          <p:cNvPr id="30" name="Shape 26"/>
+          <p:cNvSpPr/>
+          <p:nvPr/>
+        </p:nvSpPr>
+        <p:spPr>
+          <a:xfrm>
+            <a:off x="2080260" y="3383280"/>
+            <a:ext cx="0" cy="91440"/>
+          </a:xfrm>
+          <a:prstGeom prst="line">
+            <a:avLst/>
+          </a:prstGeom>
+          <a:noFill/>
+          <a:ln w="12700">
+            <a:solidFill>
+              <a:srgbClr val="6E6E73"/>
+            </a:solidFill>
+            <a:prstDash val="solid"/>
+            <a:tailEnd type="triangle"/>
+          </a:ln>
+        </p:spPr>
+      </p:sp>
+      <p:sp>
+        <p:nvSpPr>
+          <p:cNvPr id="31" name="Shape 27"/>
+          <p:cNvSpPr/>
+          <p:nvPr/>
+        </p:nvSpPr>
+        <p:spPr>
+          <a:xfrm>
+            <a:off x="3703320" y="3191256"/>
+            <a:ext cx="182880" cy="0"/>
+          </a:xfrm>
+          <a:prstGeom prst="line">
+            <a:avLst/>
+          </a:prstGeom>
+          <a:noFill/>
+          <a:ln w="12700">
+            <a:solidFill>
+              <a:srgbClr val="6E6E73"/>
+            </a:solidFill>
+            <a:prstDash val="solid"/>
+          </a:ln>
+        </p:spPr>
+      </p:sp>
+      <p:sp>
+        <p:nvSpPr>
+          <p:cNvPr id="32" name="type5Desc"/>
+          <p:cNvSpPr txBox="1"/>
+          <p:nvPr/>
+        </p:nvSpPr>
+        <p:spPr>
+          <a:xfrm>
+            <a:off x="3977640" y="2962656"/>
+            <a:ext cx="4983480" cy="457200"/>
+          </a:xfrm>
+          <a:prstGeom prst="rect">
+            <a:avLst/>
+          </a:prstGeom>
+          <a:noFill/>
+          <a:ln/>
+        </p:spPr>
+        <p:txBody>
+          <a:bodyPr wrap="square" lIns="0" tIns="0" rIns="0" bIns="0" rtlCol="0" anchor="ctr"/>
+          <a:lstStyle/>
+          <a:p>
+            <a:pPr indent="0" marL="0">
+              <a:buNone/>
+            </a:pPr>
+            <a:r>
+              <a:rPr lang="en-US" sz="850" dirty="0">
+                <a:solidFill>
+                  <a:srgbClr val="6E6E73"/>
+                </a:solidFill>
+                <a:latin typeface="SF Pro Text" pitchFamily="34" charset="0"/>
+                <a:ea typeface="SF Pro Text" pitchFamily="34" charset="-122"/>
+                <a:cs typeface="SF Pro Text" pitchFamily="34" charset="-120"/>
+              </a:rPr>
+              <a:t>Refund via the CP Dashboard. Partial cash: admin refund the cash-paid portion (based on CP Pay, not C Price) + a CP Holdback for the same amount.</a:t>
+            </a:r>
+            <a:endParaRPr lang="en-US" sz="850" dirty="0"/>
+          </a:p>
+        </p:txBody>
+      </p:sp>
+      <p:sp>
+        <p:nvSpPr>
+          <p:cNvPr id="33" name="Shape 29"/>
+          <p:cNvSpPr/>
+          <p:nvPr/>
+        </p:nvSpPr>
+        <p:spPr>
+          <a:xfrm>
+            <a:off x="457200" y="3474720"/>
+            <a:ext cx="3246120" cy="384048"/>
+          </a:xfrm>
+          <a:prstGeom prst="roundRect">
+            <a:avLst>
+              <a:gd name="adj" fmla="val 19048"/>
+            </a:avLst>
+          </a:prstGeom>
+          <a:solidFill>
+            <a:srgbClr val="FFFFFF"/>
+          </a:solidFill>
+          <a:ln w="12700">
+            <a:solidFill>
+              <a:srgbClr val="DCE1E7"/>
+            </a:solidFill>
+            <a:prstDash val="solid"/>
+          </a:ln>
+        </p:spPr>
+      </p:sp>
+      <p:sp>
+        <p:nvSpPr>
+          <p:cNvPr id="34" name="Text 30"/>
+          <p:cNvSpPr txBox="1"/>
+          <p:nvPr/>
+        </p:nvSpPr>
+        <p:spPr>
+          <a:xfrm>
+            <a:off x="457200" y="3474720"/>
+            <a:ext cx="3246120" cy="384048"/>
+          </a:xfrm>
+          <a:prstGeom prst="rect">
+            <a:avLst/>
+          </a:prstGeom>
+          <a:noFill/>
+          <a:ln/>
+        </p:spPr>
+        <p:txBody>
+          <a:bodyPr wrap="square" lIns="0" tIns="0" rIns="0" bIns="0" rtlCol="0" anchor="ctr"/>
+          <a:lstStyle/>
+          <a:p>
+            <a:pPr algn="ctr" indent="0" marL="0">
+              <a:buNone/>
+            </a:pPr>
+            <a:r>
+              <a:rPr lang="en-US" sz="1000" b="1" dirty="0">
+                <a:solidFill>
+                  <a:srgbClr val="1D1D1F"/>
+                </a:solidFill>
+                <a:latin typeface="SF Pro Display" pitchFamily="34" charset="0"/>
+                <a:ea typeface="SF Pro Display" pitchFamily="34" charset="-122"/>
+                <a:cs typeface="SF Pro Display" pitchFamily="34" charset="-120"/>
+              </a:rPr>
+              <a:t>Apply the soft ladder</a:t>
+            </a:r>
+            <a:endParaRPr lang="en-US" sz="1000" dirty="0"/>
+          </a:p>
+        </p:txBody>
+      </p:sp>
+      <p:sp>
+        <p:nvSpPr>
+          <p:cNvPr id="35" name="Shape 31"/>
+          <p:cNvSpPr/>
+          <p:nvPr/>
+        </p:nvSpPr>
+        <p:spPr>
+          <a:xfrm>
+            <a:off x="3703320" y="3666744"/>
+            <a:ext cx="182880" cy="0"/>
+          </a:xfrm>
+          <a:prstGeom prst="line">
+            <a:avLst/>
+          </a:prstGeom>
+          <a:noFill/>
+          <a:ln w="12700">
+            <a:solidFill>
+              <a:srgbClr val="6E6E73"/>
+            </a:solidFill>
+            <a:prstDash val="solid"/>
+          </a:ln>
+        </p:spPr>
+      </p:sp>
+      <p:sp>
+        <p:nvSpPr>
+          <p:cNvPr id="36" name="type6Desc"/>
+          <p:cNvSpPr txBox="1"/>
+          <p:nvPr/>
+        </p:nvSpPr>
+        <p:spPr>
+          <a:xfrm>
+            <a:off x="3977640" y="3438144"/>
+            <a:ext cx="4983480" cy="457200"/>
+          </a:xfrm>
+          <a:prstGeom prst="rect">
+            <a:avLst/>
+          </a:prstGeom>
+          <a:noFill/>
+          <a:ln/>
+        </p:spPr>
+        <p:txBody>
+          <a:bodyPr wrap="square" lIns="0" tIns="0" rIns="0" bIns="0" rtlCol="0" anchor="ctr"/>
+          <a:lstStyle/>
+          <a:p>
+            <a:pPr indent="0" marL="0">
+              <a:buNone/>
+            </a:pPr>
+            <a:r>
+              <a:rPr lang="en-US" sz="850" dirty="0">
+                <a:solidFill>
+                  <a:srgbClr val="6E6E73"/>
+                </a:solidFill>
+                <a:latin typeface="SF Pro Text" pitchFamily="34" charset="0"/>
+                <a:ea typeface="SF Pro Text" pitchFamily="34" charset="-122"/>
+                <a:cs typeface="SF Pro Text" pitchFamily="34" charset="-120"/>
+              </a:rPr>
+              <a:t>It's a CP admission, just one a C-side agent is closing out. Use the soft ladder on the penalty ladder slide.</a:t>
+            </a:r>
+            <a:endParaRPr lang="en-US" sz="850" dirty="0"/>
+          </a:p>
+        </p:txBody>
+      </p:sp>
+      <p:sp>
+        <p:nvSpPr>
+          <p:cNvPr id="25" name="Slide Number Placeholder 0"/>
+          <p:cNvSpPr>
+            <a:spLocks noGrp="1"/>
+          </p:cNvSpPr>
+          <p:nvPr>
+            <p:ph type="sldNum" sz="quarter" idx="4294967295"/>
+          </p:nvPr>
+        </p:nvSpPr>
+        <p:spPr>
+          <a:xfrm>
+            <a:off x="8229600" y="4800600"/>
+            <a:ext cx="457200" cy="182880"/>
+          </a:xfrm>
+          <a:prstGeom prst="rect">
+            <a:avLst/>
+          </a:prstGeom>
+          <a:extLst>
+            <a:ext uri="{C572A759-6A51-4108-AA02-DFA0A04FC94B}">
+              <ma14:wrappingTextBoxFlag xmlns:ma14="http://schemas.microsoft.com/office/mac/drawingml/2011/main" val="0"/>
+            </a:ext>
+          </a:extLst>
+        </p:spPr>
+        <p:txBody>
+          <a:bodyPr/>
+          <a:lstStyle>
+            <a:lvl1pPr>
+              <a:defRPr sz="700">
+                <a:solidFill>
+                  <a:srgbClr val="6E6E73"/>
+                </a:solidFill>
+                <a:latin typeface="SF Pro Text"/>
+                <a:ea typeface="SF Pro Text"/>
+                <a:cs typeface="SF Pro Text"/>
+              </a:defRPr>
+            </a:lvl1pPr>
+          </a:lstStyle>
+          <a:p>
+            <a:pPr algn="r"/>
+            <a:fld id="{F7021451-1387-4CA6-816F-3879F97B5CBC}" type="slidenum">
+              <a:rPr b="0" lang="en-US"/>
+              <a:t>41</a:t>
+            </a:fld>
+            <a:endParaRPr lang="en-US"/>
+          </a:p>
+        </p:txBody>
+      </p:sp>
+    </p:spTree>
+  </p:cSld>
+  <p:clrMapOvr>
+    <a:masterClrMapping/>
+  </p:clrMapOvr>
+  <p:timing>
+    <p:tnLst>
+      <p:par>
+        <p:cTn id="1" dur="indefinite" restart="never" nodeType="tmRoot">
+          <p:childTnLst>
+            <p:seq concurrent="1" nextAc="seek">
+              <p:cTn id="2" dur="indefinite" nodeType="mainSeq">
+                <p:childTnLst>
+                  <p:par>
+                    <p:cTn id="3" fill="hold">
+                      <p:stCondLst>
+                        <p:cond delay="indefinite"/>
+                      </p:stCondLst>
+                      <p:childTnLst>
+                        <p:par>
+                          <p:cTn id="4" fill="hold">
+                            <p:stCondLst>
+                              <p:cond delay="0"/>
+                            </p:stCondLst>
+                            <p:childTnLst>
+                              <p:par>
+                                <p:cTn id="5" presetID="1" presetClass="entr" presetSubtype="0" fill="hold" grpId="0" nodeType="clickEffect">
+                                  <p:stCondLst>
+                                    <p:cond delay="0"/>
+                                  </p:stCondLst>
+                                  <p:iterate type="lt">
+                                    <p:tmAbs val="40"/>
+                                  </p:iterate>
+                                  <p:childTnLst>
+                                    <p:set>
+                                      <p:cBhvr>
+                                        <p:cTn id="6" dur="1" fill="hold">
+                                          <p:stCondLst>
+                                            <p:cond delay="0"/>
+                                          </p:stCondLst>
+                                        </p:cTn>
+                                        <p:tgtEl>
+                                          <p:spTgt spid="12"/>
+                                        </p:tgtEl>
+                                        <p:attrNameLst>
+                                          <p:attrName>style.visibility</p:attrName>
+                                        </p:attrNameLst>
+                                      </p:cBhvr>
+                                      <p:to>
+                                        <p:strVal val="visible"/>
+                                      </p:to>
+                                    </p:set>
+                                  </p:childTnLst>
+                                </p:cTn>
+                              </p:par>
+                            </p:childTnLst>
+                          </p:cTn>
+                        </p:par>
+                      </p:childTnLst>
+                    </p:cTn>
+                  </p:par>
+                  <p:par>
+                    <p:cTn id="7" fill="hold">
+                      <p:stCondLst>
+                        <p:cond delay="indefinite"/>
+                      </p:stCondLst>
+                      <p:childTnLst>
+                        <p:par>
+                          <p:cTn id="8" fill="hold">
+                            <p:stCondLst>
+                              <p:cond delay="0"/>
+                            </p:stCondLst>
+                            <p:childTnLst>
+                              <p:par>
+                                <p:cTn id="9" presetID="1" presetClass="entr" presetSubtype="0" fill="hold" grpId="0" nodeType="clickEffect">
+                                  <p:stCondLst>
+                                    <p:cond delay="0"/>
+                                  </p:stCondLst>
+                                  <p:iterate type="lt">
+                                    <p:tmAbs val="40"/>
+                                  </p:iterate>
+                                  <p:childTnLst>
+                                    <p:set>
+                                      <p:cBhvr>
+                                        <p:cTn id="10" dur="1" fill="hold">
+                                          <p:stCondLst>
+                                            <p:cond delay="0"/>
+                                          </p:stCondLst>
+                                        </p:cTn>
+                                        <p:tgtEl>
+                                          <p:spTgt spid="17"/>
+                                        </p:tgtEl>
+                                        <p:attrNameLst>
+                                          <p:attrName>style.visibility</p:attrName>
+                                        </p:attrNameLst>
+                                      </p:cBhvr>
+                                      <p:to>
+                                        <p:strVal val="visible"/>
+                                      </p:to>
+                                    </p:set>
+                                  </p:childTnLst>
+                                </p:cTn>
+                              </p:par>
+                            </p:childTnLst>
+                          </p:cTn>
+                        </p:par>
+                      </p:childTnLst>
+                    </p:cTn>
+                  </p:par>
+                  <p:par>
+                    <p:cTn id="11" fill="hold">
+                      <p:stCondLst>
+                        <p:cond delay="indefinite"/>
+                      </p:stCondLst>
+                      <p:childTnLst>
+                        <p:par>
+                          <p:cTn id="12" fill="hold">
+                            <p:stCondLst>
+                              <p:cond delay="0"/>
+                            </p:stCondLst>
+                            <p:childTnLst>
+                              <p:par>
+                                <p:cTn id="13" presetID="1" presetClass="entr" presetSubtype="0" fill="hold" grpId="0" nodeType="clickEffect">
+                                  <p:stCondLst>
+                                    <p:cond delay="0"/>
+                                  </p:stCondLst>
+                                  <p:iterate type="lt">
+                                    <p:tmAbs val="40"/>
+                                  </p:iterate>
+                                  <p:childTnLst>
+                                    <p:set>
+                                      <p:cBhvr>
+                                        <p:cTn id="14" dur="1" fill="hold">
+                                          <p:stCondLst>
+                                            <p:cond delay="0"/>
+                                          </p:stCondLst>
+                                        </p:cTn>
+                                        <p:tgtEl>
+                                          <p:spTgt spid="22"/>
+                                        </p:tgtEl>
+                                        <p:attrNameLst>
+                                          <p:attrName>style.visibility</p:attrName>
+                                        </p:attrNameLst>
+                                      </p:cBhvr>
+                                      <p:to>
+                                        <p:strVal val="visible"/>
+                                      </p:to>
+                                    </p:set>
+                                  </p:childTnLst>
+                                </p:cTn>
+                              </p:par>
+                            </p:childTnLst>
+                          </p:cTn>
+                        </p:par>
+                      </p:childTnLst>
+                    </p:cTn>
+                  </p:par>
+                  <p:par>
+                    <p:cTn id="15" fill="hold">
+                      <p:stCondLst>
+                        <p:cond delay="indefinite"/>
+                      </p:stCondLst>
+                      <p:childTnLst>
+                        <p:par>
+                          <p:cTn id="16" fill="hold">
+                            <p:stCondLst>
+                              <p:cond delay="0"/>
+                            </p:stCondLst>
+                            <p:childTnLst>
+                              <p:par>
+                                <p:cTn id="17" presetID="1" presetClass="entr" presetSubtype="0" fill="hold" grpId="0" nodeType="clickEffect">
+                                  <p:stCondLst>
+                                    <p:cond delay="0"/>
+                                  </p:stCondLst>
+                                  <p:iterate type="lt">
+                                    <p:tmAbs val="40"/>
+                                  </p:iterate>
+                                  <p:childTnLst>
+                                    <p:set>
+                                      <p:cBhvr>
+                                        <p:cTn id="18" dur="1" fill="hold">
+                                          <p:stCondLst>
+                                            <p:cond delay="0"/>
+                                          </p:stCondLst>
+                                        </p:cTn>
+                                        <p:tgtEl>
+                                          <p:spTgt spid="27"/>
+                                        </p:tgtEl>
+                                        <p:attrNameLst>
+                                          <p:attrName>style.visibility</p:attrName>
+                                        </p:attrNameLst>
+                                      </p:cBhvr>
+                                      <p:to>
+                                        <p:strVal val="visible"/>
+                                      </p:to>
+                                    </p:set>
+                                  </p:childTnLst>
+                                </p:cTn>
+                              </p:par>
+                            </p:childTnLst>
+                          </p:cTn>
+                        </p:par>
+                      </p:childTnLst>
+                    </p:cTn>
+                  </p:par>
+                  <p:par>
+                    <p:cTn id="19" fill="hold">
+                      <p:stCondLst>
+                        <p:cond delay="indefinite"/>
+                      </p:stCondLst>
+                      <p:childTnLst>
+                        <p:par>
+                          <p:cTn id="20" fill="hold">
+                            <p:stCondLst>
+                              <p:cond delay="0"/>
+                            </p:stCondLst>
+                            <p:childTnLst>
+                              <p:par>
+                                <p:cTn id="21" presetID="1" presetClass="entr" presetSubtype="0" fill="hold" grpId="0" nodeType="clickEffect">
+                                  <p:stCondLst>
+                                    <p:cond delay="0"/>
+                                  </p:stCondLst>
+                                  <p:iterate type="lt">
+                                    <p:tmAbs val="40"/>
+                                  </p:iterate>
+                                  <p:childTnLst>
+                                    <p:set>
+                                      <p:cBhvr>
+                                        <p:cTn id="22" dur="1" fill="hold">
+                                          <p:stCondLst>
+                                            <p:cond delay="0"/>
+                                          </p:stCondLst>
+                                        </p:cTn>
+                                        <p:tgtEl>
+                                          <p:spTgt spid="32"/>
+                                        </p:tgtEl>
+                                        <p:attrNameLst>
+                                          <p:attrName>style.visibility</p:attrName>
+                                        </p:attrNameLst>
+                                      </p:cBhvr>
+                                      <p:to>
+                                        <p:strVal val="visible"/>
+                                      </p:to>
+                                    </p:set>
+                                  </p:childTnLst>
+                                </p:cTn>
+                              </p:par>
+                            </p:childTnLst>
+                          </p:cTn>
+                        </p:par>
+                      </p:childTnLst>
+                    </p:cTn>
+                  </p:par>
+                  <p:par>
+                    <p:cTn id="23" fill="hold">
+                      <p:stCondLst>
+                        <p:cond delay="indefinite"/>
+                      </p:stCondLst>
+                      <p:childTnLst>
+                        <p:par>
+                          <p:cTn id="24" fill="hold">
+                            <p:stCondLst>
+                              <p:cond delay="0"/>
+                            </p:stCondLst>
+                            <p:childTnLst>
+                              <p:par>
+                                <p:cTn id="25" presetID="1" presetClass="entr" presetSubtype="0" fill="hold" grpId="0" nodeType="clickEffect">
+                                  <p:stCondLst>
+                                    <p:cond delay="0"/>
+                                  </p:stCondLst>
+                                  <p:iterate type="lt">
+                                    <p:tmAbs val="40"/>
+                                  </p:iterate>
+                                  <p:childTnLst>
+                                    <p:set>
+                                      <p:cBhvr>
+                                        <p:cTn id="26" dur="1" fill="hold">
+                                          <p:stCondLst>
+                                            <p:cond delay="0"/>
+                                          </p:stCondLst>
+                                        </p:cTn>
+                                        <p:tgtEl>
+                                          <p:spTgt spid="36"/>
+                                        </p:tgtEl>
+                                        <p:attrNameLst>
+                                          <p:attrName>style.visibility</p:attrName>
+                                        </p:attrNameLst>
+                                      </p:cBhvr>
+                                      <p:to>
+                                        <p:strVal val="visible"/>
+                                      </p:to>
+                                    </p:set>
+                                  </p:childTnLst>
+                                </p:cTn>
+                              </p:par>
+                            </p:childTnLst>
+                          </p:cTn>
+                        </p:par>
+                      </p:childTnLst>
+                    </p:cTn>
+                  </p:par>
+                </p:childTnLst>
+              </p:cTn>
+              <p:prevCondLst>
+                <p:cond evt="onPrev" delay="0">
+                  <p:tgtEl>
+                    <p:sldTgt/>
+                  </p:tgtEl>
+                </p:cond>
+              </p:prevCondLst>
+              <p:nextCondLst>
+                <p:cond evt="onNext" delay="0">
+                  <p:tgtEl>
+                    <p:sldTgt/>
+                  </p:tgtEl>
+                </p:cond>
+              </p:nextCondLst>
+            </p:seq>
+          </p:childTnLst>
+        </p:cTn>
+      </p:par>
+    </p:tnLst>
+    <p:bldLst>
+      <p:bldP spid="12" grpId="0" animBg="1"/>
+      <p:bldP spid="17" grpId="0" animBg="1"/>
+      <p:bldP spid="22" grpId="0" animBg="1"/>
+      <p:bldP spid="27" grpId="0" animBg="1"/>
+      <p:bldP spid="32" grpId="0" animBg="1"/>
+      <p:bldP spid="36" grpId="0" animBg="1"/>
+    </p:bldLst>
+  </p:timing>
+</p:sld>
+</file>
+
+<file path=ppt/slides/slide42.xml><?xml version="1.0" encoding="utf-8"?>
+<p:sld xmlns:a="http://schemas.openxmlformats.org/drawingml/2006/main" xmlns:r="http://schemas.openxmlformats.org/officeDocument/2006/relationships" xmlns:p="http://schemas.openxmlformats.org/presentationml/2006/main">
+  <p:cSld name="Slide 42">
+    <p:spTree>
+      <p:nvGrpSpPr>
+        <p:cNvPr id="1" name=""/>
+        <p:cNvGrpSpPr/>
+        <p:nvPr/>
+      </p:nvGrpSpPr>
+      <p:grpSpPr>
+        <a:xfrm>
+          <a:off x="0" y="0"/>
+          <a:ext cx="0" cy="0"/>
+          <a:chOff x="0" y="0"/>
+          <a:chExt cx="0" cy="0"/>
+        </a:xfrm>
+      </p:grpSpPr>
+      <p:sp>
+        <p:nvSpPr>
+          <p:cNvPr id="2" name="Text 0"/>
+          <p:cNvSpPr txBox="1"/>
+          <p:nvPr/>
+        </p:nvSpPr>
+        <p:spPr>
+          <a:xfrm>
+            <a:off x="438912" y="274320"/>
+            <a:ext cx="8229600" cy="182880"/>
+          </a:xfrm>
+          <a:prstGeom prst="rect">
+            <a:avLst/>
+          </a:prstGeom>
+          <a:noFill/>
+          <a:ln/>
+        </p:spPr>
+        <p:txBody>
+          <a:bodyPr wrap="square" lIns="0" tIns="0" rIns="0" bIns="0" rtlCol="0" anchor="t"/>
+          <a:lstStyle/>
+          <a:p>
+            <a:pPr indent="0" marL="0">
+              <a:buNone/>
+            </a:pPr>
+            <a:r>
+              <a:rPr lang="en-US" sz="800" b="1" spc="50" kern="0" dirty="0">
+                <a:solidFill>
+                  <a:srgbClr val="0B7A6F"/>
+                </a:solidFill>
+                <a:latin typeface="SF Pro Display" pitchFamily="34" charset="0"/>
+                <a:ea typeface="SF Pro Display" pitchFamily="34" charset="-122"/>
+                <a:cs typeface="SF Pro Display" pitchFamily="34" charset="-120"/>
+              </a:rPr>
+              <a:t>CASH PAYMENT</a:t>
+            </a:r>
+            <a:endParaRPr lang="en-US" sz="800" dirty="0"/>
+          </a:p>
+        </p:txBody>
+      </p:sp>
+      <p:sp>
+        <p:nvSpPr>
+          <p:cNvPr id="3" name="Text 1"/>
+          <p:cNvSpPr txBox="1"/>
+          <p:nvPr/>
+        </p:nvSpPr>
+        <p:spPr>
+          <a:xfrm>
+            <a:off x="438912" y="457200"/>
+            <a:ext cx="8229600" cy="457200"/>
+          </a:xfrm>
+          <a:prstGeom prst="rect">
+            <a:avLst/>
+          </a:prstGeom>
+          <a:noFill/>
+          <a:ln/>
+        </p:spPr>
+        <p:txBody>
+          <a:bodyPr wrap="square" lIns="0" tIns="0" rIns="0" bIns="0" rtlCol="0" anchor="t"/>
+          <a:lstStyle/>
+          <a:p>
+            <a:pPr indent="0" marL="0">
+              <a:buNone/>
+            </a:pPr>
+            <a:r>
+              <a:rPr lang="en-US" sz="2400" b="1" dirty="0">
+                <a:solidFill>
+                  <a:srgbClr val="1D1D1F"/>
+                </a:solidFill>
+                <a:latin typeface="SF Pro Display" pitchFamily="34" charset="0"/>
+                <a:ea typeface="SF Pro Display" pitchFamily="34" charset="-122"/>
+                <a:cs typeface="SF Pro Display" pitchFamily="34" charset="-120"/>
+              </a:rPr>
+              <a:t>Branch B: nothing on file</a:t>
+            </a:r>
+            <a:endParaRPr lang="en-US" sz="2400" dirty="0"/>
+          </a:p>
+        </p:txBody>
+      </p:sp>
+      <p:sp>
+        <p:nvSpPr>
+          <p:cNvPr id="5" name="Shape 2"/>
+          <p:cNvSpPr/>
+          <p:nvPr/>
+        </p:nvSpPr>
+        <p:spPr>
+          <a:xfrm>
+            <a:off x="6949440" y="502920"/>
+            <a:ext cx="1783080" cy="365760"/>
+          </a:xfrm>
+          <a:prstGeom prst="roundRect">
+            <a:avLst>
+              <a:gd name="adj" fmla="val 20000"/>
             </a:avLst>
           </a:prstGeom>
           <a:solidFill>
@@ -36329,16 +37327,40 @@
           </a:ln>
         </p:spPr>
       </p:sp>
-      <p:sp>
-        <p:nvSpPr>
-          <p:cNvPr id="24" name="Text 20"/>
-          <p:cNvSpPr txBox="1"/>
-          <p:nvPr/>
-        </p:nvSpPr>
-        <p:spPr>
-          <a:xfrm>
-            <a:off x="457200" y="2203704"/>
-            <a:ext cx="3246120" cy="310896"/>
+      <p:pic>
+        <p:nvPicPr>
+          <p:cNvPr id="6" name="Image 0" descr="preencoded.png">    </p:cNvPr>
+          <p:cNvPicPr>
+            <a:picLocks noChangeAspect="1"/>
+          </p:cNvPicPr>
+          <p:nvPr/>
+        </p:nvPicPr>
+        <p:blipFill>
+          <a:blip r:embed="rId1"/>
+          <a:stretch>
+            <a:fillRect/>
+          </a:stretch>
+        </p:blipFill>
+        <p:spPr>
+          <a:xfrm>
+            <a:off x="7086600" y="594360"/>
+            <a:ext cx="182880" cy="182880"/>
+          </a:xfrm>
+          <a:prstGeom prst="rect">
+            <a:avLst/>
+          </a:prstGeom>
+        </p:spPr>
+      </p:pic>
+      <p:sp>
+        <p:nvSpPr>
+          <p:cNvPr id="7" name="Text 3"/>
+          <p:cNvSpPr txBox="1"/>
+          <p:nvPr/>
+        </p:nvSpPr>
+        <p:spPr>
+          <a:xfrm>
+            <a:off x="7333488" y="502920"/>
+            <a:ext cx="1325880" cy="365760"/>
           </a:xfrm>
           <a:prstGeom prst="rect">
             <a:avLst/>
@@ -36350,11 +37372,11 @@
           <a:bodyPr wrap="square" lIns="0" tIns="0" rIns="0" bIns="0" rtlCol="0" anchor="ctr"/>
           <a:lstStyle/>
           <a:p>
-            <a:pPr algn="ctr" indent="0" marL="0">
-              <a:buNone/>
-            </a:pPr>
-            <a:r>
-              <a:rPr lang="en-US" sz="1000" b="1" dirty="0">
+            <a:pPr indent="0" marL="0">
+              <a:buNone/>
+            </a:pPr>
+            <a:r>
+              <a:rPr lang="en-US" sz="1100" b="1" dirty="0">
                 <a:solidFill>
                   <a:srgbClr val="FFFFFF"/>
                 </a:solidFill>
@@ -36362,7 +37384,73 @@
                 <a:ea typeface="SF Pro Display" pitchFamily="34" charset="-122"/>
                 <a:cs typeface="SF Pro Display" pitchFamily="34" charset="-120"/>
               </a:rPr>
-              <a:t>Nothing on file: ask C for proof</a:t>
+              <a:t>Show details</a:t>
+            </a:r>
+            <a:endParaRPr lang="en-US" sz="1100" dirty="0"/>
+          </a:p>
+        </p:txBody>
+      </p:sp>
+      <p:sp>
+        <p:nvSpPr>
+          <p:cNvPr id="8" name="Shape 4"/>
+          <p:cNvSpPr/>
+          <p:nvPr/>
+        </p:nvSpPr>
+        <p:spPr>
+          <a:xfrm>
+            <a:off x="457200" y="1097280"/>
+            <a:ext cx="3246120" cy="348615"/>
+          </a:xfrm>
+          <a:prstGeom prst="roundRect">
+            <a:avLst>
+              <a:gd name="adj" fmla="val 20984"/>
+            </a:avLst>
+          </a:prstGeom>
+          <a:solidFill>
+            <a:srgbClr val="1D1D1F"/>
+          </a:solidFill>
+          <a:ln w="12700">
+            <a:solidFill>
+              <a:srgbClr val="1D1D1F"/>
+            </a:solidFill>
+            <a:prstDash val="solid"/>
+          </a:ln>
+        </p:spPr>
+      </p:sp>
+      <p:sp>
+        <p:nvSpPr>
+          <p:cNvPr id="9" name="Text 5"/>
+          <p:cNvSpPr txBox="1"/>
+          <p:nvPr/>
+        </p:nvSpPr>
+        <p:spPr>
+          <a:xfrm>
+            <a:off x="457200" y="1097280"/>
+            <a:ext cx="3246120" cy="348615"/>
+          </a:xfrm>
+          <a:prstGeom prst="rect">
+            <a:avLst/>
+          </a:prstGeom>
+          <a:noFill/>
+          <a:ln/>
+        </p:spPr>
+        <p:txBody>
+          <a:bodyPr wrap="square" lIns="0" tIns="0" rIns="0" bIns="0" rtlCol="0" anchor="ctr"/>
+          <a:lstStyle/>
+          <a:p>
+            <a:pPr algn="ctr" indent="0" marL="0">
+              <a:buNone/>
+            </a:pPr>
+            <a:r>
+              <a:rPr lang="en-US" sz="1000" b="1" dirty="0">
+                <a:solidFill>
+                  <a:srgbClr val="FFFFFF"/>
+                </a:solidFill>
+                <a:latin typeface="SF Pro Display" pitchFamily="34" charset="0"/>
+                <a:ea typeface="SF Pro Display" pitchFamily="34" charset="-122"/>
+                <a:cs typeface="SF Pro Display" pitchFamily="34" charset="-120"/>
+              </a:rPr>
+              <a:t>Customer says they paid the CP cash</a:t>
             </a:r>
             <a:endParaRPr lang="en-US" sz="1000" dirty="0"/>
           </a:p>
@@ -36370,14 +37458,14 @@
       </p:sp>
       <p:sp>
         <p:nvSpPr>
-          <p:cNvPr id="25" name="Shape 21"/>
+          <p:cNvPr id="10" name="Shape 6"/>
           <p:cNvSpPr/>
           <p:nvPr/>
         </p:nvSpPr>
         <p:spPr>
           <a:xfrm>
-            <a:off x="2080260" y="2514600"/>
-            <a:ext cx="0" cy="73152"/>
+            <a:off x="2080260" y="1445895"/>
+            <a:ext cx="0" cy="91440"/>
           </a:xfrm>
           <a:prstGeom prst="line">
             <a:avLst/>
@@ -36394,13 +37482,13 @@
       </p:sp>
       <p:sp>
         <p:nvSpPr>
-          <p:cNvPr id="26" name="Shape 22"/>
+          <p:cNvPr id="11" name="Shape 7"/>
           <p:cNvSpPr/>
           <p:nvPr/>
         </p:nvSpPr>
         <p:spPr>
           <a:xfrm>
-            <a:off x="3703320" y="2359152"/>
+            <a:off x="3703320" y="1271588"/>
             <a:ext cx="182880" cy="0"/>
           </a:xfrm>
           <a:prstGeom prst="line">
@@ -36417,14 +37505,14 @@
       </p:sp>
       <p:sp>
         <p:nvSpPr>
-          <p:cNvPr id="27" name="type4Desc"/>
-          <p:cNvSpPr txBox="1"/>
-          <p:nvPr/>
-        </p:nvSpPr>
-        <p:spPr>
-          <a:xfrm>
-            <a:off x="3977640" y="2167128"/>
-            <a:ext cx="4983480" cy="384048"/>
+          <p:cNvPr id="12" name="type1Desc"/>
+          <p:cNvSpPr txBox="1"/>
+          <p:nvPr/>
+        </p:nvSpPr>
+        <p:spPr>
+          <a:xfrm>
+            <a:off x="3977640" y="1060704"/>
+            <a:ext cx="4983480" cy="421767"/>
           </a:xfrm>
           <a:prstGeom prst="rect">
             <a:avLst/>
@@ -36440,7 +37528,7 @@
               <a:buNone/>
             </a:pPr>
             <a:r>
-              <a:rPr lang="en-US" sz="800" dirty="0">
+              <a:rPr lang="en-US" sz="850" dirty="0">
                 <a:solidFill>
                   <a:srgbClr val="6E6E73"/>
                 </a:solidFill>
@@ -36448,26 +37536,178 @@
                 <a:ea typeface="SF Pro Text" pitchFamily="34" charset="-122"/>
                 <a:cs typeface="SF Pro Text" pitchFamily="34" charset="-120"/>
               </a:rPr>
-              <a:t>Encourage proof, don't require it.</a:t>
-            </a:r>
-            <a:endParaRPr lang="en-US" sz="800" dirty="0"/>
-          </a:p>
-        </p:txBody>
-      </p:sp>
-      <p:sp>
-        <p:nvSpPr>
-          <p:cNvPr id="28" name="Shape 24"/>
+              <a:t>C-side agent: the customer contacted us first. The CP-side ticket may not be worked yet, or the CP never reported it.</a:t>
+            </a:r>
+            <a:endParaRPr lang="en-US" sz="850" dirty="0"/>
+          </a:p>
+        </p:txBody>
+      </p:sp>
+      <p:sp>
+        <p:nvSpPr>
+          <p:cNvPr id="13" name="Shape 9"/>
           <p:cNvSpPr/>
           <p:nvPr/>
         </p:nvSpPr>
         <p:spPr>
           <a:xfrm>
-            <a:off x="457200" y="2587752"/>
-            <a:ext cx="3246120" cy="310896"/>
+            <a:off x="457200" y="1537335"/>
+            <a:ext cx="3246120" cy="348615"/>
           </a:xfrm>
           <a:prstGeom prst="roundRect">
             <a:avLst>
-              <a:gd name="adj" fmla="val 23529"/>
+              <a:gd name="adj" fmla="val 20984"/>
+            </a:avLst>
+          </a:prstGeom>
+          <a:solidFill>
+            <a:srgbClr val="FFF3D6"/>
+          </a:solidFill>
+          <a:ln w="12700">
+            <a:solidFill>
+              <a:srgbClr val="9A6410"/>
+            </a:solidFill>
+            <a:prstDash val="solid"/>
+          </a:ln>
+        </p:spPr>
+      </p:sp>
+      <p:sp>
+        <p:nvSpPr>
+          <p:cNvPr id="14" name="Text 10"/>
+          <p:cNvSpPr txBox="1"/>
+          <p:nvPr/>
+        </p:nvSpPr>
+        <p:spPr>
+          <a:xfrm>
+            <a:off x="457200" y="1537335"/>
+            <a:ext cx="3246120" cy="348615"/>
+          </a:xfrm>
+          <a:prstGeom prst="rect">
+            <a:avLst/>
+          </a:prstGeom>
+          <a:noFill/>
+          <a:ln/>
+        </p:spPr>
+        <p:txBody>
+          <a:bodyPr wrap="square" lIns="0" tIns="0" rIns="0" bIns="0" rtlCol="0" anchor="ctr"/>
+          <a:lstStyle/>
+          <a:p>
+            <a:pPr algn="ctr" indent="0" marL="0">
+              <a:buNone/>
+            </a:pPr>
+            <a:r>
+              <a:rPr lang="en-US" sz="1000" b="1" dirty="0">
+                <a:solidFill>
+                  <a:srgbClr val="9A6410"/>
+                </a:solidFill>
+                <a:latin typeface="SF Pro Display" pitchFamily="34" charset="0"/>
+                <a:ea typeface="SF Pro Display" pitchFamily="34" charset="-122"/>
+                <a:cs typeface="SF Pro Display" pitchFamily="34" charset="-120"/>
+              </a:rPr>
+              <a:t>Check CP CRM: nothing on file</a:t>
+            </a:r>
+            <a:endParaRPr lang="en-US" sz="1000" dirty="0"/>
+          </a:p>
+        </p:txBody>
+      </p:sp>
+      <p:sp>
+        <p:nvSpPr>
+          <p:cNvPr id="15" name="Shape 11"/>
+          <p:cNvSpPr/>
+          <p:nvPr/>
+        </p:nvSpPr>
+        <p:spPr>
+          <a:xfrm>
+            <a:off x="2080260" y="1885950"/>
+            <a:ext cx="0" cy="91440"/>
+          </a:xfrm>
+          <a:prstGeom prst="line">
+            <a:avLst/>
+          </a:prstGeom>
+          <a:noFill/>
+          <a:ln w="12700">
+            <a:solidFill>
+              <a:srgbClr val="6E6E73"/>
+            </a:solidFill>
+            <a:prstDash val="solid"/>
+            <a:tailEnd type="triangle"/>
+          </a:ln>
+        </p:spPr>
+      </p:sp>
+      <p:sp>
+        <p:nvSpPr>
+          <p:cNvPr id="16" name="Shape 12"/>
+          <p:cNvSpPr/>
+          <p:nvPr/>
+        </p:nvSpPr>
+        <p:spPr>
+          <a:xfrm>
+            <a:off x="3703320" y="1711643"/>
+            <a:ext cx="182880" cy="0"/>
+          </a:xfrm>
+          <a:prstGeom prst="line">
+            <a:avLst/>
+          </a:prstGeom>
+          <a:noFill/>
+          <a:ln w="12700">
+            <a:solidFill>
+              <a:srgbClr val="6E6E73"/>
+            </a:solidFill>
+            <a:prstDash val="solid"/>
+          </a:ln>
+        </p:spPr>
+      </p:sp>
+      <p:sp>
+        <p:nvSpPr>
+          <p:cNvPr id="17" name="type2Desc"/>
+          <p:cNvSpPr txBox="1"/>
+          <p:nvPr/>
+        </p:nvSpPr>
+        <p:spPr>
+          <a:xfrm>
+            <a:off x="3977640" y="1500759"/>
+            <a:ext cx="4983480" cy="421767"/>
+          </a:xfrm>
+          <a:prstGeom prst="rect">
+            <a:avLst/>
+          </a:prstGeom>
+          <a:noFill/>
+          <a:ln/>
+        </p:spPr>
+        <p:txBody>
+          <a:bodyPr wrap="square" lIns="0" tIns="0" rIns="0" bIns="0" rtlCol="0" anchor="ctr"/>
+          <a:lstStyle/>
+          <a:p>
+            <a:pPr indent="0" marL="0">
+              <a:buNone/>
+            </a:pPr>
+            <a:r>
+              <a:rPr lang="en-US" sz="850" dirty="0">
+                <a:solidFill>
+                  <a:srgbClr val="6E6E73"/>
+                </a:solidFill>
+                <a:latin typeface="SF Pro Text" pitchFamily="34" charset="0"/>
+                <a:ea typeface="SF Pro Text" pitchFamily="34" charset="-122"/>
+                <a:cs typeface="SF Pro Text" pitchFamily="34" charset="-120"/>
+              </a:rPr>
+              <a:t>Nothing is confirmed yet. Treat it like any other unconfirmed claim.</a:t>
+            </a:r>
+            <a:endParaRPr lang="en-US" sz="850" dirty="0"/>
+          </a:p>
+        </p:txBody>
+      </p:sp>
+      <p:sp>
+        <p:nvSpPr>
+          <p:cNvPr id="18" name="Shape 14"/>
+          <p:cNvSpPr/>
+          <p:nvPr/>
+        </p:nvSpPr>
+        <p:spPr>
+          <a:xfrm>
+            <a:off x="457200" y="1977390"/>
+            <a:ext cx="3246120" cy="348615"/>
+          </a:xfrm>
+          <a:prstGeom prst="roundRect">
+            <a:avLst>
+              <a:gd name="adj" fmla="val 20984"/>
             </a:avLst>
           </a:prstGeom>
           <a:solidFill>
@@ -36483,14 +37723,14 @@
       </p:sp>
       <p:sp>
         <p:nvSpPr>
-          <p:cNvPr id="29" name="Text 25"/>
-          <p:cNvSpPr txBox="1"/>
-          <p:nvPr/>
-        </p:nvSpPr>
-        <p:spPr>
-          <a:xfrm>
-            <a:off x="457200" y="2587752"/>
-            <a:ext cx="3246120" cy="310896"/>
+          <p:cNvPr id="19" name="Text 15"/>
+          <p:cNvSpPr txBox="1"/>
+          <p:nvPr/>
+        </p:nvSpPr>
+        <p:spPr>
+          <a:xfrm>
+            <a:off x="457200" y="1977390"/>
+            <a:ext cx="3246120" cy="348615"/>
           </a:xfrm>
           <a:prstGeom prst="rect">
             <a:avLst/>
@@ -36514,7 +37754,7 @@
                 <a:ea typeface="SF Pro Display" pitchFamily="34" charset="-122"/>
                 <a:cs typeface="SF Pro Display" pitchFamily="34" charset="-120"/>
               </a:rPr>
-              <a:t>Contact the CP</a:t>
+              <a:t>Ask C for proof</a:t>
             </a:r>
             <a:endParaRPr lang="en-US" sz="1000" dirty="0"/>
           </a:p>
@@ -36522,14 +37762,14 @@
       </p:sp>
       <p:sp>
         <p:nvSpPr>
-          <p:cNvPr id="30" name="Shape 26"/>
+          <p:cNvPr id="20" name="Shape 16"/>
           <p:cNvSpPr/>
           <p:nvPr/>
         </p:nvSpPr>
         <p:spPr>
           <a:xfrm>
-            <a:off x="2080260" y="2898648"/>
-            <a:ext cx="0" cy="73152"/>
+            <a:off x="2080260" y="2326005"/>
+            <a:ext cx="0" cy="91440"/>
           </a:xfrm>
           <a:prstGeom prst="line">
             <a:avLst/>
@@ -36546,13 +37786,13 @@
       </p:sp>
       <p:sp>
         <p:nvSpPr>
-          <p:cNvPr id="31" name="Shape 27"/>
+          <p:cNvPr id="21" name="Shape 17"/>
           <p:cNvSpPr/>
           <p:nvPr/>
         </p:nvSpPr>
         <p:spPr>
           <a:xfrm>
-            <a:off x="3703320" y="2743200"/>
+            <a:off x="3703320" y="2151697"/>
             <a:ext cx="182880" cy="0"/>
           </a:xfrm>
           <a:prstGeom prst="line">
@@ -36569,14 +37809,14 @@
       </p:sp>
       <p:sp>
         <p:nvSpPr>
-          <p:cNvPr id="32" name="type5Desc"/>
-          <p:cNvSpPr txBox="1"/>
-          <p:nvPr/>
-        </p:nvSpPr>
-        <p:spPr>
-          <a:xfrm>
-            <a:off x="3977640" y="2551176"/>
-            <a:ext cx="4983480" cy="384048"/>
+          <p:cNvPr id="22" name="type3Desc"/>
+          <p:cNvSpPr txBox="1"/>
+          <p:nvPr/>
+        </p:nvSpPr>
+        <p:spPr>
+          <a:xfrm>
+            <a:off x="3977640" y="1940814"/>
+            <a:ext cx="4983480" cy="421767"/>
           </a:xfrm>
           <a:prstGeom prst="rect">
             <a:avLst/>
@@ -36592,7 +37832,7 @@
               <a:buNone/>
             </a:pPr>
             <a:r>
-              <a:rPr lang="en-US" sz="800" dirty="0">
+              <a:rPr lang="en-US" sz="850" dirty="0">
                 <a:solidFill>
                   <a:srgbClr val="6E6E73"/>
                 </a:solidFill>
@@ -36600,26 +37840,26 @@
                 <a:ea typeface="SF Pro Text" pitchFamily="34" charset="-122"/>
                 <a:cs typeface="SF Pro Text" pitchFamily="34" charset="-120"/>
               </a:rPr>
-              <a:t>Call within business hours (8AM–8PM CP local time). No answer: SMS. Outside business hours: email.</a:t>
-            </a:r>
-            <a:endParaRPr lang="en-US" sz="800" dirty="0"/>
-          </a:p>
-        </p:txBody>
-      </p:sp>
-      <p:sp>
-        <p:nvSpPr>
-          <p:cNvPr id="33" name="Shape 29"/>
+              <a:t>Encourage proof, don't require it.</a:t>
+            </a:r>
+            <a:endParaRPr lang="en-US" sz="850" dirty="0"/>
+          </a:p>
+        </p:txBody>
+      </p:sp>
+      <p:sp>
+        <p:nvSpPr>
+          <p:cNvPr id="23" name="Shape 19"/>
           <p:cNvSpPr/>
           <p:nvPr/>
         </p:nvSpPr>
         <p:spPr>
           <a:xfrm>
-            <a:off x="457200" y="2971800"/>
-            <a:ext cx="3246120" cy="310896"/>
+            <a:off x="457200" y="2417445"/>
+            <a:ext cx="3246120" cy="348615"/>
           </a:xfrm>
           <a:prstGeom prst="roundRect">
             <a:avLst>
-              <a:gd name="adj" fmla="val 23529"/>
+              <a:gd name="adj" fmla="val 20984"/>
             </a:avLst>
           </a:prstGeom>
           <a:solidFill>
@@ -36635,14 +37875,14 @@
       </p:sp>
       <p:sp>
         <p:nvSpPr>
-          <p:cNvPr id="34" name="Text 30"/>
-          <p:cNvSpPr txBox="1"/>
-          <p:nvPr/>
-        </p:nvSpPr>
-        <p:spPr>
-          <a:xfrm>
-            <a:off x="457200" y="2971800"/>
-            <a:ext cx="3246120" cy="310896"/>
+          <p:cNvPr id="24" name="Text 20"/>
+          <p:cNvSpPr txBox="1"/>
+          <p:nvPr/>
+        </p:nvSpPr>
+        <p:spPr>
+          <a:xfrm>
+            <a:off x="457200" y="2417445"/>
+            <a:ext cx="3246120" cy="348615"/>
           </a:xfrm>
           <a:prstGeom prst="rect">
             <a:avLst/>
@@ -36666,7 +37906,7 @@
                 <a:ea typeface="SF Pro Display" pitchFamily="34" charset="-122"/>
                 <a:cs typeface="SF Pro Display" pitchFamily="34" charset="-120"/>
               </a:rPr>
-              <a:t>Set a 48-hour Timed Reminder</a:t>
+              <a:t>Contact the CP</a:t>
             </a:r>
             <a:endParaRPr lang="en-US" sz="1000" dirty="0"/>
           </a:p>
@@ -36674,14 +37914,14 @@
       </p:sp>
       <p:sp>
         <p:nvSpPr>
-          <p:cNvPr id="35" name="Shape 31"/>
+          <p:cNvPr id="25" name="Shape 21"/>
           <p:cNvSpPr/>
           <p:nvPr/>
         </p:nvSpPr>
         <p:spPr>
           <a:xfrm>
-            <a:off x="2080260" y="3282696"/>
-            <a:ext cx="0" cy="73152"/>
+            <a:off x="2080260" y="2766060"/>
+            <a:ext cx="0" cy="91440"/>
           </a:xfrm>
           <a:prstGeom prst="line">
             <a:avLst/>
@@ -36698,13 +37938,13 @@
       </p:sp>
       <p:sp>
         <p:nvSpPr>
-          <p:cNvPr id="36" name="Shape 32"/>
+          <p:cNvPr id="26" name="Shape 22"/>
           <p:cNvSpPr/>
           <p:nvPr/>
         </p:nvSpPr>
         <p:spPr>
           <a:xfrm>
-            <a:off x="3703320" y="3127248"/>
+            <a:off x="3703320" y="2591752"/>
             <a:ext cx="182880" cy="0"/>
           </a:xfrm>
           <a:prstGeom prst="line">
@@ -36721,14 +37961,14 @@
       </p:sp>
       <p:sp>
         <p:nvSpPr>
-          <p:cNvPr id="37" name="type6Desc"/>
-          <p:cNvSpPr txBox="1"/>
-          <p:nvPr/>
-        </p:nvSpPr>
-        <p:spPr>
-          <a:xfrm>
-            <a:off x="3977640" y="2935224"/>
-            <a:ext cx="4983480" cy="384048"/>
+          <p:cNvPr id="27" name="type4Desc"/>
+          <p:cNvSpPr txBox="1"/>
+          <p:nvPr/>
+        </p:nvSpPr>
+        <p:spPr>
+          <a:xfrm>
+            <a:off x="3977640" y="2380869"/>
+            <a:ext cx="4983480" cy="421767"/>
           </a:xfrm>
           <a:prstGeom prst="rect">
             <a:avLst/>
@@ -36744,7 +37984,7 @@
               <a:buNone/>
             </a:pPr>
             <a:r>
-              <a:rPr lang="en-US" sz="800" dirty="0">
+              <a:rPr lang="en-US" sz="850" dirty="0">
                 <a:solidFill>
                   <a:srgbClr val="6E6E73"/>
                 </a:solidFill>
@@ -36752,26 +37992,26 @@
                 <a:ea typeface="SF Pro Text" pitchFamily="34" charset="-122"/>
                 <a:cs typeface="SF Pro Text" pitchFamily="34" charset="-120"/>
               </a:rPr>
-              <a:t>Pick the ticket back up when it triggers.</a:t>
-            </a:r>
-            <a:endParaRPr lang="en-US" sz="800" dirty="0"/>
-          </a:p>
-        </p:txBody>
-      </p:sp>
-      <p:sp>
-        <p:nvSpPr>
-          <p:cNvPr id="38" name="Shape 34"/>
+              <a:t>Call within business hours (8AM–8PM CP local time). No answer: SMS. Outside business hours: email.</a:t>
+            </a:r>
+            <a:endParaRPr lang="en-US" sz="850" dirty="0"/>
+          </a:p>
+        </p:txBody>
+      </p:sp>
+      <p:sp>
+        <p:nvSpPr>
+          <p:cNvPr id="28" name="Shape 24"/>
           <p:cNvSpPr/>
           <p:nvPr/>
         </p:nvSpPr>
         <p:spPr>
           <a:xfrm>
-            <a:off x="457200" y="3355848"/>
-            <a:ext cx="3246120" cy="310896"/>
+            <a:off x="457200" y="2857500"/>
+            <a:ext cx="3246120" cy="348615"/>
           </a:xfrm>
           <a:prstGeom prst="roundRect">
             <a:avLst>
-              <a:gd name="adj" fmla="val 23529"/>
+              <a:gd name="adj" fmla="val 20984"/>
             </a:avLst>
           </a:prstGeom>
           <a:solidFill>
@@ -36787,14 +38027,14 @@
       </p:sp>
       <p:sp>
         <p:nvSpPr>
-          <p:cNvPr id="39" name="Text 35"/>
-          <p:cNvSpPr txBox="1"/>
-          <p:nvPr/>
-        </p:nvSpPr>
-        <p:spPr>
-          <a:xfrm>
-            <a:off x="457200" y="3355848"/>
-            <a:ext cx="3246120" cy="310896"/>
+          <p:cNvPr id="29" name="Text 25"/>
+          <p:cNvSpPr txBox="1"/>
+          <p:nvPr/>
+        </p:nvSpPr>
+        <p:spPr>
+          <a:xfrm>
+            <a:off x="457200" y="2857500"/>
+            <a:ext cx="3246120" cy="348615"/>
           </a:xfrm>
           <a:prstGeom prst="rect">
             <a:avLst/>
@@ -36818,7 +38058,7 @@
                 <a:ea typeface="SF Pro Display" pitchFamily="34" charset="-122"/>
                 <a:cs typeface="SF Pro Display" pitchFamily="34" charset="-120"/>
               </a:rPr>
-              <a:t>C provides proof → hard ladder</a:t>
+              <a:t>Set a 48-hour Timed Reminder</a:t>
             </a:r>
             <a:endParaRPr lang="en-US" sz="1000" dirty="0"/>
           </a:p>
@@ -36826,14 +38066,14 @@
       </p:sp>
       <p:sp>
         <p:nvSpPr>
-          <p:cNvPr id="40" name="Shape 36"/>
+          <p:cNvPr id="30" name="Shape 26"/>
           <p:cNvSpPr/>
           <p:nvPr/>
         </p:nvSpPr>
         <p:spPr>
           <a:xfrm>
-            <a:off x="2080260" y="3666744"/>
-            <a:ext cx="0" cy="73152"/>
+            <a:off x="2080260" y="3206115"/>
+            <a:ext cx="0" cy="91440"/>
           </a:xfrm>
           <a:prstGeom prst="line">
             <a:avLst/>
@@ -36850,13 +38090,13 @@
       </p:sp>
       <p:sp>
         <p:nvSpPr>
-          <p:cNvPr id="41" name="Shape 37"/>
+          <p:cNvPr id="31" name="Shape 27"/>
           <p:cNvSpPr/>
           <p:nvPr/>
         </p:nvSpPr>
         <p:spPr>
           <a:xfrm>
-            <a:off x="3703320" y="3511296"/>
+            <a:off x="3703320" y="3031808"/>
             <a:ext cx="182880" cy="0"/>
           </a:xfrm>
           <a:prstGeom prst="line">
@@ -36873,14 +38113,14 @@
       </p:sp>
       <p:sp>
         <p:nvSpPr>
-          <p:cNvPr id="42" name="type7Desc"/>
-          <p:cNvSpPr txBox="1"/>
-          <p:nvPr/>
-        </p:nvSpPr>
-        <p:spPr>
-          <a:xfrm>
-            <a:off x="3977640" y="3319272"/>
-            <a:ext cx="4983480" cy="384048"/>
+          <p:cNvPr id="32" name="type5Desc"/>
+          <p:cNvSpPr txBox="1"/>
+          <p:nvPr/>
+        </p:nvSpPr>
+        <p:spPr>
+          <a:xfrm>
+            <a:off x="3977640" y="2820924"/>
+            <a:ext cx="4983480" cy="421767"/>
           </a:xfrm>
           <a:prstGeom prst="rect">
             <a:avLst/>
@@ -36896,7 +38136,7 @@
               <a:buNone/>
             </a:pPr>
             <a:r>
-              <a:rPr lang="en-US" sz="800" dirty="0">
+              <a:rPr lang="en-US" sz="850" dirty="0">
                 <a:solidFill>
                   <a:srgbClr val="6E6E73"/>
                 </a:solidFill>
@@ -36904,26 +38144,26 @@
                 <a:ea typeface="SF Pro Text" pitchFamily="34" charset="-122"/>
                 <a:cs typeface="SF Pro Text" pitchFamily="34" charset="-120"/>
               </a:rPr>
-              <a:t>Resolve per job status, whatever the CP says. It's treated as getting caught, not disclosing.</a:t>
-            </a:r>
-            <a:endParaRPr lang="en-US" sz="800" dirty="0"/>
-          </a:p>
-        </p:txBody>
-      </p:sp>
-      <p:sp>
-        <p:nvSpPr>
-          <p:cNvPr id="43" name="Shape 39"/>
+              <a:t>Pick the ticket back up when it triggers.</a:t>
+            </a:r>
+            <a:endParaRPr lang="en-US" sz="850" dirty="0"/>
+          </a:p>
+        </p:txBody>
+      </p:sp>
+      <p:sp>
+        <p:nvSpPr>
+          <p:cNvPr id="33" name="Shape 29"/>
           <p:cNvSpPr/>
           <p:nvPr/>
         </p:nvSpPr>
         <p:spPr>
           <a:xfrm>
-            <a:off x="457200" y="3739896"/>
-            <a:ext cx="3246120" cy="310896"/>
+            <a:off x="457200" y="3297555"/>
+            <a:ext cx="3246120" cy="348615"/>
           </a:xfrm>
           <a:prstGeom prst="roundRect">
             <a:avLst>
-              <a:gd name="adj" fmla="val 23529"/>
+              <a:gd name="adj" fmla="val 20984"/>
             </a:avLst>
           </a:prstGeom>
           <a:solidFill>
@@ -36939,14 +38179,14 @@
       </p:sp>
       <p:sp>
         <p:nvSpPr>
-          <p:cNvPr id="44" name="Text 40"/>
-          <p:cNvSpPr txBox="1"/>
-          <p:nvPr/>
-        </p:nvSpPr>
-        <p:spPr>
-          <a:xfrm>
-            <a:off x="457200" y="3739896"/>
-            <a:ext cx="3246120" cy="310896"/>
+          <p:cNvPr id="34" name="Text 30"/>
+          <p:cNvSpPr txBox="1"/>
+          <p:nvPr/>
+        </p:nvSpPr>
+        <p:spPr>
+          <a:xfrm>
+            <a:off x="457200" y="3297555"/>
+            <a:ext cx="3246120" cy="348615"/>
           </a:xfrm>
           <a:prstGeom prst="rect">
             <a:avLst/>
@@ -36970,7 +38210,7 @@
                 <a:ea typeface="SF Pro Display" pitchFamily="34" charset="-122"/>
                 <a:cs typeface="SF Pro Display" pitchFamily="34" charset="-120"/>
               </a:rPr>
-              <a:t>CP admits it → soft ladder</a:t>
+              <a:t>C provides proof → hard ladder</a:t>
             </a:r>
             <a:endParaRPr lang="en-US" sz="1000" dirty="0"/>
           </a:p>
@@ -36978,14 +38218,14 @@
       </p:sp>
       <p:sp>
         <p:nvSpPr>
-          <p:cNvPr id="45" name="Shape 41"/>
+          <p:cNvPr id="35" name="Shape 31"/>
           <p:cNvSpPr/>
           <p:nvPr/>
         </p:nvSpPr>
         <p:spPr>
           <a:xfrm>
-            <a:off x="2080260" y="4050792"/>
-            <a:ext cx="0" cy="73152"/>
+            <a:off x="2080260" y="3646170"/>
+            <a:ext cx="0" cy="91440"/>
           </a:xfrm>
           <a:prstGeom prst="line">
             <a:avLst/>
@@ -37002,13 +38242,13 @@
       </p:sp>
       <p:sp>
         <p:nvSpPr>
-          <p:cNvPr id="46" name="Shape 42"/>
+          <p:cNvPr id="36" name="Shape 32"/>
           <p:cNvSpPr/>
           <p:nvPr/>
         </p:nvSpPr>
         <p:spPr>
           <a:xfrm>
-            <a:off x="3703320" y="3895344"/>
+            <a:off x="3703320" y="3471863"/>
             <a:ext cx="182880" cy="0"/>
           </a:xfrm>
           <a:prstGeom prst="line">
@@ -37025,14 +38265,14 @@
       </p:sp>
       <p:sp>
         <p:nvSpPr>
-          <p:cNvPr id="47" name="type8Desc"/>
-          <p:cNvSpPr txBox="1"/>
-          <p:nvPr/>
-        </p:nvSpPr>
-        <p:spPr>
-          <a:xfrm>
-            <a:off x="3977640" y="3703320"/>
-            <a:ext cx="4983480" cy="384048"/>
+          <p:cNvPr id="37" name="type6Desc"/>
+          <p:cNvSpPr txBox="1"/>
+          <p:nvPr/>
+        </p:nvSpPr>
+        <p:spPr>
+          <a:xfrm>
+            <a:off x="3977640" y="3260979"/>
+            <a:ext cx="4983480" cy="421767"/>
           </a:xfrm>
           <a:prstGeom prst="rect">
             <a:avLst/>
@@ -37048,7 +38288,7 @@
               <a:buNone/>
             </a:pPr>
             <a:r>
-              <a:rPr lang="en-US" sz="800" dirty="0">
+              <a:rPr lang="en-US" sz="850" dirty="0">
                 <a:solidFill>
                   <a:srgbClr val="6E6E73"/>
                 </a:solidFill>
@@ -37056,26 +38296,178 @@
                 <a:ea typeface="SF Pro Text" pitchFamily="34" charset="-122"/>
                 <a:cs typeface="SF Pro Text" pitchFamily="34" charset="-120"/>
               </a:rPr>
-              <a:t>Resolve per job status. It's still an admission, just a later one.</a:t>
-            </a:r>
-            <a:endParaRPr lang="en-US" sz="800" dirty="0"/>
-          </a:p>
-        </p:txBody>
-      </p:sp>
-      <p:sp>
-        <p:nvSpPr>
-          <p:cNvPr id="48" name="Shape 44"/>
+              <a:t>Resolve per job status, whatever the CP says. It's treated as getting caught, not disclosing.</a:t>
+            </a:r>
+            <a:endParaRPr lang="en-US" sz="850" dirty="0"/>
+          </a:p>
+        </p:txBody>
+      </p:sp>
+      <p:sp>
+        <p:nvSpPr>
+          <p:cNvPr id="38" name="Shape 34"/>
           <p:cNvSpPr/>
           <p:nvPr/>
         </p:nvSpPr>
         <p:spPr>
           <a:xfrm>
-            <a:off x="457200" y="4123944"/>
-            <a:ext cx="3246120" cy="310896"/>
+            <a:off x="457200" y="3737610"/>
+            <a:ext cx="3246120" cy="348615"/>
           </a:xfrm>
           <a:prstGeom prst="roundRect">
             <a:avLst>
-              <a:gd name="adj" fmla="val 23529"/>
+              <a:gd name="adj" fmla="val 20984"/>
+            </a:avLst>
+          </a:prstGeom>
+          <a:solidFill>
+            <a:srgbClr val="0B7A6F"/>
+          </a:solidFill>
+          <a:ln w="12700">
+            <a:solidFill>
+              <a:srgbClr val="0B7A6F"/>
+            </a:solidFill>
+            <a:prstDash val="solid"/>
+          </a:ln>
+        </p:spPr>
+      </p:sp>
+      <p:sp>
+        <p:nvSpPr>
+          <p:cNvPr id="39" name="Text 35"/>
+          <p:cNvSpPr txBox="1"/>
+          <p:nvPr/>
+        </p:nvSpPr>
+        <p:spPr>
+          <a:xfrm>
+            <a:off x="457200" y="3737610"/>
+            <a:ext cx="3246120" cy="348615"/>
+          </a:xfrm>
+          <a:prstGeom prst="rect">
+            <a:avLst/>
+          </a:prstGeom>
+          <a:noFill/>
+          <a:ln/>
+        </p:spPr>
+        <p:txBody>
+          <a:bodyPr wrap="square" lIns="0" tIns="0" rIns="0" bIns="0" rtlCol="0" anchor="ctr"/>
+          <a:lstStyle/>
+          <a:p>
+            <a:pPr algn="ctr" indent="0" marL="0">
+              <a:buNone/>
+            </a:pPr>
+            <a:r>
+              <a:rPr lang="en-US" sz="1000" b="1" dirty="0">
+                <a:solidFill>
+                  <a:srgbClr val="FFFFFF"/>
+                </a:solidFill>
+                <a:latin typeface="SF Pro Display" pitchFamily="34" charset="0"/>
+                <a:ea typeface="SF Pro Display" pitchFamily="34" charset="-122"/>
+                <a:cs typeface="SF Pro Display" pitchFamily="34" charset="-120"/>
+              </a:rPr>
+              <a:t>CP admits it → soft ladder</a:t>
+            </a:r>
+            <a:endParaRPr lang="en-US" sz="1000" dirty="0"/>
+          </a:p>
+        </p:txBody>
+      </p:sp>
+      <p:sp>
+        <p:nvSpPr>
+          <p:cNvPr id="40" name="Shape 36"/>
+          <p:cNvSpPr/>
+          <p:nvPr/>
+        </p:nvSpPr>
+        <p:spPr>
+          <a:xfrm>
+            <a:off x="2080260" y="4086225"/>
+            <a:ext cx="0" cy="91440"/>
+          </a:xfrm>
+          <a:prstGeom prst="line">
+            <a:avLst/>
+          </a:prstGeom>
+          <a:noFill/>
+          <a:ln w="12700">
+            <a:solidFill>
+              <a:srgbClr val="6E6E73"/>
+            </a:solidFill>
+            <a:prstDash val="solid"/>
+            <a:tailEnd type="triangle"/>
+          </a:ln>
+        </p:spPr>
+      </p:sp>
+      <p:sp>
+        <p:nvSpPr>
+          <p:cNvPr id="41" name="Shape 37"/>
+          <p:cNvSpPr/>
+          <p:nvPr/>
+        </p:nvSpPr>
+        <p:spPr>
+          <a:xfrm>
+            <a:off x="3703320" y="3911917"/>
+            <a:ext cx="182880" cy="0"/>
+          </a:xfrm>
+          <a:prstGeom prst="line">
+            <a:avLst/>
+          </a:prstGeom>
+          <a:noFill/>
+          <a:ln w="12700">
+            <a:solidFill>
+              <a:srgbClr val="6E6E73"/>
+            </a:solidFill>
+            <a:prstDash val="solid"/>
+          </a:ln>
+        </p:spPr>
+      </p:sp>
+      <p:sp>
+        <p:nvSpPr>
+          <p:cNvPr id="42" name="type7Desc"/>
+          <p:cNvSpPr txBox="1"/>
+          <p:nvPr/>
+        </p:nvSpPr>
+        <p:spPr>
+          <a:xfrm>
+            <a:off x="3977640" y="3701034"/>
+            <a:ext cx="4983480" cy="421767"/>
+          </a:xfrm>
+          <a:prstGeom prst="rect">
+            <a:avLst/>
+          </a:prstGeom>
+          <a:noFill/>
+          <a:ln/>
+        </p:spPr>
+        <p:txBody>
+          <a:bodyPr wrap="square" lIns="0" tIns="0" rIns="0" bIns="0" rtlCol="0" anchor="ctr"/>
+          <a:lstStyle/>
+          <a:p>
+            <a:pPr indent="0" marL="0">
+              <a:buNone/>
+            </a:pPr>
+            <a:r>
+              <a:rPr lang="en-US" sz="850" dirty="0">
+                <a:solidFill>
+                  <a:srgbClr val="6E6E73"/>
+                </a:solidFill>
+                <a:latin typeface="SF Pro Text" pitchFamily="34" charset="0"/>
+                <a:ea typeface="SF Pro Text" pitchFamily="34" charset="-122"/>
+                <a:cs typeface="SF Pro Text" pitchFamily="34" charset="-120"/>
+              </a:rPr>
+              <a:t>Resolve per job status. It's still an admission, just a later one.</a:t>
+            </a:r>
+            <a:endParaRPr lang="en-US" sz="850" dirty="0"/>
+          </a:p>
+        </p:txBody>
+      </p:sp>
+      <p:sp>
+        <p:nvSpPr>
+          <p:cNvPr id="43" name="Shape 39"/>
+          <p:cNvSpPr/>
+          <p:nvPr/>
+        </p:nvSpPr>
+        <p:spPr>
+          <a:xfrm>
+            <a:off x="457200" y="4177665"/>
+            <a:ext cx="3246120" cy="348615"/>
+          </a:xfrm>
+          <a:prstGeom prst="roundRect">
+            <a:avLst>
+              <a:gd name="adj" fmla="val 20984"/>
             </a:avLst>
           </a:prstGeom>
           <a:solidFill>
@@ -37091,14 +38483,14 @@
       </p:sp>
       <p:sp>
         <p:nvSpPr>
-          <p:cNvPr id="49" name="Text 45"/>
-          <p:cNvSpPr txBox="1"/>
-          <p:nvPr/>
-        </p:nvSpPr>
-        <p:spPr>
-          <a:xfrm>
-            <a:off x="457200" y="4123944"/>
-            <a:ext cx="3246120" cy="310896"/>
+          <p:cNvPr id="44" name="Text 40"/>
+          <p:cNvSpPr txBox="1"/>
+          <p:nvPr/>
+        </p:nvSpPr>
+        <p:spPr>
+          <a:xfrm>
+            <a:off x="457200" y="4177665"/>
+            <a:ext cx="3246120" cy="348615"/>
           </a:xfrm>
           <a:prstGeom prst="rect">
             <a:avLst/>
@@ -37130,13 +38522,13 @@
       </p:sp>
       <p:sp>
         <p:nvSpPr>
-          <p:cNvPr id="50" name="Shape 46"/>
+          <p:cNvPr id="45" name="Shape 41"/>
           <p:cNvSpPr/>
           <p:nvPr/>
         </p:nvSpPr>
         <p:spPr>
           <a:xfrm>
-            <a:off x="3703320" y="4279392"/>
+            <a:off x="3703320" y="4351972"/>
             <a:ext cx="182880" cy="0"/>
           </a:xfrm>
           <a:prstGeom prst="line">
@@ -37153,14 +38545,14 @@
       </p:sp>
       <p:sp>
         <p:nvSpPr>
-          <p:cNvPr id="51" name="type9Desc"/>
-          <p:cNvSpPr txBox="1"/>
-          <p:nvPr/>
-        </p:nvSpPr>
-        <p:spPr>
-          <a:xfrm>
-            <a:off x="3977640" y="4087368"/>
-            <a:ext cx="4983480" cy="384048"/>
+          <p:cNvPr id="46" name="type8Desc"/>
+          <p:cNvSpPr txBox="1"/>
+          <p:nvPr/>
+        </p:nvSpPr>
+        <p:spPr>
+          <a:xfrm>
+            <a:off x="3977640" y="4141089"/>
+            <a:ext cx="4983480" cy="421767"/>
           </a:xfrm>
           <a:prstGeom prst="rect">
             <a:avLst/>
@@ -37176,7 +38568,7 @@
               <a:buNone/>
             </a:pPr>
             <a:r>
-              <a:rPr lang="en-US" sz="800" dirty="0">
+              <a:rPr lang="en-US" sz="850" dirty="0">
                 <a:solidFill>
                   <a:srgbClr val="6E6E73"/>
                 </a:solidFill>
@@ -37186,7 +38578,7 @@
               </a:rPr>
               <a:t>No refund, no penalty. High value: voucher for the full job hours. Otherwise $20–$50 credits. Reason: cash_payment.</a:t>
             </a:r>
-            <a:endParaRPr lang="en-US" sz="800" dirty="0"/>
+            <a:endParaRPr lang="en-US" sz="850" dirty="0"/>
           </a:p>
         </p:txBody>
       </p:sp>
@@ -37232,7 +38624,7 @@
             <a:pPr algn="r"/>
             <a:fld id="{F7021451-1387-4CA6-816F-3879F97B5CBC}" type="slidenum">
               <a:rPr b="0" lang="en-US"/>
-              <a:t>41</a:t>
+              <a:t>42</a:t>
             </a:fld>
             <a:endParaRPr lang="en-US"/>
           </a:p>
@@ -37616,55 +39008,7 @@
                                           </p:stCondLst>
                                         </p:cTn>
                                         <p:tgtEl>
-                                          <p:spTgt spid="47"/>
-                                        </p:tgtEl>
-                                        <p:attrNameLst>
-                                          <p:attrName>style.visibility</p:attrName>
-                                        </p:attrNameLst>
-                                      </p:cBhvr>
-                                      <p:to>
-                                        <p:strVal val="visible"/>
-                                      </p:to>
-                                    </p:set>
-                                  </p:childTnLst>
-                                </p:cTn>
-                              </p:par>
-                            </p:childTnLst>
-                          </p:cTn>
-                        </p:par>
-                      </p:childTnLst>
-                    </p:cTn>
-                  </p:par>
-                  <p:par>
-                    <p:cTn id="35" fill="hold">
-                      <p:stCondLst>
-                        <p:cond delay="indefinite"/>
-                      </p:stCondLst>
-                      <p:childTnLst>
-                        <p:par>
-                          <p:cTn id="36" fill="hold">
-                            <p:stCondLst>
-                              <p:cond delay="0"/>
-                            </p:stCondLst>
-                            <p:childTnLst>
-                              <p:par>
-                                <p:cTn id="37" presetID="1" presetClass="entr" presetSubtype="0" fill="hold" grpId="0" nodeType="clickEffect">
-                                  <p:stCondLst>
-                                    <p:cond delay="0"/>
-                                  </p:stCondLst>
-                                  <p:iterate type="lt">
-                                    <p:tmAbs val="40"/>
-                                  </p:iterate>
-                                  <p:childTnLst>
-                                    <p:set>
-                                      <p:cBhvr>
-                                        <p:cTn id="38" dur="1" fill="hold">
-                                          <p:stCondLst>
-                                            <p:cond delay="0"/>
-                                          </p:stCondLst>
-                                        </p:cTn>
-                                        <p:tgtEl>
-                                          <p:spTgt spid="51"/>
+                                          <p:spTgt spid="46"/>
                                         </p:tgtEl>
                                         <p:attrNameLst>
                                           <p:attrName>style.visibility</p:attrName>
@@ -37712,16 +39056,15 @@
       <p:bldP spid="32" grpId="0" animBg="1"/>
       <p:bldP spid="37" grpId="0" animBg="1"/>
       <p:bldP spid="42" grpId="0" animBg="1"/>
-      <p:bldP spid="47" grpId="0" animBg="1"/>
-      <p:bldP spid="51" grpId="0" animBg="1"/>
+      <p:bldP spid="46" grpId="0" animBg="1"/>
     </p:bldLst>
   </p:timing>
 </p:sld>
 </file>
 
-<file path=ppt/slides/slide42.xml><?xml version="1.0" encoding="utf-8"?>
+<file path=ppt/slides/slide43.xml><?xml version="1.0" encoding="utf-8"?>
 <p:sld xmlns:a="http://schemas.openxmlformats.org/drawingml/2006/main" xmlns:r="http://schemas.openxmlformats.org/officeDocument/2006/relationships" xmlns:p="http://schemas.openxmlformats.org/presentationml/2006/main">
-  <p:cSld name="Slide 42">
+  <p:cSld name="Slide 43">
     <p:spTree>
       <p:nvGrpSpPr>
         <p:cNvPr id="1" name=""/>
@@ -38679,7 +40022,7 @@
             <a:pPr algn="r"/>
             <a:fld id="{F7021451-1387-4CA6-816F-3879F97B5CBC}" type="slidenum">
               <a:rPr b="0" lang="en-US"/>
-              <a:t>42</a:t>
+              <a:t>43</a:t>
             </a:fld>
             <a:endParaRPr lang="en-US"/>
           </a:p>
@@ -38941,810 +40284,6 @@
 </p:sld>
 </file>
 
-<file path=ppt/slides/slide43.xml><?xml version="1.0" encoding="utf-8"?>
-<p:sld xmlns:a="http://schemas.openxmlformats.org/drawingml/2006/main" xmlns:r="http://schemas.openxmlformats.org/officeDocument/2006/relationships" xmlns:p="http://schemas.openxmlformats.org/presentationml/2006/main">
-  <p:cSld name="Slide 43">
-    <p:spTree>
-      <p:nvGrpSpPr>
-        <p:cNvPr id="1" name=""/>
-        <p:cNvGrpSpPr/>
-        <p:nvPr/>
-      </p:nvGrpSpPr>
-      <p:grpSpPr>
-        <a:xfrm>
-          <a:off x="0" y="0"/>
-          <a:ext cx="0" cy="0"/>
-          <a:chOff x="0" y="0"/>
-          <a:chExt cx="0" cy="0"/>
-        </a:xfrm>
-      </p:grpSpPr>
-      <p:sp>
-        <p:nvSpPr>
-          <p:cNvPr id="2" name="Text 0"/>
-          <p:cNvSpPr txBox="1"/>
-          <p:nvPr/>
-        </p:nvSpPr>
-        <p:spPr>
-          <a:xfrm>
-            <a:off x="438912" y="274320"/>
-            <a:ext cx="8229600" cy="182880"/>
-          </a:xfrm>
-          <a:prstGeom prst="rect">
-            <a:avLst/>
-          </a:prstGeom>
-          <a:noFill/>
-          <a:ln/>
-        </p:spPr>
-        <p:txBody>
-          <a:bodyPr wrap="square" lIns="0" tIns="0" rIns="0" bIns="0" rtlCol="0" anchor="t"/>
-          <a:lstStyle/>
-          <a:p>
-            <a:pPr indent="0" marL="0">
-              <a:buNone/>
-            </a:pPr>
-            <a:r>
-              <a:rPr lang="en-US" sz="800" b="1" spc="50" kern="0" dirty="0">
-                <a:solidFill>
-                  <a:srgbClr val="0B7A6F"/>
-                </a:solidFill>
-                <a:latin typeface="SF Pro Display" pitchFamily="34" charset="0"/>
-                <a:ea typeface="SF Pro Display" pitchFamily="34" charset="-122"/>
-                <a:cs typeface="SF Pro Display" pitchFamily="34" charset="-120"/>
-              </a:rPr>
-              <a:t>CASH PAYMENT  ·  WRAP-UP</a:t>
-            </a:r>
-            <a:endParaRPr lang="en-US" sz="800" dirty="0"/>
-          </a:p>
-        </p:txBody>
-      </p:sp>
-      <p:sp>
-        <p:nvSpPr>
-          <p:cNvPr id="3" name="Text 1"/>
-          <p:cNvSpPr txBox="1"/>
-          <p:nvPr/>
-        </p:nvSpPr>
-        <p:spPr>
-          <a:xfrm>
-            <a:off x="438912" y="457200"/>
-            <a:ext cx="8229600" cy="457200"/>
-          </a:xfrm>
-          <a:prstGeom prst="rect">
-            <a:avLst/>
-          </a:prstGeom>
-          <a:noFill/>
-          <a:ln/>
-        </p:spPr>
-        <p:txBody>
-          <a:bodyPr wrap="square" lIns="0" tIns="0" rIns="0" bIns="0" rtlCol="0" anchor="t"/>
-          <a:lstStyle/>
-          <a:p>
-            <a:pPr indent="0" marL="0">
-              <a:buNone/>
-            </a:pPr>
-            <a:r>
-              <a:rPr lang="en-US" sz="2400" b="1" dirty="0">
-                <a:solidFill>
-                  <a:srgbClr val="1D1D1F"/>
-                </a:solidFill>
-                <a:latin typeface="SF Pro Display" pitchFamily="34" charset="0"/>
-                <a:ea typeface="SF Pro Display" pitchFamily="34" charset="-122"/>
-                <a:cs typeface="SF Pro Display" pitchFamily="34" charset="-120"/>
-              </a:rPr>
-              <a:t>Wrap-up</a:t>
-            </a:r>
-            <a:endParaRPr lang="en-US" sz="2400" dirty="0"/>
-          </a:p>
-        </p:txBody>
-      </p:sp>
-      <p:sp>
-        <p:nvSpPr>
-          <p:cNvPr id="4" name="Text 2"/>
-          <p:cNvSpPr txBox="1"/>
-          <p:nvPr/>
-        </p:nvSpPr>
-        <p:spPr>
-          <a:xfrm>
-            <a:off x="438912" y="960120"/>
-            <a:ext cx="8229600" cy="274320"/>
-          </a:xfrm>
-          <a:prstGeom prst="rect">
-            <a:avLst/>
-          </a:prstGeom>
-          <a:noFill/>
-          <a:ln/>
-        </p:spPr>
-        <p:txBody>
-          <a:bodyPr wrap="square" lIns="0" tIns="0" rIns="0" bIns="0" rtlCol="0" anchor="t"/>
-          <a:lstStyle/>
-          <a:p>
-            <a:pPr indent="0" marL="0">
-              <a:buNone/>
-            </a:pPr>
-            <a:r>
-              <a:rPr lang="en-US" sz="1200" dirty="0">
-                <a:solidFill>
-                  <a:srgbClr val="6E6E73"/>
-                </a:solidFill>
-                <a:latin typeface="SF Pro Text" pitchFamily="34" charset="0"/>
-                <a:ea typeface="SF Pro Text" pitchFamily="34" charset="-122"/>
-                <a:cs typeface="SF Pro Text" pitchFamily="34" charset="-120"/>
-              </a:rPr>
-              <a:t>Key takeaways before we move on.</a:t>
-            </a:r>
-            <a:endParaRPr lang="en-US" sz="1200" dirty="0"/>
-          </a:p>
-        </p:txBody>
-      </p:sp>
-      <p:sp>
-        <p:nvSpPr>
-          <p:cNvPr id="6" name="Shape 3"/>
-          <p:cNvSpPr/>
-          <p:nvPr/>
-        </p:nvSpPr>
-        <p:spPr>
-          <a:xfrm>
-            <a:off x="411480" y="1325880"/>
-            <a:ext cx="2682240" cy="1600200"/>
-          </a:xfrm>
-          <a:prstGeom prst="roundRect">
-            <a:avLst>
-              <a:gd name="adj" fmla="val 4571"/>
-            </a:avLst>
-          </a:prstGeom>
-          <a:solidFill>
-            <a:srgbClr val="FFFFFF"/>
-          </a:solidFill>
-          <a:ln w="9525">
-            <a:solidFill>
-              <a:srgbClr val="DCE1E7"/>
-            </a:solidFill>
-            <a:prstDash val="solid"/>
-          </a:ln>
-        </p:spPr>
-      </p:sp>
-      <p:sp>
-        <p:nvSpPr>
-          <p:cNvPr id="7" name="Shape 4"/>
-          <p:cNvSpPr/>
-          <p:nvPr/>
-        </p:nvSpPr>
-        <p:spPr>
-          <a:xfrm>
-            <a:off x="576072" y="1508760"/>
-            <a:ext cx="274320" cy="274320"/>
-          </a:xfrm>
-          <a:prstGeom prst="ellipse">
-            <a:avLst/>
-          </a:prstGeom>
-          <a:solidFill>
-            <a:srgbClr val="E3F4F1"/>
-          </a:solidFill>
-          <a:ln w="12700">
-            <a:solidFill>
-              <a:srgbClr val="E3F4F1"/>
-            </a:solidFill>
-            <a:prstDash val="solid"/>
-          </a:ln>
-        </p:spPr>
-      </p:sp>
-      <p:sp>
-        <p:nvSpPr>
-          <p:cNvPr id="8" name="Text 5"/>
-          <p:cNvSpPr txBox="1"/>
-          <p:nvPr/>
-        </p:nvSpPr>
-        <p:spPr>
-          <a:xfrm>
-            <a:off x="576072" y="1508760"/>
-            <a:ext cx="274320" cy="274320"/>
-          </a:xfrm>
-          <a:prstGeom prst="rect">
-            <a:avLst/>
-          </a:prstGeom>
-          <a:noFill/>
-          <a:ln/>
-        </p:spPr>
-        <p:txBody>
-          <a:bodyPr wrap="square" lIns="0" tIns="0" rIns="0" bIns="0" rtlCol="0" anchor="ctr"/>
-          <a:lstStyle/>
-          <a:p>
-            <a:pPr algn="ctr" indent="0" marL="0">
-              <a:buNone/>
-            </a:pPr>
-            <a:r>
-              <a:rPr lang="en-US" sz="900" b="1" dirty="0">
-                <a:solidFill>
-                  <a:srgbClr val="0B7A6F"/>
-                </a:solidFill>
-                <a:latin typeface="SF Pro Display" pitchFamily="34" charset="0"/>
-                <a:ea typeface="SF Pro Display" pitchFamily="34" charset="-122"/>
-                <a:cs typeface="SF Pro Display" pitchFamily="34" charset="-120"/>
-              </a:rPr>
-              <a:t>1</a:t>
-            </a:r>
-            <a:endParaRPr lang="en-US" sz="900" dirty="0"/>
-          </a:p>
-        </p:txBody>
-      </p:sp>
-      <p:sp>
-        <p:nvSpPr>
-          <p:cNvPr id="9" name="Text 6"/>
-          <p:cNvSpPr txBox="1"/>
-          <p:nvPr/>
-        </p:nvSpPr>
-        <p:spPr>
-          <a:xfrm>
-            <a:off x="576072" y="1929384"/>
-            <a:ext cx="2353056" cy="274320"/>
-          </a:xfrm>
-          <a:prstGeom prst="rect">
-            <a:avLst/>
-          </a:prstGeom>
-          <a:noFill/>
-          <a:ln/>
-        </p:spPr>
-        <p:txBody>
-          <a:bodyPr wrap="square" lIns="0" tIns="0" rIns="0" bIns="0" rtlCol="0" anchor="t"/>
-          <a:lstStyle/>
-          <a:p>
-            <a:pPr indent="0" marL="0">
-              <a:buNone/>
-            </a:pPr>
-            <a:r>
-              <a:rPr lang="en-US" sz="1200" b="1" dirty="0">
-                <a:solidFill>
-                  <a:srgbClr val="1D1D1F"/>
-                </a:solidFill>
-                <a:latin typeface="SF Pro Display" pitchFamily="34" charset="0"/>
-                <a:ea typeface="SF Pro Display" pitchFamily="34" charset="-122"/>
-                <a:cs typeface="SF Pro Display" pitchFamily="34" charset="-120"/>
-              </a:rPr>
-              <a:t>Status decides the action</a:t>
-            </a:r>
-            <a:endParaRPr lang="en-US" sz="1200" dirty="0"/>
-          </a:p>
-        </p:txBody>
-      </p:sp>
-      <p:sp>
-        <p:nvSpPr>
-          <p:cNvPr id="10" name="Text 7"/>
-          <p:cNvSpPr txBox="1"/>
-          <p:nvPr/>
-        </p:nvSpPr>
-        <p:spPr>
-          <a:xfrm>
-            <a:off x="576072" y="2221992"/>
-            <a:ext cx="2353056" cy="612648"/>
-          </a:xfrm>
-          <a:prstGeom prst="rect">
-            <a:avLst/>
-          </a:prstGeom>
-          <a:noFill/>
-          <a:ln/>
-        </p:spPr>
-        <p:txBody>
-          <a:bodyPr wrap="square" lIns="0" tIns="0" rIns="0" bIns="0" rtlCol="0" anchor="t"/>
-          <a:lstStyle/>
-          <a:p>
-            <a:pPr indent="0" marL="0">
-              <a:buNone/>
-            </a:pPr>
-            <a:r>
-              <a:rPr lang="en-US" sz="950" dirty="0">
-                <a:solidFill>
-                  <a:srgbClr val="6E6E73"/>
-                </a:solidFill>
-                <a:latin typeface="SF Pro Text" pitchFamily="34" charset="0"/>
-                <a:ea typeface="SF Pro Text" pitchFamily="34" charset="-122"/>
-                <a:cs typeface="SF Pro Text" pitchFamily="34" charset="-120"/>
-              </a:rPr>
-              <a:t>Pending Invoice: cancel. Invoiced: refund. Cancelled: don't recreate.</a:t>
-            </a:r>
-            <a:endParaRPr lang="en-US" sz="950" dirty="0"/>
-          </a:p>
-        </p:txBody>
-      </p:sp>
-      <p:sp>
-        <p:nvSpPr>
-          <p:cNvPr id="11" name="Shape 8"/>
-          <p:cNvSpPr/>
-          <p:nvPr/>
-        </p:nvSpPr>
-        <p:spPr>
-          <a:xfrm>
-            <a:off x="3230880" y="1325880"/>
-            <a:ext cx="2682240" cy="1600200"/>
-          </a:xfrm>
-          <a:prstGeom prst="roundRect">
-            <a:avLst>
-              <a:gd name="adj" fmla="val 4571"/>
-            </a:avLst>
-          </a:prstGeom>
-          <a:solidFill>
-            <a:srgbClr val="FFFFFF"/>
-          </a:solidFill>
-          <a:ln w="9525">
-            <a:solidFill>
-              <a:srgbClr val="DCE1E7"/>
-            </a:solidFill>
-            <a:prstDash val="solid"/>
-          </a:ln>
-        </p:spPr>
-      </p:sp>
-      <p:sp>
-        <p:nvSpPr>
-          <p:cNvPr id="12" name="Shape 9"/>
-          <p:cNvSpPr/>
-          <p:nvPr/>
-        </p:nvSpPr>
-        <p:spPr>
-          <a:xfrm>
-            <a:off x="3395472" y="1508760"/>
-            <a:ext cx="274320" cy="274320"/>
-          </a:xfrm>
-          <a:prstGeom prst="ellipse">
-            <a:avLst/>
-          </a:prstGeom>
-          <a:solidFill>
-            <a:srgbClr val="E3F4F1"/>
-          </a:solidFill>
-          <a:ln w="12700">
-            <a:solidFill>
-              <a:srgbClr val="E3F4F1"/>
-            </a:solidFill>
-            <a:prstDash val="solid"/>
-          </a:ln>
-        </p:spPr>
-      </p:sp>
-      <p:sp>
-        <p:nvSpPr>
-          <p:cNvPr id="13" name="Text 10"/>
-          <p:cNvSpPr txBox="1"/>
-          <p:nvPr/>
-        </p:nvSpPr>
-        <p:spPr>
-          <a:xfrm>
-            <a:off x="3395472" y="1508760"/>
-            <a:ext cx="274320" cy="274320"/>
-          </a:xfrm>
-          <a:prstGeom prst="rect">
-            <a:avLst/>
-          </a:prstGeom>
-          <a:noFill/>
-          <a:ln/>
-        </p:spPr>
-        <p:txBody>
-          <a:bodyPr wrap="square" lIns="0" tIns="0" rIns="0" bIns="0" rtlCol="0" anchor="ctr"/>
-          <a:lstStyle/>
-          <a:p>
-            <a:pPr algn="ctr" indent="0" marL="0">
-              <a:buNone/>
-            </a:pPr>
-            <a:r>
-              <a:rPr lang="en-US" sz="900" b="1" dirty="0">
-                <a:solidFill>
-                  <a:srgbClr val="0B7A6F"/>
-                </a:solidFill>
-                <a:latin typeface="SF Pro Display" pitchFamily="34" charset="0"/>
-                <a:ea typeface="SF Pro Display" pitchFamily="34" charset="-122"/>
-                <a:cs typeface="SF Pro Display" pitchFamily="34" charset="-120"/>
-              </a:rPr>
-              <a:t>2</a:t>
-            </a:r>
-            <a:endParaRPr lang="en-US" sz="900" dirty="0"/>
-          </a:p>
-        </p:txBody>
-      </p:sp>
-      <p:sp>
-        <p:nvSpPr>
-          <p:cNvPr id="14" name="Text 11"/>
-          <p:cNvSpPr txBox="1"/>
-          <p:nvPr/>
-        </p:nvSpPr>
-        <p:spPr>
-          <a:xfrm>
-            <a:off x="3395472" y="1929384"/>
-            <a:ext cx="2353056" cy="274320"/>
-          </a:xfrm>
-          <a:prstGeom prst="rect">
-            <a:avLst/>
-          </a:prstGeom>
-          <a:noFill/>
-          <a:ln/>
-        </p:spPr>
-        <p:txBody>
-          <a:bodyPr wrap="square" lIns="0" tIns="0" rIns="0" bIns="0" rtlCol="0" anchor="t"/>
-          <a:lstStyle/>
-          <a:p>
-            <a:pPr indent="0" marL="0">
-              <a:buNone/>
-            </a:pPr>
-            <a:r>
-              <a:rPr lang="en-US" sz="1200" b="1" dirty="0">
-                <a:solidFill>
-                  <a:srgbClr val="1D1D1F"/>
-                </a:solidFill>
-                <a:latin typeface="SF Pro Display" pitchFamily="34" charset="0"/>
-                <a:ea typeface="SF Pro Display" pitchFamily="34" charset="-122"/>
-                <a:cs typeface="SF Pro Display" pitchFamily="34" charset="-120"/>
-              </a:rPr>
-              <a:t>Get the amount first</a:t>
-            </a:r>
-            <a:endParaRPr lang="en-US" sz="1200" dirty="0"/>
-          </a:p>
-        </p:txBody>
-      </p:sp>
-      <p:sp>
-        <p:nvSpPr>
-          <p:cNvPr id="15" name="Text 12"/>
-          <p:cNvSpPr txBox="1"/>
-          <p:nvPr/>
-        </p:nvSpPr>
-        <p:spPr>
-          <a:xfrm>
-            <a:off x="3395472" y="2221992"/>
-            <a:ext cx="2353056" cy="612648"/>
-          </a:xfrm>
-          <a:prstGeom prst="rect">
-            <a:avLst/>
-          </a:prstGeom>
-          <a:noFill/>
-          <a:ln/>
-        </p:spPr>
-        <p:txBody>
-          <a:bodyPr wrap="square" lIns="0" tIns="0" rIns="0" bIns="0" rtlCol="0" anchor="t"/>
-          <a:lstStyle/>
-          <a:p>
-            <a:pPr indent="0" marL="0">
-              <a:buNone/>
-            </a:pPr>
-            <a:r>
-              <a:rPr lang="en-US" sz="950" dirty="0">
-                <a:solidFill>
-                  <a:srgbClr val="6E6E73"/>
-                </a:solidFill>
-                <a:latin typeface="SF Pro Text" pitchFamily="34" charset="0"/>
-                <a:ea typeface="SF Pro Text" pitchFamily="34" charset="-122"/>
-                <a:cs typeface="SF Pro Text" pitchFamily="34" charset="-120"/>
-              </a:rPr>
-              <a:t>Full vs partial is based on CP Pay, not the C Price.</a:t>
-            </a:r>
-            <a:endParaRPr lang="en-US" sz="950" dirty="0"/>
-          </a:p>
-        </p:txBody>
-      </p:sp>
-      <p:sp>
-        <p:nvSpPr>
-          <p:cNvPr id="16" name="Shape 13"/>
-          <p:cNvSpPr/>
-          <p:nvPr/>
-        </p:nvSpPr>
-        <p:spPr>
-          <a:xfrm>
-            <a:off x="6050280" y="1325880"/>
-            <a:ext cx="2682240" cy="1600200"/>
-          </a:xfrm>
-          <a:prstGeom prst="roundRect">
-            <a:avLst>
-              <a:gd name="adj" fmla="val 4571"/>
-            </a:avLst>
-          </a:prstGeom>
-          <a:solidFill>
-            <a:srgbClr val="FFFFFF"/>
-          </a:solidFill>
-          <a:ln w="9525">
-            <a:solidFill>
-              <a:srgbClr val="DCE1E7"/>
-            </a:solidFill>
-            <a:prstDash val="solid"/>
-          </a:ln>
-        </p:spPr>
-      </p:sp>
-      <p:sp>
-        <p:nvSpPr>
-          <p:cNvPr id="17" name="Shape 14"/>
-          <p:cNvSpPr/>
-          <p:nvPr/>
-        </p:nvSpPr>
-        <p:spPr>
-          <a:xfrm>
-            <a:off x="6214872" y="1508760"/>
-            <a:ext cx="274320" cy="274320"/>
-          </a:xfrm>
-          <a:prstGeom prst="ellipse">
-            <a:avLst/>
-          </a:prstGeom>
-          <a:solidFill>
-            <a:srgbClr val="E3F4F1"/>
-          </a:solidFill>
-          <a:ln w="12700">
-            <a:solidFill>
-              <a:srgbClr val="E3F4F1"/>
-            </a:solidFill>
-            <a:prstDash val="solid"/>
-          </a:ln>
-        </p:spPr>
-      </p:sp>
-      <p:sp>
-        <p:nvSpPr>
-          <p:cNvPr id="18" name="Text 15"/>
-          <p:cNvSpPr txBox="1"/>
-          <p:nvPr/>
-        </p:nvSpPr>
-        <p:spPr>
-          <a:xfrm>
-            <a:off x="6214872" y="1508760"/>
-            <a:ext cx="274320" cy="274320"/>
-          </a:xfrm>
-          <a:prstGeom prst="rect">
-            <a:avLst/>
-          </a:prstGeom>
-          <a:noFill/>
-          <a:ln/>
-        </p:spPr>
-        <p:txBody>
-          <a:bodyPr wrap="square" lIns="0" tIns="0" rIns="0" bIns="0" rtlCol="0" anchor="ctr"/>
-          <a:lstStyle/>
-          <a:p>
-            <a:pPr algn="ctr" indent="0" marL="0">
-              <a:buNone/>
-            </a:pPr>
-            <a:r>
-              <a:rPr lang="en-US" sz="900" b="1" dirty="0">
-                <a:solidFill>
-                  <a:srgbClr val="0B7A6F"/>
-                </a:solidFill>
-                <a:latin typeface="SF Pro Display" pitchFamily="34" charset="0"/>
-                <a:ea typeface="SF Pro Display" pitchFamily="34" charset="-122"/>
-                <a:cs typeface="SF Pro Display" pitchFamily="34" charset="-120"/>
-              </a:rPr>
-              <a:t>3</a:t>
-            </a:r>
-            <a:endParaRPr lang="en-US" sz="900" dirty="0"/>
-          </a:p>
-        </p:txBody>
-      </p:sp>
-      <p:sp>
-        <p:nvSpPr>
-          <p:cNvPr id="19" name="Text 16"/>
-          <p:cNvSpPr txBox="1"/>
-          <p:nvPr/>
-        </p:nvSpPr>
-        <p:spPr>
-          <a:xfrm>
-            <a:off x="6214872" y="1929384"/>
-            <a:ext cx="2353056" cy="274320"/>
-          </a:xfrm>
-          <a:prstGeom prst="rect">
-            <a:avLst/>
-          </a:prstGeom>
-          <a:noFill/>
-          <a:ln/>
-        </p:spPr>
-        <p:txBody>
-          <a:bodyPr wrap="square" lIns="0" tIns="0" rIns="0" bIns="0" rtlCol="0" anchor="t"/>
-          <a:lstStyle/>
-          <a:p>
-            <a:pPr indent="0" marL="0">
-              <a:buNone/>
-            </a:pPr>
-            <a:r>
-              <a:rPr lang="en-US" sz="1200" b="1" dirty="0">
-                <a:solidFill>
-                  <a:srgbClr val="1D1D1F"/>
-                </a:solidFill>
-                <a:latin typeface="SF Pro Display" pitchFamily="34" charset="0"/>
-                <a:ea typeface="SF Pro Display" pitchFamily="34" charset="-122"/>
-                <a:cs typeface="SF Pro Display" pitchFamily="34" charset="-120"/>
-              </a:rPr>
-              <a:t>Never penalize the customer</a:t>
-            </a:r>
-            <a:endParaRPr lang="en-US" sz="1200" dirty="0"/>
-          </a:p>
-        </p:txBody>
-      </p:sp>
-      <p:sp>
-        <p:nvSpPr>
-          <p:cNvPr id="20" name="Text 17"/>
-          <p:cNvSpPr txBox="1"/>
-          <p:nvPr/>
-        </p:nvSpPr>
-        <p:spPr>
-          <a:xfrm>
-            <a:off x="6214872" y="2221992"/>
-            <a:ext cx="2353056" cy="612648"/>
-          </a:xfrm>
-          <a:prstGeom prst="rect">
-            <a:avLst/>
-          </a:prstGeom>
-          <a:noFill/>
-          <a:ln/>
-        </p:spPr>
-        <p:txBody>
-          <a:bodyPr wrap="square" lIns="0" tIns="0" rIns="0" bIns="0" rtlCol="0" anchor="t"/>
-          <a:lstStyle/>
-          <a:p>
-            <a:pPr indent="0" marL="0">
-              <a:buNone/>
-            </a:pPr>
-            <a:r>
-              <a:rPr lang="en-US" sz="950" dirty="0">
-                <a:solidFill>
-                  <a:srgbClr val="6E6E73"/>
-                </a:solidFill>
-                <a:latin typeface="SF Pro Text" pitchFamily="34" charset="0"/>
-                <a:ea typeface="SF Pro Text" pitchFamily="34" charset="-122"/>
-                <a:cs typeface="SF Pro Text" pitchFamily="34" charset="-120"/>
-              </a:rPr>
-              <a:t>Coach the cleaner. C-side never suspends or adds DNR.</a:t>
-            </a:r>
-            <a:endParaRPr lang="en-US" sz="950" dirty="0"/>
-          </a:p>
-        </p:txBody>
-      </p:sp>
-      <p:sp>
-        <p:nvSpPr>
-          <p:cNvPr id="21" name="Shape 18"/>
-          <p:cNvSpPr/>
-          <p:nvPr/>
-        </p:nvSpPr>
-        <p:spPr>
-          <a:xfrm>
-            <a:off x="411480" y="3108960"/>
-            <a:ext cx="8321040" cy="914400"/>
-          </a:xfrm>
-          <a:prstGeom prst="roundRect">
-            <a:avLst>
-              <a:gd name="adj" fmla="val 8000"/>
-            </a:avLst>
-          </a:prstGeom>
-          <a:solidFill>
-            <a:srgbClr val="0B7A6F"/>
-          </a:solidFill>
-          <a:ln w="9525">
-            <a:solidFill>
-              <a:srgbClr val="0B7A6F"/>
-            </a:solidFill>
-            <a:prstDash val="solid"/>
-          </a:ln>
-        </p:spPr>
-      </p:sp>
-      <p:pic>
-        <p:nvPicPr>
-          <p:cNvPr id="22" name="Image 0" descr="preencoded.png">    </p:cNvPr>
-          <p:cNvPicPr>
-            <a:picLocks noChangeAspect="1"/>
-          </p:cNvPicPr>
-          <p:nvPr/>
-        </p:nvPicPr>
-        <p:blipFill>
-          <a:blip r:embed="rId1"/>
-          <a:stretch>
-            <a:fillRect/>
-          </a:stretch>
-        </p:blipFill>
-        <p:spPr>
-          <a:xfrm>
-            <a:off x="731520" y="3383280"/>
-            <a:ext cx="365760" cy="365760"/>
-          </a:xfrm>
-          <a:prstGeom prst="rect">
-            <a:avLst/>
-          </a:prstGeom>
-        </p:spPr>
-      </p:pic>
-      <p:sp>
-        <p:nvSpPr>
-          <p:cNvPr id="23" name="Text 19"/>
-          <p:cNvSpPr txBox="1"/>
-          <p:nvPr/>
-        </p:nvSpPr>
-        <p:spPr>
-          <a:xfrm>
-            <a:off x="1325880" y="3108960"/>
-            <a:ext cx="7223760" cy="914400"/>
-          </a:xfrm>
-          <a:prstGeom prst="rect">
-            <a:avLst/>
-          </a:prstGeom>
-          <a:noFill/>
-          <a:ln/>
-        </p:spPr>
-        <p:txBody>
-          <a:bodyPr wrap="square" lIns="0" tIns="0" rIns="0" bIns="0" rtlCol="0" anchor="ctr"/>
-          <a:lstStyle/>
-          <a:p>
-            <a:pPr indent="0" marL="0">
-              <a:buNone/>
-            </a:pPr>
-            <a:r>
-              <a:rPr lang="en-US" sz="2000" b="1" dirty="0">
-                <a:solidFill>
-                  <a:srgbClr val="FFFFFF"/>
-                </a:solidFill>
-                <a:latin typeface="SF Pro Display" pitchFamily="34" charset="0"/>
-                <a:ea typeface="SF Pro Display" pitchFamily="34" charset="-122"/>
-                <a:cs typeface="SF Pro Display" pitchFamily="34" charset="-120"/>
-              </a:rPr>
-              <a:t>Questions?</a:t>
-            </a:r>
-            <a:endParaRPr lang="en-US" sz="2000" dirty="0"/>
-          </a:p>
-          <a:p>
-            <a:pPr indent="0" marL="0">
-              <a:buNone/>
-            </a:pPr>
-            <a:r>
-              <a:rPr lang="en-US" sz="1100" dirty="0">
-                <a:solidFill>
-                  <a:srgbClr val="FFFFFF"/>
-                </a:solidFill>
-                <a:latin typeface="SF Pro Text" pitchFamily="34" charset="0"/>
-                <a:ea typeface="SF Pro Text" pitchFamily="34" charset="-122"/>
-                <a:cs typeface="SF Pro Text" pitchFamily="34" charset="-120"/>
-              </a:rPr>
-              <a:t>Open the floor before we move to the next topic.</a:t>
-            </a:r>
-            <a:endParaRPr lang="en-US" sz="2000" dirty="0"/>
-          </a:p>
-        </p:txBody>
-      </p:sp>
-      <p:sp>
-        <p:nvSpPr>
-          <p:cNvPr id="25" name="Slide Number Placeholder 0"/>
-          <p:cNvSpPr>
-            <a:spLocks noGrp="1"/>
-          </p:cNvSpPr>
-          <p:nvPr>
-            <p:ph type="sldNum" sz="quarter" idx="4294967295"/>
-          </p:nvPr>
-        </p:nvSpPr>
-        <p:spPr>
-          <a:xfrm>
-            <a:off x="8229600" y="4800600"/>
-            <a:ext cx="457200" cy="182880"/>
-          </a:xfrm>
-          <a:prstGeom prst="rect">
-            <a:avLst/>
-          </a:prstGeom>
-          <a:extLst>
-            <a:ext uri="{C572A759-6A51-4108-AA02-DFA0A04FC94B}">
-              <ma14:wrappingTextBoxFlag xmlns:ma14="http://schemas.microsoft.com/office/mac/drawingml/2011/main" val="0"/>
-            </a:ext>
-          </a:extLst>
-        </p:spPr>
-        <p:txBody>
-          <a:bodyPr/>
-          <a:lstStyle>
-            <a:lvl1pPr>
-              <a:defRPr sz="700">
-                <a:solidFill>
-                  <a:srgbClr val="6E6E73"/>
-                </a:solidFill>
-                <a:latin typeface="SF Pro Text"/>
-                <a:ea typeface="SF Pro Text"/>
-                <a:cs typeface="SF Pro Text"/>
-              </a:defRPr>
-            </a:lvl1pPr>
-          </a:lstStyle>
-          <a:p>
-            <a:pPr algn="r"/>
-            <a:fld id="{F7021451-1387-4CA6-816F-3879F97B5CBC}" type="slidenum">
-              <a:rPr b="0" lang="en-US"/>
-              <a:t>43</a:t>
-            </a:fld>
-            <a:endParaRPr lang="en-US"/>
-          </a:p>
-        </p:txBody>
-      </p:sp>
-    </p:spTree>
-  </p:cSld>
-  <p:clrMapOvr>
-    <a:masterClrMapping/>
-  </p:clrMapOvr>
-</p:sld>
-</file>
-
 <file path=ppt/slides/slide44.xml><?xml version="1.0" encoding="utf-8"?>
 <p:sld xmlns:a="http://schemas.openxmlformats.org/drawingml/2006/main" xmlns:r="http://schemas.openxmlformats.org/officeDocument/2006/relationships" xmlns:p="http://schemas.openxmlformats.org/presentationml/2006/main">
   <p:cSld name="Slide 44">
@@ -39770,6 +40309,810 @@
         </p:nvSpPr>
         <p:spPr>
           <a:xfrm>
+            <a:off x="438912" y="274320"/>
+            <a:ext cx="8229600" cy="182880"/>
+          </a:xfrm>
+          <a:prstGeom prst="rect">
+            <a:avLst/>
+          </a:prstGeom>
+          <a:noFill/>
+          <a:ln/>
+        </p:spPr>
+        <p:txBody>
+          <a:bodyPr wrap="square" lIns="0" tIns="0" rIns="0" bIns="0" rtlCol="0" anchor="t"/>
+          <a:lstStyle/>
+          <a:p>
+            <a:pPr indent="0" marL="0">
+              <a:buNone/>
+            </a:pPr>
+            <a:r>
+              <a:rPr lang="en-US" sz="800" b="1" spc="50" kern="0" dirty="0">
+                <a:solidFill>
+                  <a:srgbClr val="0B7A6F"/>
+                </a:solidFill>
+                <a:latin typeface="SF Pro Display" pitchFamily="34" charset="0"/>
+                <a:ea typeface="SF Pro Display" pitchFamily="34" charset="-122"/>
+                <a:cs typeface="SF Pro Display" pitchFamily="34" charset="-120"/>
+              </a:rPr>
+              <a:t>CASH PAYMENT  ·  WRAP-UP</a:t>
+            </a:r>
+            <a:endParaRPr lang="en-US" sz="800" dirty="0"/>
+          </a:p>
+        </p:txBody>
+      </p:sp>
+      <p:sp>
+        <p:nvSpPr>
+          <p:cNvPr id="3" name="Text 1"/>
+          <p:cNvSpPr txBox="1"/>
+          <p:nvPr/>
+        </p:nvSpPr>
+        <p:spPr>
+          <a:xfrm>
+            <a:off x="438912" y="457200"/>
+            <a:ext cx="8229600" cy="457200"/>
+          </a:xfrm>
+          <a:prstGeom prst="rect">
+            <a:avLst/>
+          </a:prstGeom>
+          <a:noFill/>
+          <a:ln/>
+        </p:spPr>
+        <p:txBody>
+          <a:bodyPr wrap="square" lIns="0" tIns="0" rIns="0" bIns="0" rtlCol="0" anchor="t"/>
+          <a:lstStyle/>
+          <a:p>
+            <a:pPr indent="0" marL="0">
+              <a:buNone/>
+            </a:pPr>
+            <a:r>
+              <a:rPr lang="en-US" sz="2400" b="1" dirty="0">
+                <a:solidFill>
+                  <a:srgbClr val="1D1D1F"/>
+                </a:solidFill>
+                <a:latin typeface="SF Pro Display" pitchFamily="34" charset="0"/>
+                <a:ea typeface="SF Pro Display" pitchFamily="34" charset="-122"/>
+                <a:cs typeface="SF Pro Display" pitchFamily="34" charset="-120"/>
+              </a:rPr>
+              <a:t>Wrap-up</a:t>
+            </a:r>
+            <a:endParaRPr lang="en-US" sz="2400" dirty="0"/>
+          </a:p>
+        </p:txBody>
+      </p:sp>
+      <p:sp>
+        <p:nvSpPr>
+          <p:cNvPr id="4" name="Text 2"/>
+          <p:cNvSpPr txBox="1"/>
+          <p:nvPr/>
+        </p:nvSpPr>
+        <p:spPr>
+          <a:xfrm>
+            <a:off x="438912" y="960120"/>
+            <a:ext cx="8229600" cy="274320"/>
+          </a:xfrm>
+          <a:prstGeom prst="rect">
+            <a:avLst/>
+          </a:prstGeom>
+          <a:noFill/>
+          <a:ln/>
+        </p:spPr>
+        <p:txBody>
+          <a:bodyPr wrap="square" lIns="0" tIns="0" rIns="0" bIns="0" rtlCol="0" anchor="t"/>
+          <a:lstStyle/>
+          <a:p>
+            <a:pPr indent="0" marL="0">
+              <a:buNone/>
+            </a:pPr>
+            <a:r>
+              <a:rPr lang="en-US" sz="1200" dirty="0">
+                <a:solidFill>
+                  <a:srgbClr val="6E6E73"/>
+                </a:solidFill>
+                <a:latin typeface="SF Pro Text" pitchFamily="34" charset="0"/>
+                <a:ea typeface="SF Pro Text" pitchFamily="34" charset="-122"/>
+                <a:cs typeface="SF Pro Text" pitchFamily="34" charset="-120"/>
+              </a:rPr>
+              <a:t>Key takeaways before we move on.</a:t>
+            </a:r>
+            <a:endParaRPr lang="en-US" sz="1200" dirty="0"/>
+          </a:p>
+        </p:txBody>
+      </p:sp>
+      <p:sp>
+        <p:nvSpPr>
+          <p:cNvPr id="6" name="Shape 3"/>
+          <p:cNvSpPr/>
+          <p:nvPr/>
+        </p:nvSpPr>
+        <p:spPr>
+          <a:xfrm>
+            <a:off x="411480" y="1325880"/>
+            <a:ext cx="2682240" cy="1600200"/>
+          </a:xfrm>
+          <a:prstGeom prst="roundRect">
+            <a:avLst>
+              <a:gd name="adj" fmla="val 4571"/>
+            </a:avLst>
+          </a:prstGeom>
+          <a:solidFill>
+            <a:srgbClr val="FFFFFF"/>
+          </a:solidFill>
+          <a:ln w="9525">
+            <a:solidFill>
+              <a:srgbClr val="DCE1E7"/>
+            </a:solidFill>
+            <a:prstDash val="solid"/>
+          </a:ln>
+        </p:spPr>
+      </p:sp>
+      <p:sp>
+        <p:nvSpPr>
+          <p:cNvPr id="7" name="Shape 4"/>
+          <p:cNvSpPr/>
+          <p:nvPr/>
+        </p:nvSpPr>
+        <p:spPr>
+          <a:xfrm>
+            <a:off x="576072" y="1508760"/>
+            <a:ext cx="274320" cy="274320"/>
+          </a:xfrm>
+          <a:prstGeom prst="ellipse">
+            <a:avLst/>
+          </a:prstGeom>
+          <a:solidFill>
+            <a:srgbClr val="E3F4F1"/>
+          </a:solidFill>
+          <a:ln w="12700">
+            <a:solidFill>
+              <a:srgbClr val="E3F4F1"/>
+            </a:solidFill>
+            <a:prstDash val="solid"/>
+          </a:ln>
+        </p:spPr>
+      </p:sp>
+      <p:sp>
+        <p:nvSpPr>
+          <p:cNvPr id="8" name="Text 5"/>
+          <p:cNvSpPr txBox="1"/>
+          <p:nvPr/>
+        </p:nvSpPr>
+        <p:spPr>
+          <a:xfrm>
+            <a:off x="576072" y="1508760"/>
+            <a:ext cx="274320" cy="274320"/>
+          </a:xfrm>
+          <a:prstGeom prst="rect">
+            <a:avLst/>
+          </a:prstGeom>
+          <a:noFill/>
+          <a:ln/>
+        </p:spPr>
+        <p:txBody>
+          <a:bodyPr wrap="square" lIns="0" tIns="0" rIns="0" bIns="0" rtlCol="0" anchor="ctr"/>
+          <a:lstStyle/>
+          <a:p>
+            <a:pPr algn="ctr" indent="0" marL="0">
+              <a:buNone/>
+            </a:pPr>
+            <a:r>
+              <a:rPr lang="en-US" sz="900" b="1" dirty="0">
+                <a:solidFill>
+                  <a:srgbClr val="0B7A6F"/>
+                </a:solidFill>
+                <a:latin typeface="SF Pro Display" pitchFamily="34" charset="0"/>
+                <a:ea typeface="SF Pro Display" pitchFamily="34" charset="-122"/>
+                <a:cs typeface="SF Pro Display" pitchFamily="34" charset="-120"/>
+              </a:rPr>
+              <a:t>1</a:t>
+            </a:r>
+            <a:endParaRPr lang="en-US" sz="900" dirty="0"/>
+          </a:p>
+        </p:txBody>
+      </p:sp>
+      <p:sp>
+        <p:nvSpPr>
+          <p:cNvPr id="9" name="Text 6"/>
+          <p:cNvSpPr txBox="1"/>
+          <p:nvPr/>
+        </p:nvSpPr>
+        <p:spPr>
+          <a:xfrm>
+            <a:off x="576072" y="1929384"/>
+            <a:ext cx="2353056" cy="274320"/>
+          </a:xfrm>
+          <a:prstGeom prst="rect">
+            <a:avLst/>
+          </a:prstGeom>
+          <a:noFill/>
+          <a:ln/>
+        </p:spPr>
+        <p:txBody>
+          <a:bodyPr wrap="square" lIns="0" tIns="0" rIns="0" bIns="0" rtlCol="0" anchor="t"/>
+          <a:lstStyle/>
+          <a:p>
+            <a:pPr indent="0" marL="0">
+              <a:buNone/>
+            </a:pPr>
+            <a:r>
+              <a:rPr lang="en-US" sz="1200" b="1" dirty="0">
+                <a:solidFill>
+                  <a:srgbClr val="1D1D1F"/>
+                </a:solidFill>
+                <a:latin typeface="SF Pro Display" pitchFamily="34" charset="0"/>
+                <a:ea typeface="SF Pro Display" pitchFamily="34" charset="-122"/>
+                <a:cs typeface="SF Pro Display" pitchFamily="34" charset="-120"/>
+              </a:rPr>
+              <a:t>Status decides the action</a:t>
+            </a:r>
+            <a:endParaRPr lang="en-US" sz="1200" dirty="0"/>
+          </a:p>
+        </p:txBody>
+      </p:sp>
+      <p:sp>
+        <p:nvSpPr>
+          <p:cNvPr id="10" name="Text 7"/>
+          <p:cNvSpPr txBox="1"/>
+          <p:nvPr/>
+        </p:nvSpPr>
+        <p:spPr>
+          <a:xfrm>
+            <a:off x="576072" y="2221992"/>
+            <a:ext cx="2353056" cy="612648"/>
+          </a:xfrm>
+          <a:prstGeom prst="rect">
+            <a:avLst/>
+          </a:prstGeom>
+          <a:noFill/>
+          <a:ln/>
+        </p:spPr>
+        <p:txBody>
+          <a:bodyPr wrap="square" lIns="0" tIns="0" rIns="0" bIns="0" rtlCol="0" anchor="t"/>
+          <a:lstStyle/>
+          <a:p>
+            <a:pPr indent="0" marL="0">
+              <a:buNone/>
+            </a:pPr>
+            <a:r>
+              <a:rPr lang="en-US" sz="950" dirty="0">
+                <a:solidFill>
+                  <a:srgbClr val="6E6E73"/>
+                </a:solidFill>
+                <a:latin typeface="SF Pro Text" pitchFamily="34" charset="0"/>
+                <a:ea typeface="SF Pro Text" pitchFamily="34" charset="-122"/>
+                <a:cs typeface="SF Pro Text" pitchFamily="34" charset="-120"/>
+              </a:rPr>
+              <a:t>Pending Invoice: cancel. Invoiced: refund. Cancelled: don't recreate.</a:t>
+            </a:r>
+            <a:endParaRPr lang="en-US" sz="950" dirty="0"/>
+          </a:p>
+        </p:txBody>
+      </p:sp>
+      <p:sp>
+        <p:nvSpPr>
+          <p:cNvPr id="11" name="Shape 8"/>
+          <p:cNvSpPr/>
+          <p:nvPr/>
+        </p:nvSpPr>
+        <p:spPr>
+          <a:xfrm>
+            <a:off x="3230880" y="1325880"/>
+            <a:ext cx="2682240" cy="1600200"/>
+          </a:xfrm>
+          <a:prstGeom prst="roundRect">
+            <a:avLst>
+              <a:gd name="adj" fmla="val 4571"/>
+            </a:avLst>
+          </a:prstGeom>
+          <a:solidFill>
+            <a:srgbClr val="FFFFFF"/>
+          </a:solidFill>
+          <a:ln w="9525">
+            <a:solidFill>
+              <a:srgbClr val="DCE1E7"/>
+            </a:solidFill>
+            <a:prstDash val="solid"/>
+          </a:ln>
+        </p:spPr>
+      </p:sp>
+      <p:sp>
+        <p:nvSpPr>
+          <p:cNvPr id="12" name="Shape 9"/>
+          <p:cNvSpPr/>
+          <p:nvPr/>
+        </p:nvSpPr>
+        <p:spPr>
+          <a:xfrm>
+            <a:off x="3395472" y="1508760"/>
+            <a:ext cx="274320" cy="274320"/>
+          </a:xfrm>
+          <a:prstGeom prst="ellipse">
+            <a:avLst/>
+          </a:prstGeom>
+          <a:solidFill>
+            <a:srgbClr val="E3F4F1"/>
+          </a:solidFill>
+          <a:ln w="12700">
+            <a:solidFill>
+              <a:srgbClr val="E3F4F1"/>
+            </a:solidFill>
+            <a:prstDash val="solid"/>
+          </a:ln>
+        </p:spPr>
+      </p:sp>
+      <p:sp>
+        <p:nvSpPr>
+          <p:cNvPr id="13" name="Text 10"/>
+          <p:cNvSpPr txBox="1"/>
+          <p:nvPr/>
+        </p:nvSpPr>
+        <p:spPr>
+          <a:xfrm>
+            <a:off x="3395472" y="1508760"/>
+            <a:ext cx="274320" cy="274320"/>
+          </a:xfrm>
+          <a:prstGeom prst="rect">
+            <a:avLst/>
+          </a:prstGeom>
+          <a:noFill/>
+          <a:ln/>
+        </p:spPr>
+        <p:txBody>
+          <a:bodyPr wrap="square" lIns="0" tIns="0" rIns="0" bIns="0" rtlCol="0" anchor="ctr"/>
+          <a:lstStyle/>
+          <a:p>
+            <a:pPr algn="ctr" indent="0" marL="0">
+              <a:buNone/>
+            </a:pPr>
+            <a:r>
+              <a:rPr lang="en-US" sz="900" b="1" dirty="0">
+                <a:solidFill>
+                  <a:srgbClr val="0B7A6F"/>
+                </a:solidFill>
+                <a:latin typeface="SF Pro Display" pitchFamily="34" charset="0"/>
+                <a:ea typeface="SF Pro Display" pitchFamily="34" charset="-122"/>
+                <a:cs typeface="SF Pro Display" pitchFamily="34" charset="-120"/>
+              </a:rPr>
+              <a:t>2</a:t>
+            </a:r>
+            <a:endParaRPr lang="en-US" sz="900" dirty="0"/>
+          </a:p>
+        </p:txBody>
+      </p:sp>
+      <p:sp>
+        <p:nvSpPr>
+          <p:cNvPr id="14" name="Text 11"/>
+          <p:cNvSpPr txBox="1"/>
+          <p:nvPr/>
+        </p:nvSpPr>
+        <p:spPr>
+          <a:xfrm>
+            <a:off x="3395472" y="1929384"/>
+            <a:ext cx="2353056" cy="274320"/>
+          </a:xfrm>
+          <a:prstGeom prst="rect">
+            <a:avLst/>
+          </a:prstGeom>
+          <a:noFill/>
+          <a:ln/>
+        </p:spPr>
+        <p:txBody>
+          <a:bodyPr wrap="square" lIns="0" tIns="0" rIns="0" bIns="0" rtlCol="0" anchor="t"/>
+          <a:lstStyle/>
+          <a:p>
+            <a:pPr indent="0" marL="0">
+              <a:buNone/>
+            </a:pPr>
+            <a:r>
+              <a:rPr lang="en-US" sz="1200" b="1" dirty="0">
+                <a:solidFill>
+                  <a:srgbClr val="1D1D1F"/>
+                </a:solidFill>
+                <a:latin typeface="SF Pro Display" pitchFamily="34" charset="0"/>
+                <a:ea typeface="SF Pro Display" pitchFamily="34" charset="-122"/>
+                <a:cs typeface="SF Pro Display" pitchFamily="34" charset="-120"/>
+              </a:rPr>
+              <a:t>Get the amount first</a:t>
+            </a:r>
+            <a:endParaRPr lang="en-US" sz="1200" dirty="0"/>
+          </a:p>
+        </p:txBody>
+      </p:sp>
+      <p:sp>
+        <p:nvSpPr>
+          <p:cNvPr id="15" name="Text 12"/>
+          <p:cNvSpPr txBox="1"/>
+          <p:nvPr/>
+        </p:nvSpPr>
+        <p:spPr>
+          <a:xfrm>
+            <a:off x="3395472" y="2221992"/>
+            <a:ext cx="2353056" cy="612648"/>
+          </a:xfrm>
+          <a:prstGeom prst="rect">
+            <a:avLst/>
+          </a:prstGeom>
+          <a:noFill/>
+          <a:ln/>
+        </p:spPr>
+        <p:txBody>
+          <a:bodyPr wrap="square" lIns="0" tIns="0" rIns="0" bIns="0" rtlCol="0" anchor="t"/>
+          <a:lstStyle/>
+          <a:p>
+            <a:pPr indent="0" marL="0">
+              <a:buNone/>
+            </a:pPr>
+            <a:r>
+              <a:rPr lang="en-US" sz="950" dirty="0">
+                <a:solidFill>
+                  <a:srgbClr val="6E6E73"/>
+                </a:solidFill>
+                <a:latin typeface="SF Pro Text" pitchFamily="34" charset="0"/>
+                <a:ea typeface="SF Pro Text" pitchFamily="34" charset="-122"/>
+                <a:cs typeface="SF Pro Text" pitchFamily="34" charset="-120"/>
+              </a:rPr>
+              <a:t>Full vs partial is based on CP Pay, not the C Price.</a:t>
+            </a:r>
+            <a:endParaRPr lang="en-US" sz="950" dirty="0"/>
+          </a:p>
+        </p:txBody>
+      </p:sp>
+      <p:sp>
+        <p:nvSpPr>
+          <p:cNvPr id="16" name="Shape 13"/>
+          <p:cNvSpPr/>
+          <p:nvPr/>
+        </p:nvSpPr>
+        <p:spPr>
+          <a:xfrm>
+            <a:off x="6050280" y="1325880"/>
+            <a:ext cx="2682240" cy="1600200"/>
+          </a:xfrm>
+          <a:prstGeom prst="roundRect">
+            <a:avLst>
+              <a:gd name="adj" fmla="val 4571"/>
+            </a:avLst>
+          </a:prstGeom>
+          <a:solidFill>
+            <a:srgbClr val="FFFFFF"/>
+          </a:solidFill>
+          <a:ln w="9525">
+            <a:solidFill>
+              <a:srgbClr val="DCE1E7"/>
+            </a:solidFill>
+            <a:prstDash val="solid"/>
+          </a:ln>
+        </p:spPr>
+      </p:sp>
+      <p:sp>
+        <p:nvSpPr>
+          <p:cNvPr id="17" name="Shape 14"/>
+          <p:cNvSpPr/>
+          <p:nvPr/>
+        </p:nvSpPr>
+        <p:spPr>
+          <a:xfrm>
+            <a:off x="6214872" y="1508760"/>
+            <a:ext cx="274320" cy="274320"/>
+          </a:xfrm>
+          <a:prstGeom prst="ellipse">
+            <a:avLst/>
+          </a:prstGeom>
+          <a:solidFill>
+            <a:srgbClr val="E3F4F1"/>
+          </a:solidFill>
+          <a:ln w="12700">
+            <a:solidFill>
+              <a:srgbClr val="E3F4F1"/>
+            </a:solidFill>
+            <a:prstDash val="solid"/>
+          </a:ln>
+        </p:spPr>
+      </p:sp>
+      <p:sp>
+        <p:nvSpPr>
+          <p:cNvPr id="18" name="Text 15"/>
+          <p:cNvSpPr txBox="1"/>
+          <p:nvPr/>
+        </p:nvSpPr>
+        <p:spPr>
+          <a:xfrm>
+            <a:off x="6214872" y="1508760"/>
+            <a:ext cx="274320" cy="274320"/>
+          </a:xfrm>
+          <a:prstGeom prst="rect">
+            <a:avLst/>
+          </a:prstGeom>
+          <a:noFill/>
+          <a:ln/>
+        </p:spPr>
+        <p:txBody>
+          <a:bodyPr wrap="square" lIns="0" tIns="0" rIns="0" bIns="0" rtlCol="0" anchor="ctr"/>
+          <a:lstStyle/>
+          <a:p>
+            <a:pPr algn="ctr" indent="0" marL="0">
+              <a:buNone/>
+            </a:pPr>
+            <a:r>
+              <a:rPr lang="en-US" sz="900" b="1" dirty="0">
+                <a:solidFill>
+                  <a:srgbClr val="0B7A6F"/>
+                </a:solidFill>
+                <a:latin typeface="SF Pro Display" pitchFamily="34" charset="0"/>
+                <a:ea typeface="SF Pro Display" pitchFamily="34" charset="-122"/>
+                <a:cs typeface="SF Pro Display" pitchFamily="34" charset="-120"/>
+              </a:rPr>
+              <a:t>3</a:t>
+            </a:r>
+            <a:endParaRPr lang="en-US" sz="900" dirty="0"/>
+          </a:p>
+        </p:txBody>
+      </p:sp>
+      <p:sp>
+        <p:nvSpPr>
+          <p:cNvPr id="19" name="Text 16"/>
+          <p:cNvSpPr txBox="1"/>
+          <p:nvPr/>
+        </p:nvSpPr>
+        <p:spPr>
+          <a:xfrm>
+            <a:off x="6214872" y="1929384"/>
+            <a:ext cx="2353056" cy="274320"/>
+          </a:xfrm>
+          <a:prstGeom prst="rect">
+            <a:avLst/>
+          </a:prstGeom>
+          <a:noFill/>
+          <a:ln/>
+        </p:spPr>
+        <p:txBody>
+          <a:bodyPr wrap="square" lIns="0" tIns="0" rIns="0" bIns="0" rtlCol="0" anchor="t"/>
+          <a:lstStyle/>
+          <a:p>
+            <a:pPr indent="0" marL="0">
+              <a:buNone/>
+            </a:pPr>
+            <a:r>
+              <a:rPr lang="en-US" sz="1200" b="1" dirty="0">
+                <a:solidFill>
+                  <a:srgbClr val="1D1D1F"/>
+                </a:solidFill>
+                <a:latin typeface="SF Pro Display" pitchFamily="34" charset="0"/>
+                <a:ea typeface="SF Pro Display" pitchFamily="34" charset="-122"/>
+                <a:cs typeface="SF Pro Display" pitchFamily="34" charset="-120"/>
+              </a:rPr>
+              <a:t>Never penalize the customer</a:t>
+            </a:r>
+            <a:endParaRPr lang="en-US" sz="1200" dirty="0"/>
+          </a:p>
+        </p:txBody>
+      </p:sp>
+      <p:sp>
+        <p:nvSpPr>
+          <p:cNvPr id="20" name="Text 17"/>
+          <p:cNvSpPr txBox="1"/>
+          <p:nvPr/>
+        </p:nvSpPr>
+        <p:spPr>
+          <a:xfrm>
+            <a:off x="6214872" y="2221992"/>
+            <a:ext cx="2353056" cy="612648"/>
+          </a:xfrm>
+          <a:prstGeom prst="rect">
+            <a:avLst/>
+          </a:prstGeom>
+          <a:noFill/>
+          <a:ln/>
+        </p:spPr>
+        <p:txBody>
+          <a:bodyPr wrap="square" lIns="0" tIns="0" rIns="0" bIns="0" rtlCol="0" anchor="t"/>
+          <a:lstStyle/>
+          <a:p>
+            <a:pPr indent="0" marL="0">
+              <a:buNone/>
+            </a:pPr>
+            <a:r>
+              <a:rPr lang="en-US" sz="950" dirty="0">
+                <a:solidFill>
+                  <a:srgbClr val="6E6E73"/>
+                </a:solidFill>
+                <a:latin typeface="SF Pro Text" pitchFamily="34" charset="0"/>
+                <a:ea typeface="SF Pro Text" pitchFamily="34" charset="-122"/>
+                <a:cs typeface="SF Pro Text" pitchFamily="34" charset="-120"/>
+              </a:rPr>
+              <a:t>Coach the cleaner. C-side never suspends or adds DNR.</a:t>
+            </a:r>
+            <a:endParaRPr lang="en-US" sz="950" dirty="0"/>
+          </a:p>
+        </p:txBody>
+      </p:sp>
+      <p:sp>
+        <p:nvSpPr>
+          <p:cNvPr id="21" name="Shape 18"/>
+          <p:cNvSpPr/>
+          <p:nvPr/>
+        </p:nvSpPr>
+        <p:spPr>
+          <a:xfrm>
+            <a:off x="411480" y="3108960"/>
+            <a:ext cx="8321040" cy="914400"/>
+          </a:xfrm>
+          <a:prstGeom prst="roundRect">
+            <a:avLst>
+              <a:gd name="adj" fmla="val 8000"/>
+            </a:avLst>
+          </a:prstGeom>
+          <a:solidFill>
+            <a:srgbClr val="0B7A6F"/>
+          </a:solidFill>
+          <a:ln w="9525">
+            <a:solidFill>
+              <a:srgbClr val="0B7A6F"/>
+            </a:solidFill>
+            <a:prstDash val="solid"/>
+          </a:ln>
+        </p:spPr>
+      </p:sp>
+      <p:pic>
+        <p:nvPicPr>
+          <p:cNvPr id="22" name="Image 0" descr="preencoded.png">    </p:cNvPr>
+          <p:cNvPicPr>
+            <a:picLocks noChangeAspect="1"/>
+          </p:cNvPicPr>
+          <p:nvPr/>
+        </p:nvPicPr>
+        <p:blipFill>
+          <a:blip r:embed="rId1"/>
+          <a:stretch>
+            <a:fillRect/>
+          </a:stretch>
+        </p:blipFill>
+        <p:spPr>
+          <a:xfrm>
+            <a:off x="731520" y="3383280"/>
+            <a:ext cx="365760" cy="365760"/>
+          </a:xfrm>
+          <a:prstGeom prst="rect">
+            <a:avLst/>
+          </a:prstGeom>
+        </p:spPr>
+      </p:pic>
+      <p:sp>
+        <p:nvSpPr>
+          <p:cNvPr id="23" name="Text 19"/>
+          <p:cNvSpPr txBox="1"/>
+          <p:nvPr/>
+        </p:nvSpPr>
+        <p:spPr>
+          <a:xfrm>
+            <a:off x="1325880" y="3108960"/>
+            <a:ext cx="7223760" cy="914400"/>
+          </a:xfrm>
+          <a:prstGeom prst="rect">
+            <a:avLst/>
+          </a:prstGeom>
+          <a:noFill/>
+          <a:ln/>
+        </p:spPr>
+        <p:txBody>
+          <a:bodyPr wrap="square" lIns="0" tIns="0" rIns="0" bIns="0" rtlCol="0" anchor="ctr"/>
+          <a:lstStyle/>
+          <a:p>
+            <a:pPr indent="0" marL="0">
+              <a:buNone/>
+            </a:pPr>
+            <a:r>
+              <a:rPr lang="en-US" sz="2000" b="1" dirty="0">
+                <a:solidFill>
+                  <a:srgbClr val="FFFFFF"/>
+                </a:solidFill>
+                <a:latin typeface="SF Pro Display" pitchFamily="34" charset="0"/>
+                <a:ea typeface="SF Pro Display" pitchFamily="34" charset="-122"/>
+                <a:cs typeface="SF Pro Display" pitchFamily="34" charset="-120"/>
+              </a:rPr>
+              <a:t>Questions?</a:t>
+            </a:r>
+            <a:endParaRPr lang="en-US" sz="2000" dirty="0"/>
+          </a:p>
+          <a:p>
+            <a:pPr indent="0" marL="0">
+              <a:buNone/>
+            </a:pPr>
+            <a:r>
+              <a:rPr lang="en-US" sz="1100" dirty="0">
+                <a:solidFill>
+                  <a:srgbClr val="FFFFFF"/>
+                </a:solidFill>
+                <a:latin typeface="SF Pro Text" pitchFamily="34" charset="0"/>
+                <a:ea typeface="SF Pro Text" pitchFamily="34" charset="-122"/>
+                <a:cs typeface="SF Pro Text" pitchFamily="34" charset="-120"/>
+              </a:rPr>
+              <a:t>Open the floor before we move to the next topic.</a:t>
+            </a:r>
+            <a:endParaRPr lang="en-US" sz="2000" dirty="0"/>
+          </a:p>
+        </p:txBody>
+      </p:sp>
+      <p:sp>
+        <p:nvSpPr>
+          <p:cNvPr id="25" name="Slide Number Placeholder 0"/>
+          <p:cNvSpPr>
+            <a:spLocks noGrp="1"/>
+          </p:cNvSpPr>
+          <p:nvPr>
+            <p:ph type="sldNum" sz="quarter" idx="4294967295"/>
+          </p:nvPr>
+        </p:nvSpPr>
+        <p:spPr>
+          <a:xfrm>
+            <a:off x="8229600" y="4800600"/>
+            <a:ext cx="457200" cy="182880"/>
+          </a:xfrm>
+          <a:prstGeom prst="rect">
+            <a:avLst/>
+          </a:prstGeom>
+          <a:extLst>
+            <a:ext uri="{C572A759-6A51-4108-AA02-DFA0A04FC94B}">
+              <ma14:wrappingTextBoxFlag xmlns:ma14="http://schemas.microsoft.com/office/mac/drawingml/2011/main" val="0"/>
+            </a:ext>
+          </a:extLst>
+        </p:spPr>
+        <p:txBody>
+          <a:bodyPr/>
+          <a:lstStyle>
+            <a:lvl1pPr>
+              <a:defRPr sz="700">
+                <a:solidFill>
+                  <a:srgbClr val="6E6E73"/>
+                </a:solidFill>
+                <a:latin typeface="SF Pro Text"/>
+                <a:ea typeface="SF Pro Text"/>
+                <a:cs typeface="SF Pro Text"/>
+              </a:defRPr>
+            </a:lvl1pPr>
+          </a:lstStyle>
+          <a:p>
+            <a:pPr algn="r"/>
+            <a:fld id="{F7021451-1387-4CA6-816F-3879F97B5CBC}" type="slidenum">
+              <a:rPr b="0" lang="en-US"/>
+              <a:t>44</a:t>
+            </a:fld>
+            <a:endParaRPr lang="en-US"/>
+          </a:p>
+        </p:txBody>
+      </p:sp>
+    </p:spTree>
+  </p:cSld>
+  <p:clrMapOvr>
+    <a:masterClrMapping/>
+  </p:clrMapOvr>
+</p:sld>
+</file>
+
+<file path=ppt/slides/slide45.xml><?xml version="1.0" encoding="utf-8"?>
+<p:sld xmlns:a="http://schemas.openxmlformats.org/drawingml/2006/main" xmlns:r="http://schemas.openxmlformats.org/officeDocument/2006/relationships" xmlns:p="http://schemas.openxmlformats.org/presentationml/2006/main">
+  <p:cSld name="Slide 45">
+    <p:spTree>
+      <p:nvGrpSpPr>
+        <p:cNvPr id="1" name=""/>
+        <p:cNvGrpSpPr/>
+        <p:nvPr/>
+      </p:nvGrpSpPr>
+      <p:grpSpPr>
+        <a:xfrm>
+          <a:off x="0" y="0"/>
+          <a:ext cx="0" cy="0"/>
+          <a:chOff x="0" y="0"/>
+          <a:chExt cx="0" cy="0"/>
+        </a:xfrm>
+      </p:grpSpPr>
+      <p:sp>
+        <p:nvSpPr>
+          <p:cNvPr id="2" name="Text 0"/>
+          <p:cNvSpPr txBox="1"/>
+          <p:nvPr/>
+        </p:nvSpPr>
+        <p:spPr>
+          <a:xfrm>
             <a:off x="566928" y="1737360"/>
             <a:ext cx="4572000" cy="182880"/>
           </a:xfrm>
@@ -40147,7 +41490,7 @@
             <a:pPr algn="r"/>
             <a:fld id="{F7021451-1387-4CA6-816F-3879F97B5CBC}" type="slidenum">
               <a:rPr b="0" lang="en-US"/>
-              <a:t>44</a:t>
+              <a:t>45</a:t>
             </a:fld>
             <a:endParaRPr lang="en-US"/>
           </a:p>

</xml_diff>

<commit_message>
Add Cash Payment live-ticket practice slide; carry over Google edits on slides 41-42
Co-Authored-By: Claude Opus 5.5 <noreply@anthropic.com>
Claude-Session: https://claude.ai/code/session_01FEzv8wwqWDgTsXP8Yz6XYn
</commit_message>
<xml_diff>
--- a/billing-disputes/billing-disputes-cash-payments.pptx
+++ b/billing-disputes/billing-disputes-cash-payments.pptx
@@ -50,9 +50,10 @@
     <p:sldId id="298" r:id="rId44"/>
     <p:sldId id="299" r:id="rId45"/>
     <p:sldId id="300" r:id="rId46"/>
+    <p:sldId id="301" r:id="rId47"/>
   </p:sldIdLst>
   <p:notesMasterIdLst>
-    <p:notesMasterId r:id="rId47"/>
+    <p:notesMasterId r:id="rId48"/>
   </p:notesMasterIdLst>
   <p:sldSz cx="9144000" cy="5143500"/>
   <p:notesSz cx="5143500" cy="9144000"/>
@@ -3890,7 +3891,7 @@
           <a:p>
             <a:r>
               <a:rPr lang="en-US" dirty="0"/>
-              <a:t>TRAINER: recap the three takeaways, then open the floor for questions on Cash Payment.</a:t>
+              <a:t>TRAINER: provide a live ticket for trainees to review. Give them time to investigate (job history, CTJ, C/CP messages, Premium charge), then discuss. Ask: Did the CP already report the cash payment (check the CP CRM)? How much was paid in cash, full or partial? What is the job status? What actions will you take (cancel via C CRM, invoice the balance, refund via CP Dashboard, or admin refund + CP Holdback), and which ladder applies? How will you respond to the customer?</a:t>
             </a:r>
             <a:endParaRPr lang="en-US" dirty="0"/>
           </a:p>
@@ -3978,7 +3979,7 @@
           <a:p>
             <a:r>
               <a:rPr lang="en-US" dirty="0"/>
-              <a:t>Close the module. Recap: OCH (billed more than worked), Unauthorized Hours (worked but never asked), False Invoice (never showed, check who invoiced first), and Cash Payment (job status decides the action).</a:t>
+              <a:t>TRAINER: recap the three takeaways, then open the floor for questions on Cash Payment.</a:t>
             </a:r>
             <a:endParaRPr lang="en-US" dirty="0"/>
           </a:p>
@@ -4002,6 +4003,94 @@
             <a:fld id="{F7021451-1387-4CA6-816F-3879F97B5CBC}" type="slidenum">
               <a:rPr lang="en-US"/>
               <a:t>45</a:t>
+            </a:fld>
+            <a:endParaRPr lang="en-US"/>
+          </a:p>
+        </p:txBody>
+      </p:sp>
+    </p:spTree>
+    <p:extLst>
+      <p:ext uri="{BB962C8B-B14F-4D97-AF65-F5344CB8AC3E}">
+        <p14:creationId xmlns:p14="http://schemas.microsoft.com/office/powerpoint/2010/main" val="1024086991"/>
+      </p:ext>
+    </p:extLst>
+  </p:cSld>
+  <p:clrMapOvr>
+    <a:masterClrMapping/>
+  </p:clrMapOvr>
+</p:notes>
+</file>
+
+<file path=ppt/notesSlides/notesSlide46.xml><?xml version="1.0" encoding="utf-8"?>
+<p:notes xmlns:a="http://schemas.openxmlformats.org/drawingml/2006/main" xmlns:r="http://schemas.openxmlformats.org/officeDocument/2006/relationships" xmlns:p="http://schemas.openxmlformats.org/presentationml/2006/main">
+  <p:cSld>
+    <p:spTree>
+      <p:nvGrpSpPr>
+        <p:cNvPr id="1" name=""/>
+        <p:cNvGrpSpPr/>
+        <p:nvPr/>
+      </p:nvGrpSpPr>
+      <p:grpSpPr>
+        <a:xfrm>
+          <a:off x="0" y="0"/>
+          <a:ext cx="0" cy="0"/>
+          <a:chOff x="0" y="0"/>
+          <a:chExt cx="0" cy="0"/>
+        </a:xfrm>
+      </p:grpSpPr>
+      <p:sp>
+        <p:nvSpPr>
+          <p:cNvPr id="2" name="Slide Image Placeholder 1"/>
+          <p:cNvSpPr>
+            <a:spLocks noGrp="1" noRot="1" noChangeAspect="1"/>
+          </p:cNvSpPr>
+          <p:nvPr>
+            <p:ph type="sldImg"/>
+          </p:nvPr>
+        </p:nvSpPr>
+        <p:spPr/>
+      </p:sp>
+      <p:sp>
+        <p:nvSpPr>
+          <p:cNvPr id="3" name="Notes Placeholder 2"/>
+          <p:cNvSpPr>
+            <a:spLocks noGrp="1"/>
+          </p:cNvSpPr>
+          <p:nvPr>
+            <p:ph type="body" idx="1"/>
+          </p:nvPr>
+        </p:nvSpPr>
+        <p:spPr/>
+        <p:txBody>
+          <a:bodyPr/>
+          <a:lstStyle/>
+          <a:p>
+            <a:r>
+              <a:rPr lang="en-US" dirty="0"/>
+              <a:t>Close the module. Recap: OCH (billed more than worked), Unauthorized Hours (worked but never asked), False Invoice (never showed, check who invoiced first), and Cash Payment (job status decides the action).</a:t>
+            </a:r>
+            <a:endParaRPr lang="en-US" dirty="0"/>
+          </a:p>
+        </p:txBody>
+      </p:sp>
+      <p:sp>
+        <p:nvSpPr>
+          <p:cNvPr id="4" name="Slide Number Placeholder 3"/>
+          <p:cNvSpPr>
+            <a:spLocks noGrp="1"/>
+          </p:cNvSpPr>
+          <p:nvPr>
+            <p:ph type="sldNum" sz="quarter" idx="10"/>
+          </p:nvPr>
+        </p:nvSpPr>
+        <p:spPr/>
+        <p:txBody>
+          <a:bodyPr/>
+          <a:lstStyle/>
+          <a:p>
+            <a:fld id="{F7021451-1387-4CA6-816F-3879F97B5CBC}" type="slidenum">
+              <a:rPr lang="en-US"/>
+              <a:t>46</a:t>
             </a:fld>
             <a:endParaRPr lang="en-US"/>
           </a:p>
@@ -36529,7 +36618,7 @@
               <a:buNone/>
             </a:pPr>
             <a:r>
-              <a:rPr lang="en-US" sz="850" dirty="0">
+              <a:rPr lang="en-US" sz="750" dirty="0">
                 <a:solidFill>
                   <a:srgbClr val="6E6E73"/>
                 </a:solidFill>
@@ -36537,9 +36626,26 @@
                 <a:ea typeface="SF Pro Text" pitchFamily="34" charset="-122"/>
                 <a:cs typeface="SF Pro Text" pitchFamily="34" charset="-120"/>
               </a:rPr>
-              <a:t>Cancel via C CRM, reason code "does not want the service". Partial cash: invoice the remaining balance instead.</a:t>
-            </a:r>
-            <a:endParaRPr lang="en-US" sz="850" dirty="0"/>
+              <a:t>Fully paid in cash? Cancel via C CRM: Reason code "does not want the service".</a:t>
+            </a:r>
+            <a:endParaRPr lang="en-US" sz="750" dirty="0"/>
+          </a:p>
+          <a:p>
+            <a:pPr indent="0" marL="0">
+              <a:buNone/>
+            </a:pPr>
+            <a:r>
+              <a:rPr lang="en-US" sz="750" dirty="0">
+                <a:solidFill>
+                  <a:srgbClr val="6E6E73"/>
+                </a:solidFill>
+                <a:latin typeface="SF Pro Text" pitchFamily="34" charset="0"/>
+                <a:ea typeface="SF Pro Text" pitchFamily="34" charset="-122"/>
+                <a:cs typeface="SF Pro Text" pitchFamily="34" charset="-120"/>
+              </a:rPr>
+              <a:t>Partial payment? Invoice the remaining balance instead.</a:t>
+            </a:r>
+            <a:endParaRPr lang="en-US" sz="750" dirty="0"/>
           </a:p>
         </p:txBody>
       </p:sp>
@@ -36681,7 +36787,7 @@
               <a:buNone/>
             </a:pPr>
             <a:r>
-              <a:rPr lang="en-US" sz="850" dirty="0">
+              <a:rPr lang="en-US" sz="750" dirty="0">
                 <a:solidFill>
                   <a:srgbClr val="6E6E73"/>
                 </a:solidFill>
@@ -36689,9 +36795,26 @@
                 <a:ea typeface="SF Pro Text" pitchFamily="34" charset="-122"/>
                 <a:cs typeface="SF Pro Text" pitchFamily="34" charset="-120"/>
               </a:rPr>
-              <a:t>Refund via the CP Dashboard. Partial cash: admin refund the cash-paid portion (based on CP Pay, not C Price) + a CP Holdback for the same amount.</a:t>
-            </a:r>
-            <a:endParaRPr lang="en-US" sz="850" dirty="0"/>
+              <a:t>Fully paid in cash? Refund via the CP Dashboard.</a:t>
+            </a:r>
+            <a:endParaRPr lang="en-US" sz="750" dirty="0"/>
+          </a:p>
+          <a:p>
+            <a:pPr indent="0" marL="0">
+              <a:buNone/>
+            </a:pPr>
+            <a:r>
+              <a:rPr lang="en-US" sz="750" dirty="0">
+                <a:solidFill>
+                  <a:srgbClr val="6E6E73"/>
+                </a:solidFill>
+                <a:latin typeface="SF Pro Text" pitchFamily="34" charset="0"/>
+                <a:ea typeface="SF Pro Text" pitchFamily="34" charset="-122"/>
+                <a:cs typeface="SF Pro Text" pitchFamily="34" charset="-120"/>
+              </a:rPr>
+              <a:t>Partial payment? Admin refund the cash-paid portion (based on CP Pay, not C Price) + a CP Holdback for the same amount.</a:t>
+            </a:r>
+            <a:endParaRPr lang="en-US" sz="750" dirty="0"/>
           </a:p>
         </p:txBody>
       </p:sp>
@@ -37399,11 +37522,11 @@
         <p:spPr>
           <a:xfrm>
             <a:off x="457200" y="1097280"/>
-            <a:ext cx="3246120" cy="348615"/>
+            <a:ext cx="3246120" cy="310896"/>
           </a:xfrm>
           <a:prstGeom prst="roundRect">
             <a:avLst>
-              <a:gd name="adj" fmla="val 20984"/>
+              <a:gd name="adj" fmla="val 23529"/>
             </a:avLst>
           </a:prstGeom>
           <a:solidFill>
@@ -37426,7 +37549,7 @@
         <p:spPr>
           <a:xfrm>
             <a:off x="457200" y="1097280"/>
-            <a:ext cx="3246120" cy="348615"/>
+            <a:ext cx="3246120" cy="310896"/>
           </a:xfrm>
           <a:prstGeom prst="rect">
             <a:avLst/>
@@ -37464,7 +37587,7 @@
         </p:nvSpPr>
         <p:spPr>
           <a:xfrm>
-            <a:off x="2080260" y="1445895"/>
+            <a:off x="2080260" y="1408176"/>
             <a:ext cx="0" cy="91440"/>
           </a:xfrm>
           <a:prstGeom prst="line">
@@ -37488,7 +37611,7 @@
         </p:nvSpPr>
         <p:spPr>
           <a:xfrm>
-            <a:off x="3703320" y="1271588"/>
+            <a:off x="3703320" y="1252728"/>
             <a:ext cx="182880" cy="0"/>
           </a:xfrm>
           <a:prstGeom prst="line">
@@ -37512,7 +37635,7 @@
         <p:spPr>
           <a:xfrm>
             <a:off x="3977640" y="1060704"/>
-            <a:ext cx="4983480" cy="421767"/>
+            <a:ext cx="4983480" cy="384048"/>
           </a:xfrm>
           <a:prstGeom prst="rect">
             <a:avLst/>
@@ -37550,12 +37673,12 @@
         </p:nvSpPr>
         <p:spPr>
           <a:xfrm>
-            <a:off x="457200" y="1537335"/>
-            <a:ext cx="3246120" cy="348615"/>
+            <a:off x="457200" y="1499616"/>
+            <a:ext cx="3246120" cy="310896"/>
           </a:xfrm>
           <a:prstGeom prst="roundRect">
             <a:avLst>
-              <a:gd name="adj" fmla="val 20984"/>
+              <a:gd name="adj" fmla="val 23529"/>
             </a:avLst>
           </a:prstGeom>
           <a:solidFill>
@@ -37577,8 +37700,8 @@
         </p:nvSpPr>
         <p:spPr>
           <a:xfrm>
-            <a:off x="457200" y="1537335"/>
-            <a:ext cx="3246120" cy="348615"/>
+            <a:off x="457200" y="1499616"/>
+            <a:ext cx="3246120" cy="310896"/>
           </a:xfrm>
           <a:prstGeom prst="rect">
             <a:avLst/>
@@ -37616,7 +37739,7 @@
         </p:nvSpPr>
         <p:spPr>
           <a:xfrm>
-            <a:off x="2080260" y="1885950"/>
+            <a:off x="2080260" y="1810512"/>
             <a:ext cx="0" cy="91440"/>
           </a:xfrm>
           <a:prstGeom prst="line">
@@ -37640,7 +37763,7 @@
         </p:nvSpPr>
         <p:spPr>
           <a:xfrm>
-            <a:off x="3703320" y="1711643"/>
+            <a:off x="3703320" y="1655064"/>
             <a:ext cx="182880" cy="0"/>
           </a:xfrm>
           <a:prstGeom prst="line">
@@ -37663,8 +37786,8 @@
         </p:nvSpPr>
         <p:spPr>
           <a:xfrm>
-            <a:off x="3977640" y="1500759"/>
-            <a:ext cx="4983480" cy="421767"/>
+            <a:off x="3977640" y="1463040"/>
+            <a:ext cx="4983480" cy="384048"/>
           </a:xfrm>
           <a:prstGeom prst="rect">
             <a:avLst/>
@@ -37688,7 +37811,7 @@
                 <a:ea typeface="SF Pro Text" pitchFamily="34" charset="-122"/>
                 <a:cs typeface="SF Pro Text" pitchFamily="34" charset="-120"/>
               </a:rPr>
-              <a:t>Nothing is confirmed yet. Treat it like any other unconfirmed claim.</a:t>
+              <a:t>No report from CP. Treat it like any other unconfirmed claim.</a:t>
             </a:r>
             <a:endParaRPr lang="en-US" sz="850" dirty="0"/>
           </a:p>
@@ -37702,12 +37825,12 @@
         </p:nvSpPr>
         <p:spPr>
           <a:xfrm>
-            <a:off x="457200" y="1977390"/>
-            <a:ext cx="3246120" cy="348615"/>
+            <a:off x="457200" y="1901952"/>
+            <a:ext cx="3246120" cy="310896"/>
           </a:xfrm>
           <a:prstGeom prst="roundRect">
             <a:avLst>
-              <a:gd name="adj" fmla="val 20984"/>
+              <a:gd name="adj" fmla="val 23529"/>
             </a:avLst>
           </a:prstGeom>
           <a:solidFill>
@@ -37729,8 +37852,8 @@
         </p:nvSpPr>
         <p:spPr>
           <a:xfrm>
-            <a:off x="457200" y="1977390"/>
-            <a:ext cx="3246120" cy="348615"/>
+            <a:off x="457200" y="1901952"/>
+            <a:ext cx="3246120" cy="310896"/>
           </a:xfrm>
           <a:prstGeom prst="rect">
             <a:avLst/>
@@ -37768,7 +37891,7 @@
         </p:nvSpPr>
         <p:spPr>
           <a:xfrm>
-            <a:off x="2080260" y="2326005"/>
+            <a:off x="2080260" y="2212848"/>
             <a:ext cx="0" cy="91440"/>
           </a:xfrm>
           <a:prstGeom prst="line">
@@ -37792,7 +37915,7 @@
         </p:nvSpPr>
         <p:spPr>
           <a:xfrm>
-            <a:off x="3703320" y="2151697"/>
+            <a:off x="3703320" y="2057400"/>
             <a:ext cx="182880" cy="0"/>
           </a:xfrm>
           <a:prstGeom prst="line">
@@ -37815,8 +37938,8 @@
         </p:nvSpPr>
         <p:spPr>
           <a:xfrm>
-            <a:off x="3977640" y="1940814"/>
-            <a:ext cx="4983480" cy="421767"/>
+            <a:off x="3977640" y="1865376"/>
+            <a:ext cx="4983480" cy="384048"/>
           </a:xfrm>
           <a:prstGeom prst="rect">
             <a:avLst/>
@@ -37854,12 +37977,12 @@
         </p:nvSpPr>
         <p:spPr>
           <a:xfrm>
-            <a:off x="457200" y="2417445"/>
-            <a:ext cx="3246120" cy="348615"/>
+            <a:off x="457200" y="2304288"/>
+            <a:ext cx="3246120" cy="310896"/>
           </a:xfrm>
           <a:prstGeom prst="roundRect">
             <a:avLst>
-              <a:gd name="adj" fmla="val 20984"/>
+              <a:gd name="adj" fmla="val 23529"/>
             </a:avLst>
           </a:prstGeom>
           <a:solidFill>
@@ -37881,8 +38004,8 @@
         </p:nvSpPr>
         <p:spPr>
           <a:xfrm>
-            <a:off x="457200" y="2417445"/>
-            <a:ext cx="3246120" cy="348615"/>
+            <a:off x="457200" y="2304288"/>
+            <a:ext cx="3246120" cy="310896"/>
           </a:xfrm>
           <a:prstGeom prst="rect">
             <a:avLst/>
@@ -37920,7 +38043,7 @@
         </p:nvSpPr>
         <p:spPr>
           <a:xfrm>
-            <a:off x="2080260" y="2766060"/>
+            <a:off x="2080260" y="2615184"/>
             <a:ext cx="0" cy="91440"/>
           </a:xfrm>
           <a:prstGeom prst="line">
@@ -37944,7 +38067,7 @@
         </p:nvSpPr>
         <p:spPr>
           <a:xfrm>
-            <a:off x="3703320" y="2591752"/>
+            <a:off x="3703320" y="2459736"/>
             <a:ext cx="182880" cy="0"/>
           </a:xfrm>
           <a:prstGeom prst="line">
@@ -37967,8 +38090,8 @@
         </p:nvSpPr>
         <p:spPr>
           <a:xfrm>
-            <a:off x="3977640" y="2380869"/>
-            <a:ext cx="4983480" cy="421767"/>
+            <a:off x="3977640" y="2267712"/>
+            <a:ext cx="4983480" cy="384048"/>
           </a:xfrm>
           <a:prstGeom prst="rect">
             <a:avLst/>
@@ -38006,12 +38129,12 @@
         </p:nvSpPr>
         <p:spPr>
           <a:xfrm>
-            <a:off x="457200" y="2857500"/>
-            <a:ext cx="3246120" cy="348615"/>
+            <a:off x="457200" y="2706624"/>
+            <a:ext cx="3246120" cy="310896"/>
           </a:xfrm>
           <a:prstGeom prst="roundRect">
             <a:avLst>
-              <a:gd name="adj" fmla="val 20984"/>
+              <a:gd name="adj" fmla="val 23529"/>
             </a:avLst>
           </a:prstGeom>
           <a:solidFill>
@@ -38033,8 +38156,8 @@
         </p:nvSpPr>
         <p:spPr>
           <a:xfrm>
-            <a:off x="457200" y="2857500"/>
-            <a:ext cx="3246120" cy="348615"/>
+            <a:off x="457200" y="2706624"/>
+            <a:ext cx="3246120" cy="310896"/>
           </a:xfrm>
           <a:prstGeom prst="rect">
             <a:avLst/>
@@ -38072,7 +38195,7 @@
         </p:nvSpPr>
         <p:spPr>
           <a:xfrm>
-            <a:off x="2080260" y="3206115"/>
+            <a:off x="2080260" y="3017520"/>
             <a:ext cx="0" cy="91440"/>
           </a:xfrm>
           <a:prstGeom prst="line">
@@ -38096,7 +38219,7 @@
         </p:nvSpPr>
         <p:spPr>
           <a:xfrm>
-            <a:off x="3703320" y="3031808"/>
+            <a:off x="3703320" y="2862072"/>
             <a:ext cx="182880" cy="0"/>
           </a:xfrm>
           <a:prstGeom prst="line">
@@ -38119,8 +38242,8 @@
         </p:nvSpPr>
         <p:spPr>
           <a:xfrm>
-            <a:off x="3977640" y="2820924"/>
-            <a:ext cx="4983480" cy="421767"/>
+            <a:off x="3977640" y="2670048"/>
+            <a:ext cx="4983480" cy="384048"/>
           </a:xfrm>
           <a:prstGeom prst="rect">
             <a:avLst/>
@@ -38158,12 +38281,12 @@
         </p:nvSpPr>
         <p:spPr>
           <a:xfrm>
-            <a:off x="457200" y="3297555"/>
-            <a:ext cx="3246120" cy="348615"/>
+            <a:off x="457200" y="3108960"/>
+            <a:ext cx="3246120" cy="429768"/>
           </a:xfrm>
           <a:prstGeom prst="roundRect">
             <a:avLst>
-              <a:gd name="adj" fmla="val 20984"/>
+              <a:gd name="adj" fmla="val 17021"/>
             </a:avLst>
           </a:prstGeom>
           <a:solidFill>
@@ -38185,8 +38308,8 @@
         </p:nvSpPr>
         <p:spPr>
           <a:xfrm>
-            <a:off x="457200" y="3297555"/>
-            <a:ext cx="3246120" cy="348615"/>
+            <a:off x="457200" y="3108960"/>
+            <a:ext cx="3246120" cy="429768"/>
           </a:xfrm>
           <a:prstGeom prst="rect">
             <a:avLst/>
@@ -38224,7 +38347,7 @@
         </p:nvSpPr>
         <p:spPr>
           <a:xfrm>
-            <a:off x="2080260" y="3646170"/>
+            <a:off x="2080260" y="3538728"/>
             <a:ext cx="0" cy="91440"/>
           </a:xfrm>
           <a:prstGeom prst="line">
@@ -38248,7 +38371,7 @@
         </p:nvSpPr>
         <p:spPr>
           <a:xfrm>
-            <a:off x="3703320" y="3471863"/>
+            <a:off x="3703320" y="3323844"/>
             <a:ext cx="182880" cy="0"/>
           </a:xfrm>
           <a:prstGeom prst="line">
@@ -38271,8 +38394,8 @@
         </p:nvSpPr>
         <p:spPr>
           <a:xfrm>
-            <a:off x="3977640" y="3260979"/>
-            <a:ext cx="4983480" cy="421767"/>
+            <a:off x="3977640" y="3072384"/>
+            <a:ext cx="4983480" cy="502920"/>
           </a:xfrm>
           <a:prstGeom prst="rect">
             <a:avLst/>
@@ -38288,7 +38411,7 @@
               <a:buNone/>
             </a:pPr>
             <a:r>
-              <a:rPr lang="en-US" sz="850" dirty="0">
+              <a:rPr lang="en-US" sz="750" dirty="0">
                 <a:solidFill>
                   <a:srgbClr val="6E6E73"/>
                 </a:solidFill>
@@ -38296,9 +38419,43 @@
                 <a:ea typeface="SF Pro Text" pitchFamily="34" charset="-122"/>
                 <a:cs typeface="SF Pro Text" pitchFamily="34" charset="-120"/>
               </a:rPr>
-              <a:t>Resolve per job status, whatever the CP says. It's treated as getting caught, not disclosing.</a:t>
-            </a:r>
-            <a:endParaRPr lang="en-US" sz="850" dirty="0"/>
+              <a:t>Pending Invoice: cancel from CCRM (full) or invoice remaining balance (partial)</a:t>
+            </a:r>
+            <a:endParaRPr lang="en-US" sz="750" dirty="0"/>
+          </a:p>
+          <a:p>
+            <a:pPr indent="0" marL="0">
+              <a:buNone/>
+            </a:pPr>
+            <a:r>
+              <a:rPr lang="en-US" sz="750" dirty="0">
+                <a:solidFill>
+                  <a:srgbClr val="6E6E73"/>
+                </a:solidFill>
+                <a:latin typeface="SF Pro Text" pitchFamily="34" charset="0"/>
+                <a:ea typeface="SF Pro Text" pitchFamily="34" charset="-122"/>
+                <a:cs typeface="SF Pro Text" pitchFamily="34" charset="-120"/>
+              </a:rPr>
+              <a:t>Invoiced: Refund from CP Dashboard (full) or admin refund + CP holdback (partial)</a:t>
+            </a:r>
+            <a:endParaRPr lang="en-US" sz="750" dirty="0"/>
+          </a:p>
+          <a:p>
+            <a:pPr indent="0" marL="0">
+              <a:buNone/>
+            </a:pPr>
+            <a:r>
+              <a:rPr lang="en-US" sz="750" dirty="0">
+                <a:solidFill>
+                  <a:srgbClr val="6E6E73"/>
+                </a:solidFill>
+                <a:latin typeface="SF Pro Text" pitchFamily="34" charset="0"/>
+                <a:ea typeface="SF Pro Text" pitchFamily="34" charset="-122"/>
+                <a:cs typeface="SF Pro Text" pitchFamily="34" charset="-120"/>
+              </a:rPr>
+              <a:t>Hard ladder penalty</a:t>
+            </a:r>
+            <a:endParaRPr lang="en-US" sz="750" dirty="0"/>
           </a:p>
         </p:txBody>
       </p:sp>
@@ -38310,12 +38467,12 @@
         </p:nvSpPr>
         <p:spPr>
           <a:xfrm>
-            <a:off x="457200" y="3737610"/>
-            <a:ext cx="3246120" cy="348615"/>
+            <a:off x="457200" y="3630168"/>
+            <a:ext cx="3246120" cy="548640"/>
           </a:xfrm>
           <a:prstGeom prst="roundRect">
             <a:avLst>
-              <a:gd name="adj" fmla="val 20984"/>
+              <a:gd name="adj" fmla="val 13333"/>
             </a:avLst>
           </a:prstGeom>
           <a:solidFill>
@@ -38337,8 +38494,8 @@
         </p:nvSpPr>
         <p:spPr>
           <a:xfrm>
-            <a:off x="457200" y="3737610"/>
-            <a:ext cx="3246120" cy="348615"/>
+            <a:off x="457200" y="3630168"/>
+            <a:ext cx="3246120" cy="548640"/>
           </a:xfrm>
           <a:prstGeom prst="rect">
             <a:avLst/>
@@ -38362,7 +38519,7 @@
                 <a:ea typeface="SF Pro Display" pitchFamily="34" charset="-122"/>
                 <a:cs typeface="SF Pro Display" pitchFamily="34" charset="-120"/>
               </a:rPr>
-              <a:t>CP admits it → soft ladder</a:t>
+              <a:t>No proof from C but CP admits it → soft ladder</a:t>
             </a:r>
             <a:endParaRPr lang="en-US" sz="1000" dirty="0"/>
           </a:p>
@@ -38376,7 +38533,7 @@
         </p:nvSpPr>
         <p:spPr>
           <a:xfrm>
-            <a:off x="2080260" y="4086225"/>
+            <a:off x="2080260" y="4178808"/>
             <a:ext cx="0" cy="91440"/>
           </a:xfrm>
           <a:prstGeom prst="line">
@@ -38400,7 +38557,7 @@
         </p:nvSpPr>
         <p:spPr>
           <a:xfrm>
-            <a:off x="3703320" y="3911917"/>
+            <a:off x="3703320" y="3904488"/>
             <a:ext cx="182880" cy="0"/>
           </a:xfrm>
           <a:prstGeom prst="line">
@@ -38423,8 +38580,8 @@
         </p:nvSpPr>
         <p:spPr>
           <a:xfrm>
-            <a:off x="3977640" y="3701034"/>
-            <a:ext cx="4983480" cy="421767"/>
+            <a:off x="3977640" y="3593592"/>
+            <a:ext cx="4983480" cy="621792"/>
           </a:xfrm>
           <a:prstGeom prst="rect">
             <a:avLst/>
@@ -38440,7 +38597,7 @@
               <a:buNone/>
             </a:pPr>
             <a:r>
-              <a:rPr lang="en-US" sz="850" dirty="0">
+              <a:rPr lang="en-US" sz="750" dirty="0">
                 <a:solidFill>
                   <a:srgbClr val="6E6E73"/>
                 </a:solidFill>
@@ -38448,9 +38605,60 @@
                 <a:ea typeface="SF Pro Text" pitchFamily="34" charset="-122"/>
                 <a:cs typeface="SF Pro Text" pitchFamily="34" charset="-120"/>
               </a:rPr>
-              <a:t>Resolve per job status. It's still an admission, just a later one.</a:t>
-            </a:r>
-            <a:endParaRPr lang="en-US" sz="850" dirty="0"/>
+              <a:t>Resolve per job status above + Soft ladder penalty.</a:t>
+            </a:r>
+            <a:endParaRPr lang="en-US" sz="750" dirty="0"/>
+          </a:p>
+          <a:p>
+            <a:pPr indent="0" marL="0">
+              <a:buNone/>
+            </a:pPr>
+            <a:r>
+              <a:rPr lang="en-US" sz="750" dirty="0">
+                <a:solidFill>
+                  <a:srgbClr val="6E6E73"/>
+                </a:solidFill>
+                <a:latin typeface="SF Pro Text" pitchFamily="34" charset="0"/>
+                <a:ea typeface="SF Pro Text" pitchFamily="34" charset="-122"/>
+                <a:cs typeface="SF Pro Text" pitchFamily="34" charset="-120"/>
+              </a:rPr>
+              <a:t>1st instance - coach</a:t>
+            </a:r>
+            <a:endParaRPr lang="en-US" sz="750" dirty="0"/>
+          </a:p>
+          <a:p>
+            <a:pPr indent="0" marL="0">
+              <a:buNone/>
+            </a:pPr>
+            <a:r>
+              <a:rPr lang="en-US" sz="750" dirty="0">
+                <a:solidFill>
+                  <a:srgbClr val="6E6E73"/>
+                </a:solidFill>
+                <a:latin typeface="SF Pro Text" pitchFamily="34" charset="0"/>
+                <a:ea typeface="SF Pro Text" pitchFamily="34" charset="-122"/>
+                <a:cs typeface="SF Pro Text" pitchFamily="34" charset="-120"/>
+              </a:rPr>
+              <a:t>2nd instance - coach + final warning</a:t>
+            </a:r>
+            <a:endParaRPr lang="en-US" sz="750" dirty="0"/>
+          </a:p>
+          <a:p>
+            <a:pPr indent="0" marL="0">
+              <a:buNone/>
+            </a:pPr>
+            <a:r>
+              <a:rPr lang="en-US" sz="750" dirty="0">
+                <a:solidFill>
+                  <a:srgbClr val="6E6E73"/>
+                </a:solidFill>
+                <a:latin typeface="SF Pro Text" pitchFamily="34" charset="0"/>
+                <a:ea typeface="SF Pro Text" pitchFamily="34" charset="-122"/>
+                <a:cs typeface="SF Pro Text" pitchFamily="34" charset="-120"/>
+              </a:rPr>
+              <a:t>3rd instance - suspended</a:t>
+            </a:r>
+            <a:endParaRPr lang="en-US" sz="750" dirty="0"/>
           </a:p>
         </p:txBody>
       </p:sp>
@@ -38462,12 +38670,12 @@
         </p:nvSpPr>
         <p:spPr>
           <a:xfrm>
-            <a:off x="457200" y="4177665"/>
-            <a:ext cx="3246120" cy="348615"/>
+            <a:off x="457200" y="4270248"/>
+            <a:ext cx="3246120" cy="310896"/>
           </a:xfrm>
           <a:prstGeom prst="roundRect">
             <a:avLst>
-              <a:gd name="adj" fmla="val 20984"/>
+              <a:gd name="adj" fmla="val 23529"/>
             </a:avLst>
           </a:prstGeom>
           <a:solidFill>
@@ -38489,8 +38697,8 @@
         </p:nvSpPr>
         <p:spPr>
           <a:xfrm>
-            <a:off x="457200" y="4177665"/>
-            <a:ext cx="3246120" cy="348615"/>
+            <a:off x="457200" y="4270248"/>
+            <a:ext cx="3246120" cy="310896"/>
           </a:xfrm>
           <a:prstGeom prst="rect">
             <a:avLst/>
@@ -38528,7 +38736,7 @@
         </p:nvSpPr>
         <p:spPr>
           <a:xfrm>
-            <a:off x="3703320" y="4351972"/>
+            <a:off x="3703320" y="4425696"/>
             <a:ext cx="182880" cy="0"/>
           </a:xfrm>
           <a:prstGeom prst="line">
@@ -38551,8 +38759,8 @@
         </p:nvSpPr>
         <p:spPr>
           <a:xfrm>
-            <a:off x="3977640" y="4141089"/>
-            <a:ext cx="4983480" cy="421767"/>
+            <a:off x="3977640" y="4233672"/>
+            <a:ext cx="4983480" cy="384048"/>
           </a:xfrm>
           <a:prstGeom prst="rect">
             <a:avLst/>
@@ -40334,7 +40542,7 @@
                 <a:ea typeface="SF Pro Display" pitchFamily="34" charset="-122"/>
                 <a:cs typeface="SF Pro Display" pitchFamily="34" charset="-120"/>
               </a:rPr>
-              <a:t>CASH PAYMENT  ·  WRAP-UP</a:t>
+              <a:t>CASH PAYMENT  ·  PRACTICE</a:t>
             </a:r>
             <a:endParaRPr lang="en-US" sz="800" dirty="0"/>
           </a:p>
@@ -40373,7 +40581,7 @@
                 <a:ea typeface="SF Pro Display" pitchFamily="34" charset="-122"/>
                 <a:cs typeface="SF Pro Display" pitchFamily="34" charset="-120"/>
               </a:rPr>
-              <a:t>Wrap-up</a:t>
+              <a:t>Let's practice!</a:t>
             </a:r>
             <a:endParaRPr lang="en-US" sz="2400" dirty="0"/>
           </a:p>
@@ -40412,7 +40620,7 @@
                 <a:ea typeface="SF Pro Text" pitchFamily="34" charset="-122"/>
                 <a:cs typeface="SF Pro Text" pitchFamily="34" charset="-120"/>
               </a:rPr>
-              <a:t>Key takeaways before we move on.</a:t>
+              <a:t>Review the live ticket and investigate.</a:t>
             </a:r>
             <a:endParaRPr lang="en-US" sz="1200" dirty="0"/>
           </a:p>
@@ -40427,11 +40635,11 @@
         <p:spPr>
           <a:xfrm>
             <a:off x="411480" y="1325880"/>
-            <a:ext cx="2682240" cy="1600200"/>
+            <a:ext cx="3566160" cy="2743200"/>
           </a:xfrm>
           <a:prstGeom prst="roundRect">
             <a:avLst>
-              <a:gd name="adj" fmla="val 4571"/>
+              <a:gd name="adj" fmla="val 2667"/>
             </a:avLst>
           </a:prstGeom>
           <a:solidFill>
@@ -40453,8 +40661,8 @@
         </p:nvSpPr>
         <p:spPr>
           <a:xfrm>
-            <a:off x="576072" y="1508760"/>
-            <a:ext cx="274320" cy="274320"/>
+            <a:off x="576072" y="1490472"/>
+            <a:ext cx="329184" cy="329184"/>
           </a:xfrm>
           <a:prstGeom prst="ellipse">
             <a:avLst/>
@@ -40470,79 +40678,64 @@
           </a:ln>
         </p:spPr>
       </p:sp>
-      <p:sp>
-        <p:nvSpPr>
-          <p:cNvPr id="8" name="Text 5"/>
-          <p:cNvSpPr txBox="1"/>
-          <p:nvPr/>
-        </p:nvSpPr>
-        <p:spPr>
-          <a:xfrm>
-            <a:off x="576072" y="1508760"/>
-            <a:ext cx="274320" cy="274320"/>
-          </a:xfrm>
-          <a:prstGeom prst="rect">
-            <a:avLst/>
-          </a:prstGeom>
-          <a:noFill/>
-          <a:ln/>
-        </p:spPr>
-        <p:txBody>
-          <a:bodyPr wrap="square" lIns="0" tIns="0" rIns="0" bIns="0" rtlCol="0" anchor="ctr"/>
-          <a:lstStyle/>
-          <a:p>
-            <a:pPr algn="ctr" indent="0" marL="0">
-              <a:buNone/>
-            </a:pPr>
-            <a:r>
-              <a:rPr lang="en-US" sz="900" b="1" dirty="0">
-                <a:solidFill>
-                  <a:srgbClr val="0B7A6F"/>
+      <p:pic>
+        <p:nvPicPr>
+          <p:cNvPr id="8" name="Image 0" descr="preencoded.png">    </p:cNvPr>
+          <p:cNvPicPr>
+            <a:picLocks noChangeAspect="1"/>
+          </p:cNvPicPr>
+          <p:nvPr/>
+        </p:nvPicPr>
+        <p:blipFill>
+          <a:blip r:embed="rId1"/>
+          <a:stretch>
+            <a:fillRect/>
+          </a:stretch>
+        </p:blipFill>
+        <p:spPr>
+          <a:xfrm>
+            <a:off x="655076" y="1569476"/>
+            <a:ext cx="171176" cy="171176"/>
+          </a:xfrm>
+          <a:prstGeom prst="rect">
+            <a:avLst/>
+          </a:prstGeom>
+        </p:spPr>
+      </p:pic>
+      <p:sp>
+        <p:nvSpPr>
+          <p:cNvPr id="9" name="Text 5"/>
+          <p:cNvSpPr txBox="1"/>
+          <p:nvPr/>
+        </p:nvSpPr>
+        <p:spPr>
+          <a:xfrm>
+            <a:off x="576072" y="1929384"/>
+            <a:ext cx="3236976" cy="274320"/>
+          </a:xfrm>
+          <a:prstGeom prst="rect">
+            <a:avLst/>
+          </a:prstGeom>
+          <a:noFill/>
+          <a:ln/>
+        </p:spPr>
+        <p:txBody>
+          <a:bodyPr wrap="square" lIns="0" tIns="0" rIns="0" bIns="0" rtlCol="0" anchor="t"/>
+          <a:lstStyle/>
+          <a:p>
+            <a:pPr indent="0" marL="0">
+              <a:buNone/>
+            </a:pPr>
+            <a:r>
+              <a:rPr lang="en-US" sz="1200" b="1" dirty="0">
+                <a:solidFill>
+                  <a:srgbClr val="1D1D1F"/>
                 </a:solidFill>
                 <a:latin typeface="SF Pro Display" pitchFamily="34" charset="0"/>
                 <a:ea typeface="SF Pro Display" pitchFamily="34" charset="-122"/>
                 <a:cs typeface="SF Pro Display" pitchFamily="34" charset="-120"/>
               </a:rPr>
-              <a:t>1</a:t>
-            </a:r>
-            <a:endParaRPr lang="en-US" sz="900" dirty="0"/>
-          </a:p>
-        </p:txBody>
-      </p:sp>
-      <p:sp>
-        <p:nvSpPr>
-          <p:cNvPr id="9" name="Text 6"/>
-          <p:cNvSpPr txBox="1"/>
-          <p:nvPr/>
-        </p:nvSpPr>
-        <p:spPr>
-          <a:xfrm>
-            <a:off x="576072" y="1929384"/>
-            <a:ext cx="2353056" cy="274320"/>
-          </a:xfrm>
-          <a:prstGeom prst="rect">
-            <a:avLst/>
-          </a:prstGeom>
-          <a:noFill/>
-          <a:ln/>
-        </p:spPr>
-        <p:txBody>
-          <a:bodyPr wrap="square" lIns="0" tIns="0" rIns="0" bIns="0" rtlCol="0" anchor="t"/>
-          <a:lstStyle/>
-          <a:p>
-            <a:pPr indent="0" marL="0">
-              <a:buNone/>
-            </a:pPr>
-            <a:r>
-              <a:rPr lang="en-US" sz="1200" b="1" dirty="0">
-                <a:solidFill>
-                  <a:srgbClr val="1D1D1F"/>
-                </a:solidFill>
-                <a:latin typeface="SF Pro Display" pitchFamily="34" charset="0"/>
-                <a:ea typeface="SF Pro Display" pitchFamily="34" charset="-122"/>
-                <a:cs typeface="SF Pro Display" pitchFamily="34" charset="-120"/>
-              </a:rPr>
-              <a:t>Status decides the action</a:t>
+              <a:t>Live ticket</a:t>
             </a:r>
             <a:endParaRPr lang="en-US" sz="1200" dirty="0"/>
           </a:p>
@@ -40550,14 +40743,14 @@
       </p:sp>
       <p:sp>
         <p:nvSpPr>
-          <p:cNvPr id="10" name="Text 7"/>
+          <p:cNvPr id="10" name="Text 6"/>
           <p:cNvSpPr txBox="1"/>
           <p:nvPr/>
         </p:nvSpPr>
         <p:spPr>
           <a:xfrm>
             <a:off x="576072" y="2221992"/>
-            <a:ext cx="2353056" cy="612648"/>
+            <a:ext cx="3236976" cy="1755648"/>
           </a:xfrm>
           <a:prstGeom prst="rect">
             <a:avLst/>
@@ -40581,7 +40774,7 @@
                 <a:ea typeface="SF Pro Text" pitchFamily="34" charset="-122"/>
                 <a:cs typeface="SF Pro Text" pitchFamily="34" charset="-120"/>
               </a:rPr>
-              <a:t>Pending Invoice: cancel. Invoiced: refund. Cancelled: don't recreate.</a:t>
+              <a:t>Your trainer will provide a live ticket. Review it and investigate before you decide anything.</a:t>
             </a:r>
             <a:endParaRPr lang="en-US" sz="950" dirty="0"/>
           </a:p>
@@ -40589,18 +40782,84 @@
       </p:sp>
       <p:sp>
         <p:nvSpPr>
-          <p:cNvPr id="11" name="Shape 8"/>
+          <p:cNvPr id="11" name="Shape 7"/>
           <p:cNvSpPr/>
           <p:nvPr/>
         </p:nvSpPr>
         <p:spPr>
           <a:xfrm>
-            <a:off x="3230880" y="1325880"/>
-            <a:ext cx="2682240" cy="1600200"/>
+            <a:off x="594360" y="3520440"/>
+            <a:ext cx="1234440" cy="274320"/>
           </a:xfrm>
           <a:prstGeom prst="roundRect">
             <a:avLst>
-              <a:gd name="adj" fmla="val 4571"/>
+              <a:gd name="adj" fmla="val 26667"/>
+            </a:avLst>
+          </a:prstGeom>
+          <a:solidFill>
+            <a:srgbClr val="FFF3D6"/>
+          </a:solidFill>
+          <a:ln w="9525">
+            <a:solidFill>
+              <a:srgbClr val="FFF3D6"/>
+            </a:solidFill>
+            <a:prstDash val="solid"/>
+          </a:ln>
+        </p:spPr>
+      </p:sp>
+      <p:sp>
+        <p:nvSpPr>
+          <p:cNvPr id="12" name="Text 8"/>
+          <p:cNvSpPr txBox="1"/>
+          <p:nvPr/>
+        </p:nvSpPr>
+        <p:spPr>
+          <a:xfrm>
+            <a:off x="594360" y="3520440"/>
+            <a:ext cx="1234440" cy="274320"/>
+          </a:xfrm>
+          <a:prstGeom prst="rect">
+            <a:avLst/>
+          </a:prstGeom>
+          <a:noFill/>
+          <a:ln/>
+        </p:spPr>
+        <p:txBody>
+          <a:bodyPr wrap="square" lIns="0" tIns="0" rIns="0" bIns="0" rtlCol="0" anchor="ctr"/>
+          <a:lstStyle/>
+          <a:p>
+            <a:pPr algn="ctr" indent="0" marL="0">
+              <a:buNone/>
+            </a:pPr>
+            <a:r>
+              <a:rPr lang="en-US" sz="800" b="1" dirty="0">
+                <a:solidFill>
+                  <a:srgbClr val="9A6410"/>
+                </a:solidFill>
+                <a:latin typeface="SF Pro Text" pitchFamily="34" charset="0"/>
+                <a:ea typeface="SF Pro Text" pitchFamily="34" charset="-122"/>
+                <a:cs typeface="SF Pro Text" pitchFamily="34" charset="-120"/>
+              </a:rPr>
+              <a:t>Trainer provides</a:t>
+            </a:r>
+            <a:endParaRPr lang="en-US" sz="800" dirty="0"/>
+          </a:p>
+        </p:txBody>
+      </p:sp>
+      <p:sp>
+        <p:nvSpPr>
+          <p:cNvPr id="13" name="Shape 9"/>
+          <p:cNvSpPr/>
+          <p:nvPr/>
+        </p:nvSpPr>
+        <p:spPr>
+          <a:xfrm>
+            <a:off x="4114800" y="1325880"/>
+            <a:ext cx="4617720" cy="1298448"/>
+          </a:xfrm>
+          <a:prstGeom prst="roundRect">
+            <a:avLst>
+              <a:gd name="adj" fmla="val 5634"/>
             </a:avLst>
           </a:prstGeom>
           <a:solidFill>
@@ -40616,13 +40875,13 @@
       </p:sp>
       <p:sp>
         <p:nvSpPr>
-          <p:cNvPr id="12" name="Shape 9"/>
+          <p:cNvPr id="14" name="Shape 10"/>
           <p:cNvSpPr/>
           <p:nvPr/>
         </p:nvSpPr>
         <p:spPr>
           <a:xfrm>
-            <a:off x="3395472" y="1508760"/>
+            <a:off x="4279392" y="1508760"/>
             <a:ext cx="274320" cy="274320"/>
           </a:xfrm>
           <a:prstGeom prst="ellipse">
@@ -40641,13 +40900,13 @@
       </p:sp>
       <p:sp>
         <p:nvSpPr>
-          <p:cNvPr id="13" name="Text 10"/>
-          <p:cNvSpPr txBox="1"/>
-          <p:nvPr/>
-        </p:nvSpPr>
-        <p:spPr>
-          <a:xfrm>
-            <a:off x="3395472" y="1508760"/>
+          <p:cNvPr id="15" name="Text 11"/>
+          <p:cNvSpPr txBox="1"/>
+          <p:nvPr/>
+        </p:nvSpPr>
+        <p:spPr>
+          <a:xfrm>
+            <a:off x="4279392" y="1508760"/>
             <a:ext cx="274320" cy="274320"/>
           </a:xfrm>
           <a:prstGeom prst="rect">
@@ -40672,7 +40931,7 @@
                 <a:ea typeface="SF Pro Display" pitchFamily="34" charset="-122"/>
                 <a:cs typeface="SF Pro Display" pitchFamily="34" charset="-120"/>
               </a:rPr>
-              <a:t>2</a:t>
+              <a:t>1</a:t>
             </a:r>
             <a:endParaRPr lang="en-US" sz="900" dirty="0"/>
           </a:p>
@@ -40680,14 +40939,14 @@
       </p:sp>
       <p:sp>
         <p:nvSpPr>
-          <p:cNvPr id="14" name="Text 11"/>
-          <p:cNvSpPr txBox="1"/>
-          <p:nvPr/>
-        </p:nvSpPr>
-        <p:spPr>
-          <a:xfrm>
-            <a:off x="3395472" y="1929384"/>
-            <a:ext cx="2353056" cy="274320"/>
+          <p:cNvPr id="16" name="Text 12"/>
+          <p:cNvSpPr txBox="1"/>
+          <p:nvPr/>
+        </p:nvSpPr>
+        <p:spPr>
+          <a:xfrm>
+            <a:off x="4279392" y="1929384"/>
+            <a:ext cx="4288536" cy="274320"/>
           </a:xfrm>
           <a:prstGeom prst="rect">
             <a:avLst/>
@@ -40711,7 +40970,7 @@
                 <a:ea typeface="SF Pro Display" pitchFamily="34" charset="-122"/>
                 <a:cs typeface="SF Pro Display" pitchFamily="34" charset="-120"/>
               </a:rPr>
-              <a:t>Get the amount first</a:t>
+              <a:t>What will be your actions?</a:t>
             </a:r>
             <a:endParaRPr lang="en-US" sz="1200" dirty="0"/>
           </a:p>
@@ -40719,14 +40978,14 @@
       </p:sp>
       <p:sp>
         <p:nvSpPr>
-          <p:cNvPr id="15" name="Text 12"/>
-          <p:cNvSpPr txBox="1"/>
-          <p:nvPr/>
-        </p:nvSpPr>
-        <p:spPr>
-          <a:xfrm>
-            <a:off x="3395472" y="2221992"/>
-            <a:ext cx="2353056" cy="612648"/>
+          <p:cNvPr id="17" name="Text 13"/>
+          <p:cNvSpPr txBox="1"/>
+          <p:nvPr/>
+        </p:nvSpPr>
+        <p:spPr>
+          <a:xfrm>
+            <a:off x="4279392" y="2221992"/>
+            <a:ext cx="4288536" cy="310896"/>
           </a:xfrm>
           <a:prstGeom prst="rect">
             <a:avLst/>
@@ -40750,7 +41009,7 @@
                 <a:ea typeface="SF Pro Text" pitchFamily="34" charset="-122"/>
                 <a:cs typeface="SF Pro Text" pitchFamily="34" charset="-120"/>
               </a:rPr>
-              <a:t>Full vs partial is based on CP Pay, not the C Price.</a:t>
+              <a:t>Which issue is it, and what will you do on the account?</a:t>
             </a:r>
             <a:endParaRPr lang="en-US" sz="950" dirty="0"/>
           </a:p>
@@ -40758,18 +41017,18 @@
       </p:sp>
       <p:sp>
         <p:nvSpPr>
-          <p:cNvPr id="16" name="Shape 13"/>
+          <p:cNvPr id="18" name="Shape 14"/>
           <p:cNvSpPr/>
           <p:nvPr/>
         </p:nvSpPr>
         <p:spPr>
           <a:xfrm>
-            <a:off x="6050280" y="1325880"/>
-            <a:ext cx="2682240" cy="1600200"/>
+            <a:off x="4114800" y="2770632"/>
+            <a:ext cx="4617720" cy="1298448"/>
           </a:xfrm>
           <a:prstGeom prst="roundRect">
             <a:avLst>
-              <a:gd name="adj" fmla="val 4571"/>
+              <a:gd name="adj" fmla="val 5634"/>
             </a:avLst>
           </a:prstGeom>
           <a:solidFill>
@@ -40785,13 +41044,13 @@
       </p:sp>
       <p:sp>
         <p:nvSpPr>
-          <p:cNvPr id="17" name="Shape 14"/>
+          <p:cNvPr id="19" name="Shape 15"/>
           <p:cNvSpPr/>
           <p:nvPr/>
         </p:nvSpPr>
         <p:spPr>
           <a:xfrm>
-            <a:off x="6214872" y="1508760"/>
+            <a:off x="4279392" y="2953512"/>
             <a:ext cx="274320" cy="274320"/>
           </a:xfrm>
           <a:prstGeom prst="ellipse">
@@ -40810,13 +41069,13 @@
       </p:sp>
       <p:sp>
         <p:nvSpPr>
-          <p:cNvPr id="18" name="Text 15"/>
-          <p:cNvSpPr txBox="1"/>
-          <p:nvPr/>
-        </p:nvSpPr>
-        <p:spPr>
-          <a:xfrm>
-            <a:off x="6214872" y="1508760"/>
+          <p:cNvPr id="20" name="Text 16"/>
+          <p:cNvSpPr txBox="1"/>
+          <p:nvPr/>
+        </p:nvSpPr>
+        <p:spPr>
+          <a:xfrm>
+            <a:off x="4279392" y="2953512"/>
             <a:ext cx="274320" cy="274320"/>
           </a:xfrm>
           <a:prstGeom prst="rect">
@@ -40841,7 +41100,7 @@
                 <a:ea typeface="SF Pro Display" pitchFamily="34" charset="-122"/>
                 <a:cs typeface="SF Pro Display" pitchFamily="34" charset="-120"/>
               </a:rPr>
-              <a:t>3</a:t>
+              <a:t>2</a:t>
             </a:r>
             <a:endParaRPr lang="en-US" sz="900" dirty="0"/>
           </a:p>
@@ -40849,14 +41108,14 @@
       </p:sp>
       <p:sp>
         <p:nvSpPr>
-          <p:cNvPr id="19" name="Text 16"/>
-          <p:cNvSpPr txBox="1"/>
-          <p:nvPr/>
-        </p:nvSpPr>
-        <p:spPr>
-          <a:xfrm>
-            <a:off x="6214872" y="1929384"/>
-            <a:ext cx="2353056" cy="274320"/>
+          <p:cNvPr id="21" name="Text 17"/>
+          <p:cNvSpPr txBox="1"/>
+          <p:nvPr/>
+        </p:nvSpPr>
+        <p:spPr>
+          <a:xfrm>
+            <a:off x="4279392" y="3374136"/>
+            <a:ext cx="4288536" cy="274320"/>
           </a:xfrm>
           <a:prstGeom prst="rect">
             <a:avLst/>
@@ -40880,7 +41139,7 @@
                 <a:ea typeface="SF Pro Display" pitchFamily="34" charset="-122"/>
                 <a:cs typeface="SF Pro Display" pitchFamily="34" charset="-120"/>
               </a:rPr>
-              <a:t>Never penalize the customer</a:t>
+              <a:t>How will you respond to the customer?</a:t>
             </a:r>
             <a:endParaRPr lang="en-US" sz="1200" dirty="0"/>
           </a:p>
@@ -40888,14 +41147,14 @@
       </p:sp>
       <p:sp>
         <p:nvSpPr>
-          <p:cNvPr id="20" name="Text 17"/>
-          <p:cNvSpPr txBox="1"/>
-          <p:nvPr/>
-        </p:nvSpPr>
-        <p:spPr>
-          <a:xfrm>
-            <a:off x="6214872" y="2221992"/>
-            <a:ext cx="2353056" cy="612648"/>
+          <p:cNvPr id="22" name="Text 18"/>
+          <p:cNvSpPr txBox="1"/>
+          <p:nvPr/>
+        </p:nvSpPr>
+        <p:spPr>
+          <a:xfrm>
+            <a:off x="4279392" y="3666744"/>
+            <a:ext cx="4288536" cy="310896"/>
           </a:xfrm>
           <a:prstGeom prst="rect">
             <a:avLst/>
@@ -40919,116 +41178,9 @@
                 <a:ea typeface="SF Pro Text" pitchFamily="34" charset="-122"/>
                 <a:cs typeface="SF Pro Text" pitchFamily="34" charset="-120"/>
               </a:rPr>
-              <a:t>Coach the cleaner. C-side never suspends or adds DNR.</a:t>
+              <a:t>Write the reply you would send.</a:t>
             </a:r>
             <a:endParaRPr lang="en-US" sz="950" dirty="0"/>
-          </a:p>
-        </p:txBody>
-      </p:sp>
-      <p:sp>
-        <p:nvSpPr>
-          <p:cNvPr id="21" name="Shape 18"/>
-          <p:cNvSpPr/>
-          <p:nvPr/>
-        </p:nvSpPr>
-        <p:spPr>
-          <a:xfrm>
-            <a:off x="411480" y="3108960"/>
-            <a:ext cx="8321040" cy="914400"/>
-          </a:xfrm>
-          <a:prstGeom prst="roundRect">
-            <a:avLst>
-              <a:gd name="adj" fmla="val 8000"/>
-            </a:avLst>
-          </a:prstGeom>
-          <a:solidFill>
-            <a:srgbClr val="0B7A6F"/>
-          </a:solidFill>
-          <a:ln w="9525">
-            <a:solidFill>
-              <a:srgbClr val="0B7A6F"/>
-            </a:solidFill>
-            <a:prstDash val="solid"/>
-          </a:ln>
-        </p:spPr>
-      </p:sp>
-      <p:pic>
-        <p:nvPicPr>
-          <p:cNvPr id="22" name="Image 0" descr="preencoded.png">    </p:cNvPr>
-          <p:cNvPicPr>
-            <a:picLocks noChangeAspect="1"/>
-          </p:cNvPicPr>
-          <p:nvPr/>
-        </p:nvPicPr>
-        <p:blipFill>
-          <a:blip r:embed="rId1"/>
-          <a:stretch>
-            <a:fillRect/>
-          </a:stretch>
-        </p:blipFill>
-        <p:spPr>
-          <a:xfrm>
-            <a:off x="731520" y="3383280"/>
-            <a:ext cx="365760" cy="365760"/>
-          </a:xfrm>
-          <a:prstGeom prst="rect">
-            <a:avLst/>
-          </a:prstGeom>
-        </p:spPr>
-      </p:pic>
-      <p:sp>
-        <p:nvSpPr>
-          <p:cNvPr id="23" name="Text 19"/>
-          <p:cNvSpPr txBox="1"/>
-          <p:nvPr/>
-        </p:nvSpPr>
-        <p:spPr>
-          <a:xfrm>
-            <a:off x="1325880" y="3108960"/>
-            <a:ext cx="7223760" cy="914400"/>
-          </a:xfrm>
-          <a:prstGeom prst="rect">
-            <a:avLst/>
-          </a:prstGeom>
-          <a:noFill/>
-          <a:ln/>
-        </p:spPr>
-        <p:txBody>
-          <a:bodyPr wrap="square" lIns="0" tIns="0" rIns="0" bIns="0" rtlCol="0" anchor="ctr"/>
-          <a:lstStyle/>
-          <a:p>
-            <a:pPr indent="0" marL="0">
-              <a:buNone/>
-            </a:pPr>
-            <a:r>
-              <a:rPr lang="en-US" sz="2000" b="1" dirty="0">
-                <a:solidFill>
-                  <a:srgbClr val="FFFFFF"/>
-                </a:solidFill>
-                <a:latin typeface="SF Pro Display" pitchFamily="34" charset="0"/>
-                <a:ea typeface="SF Pro Display" pitchFamily="34" charset="-122"/>
-                <a:cs typeface="SF Pro Display" pitchFamily="34" charset="-120"/>
-              </a:rPr>
-              <a:t>Questions?</a:t>
-            </a:r>
-            <a:endParaRPr lang="en-US" sz="2000" dirty="0"/>
-          </a:p>
-          <a:p>
-            <a:pPr indent="0" marL="0">
-              <a:buNone/>
-            </a:pPr>
-            <a:r>
-              <a:rPr lang="en-US" sz="1100" dirty="0">
-                <a:solidFill>
-                  <a:srgbClr val="FFFFFF"/>
-                </a:solidFill>
-                <a:latin typeface="SF Pro Text" pitchFamily="34" charset="0"/>
-                <a:ea typeface="SF Pro Text" pitchFamily="34" charset="-122"/>
-                <a:cs typeface="SF Pro Text" pitchFamily="34" charset="-120"/>
-              </a:rPr>
-              <a:t>Open the floor before we move to the next topic.</a:t>
-            </a:r>
-            <a:endParaRPr lang="en-US" sz="2000" dirty="0"/>
           </a:p>
         </p:txBody>
       </p:sp>
@@ -41113,6 +41265,810 @@
         </p:nvSpPr>
         <p:spPr>
           <a:xfrm>
+            <a:off x="438912" y="274320"/>
+            <a:ext cx="8229600" cy="182880"/>
+          </a:xfrm>
+          <a:prstGeom prst="rect">
+            <a:avLst/>
+          </a:prstGeom>
+          <a:noFill/>
+          <a:ln/>
+        </p:spPr>
+        <p:txBody>
+          <a:bodyPr wrap="square" lIns="0" tIns="0" rIns="0" bIns="0" rtlCol="0" anchor="t"/>
+          <a:lstStyle/>
+          <a:p>
+            <a:pPr indent="0" marL="0">
+              <a:buNone/>
+            </a:pPr>
+            <a:r>
+              <a:rPr lang="en-US" sz="800" b="1" spc="50" kern="0" dirty="0">
+                <a:solidFill>
+                  <a:srgbClr val="0B7A6F"/>
+                </a:solidFill>
+                <a:latin typeface="SF Pro Display" pitchFamily="34" charset="0"/>
+                <a:ea typeface="SF Pro Display" pitchFamily="34" charset="-122"/>
+                <a:cs typeface="SF Pro Display" pitchFamily="34" charset="-120"/>
+              </a:rPr>
+              <a:t>CASH PAYMENT  ·  WRAP-UP</a:t>
+            </a:r>
+            <a:endParaRPr lang="en-US" sz="800" dirty="0"/>
+          </a:p>
+        </p:txBody>
+      </p:sp>
+      <p:sp>
+        <p:nvSpPr>
+          <p:cNvPr id="3" name="Text 1"/>
+          <p:cNvSpPr txBox="1"/>
+          <p:nvPr/>
+        </p:nvSpPr>
+        <p:spPr>
+          <a:xfrm>
+            <a:off x="438912" y="457200"/>
+            <a:ext cx="8229600" cy="457200"/>
+          </a:xfrm>
+          <a:prstGeom prst="rect">
+            <a:avLst/>
+          </a:prstGeom>
+          <a:noFill/>
+          <a:ln/>
+        </p:spPr>
+        <p:txBody>
+          <a:bodyPr wrap="square" lIns="0" tIns="0" rIns="0" bIns="0" rtlCol="0" anchor="t"/>
+          <a:lstStyle/>
+          <a:p>
+            <a:pPr indent="0" marL="0">
+              <a:buNone/>
+            </a:pPr>
+            <a:r>
+              <a:rPr lang="en-US" sz="2400" b="1" dirty="0">
+                <a:solidFill>
+                  <a:srgbClr val="1D1D1F"/>
+                </a:solidFill>
+                <a:latin typeface="SF Pro Display" pitchFamily="34" charset="0"/>
+                <a:ea typeface="SF Pro Display" pitchFamily="34" charset="-122"/>
+                <a:cs typeface="SF Pro Display" pitchFamily="34" charset="-120"/>
+              </a:rPr>
+              <a:t>Wrap-up</a:t>
+            </a:r>
+            <a:endParaRPr lang="en-US" sz="2400" dirty="0"/>
+          </a:p>
+        </p:txBody>
+      </p:sp>
+      <p:sp>
+        <p:nvSpPr>
+          <p:cNvPr id="4" name="Text 2"/>
+          <p:cNvSpPr txBox="1"/>
+          <p:nvPr/>
+        </p:nvSpPr>
+        <p:spPr>
+          <a:xfrm>
+            <a:off x="438912" y="960120"/>
+            <a:ext cx="8229600" cy="274320"/>
+          </a:xfrm>
+          <a:prstGeom prst="rect">
+            <a:avLst/>
+          </a:prstGeom>
+          <a:noFill/>
+          <a:ln/>
+        </p:spPr>
+        <p:txBody>
+          <a:bodyPr wrap="square" lIns="0" tIns="0" rIns="0" bIns="0" rtlCol="0" anchor="t"/>
+          <a:lstStyle/>
+          <a:p>
+            <a:pPr indent="0" marL="0">
+              <a:buNone/>
+            </a:pPr>
+            <a:r>
+              <a:rPr lang="en-US" sz="1200" dirty="0">
+                <a:solidFill>
+                  <a:srgbClr val="6E6E73"/>
+                </a:solidFill>
+                <a:latin typeface="SF Pro Text" pitchFamily="34" charset="0"/>
+                <a:ea typeface="SF Pro Text" pitchFamily="34" charset="-122"/>
+                <a:cs typeface="SF Pro Text" pitchFamily="34" charset="-120"/>
+              </a:rPr>
+              <a:t>Key takeaways before we move on.</a:t>
+            </a:r>
+            <a:endParaRPr lang="en-US" sz="1200" dirty="0"/>
+          </a:p>
+        </p:txBody>
+      </p:sp>
+      <p:sp>
+        <p:nvSpPr>
+          <p:cNvPr id="6" name="Shape 3"/>
+          <p:cNvSpPr/>
+          <p:nvPr/>
+        </p:nvSpPr>
+        <p:spPr>
+          <a:xfrm>
+            <a:off x="411480" y="1325880"/>
+            <a:ext cx="2682240" cy="1600200"/>
+          </a:xfrm>
+          <a:prstGeom prst="roundRect">
+            <a:avLst>
+              <a:gd name="adj" fmla="val 4571"/>
+            </a:avLst>
+          </a:prstGeom>
+          <a:solidFill>
+            <a:srgbClr val="FFFFFF"/>
+          </a:solidFill>
+          <a:ln w="9525">
+            <a:solidFill>
+              <a:srgbClr val="DCE1E7"/>
+            </a:solidFill>
+            <a:prstDash val="solid"/>
+          </a:ln>
+        </p:spPr>
+      </p:sp>
+      <p:sp>
+        <p:nvSpPr>
+          <p:cNvPr id="7" name="Shape 4"/>
+          <p:cNvSpPr/>
+          <p:nvPr/>
+        </p:nvSpPr>
+        <p:spPr>
+          <a:xfrm>
+            <a:off x="576072" y="1508760"/>
+            <a:ext cx="274320" cy="274320"/>
+          </a:xfrm>
+          <a:prstGeom prst="ellipse">
+            <a:avLst/>
+          </a:prstGeom>
+          <a:solidFill>
+            <a:srgbClr val="E3F4F1"/>
+          </a:solidFill>
+          <a:ln w="12700">
+            <a:solidFill>
+              <a:srgbClr val="E3F4F1"/>
+            </a:solidFill>
+            <a:prstDash val="solid"/>
+          </a:ln>
+        </p:spPr>
+      </p:sp>
+      <p:sp>
+        <p:nvSpPr>
+          <p:cNvPr id="8" name="Text 5"/>
+          <p:cNvSpPr txBox="1"/>
+          <p:nvPr/>
+        </p:nvSpPr>
+        <p:spPr>
+          <a:xfrm>
+            <a:off x="576072" y="1508760"/>
+            <a:ext cx="274320" cy="274320"/>
+          </a:xfrm>
+          <a:prstGeom prst="rect">
+            <a:avLst/>
+          </a:prstGeom>
+          <a:noFill/>
+          <a:ln/>
+        </p:spPr>
+        <p:txBody>
+          <a:bodyPr wrap="square" lIns="0" tIns="0" rIns="0" bIns="0" rtlCol="0" anchor="ctr"/>
+          <a:lstStyle/>
+          <a:p>
+            <a:pPr algn="ctr" indent="0" marL="0">
+              <a:buNone/>
+            </a:pPr>
+            <a:r>
+              <a:rPr lang="en-US" sz="900" b="1" dirty="0">
+                <a:solidFill>
+                  <a:srgbClr val="0B7A6F"/>
+                </a:solidFill>
+                <a:latin typeface="SF Pro Display" pitchFamily="34" charset="0"/>
+                <a:ea typeface="SF Pro Display" pitchFamily="34" charset="-122"/>
+                <a:cs typeface="SF Pro Display" pitchFamily="34" charset="-120"/>
+              </a:rPr>
+              <a:t>1</a:t>
+            </a:r>
+            <a:endParaRPr lang="en-US" sz="900" dirty="0"/>
+          </a:p>
+        </p:txBody>
+      </p:sp>
+      <p:sp>
+        <p:nvSpPr>
+          <p:cNvPr id="9" name="Text 6"/>
+          <p:cNvSpPr txBox="1"/>
+          <p:nvPr/>
+        </p:nvSpPr>
+        <p:spPr>
+          <a:xfrm>
+            <a:off x="576072" y="1929384"/>
+            <a:ext cx="2353056" cy="274320"/>
+          </a:xfrm>
+          <a:prstGeom prst="rect">
+            <a:avLst/>
+          </a:prstGeom>
+          <a:noFill/>
+          <a:ln/>
+        </p:spPr>
+        <p:txBody>
+          <a:bodyPr wrap="square" lIns="0" tIns="0" rIns="0" bIns="0" rtlCol="0" anchor="t"/>
+          <a:lstStyle/>
+          <a:p>
+            <a:pPr indent="0" marL="0">
+              <a:buNone/>
+            </a:pPr>
+            <a:r>
+              <a:rPr lang="en-US" sz="1200" b="1" dirty="0">
+                <a:solidFill>
+                  <a:srgbClr val="1D1D1F"/>
+                </a:solidFill>
+                <a:latin typeface="SF Pro Display" pitchFamily="34" charset="0"/>
+                <a:ea typeface="SF Pro Display" pitchFamily="34" charset="-122"/>
+                <a:cs typeface="SF Pro Display" pitchFamily="34" charset="-120"/>
+              </a:rPr>
+              <a:t>Status decides the action</a:t>
+            </a:r>
+            <a:endParaRPr lang="en-US" sz="1200" dirty="0"/>
+          </a:p>
+        </p:txBody>
+      </p:sp>
+      <p:sp>
+        <p:nvSpPr>
+          <p:cNvPr id="10" name="Text 7"/>
+          <p:cNvSpPr txBox="1"/>
+          <p:nvPr/>
+        </p:nvSpPr>
+        <p:spPr>
+          <a:xfrm>
+            <a:off x="576072" y="2221992"/>
+            <a:ext cx="2353056" cy="612648"/>
+          </a:xfrm>
+          <a:prstGeom prst="rect">
+            <a:avLst/>
+          </a:prstGeom>
+          <a:noFill/>
+          <a:ln/>
+        </p:spPr>
+        <p:txBody>
+          <a:bodyPr wrap="square" lIns="0" tIns="0" rIns="0" bIns="0" rtlCol="0" anchor="t"/>
+          <a:lstStyle/>
+          <a:p>
+            <a:pPr indent="0" marL="0">
+              <a:buNone/>
+            </a:pPr>
+            <a:r>
+              <a:rPr lang="en-US" sz="950" dirty="0">
+                <a:solidFill>
+                  <a:srgbClr val="6E6E73"/>
+                </a:solidFill>
+                <a:latin typeface="SF Pro Text" pitchFamily="34" charset="0"/>
+                <a:ea typeface="SF Pro Text" pitchFamily="34" charset="-122"/>
+                <a:cs typeface="SF Pro Text" pitchFamily="34" charset="-120"/>
+              </a:rPr>
+              <a:t>Pending Invoice: cancel. Invoiced: refund. Cancelled: don't recreate.</a:t>
+            </a:r>
+            <a:endParaRPr lang="en-US" sz="950" dirty="0"/>
+          </a:p>
+        </p:txBody>
+      </p:sp>
+      <p:sp>
+        <p:nvSpPr>
+          <p:cNvPr id="11" name="Shape 8"/>
+          <p:cNvSpPr/>
+          <p:nvPr/>
+        </p:nvSpPr>
+        <p:spPr>
+          <a:xfrm>
+            <a:off x="3230880" y="1325880"/>
+            <a:ext cx="2682240" cy="1600200"/>
+          </a:xfrm>
+          <a:prstGeom prst="roundRect">
+            <a:avLst>
+              <a:gd name="adj" fmla="val 4571"/>
+            </a:avLst>
+          </a:prstGeom>
+          <a:solidFill>
+            <a:srgbClr val="FFFFFF"/>
+          </a:solidFill>
+          <a:ln w="9525">
+            <a:solidFill>
+              <a:srgbClr val="DCE1E7"/>
+            </a:solidFill>
+            <a:prstDash val="solid"/>
+          </a:ln>
+        </p:spPr>
+      </p:sp>
+      <p:sp>
+        <p:nvSpPr>
+          <p:cNvPr id="12" name="Shape 9"/>
+          <p:cNvSpPr/>
+          <p:nvPr/>
+        </p:nvSpPr>
+        <p:spPr>
+          <a:xfrm>
+            <a:off x="3395472" y="1508760"/>
+            <a:ext cx="274320" cy="274320"/>
+          </a:xfrm>
+          <a:prstGeom prst="ellipse">
+            <a:avLst/>
+          </a:prstGeom>
+          <a:solidFill>
+            <a:srgbClr val="E3F4F1"/>
+          </a:solidFill>
+          <a:ln w="12700">
+            <a:solidFill>
+              <a:srgbClr val="E3F4F1"/>
+            </a:solidFill>
+            <a:prstDash val="solid"/>
+          </a:ln>
+        </p:spPr>
+      </p:sp>
+      <p:sp>
+        <p:nvSpPr>
+          <p:cNvPr id="13" name="Text 10"/>
+          <p:cNvSpPr txBox="1"/>
+          <p:nvPr/>
+        </p:nvSpPr>
+        <p:spPr>
+          <a:xfrm>
+            <a:off x="3395472" y="1508760"/>
+            <a:ext cx="274320" cy="274320"/>
+          </a:xfrm>
+          <a:prstGeom prst="rect">
+            <a:avLst/>
+          </a:prstGeom>
+          <a:noFill/>
+          <a:ln/>
+        </p:spPr>
+        <p:txBody>
+          <a:bodyPr wrap="square" lIns="0" tIns="0" rIns="0" bIns="0" rtlCol="0" anchor="ctr"/>
+          <a:lstStyle/>
+          <a:p>
+            <a:pPr algn="ctr" indent="0" marL="0">
+              <a:buNone/>
+            </a:pPr>
+            <a:r>
+              <a:rPr lang="en-US" sz="900" b="1" dirty="0">
+                <a:solidFill>
+                  <a:srgbClr val="0B7A6F"/>
+                </a:solidFill>
+                <a:latin typeface="SF Pro Display" pitchFamily="34" charset="0"/>
+                <a:ea typeface="SF Pro Display" pitchFamily="34" charset="-122"/>
+                <a:cs typeface="SF Pro Display" pitchFamily="34" charset="-120"/>
+              </a:rPr>
+              <a:t>2</a:t>
+            </a:r>
+            <a:endParaRPr lang="en-US" sz="900" dirty="0"/>
+          </a:p>
+        </p:txBody>
+      </p:sp>
+      <p:sp>
+        <p:nvSpPr>
+          <p:cNvPr id="14" name="Text 11"/>
+          <p:cNvSpPr txBox="1"/>
+          <p:nvPr/>
+        </p:nvSpPr>
+        <p:spPr>
+          <a:xfrm>
+            <a:off x="3395472" y="1929384"/>
+            <a:ext cx="2353056" cy="274320"/>
+          </a:xfrm>
+          <a:prstGeom prst="rect">
+            <a:avLst/>
+          </a:prstGeom>
+          <a:noFill/>
+          <a:ln/>
+        </p:spPr>
+        <p:txBody>
+          <a:bodyPr wrap="square" lIns="0" tIns="0" rIns="0" bIns="0" rtlCol="0" anchor="t"/>
+          <a:lstStyle/>
+          <a:p>
+            <a:pPr indent="0" marL="0">
+              <a:buNone/>
+            </a:pPr>
+            <a:r>
+              <a:rPr lang="en-US" sz="1200" b="1" dirty="0">
+                <a:solidFill>
+                  <a:srgbClr val="1D1D1F"/>
+                </a:solidFill>
+                <a:latin typeface="SF Pro Display" pitchFamily="34" charset="0"/>
+                <a:ea typeface="SF Pro Display" pitchFamily="34" charset="-122"/>
+                <a:cs typeface="SF Pro Display" pitchFamily="34" charset="-120"/>
+              </a:rPr>
+              <a:t>Get the amount first</a:t>
+            </a:r>
+            <a:endParaRPr lang="en-US" sz="1200" dirty="0"/>
+          </a:p>
+        </p:txBody>
+      </p:sp>
+      <p:sp>
+        <p:nvSpPr>
+          <p:cNvPr id="15" name="Text 12"/>
+          <p:cNvSpPr txBox="1"/>
+          <p:nvPr/>
+        </p:nvSpPr>
+        <p:spPr>
+          <a:xfrm>
+            <a:off x="3395472" y="2221992"/>
+            <a:ext cx="2353056" cy="612648"/>
+          </a:xfrm>
+          <a:prstGeom prst="rect">
+            <a:avLst/>
+          </a:prstGeom>
+          <a:noFill/>
+          <a:ln/>
+        </p:spPr>
+        <p:txBody>
+          <a:bodyPr wrap="square" lIns="0" tIns="0" rIns="0" bIns="0" rtlCol="0" anchor="t"/>
+          <a:lstStyle/>
+          <a:p>
+            <a:pPr indent="0" marL="0">
+              <a:buNone/>
+            </a:pPr>
+            <a:r>
+              <a:rPr lang="en-US" sz="950" dirty="0">
+                <a:solidFill>
+                  <a:srgbClr val="6E6E73"/>
+                </a:solidFill>
+                <a:latin typeface="SF Pro Text" pitchFamily="34" charset="0"/>
+                <a:ea typeface="SF Pro Text" pitchFamily="34" charset="-122"/>
+                <a:cs typeface="SF Pro Text" pitchFamily="34" charset="-120"/>
+              </a:rPr>
+              <a:t>Full vs partial is based on CP Pay, not the C Price.</a:t>
+            </a:r>
+            <a:endParaRPr lang="en-US" sz="950" dirty="0"/>
+          </a:p>
+        </p:txBody>
+      </p:sp>
+      <p:sp>
+        <p:nvSpPr>
+          <p:cNvPr id="16" name="Shape 13"/>
+          <p:cNvSpPr/>
+          <p:nvPr/>
+        </p:nvSpPr>
+        <p:spPr>
+          <a:xfrm>
+            <a:off x="6050280" y="1325880"/>
+            <a:ext cx="2682240" cy="1600200"/>
+          </a:xfrm>
+          <a:prstGeom prst="roundRect">
+            <a:avLst>
+              <a:gd name="adj" fmla="val 4571"/>
+            </a:avLst>
+          </a:prstGeom>
+          <a:solidFill>
+            <a:srgbClr val="FFFFFF"/>
+          </a:solidFill>
+          <a:ln w="9525">
+            <a:solidFill>
+              <a:srgbClr val="DCE1E7"/>
+            </a:solidFill>
+            <a:prstDash val="solid"/>
+          </a:ln>
+        </p:spPr>
+      </p:sp>
+      <p:sp>
+        <p:nvSpPr>
+          <p:cNvPr id="17" name="Shape 14"/>
+          <p:cNvSpPr/>
+          <p:nvPr/>
+        </p:nvSpPr>
+        <p:spPr>
+          <a:xfrm>
+            <a:off x="6214872" y="1508760"/>
+            <a:ext cx="274320" cy="274320"/>
+          </a:xfrm>
+          <a:prstGeom prst="ellipse">
+            <a:avLst/>
+          </a:prstGeom>
+          <a:solidFill>
+            <a:srgbClr val="E3F4F1"/>
+          </a:solidFill>
+          <a:ln w="12700">
+            <a:solidFill>
+              <a:srgbClr val="E3F4F1"/>
+            </a:solidFill>
+            <a:prstDash val="solid"/>
+          </a:ln>
+        </p:spPr>
+      </p:sp>
+      <p:sp>
+        <p:nvSpPr>
+          <p:cNvPr id="18" name="Text 15"/>
+          <p:cNvSpPr txBox="1"/>
+          <p:nvPr/>
+        </p:nvSpPr>
+        <p:spPr>
+          <a:xfrm>
+            <a:off x="6214872" y="1508760"/>
+            <a:ext cx="274320" cy="274320"/>
+          </a:xfrm>
+          <a:prstGeom prst="rect">
+            <a:avLst/>
+          </a:prstGeom>
+          <a:noFill/>
+          <a:ln/>
+        </p:spPr>
+        <p:txBody>
+          <a:bodyPr wrap="square" lIns="0" tIns="0" rIns="0" bIns="0" rtlCol="0" anchor="ctr"/>
+          <a:lstStyle/>
+          <a:p>
+            <a:pPr algn="ctr" indent="0" marL="0">
+              <a:buNone/>
+            </a:pPr>
+            <a:r>
+              <a:rPr lang="en-US" sz="900" b="1" dirty="0">
+                <a:solidFill>
+                  <a:srgbClr val="0B7A6F"/>
+                </a:solidFill>
+                <a:latin typeface="SF Pro Display" pitchFamily="34" charset="0"/>
+                <a:ea typeface="SF Pro Display" pitchFamily="34" charset="-122"/>
+                <a:cs typeface="SF Pro Display" pitchFamily="34" charset="-120"/>
+              </a:rPr>
+              <a:t>3</a:t>
+            </a:r>
+            <a:endParaRPr lang="en-US" sz="900" dirty="0"/>
+          </a:p>
+        </p:txBody>
+      </p:sp>
+      <p:sp>
+        <p:nvSpPr>
+          <p:cNvPr id="19" name="Text 16"/>
+          <p:cNvSpPr txBox="1"/>
+          <p:nvPr/>
+        </p:nvSpPr>
+        <p:spPr>
+          <a:xfrm>
+            <a:off x="6214872" y="1929384"/>
+            <a:ext cx="2353056" cy="274320"/>
+          </a:xfrm>
+          <a:prstGeom prst="rect">
+            <a:avLst/>
+          </a:prstGeom>
+          <a:noFill/>
+          <a:ln/>
+        </p:spPr>
+        <p:txBody>
+          <a:bodyPr wrap="square" lIns="0" tIns="0" rIns="0" bIns="0" rtlCol="0" anchor="t"/>
+          <a:lstStyle/>
+          <a:p>
+            <a:pPr indent="0" marL="0">
+              <a:buNone/>
+            </a:pPr>
+            <a:r>
+              <a:rPr lang="en-US" sz="1200" b="1" dirty="0">
+                <a:solidFill>
+                  <a:srgbClr val="1D1D1F"/>
+                </a:solidFill>
+                <a:latin typeface="SF Pro Display" pitchFamily="34" charset="0"/>
+                <a:ea typeface="SF Pro Display" pitchFamily="34" charset="-122"/>
+                <a:cs typeface="SF Pro Display" pitchFamily="34" charset="-120"/>
+              </a:rPr>
+              <a:t>Never penalize the customer</a:t>
+            </a:r>
+            <a:endParaRPr lang="en-US" sz="1200" dirty="0"/>
+          </a:p>
+        </p:txBody>
+      </p:sp>
+      <p:sp>
+        <p:nvSpPr>
+          <p:cNvPr id="20" name="Text 17"/>
+          <p:cNvSpPr txBox="1"/>
+          <p:nvPr/>
+        </p:nvSpPr>
+        <p:spPr>
+          <a:xfrm>
+            <a:off x="6214872" y="2221992"/>
+            <a:ext cx="2353056" cy="612648"/>
+          </a:xfrm>
+          <a:prstGeom prst="rect">
+            <a:avLst/>
+          </a:prstGeom>
+          <a:noFill/>
+          <a:ln/>
+        </p:spPr>
+        <p:txBody>
+          <a:bodyPr wrap="square" lIns="0" tIns="0" rIns="0" bIns="0" rtlCol="0" anchor="t"/>
+          <a:lstStyle/>
+          <a:p>
+            <a:pPr indent="0" marL="0">
+              <a:buNone/>
+            </a:pPr>
+            <a:r>
+              <a:rPr lang="en-US" sz="950" dirty="0">
+                <a:solidFill>
+                  <a:srgbClr val="6E6E73"/>
+                </a:solidFill>
+                <a:latin typeface="SF Pro Text" pitchFamily="34" charset="0"/>
+                <a:ea typeface="SF Pro Text" pitchFamily="34" charset="-122"/>
+                <a:cs typeface="SF Pro Text" pitchFamily="34" charset="-120"/>
+              </a:rPr>
+              <a:t>Coach the cleaner. C-side never suspends or adds DNR.</a:t>
+            </a:r>
+            <a:endParaRPr lang="en-US" sz="950" dirty="0"/>
+          </a:p>
+        </p:txBody>
+      </p:sp>
+      <p:sp>
+        <p:nvSpPr>
+          <p:cNvPr id="21" name="Shape 18"/>
+          <p:cNvSpPr/>
+          <p:nvPr/>
+        </p:nvSpPr>
+        <p:spPr>
+          <a:xfrm>
+            <a:off x="411480" y="3108960"/>
+            <a:ext cx="8321040" cy="914400"/>
+          </a:xfrm>
+          <a:prstGeom prst="roundRect">
+            <a:avLst>
+              <a:gd name="adj" fmla="val 8000"/>
+            </a:avLst>
+          </a:prstGeom>
+          <a:solidFill>
+            <a:srgbClr val="0B7A6F"/>
+          </a:solidFill>
+          <a:ln w="9525">
+            <a:solidFill>
+              <a:srgbClr val="0B7A6F"/>
+            </a:solidFill>
+            <a:prstDash val="solid"/>
+          </a:ln>
+        </p:spPr>
+      </p:sp>
+      <p:pic>
+        <p:nvPicPr>
+          <p:cNvPr id="22" name="Image 0" descr="preencoded.png">    </p:cNvPr>
+          <p:cNvPicPr>
+            <a:picLocks noChangeAspect="1"/>
+          </p:cNvPicPr>
+          <p:nvPr/>
+        </p:nvPicPr>
+        <p:blipFill>
+          <a:blip r:embed="rId1"/>
+          <a:stretch>
+            <a:fillRect/>
+          </a:stretch>
+        </p:blipFill>
+        <p:spPr>
+          <a:xfrm>
+            <a:off x="731520" y="3383280"/>
+            <a:ext cx="365760" cy="365760"/>
+          </a:xfrm>
+          <a:prstGeom prst="rect">
+            <a:avLst/>
+          </a:prstGeom>
+        </p:spPr>
+      </p:pic>
+      <p:sp>
+        <p:nvSpPr>
+          <p:cNvPr id="23" name="Text 19"/>
+          <p:cNvSpPr txBox="1"/>
+          <p:nvPr/>
+        </p:nvSpPr>
+        <p:spPr>
+          <a:xfrm>
+            <a:off x="1325880" y="3108960"/>
+            <a:ext cx="7223760" cy="914400"/>
+          </a:xfrm>
+          <a:prstGeom prst="rect">
+            <a:avLst/>
+          </a:prstGeom>
+          <a:noFill/>
+          <a:ln/>
+        </p:spPr>
+        <p:txBody>
+          <a:bodyPr wrap="square" lIns="0" tIns="0" rIns="0" bIns="0" rtlCol="0" anchor="ctr"/>
+          <a:lstStyle/>
+          <a:p>
+            <a:pPr indent="0" marL="0">
+              <a:buNone/>
+            </a:pPr>
+            <a:r>
+              <a:rPr lang="en-US" sz="2000" b="1" dirty="0">
+                <a:solidFill>
+                  <a:srgbClr val="FFFFFF"/>
+                </a:solidFill>
+                <a:latin typeface="SF Pro Display" pitchFamily="34" charset="0"/>
+                <a:ea typeface="SF Pro Display" pitchFamily="34" charset="-122"/>
+                <a:cs typeface="SF Pro Display" pitchFamily="34" charset="-120"/>
+              </a:rPr>
+              <a:t>Questions?</a:t>
+            </a:r>
+            <a:endParaRPr lang="en-US" sz="2000" dirty="0"/>
+          </a:p>
+          <a:p>
+            <a:pPr indent="0" marL="0">
+              <a:buNone/>
+            </a:pPr>
+            <a:r>
+              <a:rPr lang="en-US" sz="1100" dirty="0">
+                <a:solidFill>
+                  <a:srgbClr val="FFFFFF"/>
+                </a:solidFill>
+                <a:latin typeface="SF Pro Text" pitchFamily="34" charset="0"/>
+                <a:ea typeface="SF Pro Text" pitchFamily="34" charset="-122"/>
+                <a:cs typeface="SF Pro Text" pitchFamily="34" charset="-120"/>
+              </a:rPr>
+              <a:t>Open the floor before we move to the next topic.</a:t>
+            </a:r>
+            <a:endParaRPr lang="en-US" sz="2000" dirty="0"/>
+          </a:p>
+        </p:txBody>
+      </p:sp>
+      <p:sp>
+        <p:nvSpPr>
+          <p:cNvPr id="25" name="Slide Number Placeholder 0"/>
+          <p:cNvSpPr>
+            <a:spLocks noGrp="1"/>
+          </p:cNvSpPr>
+          <p:nvPr>
+            <p:ph type="sldNum" sz="quarter" idx="4294967295"/>
+          </p:nvPr>
+        </p:nvSpPr>
+        <p:spPr>
+          <a:xfrm>
+            <a:off x="8229600" y="4800600"/>
+            <a:ext cx="457200" cy="182880"/>
+          </a:xfrm>
+          <a:prstGeom prst="rect">
+            <a:avLst/>
+          </a:prstGeom>
+          <a:extLst>
+            <a:ext uri="{C572A759-6A51-4108-AA02-DFA0A04FC94B}">
+              <ma14:wrappingTextBoxFlag xmlns:ma14="http://schemas.microsoft.com/office/mac/drawingml/2011/main" val="0"/>
+            </a:ext>
+          </a:extLst>
+        </p:spPr>
+        <p:txBody>
+          <a:bodyPr/>
+          <a:lstStyle>
+            <a:lvl1pPr>
+              <a:defRPr sz="700">
+                <a:solidFill>
+                  <a:srgbClr val="6E6E73"/>
+                </a:solidFill>
+                <a:latin typeface="SF Pro Text"/>
+                <a:ea typeface="SF Pro Text"/>
+                <a:cs typeface="SF Pro Text"/>
+              </a:defRPr>
+            </a:lvl1pPr>
+          </a:lstStyle>
+          <a:p>
+            <a:pPr algn="r"/>
+            <a:fld id="{F7021451-1387-4CA6-816F-3879F97B5CBC}" type="slidenum">
+              <a:rPr b="0" lang="en-US"/>
+              <a:t>45</a:t>
+            </a:fld>
+            <a:endParaRPr lang="en-US"/>
+          </a:p>
+        </p:txBody>
+      </p:sp>
+    </p:spTree>
+  </p:cSld>
+  <p:clrMapOvr>
+    <a:masterClrMapping/>
+  </p:clrMapOvr>
+</p:sld>
+</file>
+
+<file path=ppt/slides/slide46.xml><?xml version="1.0" encoding="utf-8"?>
+<p:sld xmlns:a="http://schemas.openxmlformats.org/drawingml/2006/main" xmlns:r="http://schemas.openxmlformats.org/officeDocument/2006/relationships" xmlns:p="http://schemas.openxmlformats.org/presentationml/2006/main">
+  <p:cSld name="Slide 46">
+    <p:spTree>
+      <p:nvGrpSpPr>
+        <p:cNvPr id="1" name=""/>
+        <p:cNvGrpSpPr/>
+        <p:nvPr/>
+      </p:nvGrpSpPr>
+      <p:grpSpPr>
+        <a:xfrm>
+          <a:off x="0" y="0"/>
+          <a:ext cx="0" cy="0"/>
+          <a:chOff x="0" y="0"/>
+          <a:chExt cx="0" cy="0"/>
+        </a:xfrm>
+      </p:grpSpPr>
+      <p:sp>
+        <p:nvSpPr>
+          <p:cNvPr id="2" name="Text 0"/>
+          <p:cNvSpPr txBox="1"/>
+          <p:nvPr/>
+        </p:nvSpPr>
+        <p:spPr>
+          <a:xfrm>
             <a:off x="566928" y="1737360"/>
             <a:ext cx="4572000" cy="182880"/>
           </a:xfrm>
@@ -41490,7 +42446,7 @@
             <a:pPr algn="r"/>
             <a:fld id="{F7021451-1387-4CA6-816F-3879F97B5CBC}" type="slidenum">
               <a:rPr b="0" lang="en-US"/>
-              <a:t>45</a:t>
+              <a:t>46</a:t>
             </a:fld>
             <a:endParaRPr lang="en-US"/>
           </a:p>

</xml_diff>